<commit_message>
Add DC-08 thirty-day action board as executable component (slide 7)
Co-Authored-By: Claude Fable 5 <noreply@anthropic.com>
</commit_message>
<xml_diff>
--- a/domains/yuhong/assets/components/yuhong-county-course-components-branded.pptx
+++ b/domains/yuhong/assets/components/yuhong-county-course-components-branded.pptx
@@ -5,7 +5,7 @@
     <p:sldMasterId id="2147483648" r:id="rId1"/>
   </p:sldMasterIdLst>
   <p:notesMasterIdLst>
-    <p:notesMasterId r:id="rId8"/>
+    <p:notesMasterId r:id="rId9"/>
   </p:notesMasterIdLst>
   <p:sldIdLst>
     <p:sldId id="256" r:id="rId2"/>
@@ -14,6 +14,7 @@
     <p:sldId id="259" r:id="rId5"/>
     <p:sldId id="260" r:id="rId6"/>
     <p:sldId id="261" r:id="rId7"/>
+    <p:sldId id="262" r:id="rId8"/>
   </p:sldIdLst>
   <p:sldSz cx="12192000" cy="6858000"/>
   <p:notesSz cx="6858000" cy="9144000"/>
@@ -10740,6 +10741,1680 @@
     <p:extLst>
       <p:ext uri="{BB962C8B-B14F-4D97-AF65-F5344CB8AC3E}">
         <p14:creationId xmlns:p14="http://schemas.microsoft.com/office/powerpoint/2010/main" val="15893194"/>
+      </p:ext>
+    </p:extLst>
+  </p:cSld>
+  <p:clrMapOvr>
+    <a:masterClrMapping/>
+  </p:clrMapOvr>
+</p:sld>
+</file>
+
+<file path=ppt/slides/slide7.xml><?xml version="1.0" encoding="utf-8"?>
+<p:sld xmlns:a="http://schemas.openxmlformats.org/drawingml/2006/main" xmlns:r="http://schemas.openxmlformats.org/officeDocument/2006/relationships" xmlns:p="http://schemas.openxmlformats.org/presentationml/2006/main">
+  <p:cSld>
+    <p:spTree>
+      <p:nvGrpSpPr>
+        <p:cNvPr id="1" name=""/>
+        <p:cNvGrpSpPr/>
+        <p:nvPr/>
+      </p:nvGrpSpPr>
+      <p:grpSpPr>
+        <a:xfrm>
+          <a:off x="0" y="0"/>
+          <a:ext cx="0" cy="0"/>
+          <a:chOff x="0" y="0"/>
+          <a:chExt cx="0" cy="0"/>
+        </a:xfrm>
+      </p:grpSpPr>
+      <p:sp>
+        <p:nvSpPr>
+          <p:cNvPr id="2" name="TITLE">
+            <a:extLst>
+              <a:ext uri="{FF2B5EF4-FFF2-40B4-BE49-F238E27FC236}">
+                <a16:creationId xmlns:a16="http://schemas.microsoft.com/office/drawing/2014/main" id="{88D97873-1814-2820-21C8-C16459AB8C5F}"/>
+              </a:ext>
+            </a:extLst>
+          </p:cNvPr>
+          <p:cNvSpPr txBox="1"/>
+          <p:nvPr/>
+        </p:nvSpPr>
+        <p:spPr>
+          <a:xfrm>
+            <a:off x="548640" y="384048"/>
+            <a:ext cx="10607040" cy="825500"/>
+          </a:xfrm>
+          <a:prstGeom prst="rect">
+            <a:avLst/>
+          </a:prstGeom>
+          <a:noFill/>
+        </p:spPr>
+        <p:txBody>
+          <a:bodyPr vert="horz" wrap="square" rtlCol="0">
+            <a:noAutofit/>
+          </a:bodyPr>
+          <a:lstStyle/>
+          <a:p>
+            <a:r>
+              <a:rPr lang="zh-CN" altLang="en-US" sz="2600" b="1">
+                <a:solidFill>
+                  <a:srgbClr val="172A3A"/>
+                </a:solidFill>
+                <a:latin typeface="Microsoft YaHei" panose="020B0503020204020204" pitchFamily="34" charset="-122"/>
+                <a:ea typeface="Microsoft YaHei" panose="020B0503020204020204" pitchFamily="34" charset="-122"/>
+              </a:rPr>
+              <a:t>未来 </a:t>
+            </a:r>
+            <a:r>
+              <a:rPr lang="en-US" altLang="zh-CN" sz="2600" b="1">
+                <a:solidFill>
+                  <a:srgbClr val="172A3A"/>
+                </a:solidFill>
+                <a:latin typeface="Microsoft YaHei" panose="020B0503020204020204" pitchFamily="34" charset="-122"/>
+                <a:ea typeface="Microsoft YaHei" panose="020B0503020204020204" pitchFamily="34" charset="-122"/>
+              </a:rPr>
+              <a:t>30 </a:t>
+            </a:r>
+            <a:r>
+              <a:rPr lang="zh-CN" altLang="en-US" sz="2600" b="1">
+                <a:solidFill>
+                  <a:srgbClr val="172A3A"/>
+                </a:solidFill>
+                <a:latin typeface="Microsoft YaHei" panose="020B0503020204020204" pitchFamily="34" charset="-122"/>
+                <a:ea typeface="Microsoft YaHei" panose="020B0503020204020204" pitchFamily="34" charset="-122"/>
+              </a:rPr>
+              <a:t>天：谁、对谁、做什么、怎么验收</a:t>
+            </a:r>
+          </a:p>
+        </p:txBody>
+      </p:sp>
+      <p:sp>
+        <p:nvSpPr>
+          <p:cNvPr id="3" name="SUBTITLE">
+            <a:extLst>
+              <a:ext uri="{FF2B5EF4-FFF2-40B4-BE49-F238E27FC236}">
+                <a16:creationId xmlns:a16="http://schemas.microsoft.com/office/drawing/2014/main" id="{FD0B50DC-89BD-B712-2D74-34FB9D9D87A0}"/>
+              </a:ext>
+            </a:extLst>
+          </p:cNvPr>
+          <p:cNvSpPr txBox="1"/>
+          <p:nvPr/>
+        </p:nvSpPr>
+        <p:spPr>
+          <a:xfrm>
+            <a:off x="548640" y="987552"/>
+            <a:ext cx="10607040" cy="369332"/>
+          </a:xfrm>
+          <a:prstGeom prst="rect">
+            <a:avLst/>
+          </a:prstGeom>
+          <a:noFill/>
+        </p:spPr>
+        <p:txBody>
+          <a:bodyPr vert="horz" wrap="square" rtlCol="0">
+            <a:noAutofit/>
+          </a:bodyPr>
+          <a:lstStyle/>
+          <a:p>
+            <a:r>
+              <a:rPr lang="zh-CN" altLang="en-US" sz="1400">
+                <a:solidFill>
+                  <a:srgbClr val="66747C"/>
+                </a:solidFill>
+                <a:latin typeface="Microsoft YaHei" panose="020B0503020204020204" pitchFamily="34" charset="-122"/>
+                <a:ea typeface="Microsoft YaHei" panose="020B0503020204020204" pitchFamily="34" charset="-122"/>
+              </a:rPr>
+              <a:t>对象 </a:t>
+            </a:r>
+            <a:r>
+              <a:rPr lang="en-US" altLang="zh-CN" sz="1400">
+                <a:solidFill>
+                  <a:srgbClr val="66747C"/>
+                </a:solidFill>
+                <a:latin typeface="Microsoft YaHei" panose="020B0503020204020204" pitchFamily="34" charset="-122"/>
+                <a:ea typeface="Microsoft YaHei" panose="020B0503020204020204" pitchFamily="34" charset="-122"/>
+              </a:rPr>
+              <a:t>· </a:t>
+            </a:r>
+            <a:r>
+              <a:rPr lang="zh-CN" altLang="en-US" sz="1400">
+                <a:solidFill>
+                  <a:srgbClr val="66747C"/>
+                </a:solidFill>
+                <a:latin typeface="Microsoft YaHei" panose="020B0503020204020204" pitchFamily="34" charset="-122"/>
+                <a:ea typeface="Microsoft YaHei" panose="020B0503020204020204" pitchFamily="34" charset="-122"/>
+              </a:rPr>
+              <a:t>动作 </a:t>
+            </a:r>
+            <a:r>
+              <a:rPr lang="en-US" altLang="zh-CN" sz="1400">
+                <a:solidFill>
+                  <a:srgbClr val="66747C"/>
+                </a:solidFill>
+                <a:latin typeface="Microsoft YaHei" panose="020B0503020204020204" pitchFamily="34" charset="-122"/>
+                <a:ea typeface="Microsoft YaHei" panose="020B0503020204020204" pitchFamily="34" charset="-122"/>
+              </a:rPr>
+              <a:t>· </a:t>
+            </a:r>
+            <a:r>
+              <a:rPr lang="zh-CN" altLang="en-US" sz="1400">
+                <a:solidFill>
+                  <a:srgbClr val="66747C"/>
+                </a:solidFill>
+                <a:latin typeface="Microsoft YaHei" panose="020B0503020204020204" pitchFamily="34" charset="-122"/>
+                <a:ea typeface="Microsoft YaHei" panose="020B0503020204020204" pitchFamily="34" charset="-122"/>
+              </a:rPr>
+              <a:t>责任人 </a:t>
+            </a:r>
+            <a:r>
+              <a:rPr lang="en-US" altLang="zh-CN" sz="1400">
+                <a:solidFill>
+                  <a:srgbClr val="66747C"/>
+                </a:solidFill>
+                <a:latin typeface="Microsoft YaHei" panose="020B0503020204020204" pitchFamily="34" charset="-122"/>
+                <a:ea typeface="Microsoft YaHei" panose="020B0503020204020204" pitchFamily="34" charset="-122"/>
+              </a:rPr>
+              <a:t>· </a:t>
+            </a:r>
+            <a:r>
+              <a:rPr lang="zh-CN" altLang="en-US" sz="1400">
+                <a:solidFill>
+                  <a:srgbClr val="66747C"/>
+                </a:solidFill>
+                <a:latin typeface="Microsoft YaHei" panose="020B0503020204020204" pitchFamily="34" charset="-122"/>
+                <a:ea typeface="Microsoft YaHei" panose="020B0503020204020204" pitchFamily="34" charset="-122"/>
+              </a:rPr>
+              <a:t>节点 </a:t>
+            </a:r>
+            <a:r>
+              <a:rPr lang="en-US" altLang="zh-CN" sz="1400">
+                <a:solidFill>
+                  <a:srgbClr val="66747C"/>
+                </a:solidFill>
+                <a:latin typeface="Microsoft YaHei" panose="020B0503020204020204" pitchFamily="34" charset="-122"/>
+                <a:ea typeface="Microsoft YaHei" panose="020B0503020204020204" pitchFamily="34" charset="-122"/>
+              </a:rPr>
+              <a:t>· </a:t>
+            </a:r>
+            <a:r>
+              <a:rPr lang="zh-CN" altLang="en-US" sz="1400">
+                <a:solidFill>
+                  <a:srgbClr val="66747C"/>
+                </a:solidFill>
+                <a:latin typeface="Microsoft YaHei" panose="020B0503020204020204" pitchFamily="34" charset="-122"/>
+                <a:ea typeface="Microsoft YaHei" panose="020B0503020204020204" pitchFamily="34" charset="-122"/>
+              </a:rPr>
+              <a:t>指标</a:t>
+            </a:r>
+            <a:r>
+              <a:rPr lang="en-US" altLang="zh-CN" sz="1400">
+                <a:solidFill>
+                  <a:srgbClr val="66747C"/>
+                </a:solidFill>
+                <a:latin typeface="Microsoft YaHei" panose="020B0503020204020204" pitchFamily="34" charset="-122"/>
+                <a:ea typeface="Microsoft YaHei" panose="020B0503020204020204" pitchFamily="34" charset="-122"/>
+              </a:rPr>
+              <a:t>——</a:t>
+            </a:r>
+            <a:r>
+              <a:rPr lang="zh-CN" altLang="en-US" sz="1400">
+                <a:solidFill>
+                  <a:srgbClr val="66747C"/>
+                </a:solidFill>
+                <a:latin typeface="Microsoft YaHei" panose="020B0503020204020204" pitchFamily="34" charset="-122"/>
+                <a:ea typeface="Microsoft YaHei" panose="020B0503020204020204" pitchFamily="34" charset="-122"/>
+              </a:rPr>
+              <a:t>每项行动都要能检查</a:t>
+            </a:r>
+          </a:p>
+        </p:txBody>
+      </p:sp>
+      <p:sp>
+        <p:nvSpPr>
+          <p:cNvPr id="4" name="COL_OBJECT">
+            <a:extLst>
+              <a:ext uri="{FF2B5EF4-FFF2-40B4-BE49-F238E27FC236}">
+                <a16:creationId xmlns:a16="http://schemas.microsoft.com/office/drawing/2014/main" id="{83B3AA92-49F6-BA39-4B2D-AB10FD477E09}"/>
+              </a:ext>
+            </a:extLst>
+          </p:cNvPr>
+          <p:cNvSpPr txBox="1"/>
+          <p:nvPr/>
+        </p:nvSpPr>
+        <p:spPr>
+          <a:xfrm>
+            <a:off x="731520" y="1463040"/>
+            <a:ext cx="1737360" cy="369332"/>
+          </a:xfrm>
+          <a:prstGeom prst="rect">
+            <a:avLst/>
+          </a:prstGeom>
+          <a:noFill/>
+        </p:spPr>
+        <p:txBody>
+          <a:bodyPr vert="horz" wrap="square" rtlCol="0">
+            <a:noAutofit/>
+          </a:bodyPr>
+          <a:lstStyle/>
+          <a:p>
+            <a:r>
+              <a:rPr lang="zh-CN" altLang="en-US" sz="1300" b="1">
+                <a:solidFill>
+                  <a:srgbClr val="C61720"/>
+                </a:solidFill>
+                <a:latin typeface="Microsoft YaHei" panose="020B0503020204020204" pitchFamily="34" charset="-122"/>
+                <a:ea typeface="Microsoft YaHei" panose="020B0503020204020204" pitchFamily="34" charset="-122"/>
+              </a:rPr>
+              <a:t>对象</a:t>
+            </a:r>
+          </a:p>
+        </p:txBody>
+      </p:sp>
+      <p:sp>
+        <p:nvSpPr>
+          <p:cNvPr id="5" name="COL_ACTION">
+            <a:extLst>
+              <a:ext uri="{FF2B5EF4-FFF2-40B4-BE49-F238E27FC236}">
+                <a16:creationId xmlns:a16="http://schemas.microsoft.com/office/drawing/2014/main" id="{701EFBC3-E701-A1A0-EE55-03A76C47D22A}"/>
+              </a:ext>
+            </a:extLst>
+          </p:cNvPr>
+          <p:cNvSpPr txBox="1"/>
+          <p:nvPr/>
+        </p:nvSpPr>
+        <p:spPr>
+          <a:xfrm>
+            <a:off x="2606040" y="1463040"/>
+            <a:ext cx="3840480" cy="369332"/>
+          </a:xfrm>
+          <a:prstGeom prst="rect">
+            <a:avLst/>
+          </a:prstGeom>
+          <a:noFill/>
+        </p:spPr>
+        <p:txBody>
+          <a:bodyPr vert="horz" wrap="square" rtlCol="0">
+            <a:noAutofit/>
+          </a:bodyPr>
+          <a:lstStyle/>
+          <a:p>
+            <a:r>
+              <a:rPr lang="zh-CN" altLang="en-US" sz="1300" b="1">
+                <a:solidFill>
+                  <a:srgbClr val="C61720"/>
+                </a:solidFill>
+                <a:latin typeface="Microsoft YaHei" panose="020B0503020204020204" pitchFamily="34" charset="-122"/>
+                <a:ea typeface="Microsoft YaHei" panose="020B0503020204020204" pitchFamily="34" charset="-122"/>
+              </a:rPr>
+              <a:t>动作</a:t>
+            </a:r>
+          </a:p>
+        </p:txBody>
+      </p:sp>
+      <p:sp>
+        <p:nvSpPr>
+          <p:cNvPr id="6" name="COL_OWNER">
+            <a:extLst>
+              <a:ext uri="{FF2B5EF4-FFF2-40B4-BE49-F238E27FC236}">
+                <a16:creationId xmlns:a16="http://schemas.microsoft.com/office/drawing/2014/main" id="{96185530-8BEE-7E0B-6C83-6D64F613C653}"/>
+              </a:ext>
+            </a:extLst>
+          </p:cNvPr>
+          <p:cNvSpPr txBox="1"/>
+          <p:nvPr/>
+        </p:nvSpPr>
+        <p:spPr>
+          <a:xfrm>
+            <a:off x="6583680" y="1463040"/>
+            <a:ext cx="1554480" cy="369332"/>
+          </a:xfrm>
+          <a:prstGeom prst="rect">
+            <a:avLst/>
+          </a:prstGeom>
+          <a:noFill/>
+        </p:spPr>
+        <p:txBody>
+          <a:bodyPr vert="horz" wrap="square" rtlCol="0">
+            <a:noAutofit/>
+          </a:bodyPr>
+          <a:lstStyle/>
+          <a:p>
+            <a:r>
+              <a:rPr lang="zh-CN" altLang="en-US" sz="1300" b="1">
+                <a:solidFill>
+                  <a:srgbClr val="C61720"/>
+                </a:solidFill>
+                <a:latin typeface="Microsoft YaHei" panose="020B0503020204020204" pitchFamily="34" charset="-122"/>
+                <a:ea typeface="Microsoft YaHei" panose="020B0503020204020204" pitchFamily="34" charset="-122"/>
+              </a:rPr>
+              <a:t>责任人</a:t>
+            </a:r>
+          </a:p>
+        </p:txBody>
+      </p:sp>
+      <p:sp>
+        <p:nvSpPr>
+          <p:cNvPr id="7" name="COL_DATE">
+            <a:extLst>
+              <a:ext uri="{FF2B5EF4-FFF2-40B4-BE49-F238E27FC236}">
+                <a16:creationId xmlns:a16="http://schemas.microsoft.com/office/drawing/2014/main" id="{307A33D4-CF80-CF50-EA8A-BB37A5303229}"/>
+              </a:ext>
+            </a:extLst>
+          </p:cNvPr>
+          <p:cNvSpPr txBox="1"/>
+          <p:nvPr/>
+        </p:nvSpPr>
+        <p:spPr>
+          <a:xfrm>
+            <a:off x="8229600" y="1463040"/>
+            <a:ext cx="1554480" cy="369332"/>
+          </a:xfrm>
+          <a:prstGeom prst="rect">
+            <a:avLst/>
+          </a:prstGeom>
+          <a:noFill/>
+        </p:spPr>
+        <p:txBody>
+          <a:bodyPr vert="horz" wrap="square" rtlCol="0">
+            <a:noAutofit/>
+          </a:bodyPr>
+          <a:lstStyle/>
+          <a:p>
+            <a:r>
+              <a:rPr lang="zh-CN" altLang="en-US" sz="1300" b="1">
+                <a:solidFill>
+                  <a:srgbClr val="C61720"/>
+                </a:solidFill>
+                <a:latin typeface="Microsoft YaHei" panose="020B0503020204020204" pitchFamily="34" charset="-122"/>
+                <a:ea typeface="Microsoft YaHei" panose="020B0503020204020204" pitchFamily="34" charset="-122"/>
+              </a:rPr>
+              <a:t>节点</a:t>
+            </a:r>
+          </a:p>
+        </p:txBody>
+      </p:sp>
+      <p:sp>
+        <p:nvSpPr>
+          <p:cNvPr id="8" name="COL_METRIC">
+            <a:extLst>
+              <a:ext uri="{FF2B5EF4-FFF2-40B4-BE49-F238E27FC236}">
+                <a16:creationId xmlns:a16="http://schemas.microsoft.com/office/drawing/2014/main" id="{8A46E780-5ABD-BEA3-BE8B-950DF52B954C}"/>
+              </a:ext>
+            </a:extLst>
+          </p:cNvPr>
+          <p:cNvSpPr txBox="1"/>
+          <p:nvPr/>
+        </p:nvSpPr>
+        <p:spPr>
+          <a:xfrm>
+            <a:off x="9921240" y="1463040"/>
+            <a:ext cx="2011680" cy="369332"/>
+          </a:xfrm>
+          <a:prstGeom prst="rect">
+            <a:avLst/>
+          </a:prstGeom>
+          <a:noFill/>
+        </p:spPr>
+        <p:txBody>
+          <a:bodyPr vert="horz" wrap="square" rtlCol="0">
+            <a:noAutofit/>
+          </a:bodyPr>
+          <a:lstStyle/>
+          <a:p>
+            <a:r>
+              <a:rPr lang="zh-CN" altLang="en-US" sz="1300" b="1">
+                <a:solidFill>
+                  <a:srgbClr val="C61720"/>
+                </a:solidFill>
+                <a:latin typeface="Microsoft YaHei" panose="020B0503020204020204" pitchFamily="34" charset="-122"/>
+                <a:ea typeface="Microsoft YaHei" panose="020B0503020204020204" pitchFamily="34" charset="-122"/>
+              </a:rPr>
+              <a:t>指标</a:t>
+            </a:r>
+          </a:p>
+        </p:txBody>
+      </p:sp>
+      <p:sp>
+        <p:nvSpPr>
+          <p:cNvPr id="9" name="ROW_BAND_1">
+            <a:extLst>
+              <a:ext uri="{FF2B5EF4-FFF2-40B4-BE49-F238E27FC236}">
+                <a16:creationId xmlns:a16="http://schemas.microsoft.com/office/drawing/2014/main" id="{2E9F722F-0AD7-C93C-D78D-319BC4DBC193}"/>
+              </a:ext>
+            </a:extLst>
+          </p:cNvPr>
+          <p:cNvSpPr/>
+          <p:nvPr/>
+        </p:nvSpPr>
+        <p:spPr>
+          <a:xfrm>
+            <a:off x="594360" y="1965960"/>
+            <a:ext cx="11155680" cy="822960"/>
+          </a:xfrm>
+          <a:prstGeom prst="rect">
+            <a:avLst/>
+          </a:prstGeom>
+          <a:solidFill>
+            <a:srgbClr val="F0F1EF"/>
+          </a:solidFill>
+          <a:ln w="9525">
+            <a:solidFill>
+              <a:srgbClr val="66747C"/>
+            </a:solidFill>
+          </a:ln>
+        </p:spPr>
+        <p:style>
+          <a:lnRef idx="2">
+            <a:schemeClr val="accent1">
+              <a:shade val="15000"/>
+            </a:schemeClr>
+          </a:lnRef>
+          <a:fillRef idx="1">
+            <a:schemeClr val="accent1"/>
+          </a:fillRef>
+          <a:effectRef idx="0">
+            <a:schemeClr val="accent1"/>
+          </a:effectRef>
+          <a:fontRef idx="minor">
+            <a:schemeClr val="lt1"/>
+          </a:fontRef>
+        </p:style>
+        <p:txBody>
+          <a:bodyPr rtlCol="0" anchor="ctr"/>
+          <a:lstStyle/>
+          <a:p>
+            <a:pPr algn="ctr"/>
+            <a:endParaRPr lang="zh-CN" altLang="en-US"/>
+          </a:p>
+        </p:txBody>
+      </p:sp>
+      <p:sp>
+        <p:nvSpPr>
+          <p:cNvPr id="10" name="ACT_01_OBJECT">
+            <a:extLst>
+              <a:ext uri="{FF2B5EF4-FFF2-40B4-BE49-F238E27FC236}">
+                <a16:creationId xmlns:a16="http://schemas.microsoft.com/office/drawing/2014/main" id="{23049707-75D2-6904-74C7-8B534D4649FA}"/>
+              </a:ext>
+            </a:extLst>
+          </p:cNvPr>
+          <p:cNvSpPr txBox="1"/>
+          <p:nvPr/>
+        </p:nvSpPr>
+        <p:spPr>
+          <a:xfrm>
+            <a:off x="731520" y="2167128"/>
+            <a:ext cx="1737360" cy="369332"/>
+          </a:xfrm>
+          <a:prstGeom prst="rect">
+            <a:avLst/>
+          </a:prstGeom>
+          <a:noFill/>
+        </p:spPr>
+        <p:txBody>
+          <a:bodyPr vert="horz" wrap="square" rtlCol="0">
+            <a:noAutofit/>
+          </a:bodyPr>
+          <a:lstStyle/>
+          <a:p>
+            <a:r>
+              <a:rPr lang="en-US" altLang="zh-CN" sz="1300">
+                <a:solidFill>
+                  <a:srgbClr val="172A3A"/>
+                </a:solidFill>
+                <a:latin typeface="Microsoft YaHei" panose="020B0503020204020204" pitchFamily="34" charset="-122"/>
+                <a:ea typeface="Microsoft YaHei" panose="020B0503020204020204" pitchFamily="34" charset="-122"/>
+              </a:rPr>
+              <a:t>____</a:t>
+            </a:r>
+            <a:endParaRPr lang="zh-CN" altLang="en-US" sz="1300">
+              <a:solidFill>
+                <a:srgbClr val="172A3A"/>
+              </a:solidFill>
+              <a:latin typeface="Microsoft YaHei" panose="020B0503020204020204" pitchFamily="34" charset="-122"/>
+              <a:ea typeface="Microsoft YaHei" panose="020B0503020204020204" pitchFamily="34" charset="-122"/>
+            </a:endParaRPr>
+          </a:p>
+        </p:txBody>
+      </p:sp>
+      <p:sp>
+        <p:nvSpPr>
+          <p:cNvPr id="11" name="ACT_01_ACTION">
+            <a:extLst>
+              <a:ext uri="{FF2B5EF4-FFF2-40B4-BE49-F238E27FC236}">
+                <a16:creationId xmlns:a16="http://schemas.microsoft.com/office/drawing/2014/main" id="{B0DD80EF-B808-545A-70A5-D558A4390E39}"/>
+              </a:ext>
+            </a:extLst>
+          </p:cNvPr>
+          <p:cNvSpPr txBox="1"/>
+          <p:nvPr/>
+        </p:nvSpPr>
+        <p:spPr>
+          <a:xfrm>
+            <a:off x="2606040" y="2167128"/>
+            <a:ext cx="3840480" cy="369332"/>
+          </a:xfrm>
+          <a:prstGeom prst="rect">
+            <a:avLst/>
+          </a:prstGeom>
+          <a:noFill/>
+        </p:spPr>
+        <p:txBody>
+          <a:bodyPr vert="horz" wrap="square" rtlCol="0">
+            <a:noAutofit/>
+          </a:bodyPr>
+          <a:lstStyle/>
+          <a:p>
+            <a:r>
+              <a:rPr lang="en-US" altLang="zh-CN" sz="1300">
+                <a:solidFill>
+                  <a:srgbClr val="172A3A"/>
+                </a:solidFill>
+                <a:latin typeface="Microsoft YaHei" panose="020B0503020204020204" pitchFamily="34" charset="-122"/>
+                <a:ea typeface="Microsoft YaHei" panose="020B0503020204020204" pitchFamily="34" charset="-122"/>
+              </a:rPr>
+              <a:t>____</a:t>
+            </a:r>
+            <a:endParaRPr lang="zh-CN" altLang="en-US" sz="1300">
+              <a:solidFill>
+                <a:srgbClr val="172A3A"/>
+              </a:solidFill>
+              <a:latin typeface="Microsoft YaHei" panose="020B0503020204020204" pitchFamily="34" charset="-122"/>
+              <a:ea typeface="Microsoft YaHei" panose="020B0503020204020204" pitchFamily="34" charset="-122"/>
+            </a:endParaRPr>
+          </a:p>
+        </p:txBody>
+      </p:sp>
+      <p:sp>
+        <p:nvSpPr>
+          <p:cNvPr id="12" name="ACT_01_OWNER">
+            <a:extLst>
+              <a:ext uri="{FF2B5EF4-FFF2-40B4-BE49-F238E27FC236}">
+                <a16:creationId xmlns:a16="http://schemas.microsoft.com/office/drawing/2014/main" id="{7BB6BC82-0D29-C4DD-5848-F241776B9402}"/>
+              </a:ext>
+            </a:extLst>
+          </p:cNvPr>
+          <p:cNvSpPr txBox="1"/>
+          <p:nvPr/>
+        </p:nvSpPr>
+        <p:spPr>
+          <a:xfrm>
+            <a:off x="6583680" y="2167128"/>
+            <a:ext cx="1554480" cy="369332"/>
+          </a:xfrm>
+          <a:prstGeom prst="rect">
+            <a:avLst/>
+          </a:prstGeom>
+          <a:noFill/>
+        </p:spPr>
+        <p:txBody>
+          <a:bodyPr vert="horz" wrap="square" rtlCol="0">
+            <a:noAutofit/>
+          </a:bodyPr>
+          <a:lstStyle/>
+          <a:p>
+            <a:r>
+              <a:rPr lang="en-US" altLang="zh-CN" sz="1300">
+                <a:solidFill>
+                  <a:srgbClr val="172A3A"/>
+                </a:solidFill>
+                <a:latin typeface="Microsoft YaHei" panose="020B0503020204020204" pitchFamily="34" charset="-122"/>
+                <a:ea typeface="Microsoft YaHei" panose="020B0503020204020204" pitchFamily="34" charset="-122"/>
+              </a:rPr>
+              <a:t>____</a:t>
+            </a:r>
+            <a:endParaRPr lang="zh-CN" altLang="en-US" sz="1300">
+              <a:solidFill>
+                <a:srgbClr val="172A3A"/>
+              </a:solidFill>
+              <a:latin typeface="Microsoft YaHei" panose="020B0503020204020204" pitchFamily="34" charset="-122"/>
+              <a:ea typeface="Microsoft YaHei" panose="020B0503020204020204" pitchFamily="34" charset="-122"/>
+            </a:endParaRPr>
+          </a:p>
+        </p:txBody>
+      </p:sp>
+      <p:sp>
+        <p:nvSpPr>
+          <p:cNvPr id="13" name="ACT_01_DATE">
+            <a:extLst>
+              <a:ext uri="{FF2B5EF4-FFF2-40B4-BE49-F238E27FC236}">
+                <a16:creationId xmlns:a16="http://schemas.microsoft.com/office/drawing/2014/main" id="{F8DBB096-DB44-C664-2A40-DF8D09F9BC94}"/>
+              </a:ext>
+            </a:extLst>
+          </p:cNvPr>
+          <p:cNvSpPr txBox="1"/>
+          <p:nvPr/>
+        </p:nvSpPr>
+        <p:spPr>
+          <a:xfrm>
+            <a:off x="8229600" y="2167128"/>
+            <a:ext cx="1554480" cy="369332"/>
+          </a:xfrm>
+          <a:prstGeom prst="rect">
+            <a:avLst/>
+          </a:prstGeom>
+          <a:noFill/>
+        </p:spPr>
+        <p:txBody>
+          <a:bodyPr vert="horz" wrap="square" rtlCol="0">
+            <a:noAutofit/>
+          </a:bodyPr>
+          <a:lstStyle/>
+          <a:p>
+            <a:r>
+              <a:rPr lang="en-US" altLang="zh-CN" sz="1300">
+                <a:solidFill>
+                  <a:srgbClr val="172A3A"/>
+                </a:solidFill>
+                <a:latin typeface="Microsoft YaHei" panose="020B0503020204020204" pitchFamily="34" charset="-122"/>
+                <a:ea typeface="Microsoft YaHei" panose="020B0503020204020204" pitchFamily="34" charset="-122"/>
+              </a:rPr>
+              <a:t>____</a:t>
+            </a:r>
+            <a:endParaRPr lang="zh-CN" altLang="en-US" sz="1300">
+              <a:solidFill>
+                <a:srgbClr val="172A3A"/>
+              </a:solidFill>
+              <a:latin typeface="Microsoft YaHei" panose="020B0503020204020204" pitchFamily="34" charset="-122"/>
+              <a:ea typeface="Microsoft YaHei" panose="020B0503020204020204" pitchFamily="34" charset="-122"/>
+            </a:endParaRPr>
+          </a:p>
+        </p:txBody>
+      </p:sp>
+      <p:sp>
+        <p:nvSpPr>
+          <p:cNvPr id="14" name="ACT_01_METRIC">
+            <a:extLst>
+              <a:ext uri="{FF2B5EF4-FFF2-40B4-BE49-F238E27FC236}">
+                <a16:creationId xmlns:a16="http://schemas.microsoft.com/office/drawing/2014/main" id="{3895D914-22F0-24E2-1B79-9C48F57E4690}"/>
+              </a:ext>
+            </a:extLst>
+          </p:cNvPr>
+          <p:cNvSpPr txBox="1"/>
+          <p:nvPr/>
+        </p:nvSpPr>
+        <p:spPr>
+          <a:xfrm>
+            <a:off x="9921240" y="2167128"/>
+            <a:ext cx="2011680" cy="369332"/>
+          </a:xfrm>
+          <a:prstGeom prst="rect">
+            <a:avLst/>
+          </a:prstGeom>
+          <a:noFill/>
+        </p:spPr>
+        <p:txBody>
+          <a:bodyPr vert="horz" wrap="square" rtlCol="0">
+            <a:noAutofit/>
+          </a:bodyPr>
+          <a:lstStyle/>
+          <a:p>
+            <a:r>
+              <a:rPr lang="en-US" altLang="zh-CN" sz="1300">
+                <a:solidFill>
+                  <a:srgbClr val="172A3A"/>
+                </a:solidFill>
+                <a:latin typeface="Microsoft YaHei" panose="020B0503020204020204" pitchFamily="34" charset="-122"/>
+                <a:ea typeface="Microsoft YaHei" panose="020B0503020204020204" pitchFamily="34" charset="-122"/>
+              </a:rPr>
+              <a:t>____</a:t>
+            </a:r>
+            <a:endParaRPr lang="zh-CN" altLang="en-US" sz="1300">
+              <a:solidFill>
+                <a:srgbClr val="172A3A"/>
+              </a:solidFill>
+              <a:latin typeface="Microsoft YaHei" panose="020B0503020204020204" pitchFamily="34" charset="-122"/>
+              <a:ea typeface="Microsoft YaHei" panose="020B0503020204020204" pitchFamily="34" charset="-122"/>
+            </a:endParaRPr>
+          </a:p>
+        </p:txBody>
+      </p:sp>
+      <p:sp>
+        <p:nvSpPr>
+          <p:cNvPr id="15" name="ROW_BAND_2">
+            <a:extLst>
+              <a:ext uri="{FF2B5EF4-FFF2-40B4-BE49-F238E27FC236}">
+                <a16:creationId xmlns:a16="http://schemas.microsoft.com/office/drawing/2014/main" id="{A8A49739-37FD-C673-C2CD-31A6A39F2C2C}"/>
+              </a:ext>
+            </a:extLst>
+          </p:cNvPr>
+          <p:cNvSpPr/>
+          <p:nvPr/>
+        </p:nvSpPr>
+        <p:spPr>
+          <a:xfrm>
+            <a:off x="594360" y="2834640"/>
+            <a:ext cx="11155680" cy="822960"/>
+          </a:xfrm>
+          <a:prstGeom prst="rect">
+            <a:avLst/>
+          </a:prstGeom>
+          <a:solidFill>
+            <a:srgbClr val="F7E6E6"/>
+          </a:solidFill>
+          <a:ln w="9525">
+            <a:solidFill>
+              <a:srgbClr val="66747C"/>
+            </a:solidFill>
+          </a:ln>
+        </p:spPr>
+        <p:style>
+          <a:lnRef idx="2">
+            <a:schemeClr val="accent1">
+              <a:shade val="15000"/>
+            </a:schemeClr>
+          </a:lnRef>
+          <a:fillRef idx="1">
+            <a:schemeClr val="accent1"/>
+          </a:fillRef>
+          <a:effectRef idx="0">
+            <a:schemeClr val="accent1"/>
+          </a:effectRef>
+          <a:fontRef idx="minor">
+            <a:schemeClr val="lt1"/>
+          </a:fontRef>
+        </p:style>
+        <p:txBody>
+          <a:bodyPr rtlCol="0" anchor="ctr"/>
+          <a:lstStyle/>
+          <a:p>
+            <a:pPr algn="ctr"/>
+            <a:endParaRPr lang="zh-CN" altLang="en-US"/>
+          </a:p>
+        </p:txBody>
+      </p:sp>
+      <p:sp>
+        <p:nvSpPr>
+          <p:cNvPr id="16" name="ACT_02_OBJECT">
+            <a:extLst>
+              <a:ext uri="{FF2B5EF4-FFF2-40B4-BE49-F238E27FC236}">
+                <a16:creationId xmlns:a16="http://schemas.microsoft.com/office/drawing/2014/main" id="{8E6614A7-B3FC-976A-E99B-52E80219C6AC}"/>
+              </a:ext>
+            </a:extLst>
+          </p:cNvPr>
+          <p:cNvSpPr txBox="1"/>
+          <p:nvPr/>
+        </p:nvSpPr>
+        <p:spPr>
+          <a:xfrm>
+            <a:off x="731520" y="3035808"/>
+            <a:ext cx="1737360" cy="369332"/>
+          </a:xfrm>
+          <a:prstGeom prst="rect">
+            <a:avLst/>
+          </a:prstGeom>
+          <a:noFill/>
+        </p:spPr>
+        <p:txBody>
+          <a:bodyPr vert="horz" wrap="square" rtlCol="0">
+            <a:noAutofit/>
+          </a:bodyPr>
+          <a:lstStyle/>
+          <a:p>
+            <a:r>
+              <a:rPr lang="en-US" altLang="zh-CN" sz="1300">
+                <a:solidFill>
+                  <a:srgbClr val="172A3A"/>
+                </a:solidFill>
+                <a:latin typeface="Microsoft YaHei" panose="020B0503020204020204" pitchFamily="34" charset="-122"/>
+                <a:ea typeface="Microsoft YaHei" panose="020B0503020204020204" pitchFamily="34" charset="-122"/>
+              </a:rPr>
+              <a:t>____</a:t>
+            </a:r>
+            <a:endParaRPr lang="zh-CN" altLang="en-US" sz="1300">
+              <a:solidFill>
+                <a:srgbClr val="172A3A"/>
+              </a:solidFill>
+              <a:latin typeface="Microsoft YaHei" panose="020B0503020204020204" pitchFamily="34" charset="-122"/>
+              <a:ea typeface="Microsoft YaHei" panose="020B0503020204020204" pitchFamily="34" charset="-122"/>
+            </a:endParaRPr>
+          </a:p>
+        </p:txBody>
+      </p:sp>
+      <p:sp>
+        <p:nvSpPr>
+          <p:cNvPr id="17" name="ACT_02_ACTION">
+            <a:extLst>
+              <a:ext uri="{FF2B5EF4-FFF2-40B4-BE49-F238E27FC236}">
+                <a16:creationId xmlns:a16="http://schemas.microsoft.com/office/drawing/2014/main" id="{7919B6F1-6E34-D4DC-773D-299B298078B7}"/>
+              </a:ext>
+            </a:extLst>
+          </p:cNvPr>
+          <p:cNvSpPr txBox="1"/>
+          <p:nvPr/>
+        </p:nvSpPr>
+        <p:spPr>
+          <a:xfrm>
+            <a:off x="2606040" y="3035808"/>
+            <a:ext cx="3840480" cy="369332"/>
+          </a:xfrm>
+          <a:prstGeom prst="rect">
+            <a:avLst/>
+          </a:prstGeom>
+          <a:noFill/>
+        </p:spPr>
+        <p:txBody>
+          <a:bodyPr vert="horz" wrap="square" rtlCol="0">
+            <a:noAutofit/>
+          </a:bodyPr>
+          <a:lstStyle/>
+          <a:p>
+            <a:r>
+              <a:rPr lang="en-US" altLang="zh-CN" sz="1300">
+                <a:solidFill>
+                  <a:srgbClr val="172A3A"/>
+                </a:solidFill>
+                <a:latin typeface="Microsoft YaHei" panose="020B0503020204020204" pitchFamily="34" charset="-122"/>
+                <a:ea typeface="Microsoft YaHei" panose="020B0503020204020204" pitchFamily="34" charset="-122"/>
+              </a:rPr>
+              <a:t>____</a:t>
+            </a:r>
+            <a:endParaRPr lang="zh-CN" altLang="en-US" sz="1300">
+              <a:solidFill>
+                <a:srgbClr val="172A3A"/>
+              </a:solidFill>
+              <a:latin typeface="Microsoft YaHei" panose="020B0503020204020204" pitchFamily="34" charset="-122"/>
+              <a:ea typeface="Microsoft YaHei" panose="020B0503020204020204" pitchFamily="34" charset="-122"/>
+            </a:endParaRPr>
+          </a:p>
+        </p:txBody>
+      </p:sp>
+      <p:sp>
+        <p:nvSpPr>
+          <p:cNvPr id="18" name="ACT_02_OWNER">
+            <a:extLst>
+              <a:ext uri="{FF2B5EF4-FFF2-40B4-BE49-F238E27FC236}">
+                <a16:creationId xmlns:a16="http://schemas.microsoft.com/office/drawing/2014/main" id="{955BE149-8750-C4C9-C3E3-1869F2079AAF}"/>
+              </a:ext>
+            </a:extLst>
+          </p:cNvPr>
+          <p:cNvSpPr txBox="1"/>
+          <p:nvPr/>
+        </p:nvSpPr>
+        <p:spPr>
+          <a:xfrm>
+            <a:off x="6583680" y="3035808"/>
+            <a:ext cx="1554480" cy="369332"/>
+          </a:xfrm>
+          <a:prstGeom prst="rect">
+            <a:avLst/>
+          </a:prstGeom>
+          <a:noFill/>
+        </p:spPr>
+        <p:txBody>
+          <a:bodyPr vert="horz" wrap="square" rtlCol="0">
+            <a:noAutofit/>
+          </a:bodyPr>
+          <a:lstStyle/>
+          <a:p>
+            <a:r>
+              <a:rPr lang="en-US" altLang="zh-CN" sz="1300">
+                <a:solidFill>
+                  <a:srgbClr val="172A3A"/>
+                </a:solidFill>
+                <a:latin typeface="Microsoft YaHei" panose="020B0503020204020204" pitchFamily="34" charset="-122"/>
+                <a:ea typeface="Microsoft YaHei" panose="020B0503020204020204" pitchFamily="34" charset="-122"/>
+              </a:rPr>
+              <a:t>____</a:t>
+            </a:r>
+            <a:endParaRPr lang="zh-CN" altLang="en-US" sz="1300">
+              <a:solidFill>
+                <a:srgbClr val="172A3A"/>
+              </a:solidFill>
+              <a:latin typeface="Microsoft YaHei" panose="020B0503020204020204" pitchFamily="34" charset="-122"/>
+              <a:ea typeface="Microsoft YaHei" panose="020B0503020204020204" pitchFamily="34" charset="-122"/>
+            </a:endParaRPr>
+          </a:p>
+        </p:txBody>
+      </p:sp>
+      <p:sp>
+        <p:nvSpPr>
+          <p:cNvPr id="19" name="ACT_02_DATE">
+            <a:extLst>
+              <a:ext uri="{FF2B5EF4-FFF2-40B4-BE49-F238E27FC236}">
+                <a16:creationId xmlns:a16="http://schemas.microsoft.com/office/drawing/2014/main" id="{4CF664D0-9DD8-2345-0803-62F8E661444E}"/>
+              </a:ext>
+            </a:extLst>
+          </p:cNvPr>
+          <p:cNvSpPr txBox="1"/>
+          <p:nvPr/>
+        </p:nvSpPr>
+        <p:spPr>
+          <a:xfrm>
+            <a:off x="8229600" y="3035808"/>
+            <a:ext cx="1554480" cy="369332"/>
+          </a:xfrm>
+          <a:prstGeom prst="rect">
+            <a:avLst/>
+          </a:prstGeom>
+          <a:noFill/>
+        </p:spPr>
+        <p:txBody>
+          <a:bodyPr vert="horz" wrap="square" rtlCol="0">
+            <a:noAutofit/>
+          </a:bodyPr>
+          <a:lstStyle/>
+          <a:p>
+            <a:r>
+              <a:rPr lang="en-US" altLang="zh-CN" sz="1300">
+                <a:solidFill>
+                  <a:srgbClr val="172A3A"/>
+                </a:solidFill>
+                <a:latin typeface="Microsoft YaHei" panose="020B0503020204020204" pitchFamily="34" charset="-122"/>
+                <a:ea typeface="Microsoft YaHei" panose="020B0503020204020204" pitchFamily="34" charset="-122"/>
+              </a:rPr>
+              <a:t>____</a:t>
+            </a:r>
+            <a:endParaRPr lang="zh-CN" altLang="en-US" sz="1300">
+              <a:solidFill>
+                <a:srgbClr val="172A3A"/>
+              </a:solidFill>
+              <a:latin typeface="Microsoft YaHei" panose="020B0503020204020204" pitchFamily="34" charset="-122"/>
+              <a:ea typeface="Microsoft YaHei" panose="020B0503020204020204" pitchFamily="34" charset="-122"/>
+            </a:endParaRPr>
+          </a:p>
+        </p:txBody>
+      </p:sp>
+      <p:sp>
+        <p:nvSpPr>
+          <p:cNvPr id="20" name="ACT_02_METRIC">
+            <a:extLst>
+              <a:ext uri="{FF2B5EF4-FFF2-40B4-BE49-F238E27FC236}">
+                <a16:creationId xmlns:a16="http://schemas.microsoft.com/office/drawing/2014/main" id="{DE7D4B0C-725D-41C9-7072-A980A42C9258}"/>
+              </a:ext>
+            </a:extLst>
+          </p:cNvPr>
+          <p:cNvSpPr txBox="1"/>
+          <p:nvPr/>
+        </p:nvSpPr>
+        <p:spPr>
+          <a:xfrm>
+            <a:off x="9921240" y="3035808"/>
+            <a:ext cx="2011680" cy="369332"/>
+          </a:xfrm>
+          <a:prstGeom prst="rect">
+            <a:avLst/>
+          </a:prstGeom>
+          <a:noFill/>
+        </p:spPr>
+        <p:txBody>
+          <a:bodyPr vert="horz" wrap="square" rtlCol="0">
+            <a:noAutofit/>
+          </a:bodyPr>
+          <a:lstStyle/>
+          <a:p>
+            <a:r>
+              <a:rPr lang="en-US" altLang="zh-CN" sz="1300">
+                <a:solidFill>
+                  <a:srgbClr val="172A3A"/>
+                </a:solidFill>
+                <a:latin typeface="Microsoft YaHei" panose="020B0503020204020204" pitchFamily="34" charset="-122"/>
+                <a:ea typeface="Microsoft YaHei" panose="020B0503020204020204" pitchFamily="34" charset="-122"/>
+              </a:rPr>
+              <a:t>____</a:t>
+            </a:r>
+            <a:endParaRPr lang="zh-CN" altLang="en-US" sz="1300">
+              <a:solidFill>
+                <a:srgbClr val="172A3A"/>
+              </a:solidFill>
+              <a:latin typeface="Microsoft YaHei" panose="020B0503020204020204" pitchFamily="34" charset="-122"/>
+              <a:ea typeface="Microsoft YaHei" panose="020B0503020204020204" pitchFamily="34" charset="-122"/>
+            </a:endParaRPr>
+          </a:p>
+        </p:txBody>
+      </p:sp>
+      <p:sp>
+        <p:nvSpPr>
+          <p:cNvPr id="21" name="ROW_BAND_3">
+            <a:extLst>
+              <a:ext uri="{FF2B5EF4-FFF2-40B4-BE49-F238E27FC236}">
+                <a16:creationId xmlns:a16="http://schemas.microsoft.com/office/drawing/2014/main" id="{5AB1DE9A-ACF2-CAF1-C9B5-A10BCD12F88E}"/>
+              </a:ext>
+            </a:extLst>
+          </p:cNvPr>
+          <p:cNvSpPr/>
+          <p:nvPr/>
+        </p:nvSpPr>
+        <p:spPr>
+          <a:xfrm>
+            <a:off x="594360" y="3703320"/>
+            <a:ext cx="11155680" cy="822960"/>
+          </a:xfrm>
+          <a:prstGeom prst="rect">
+            <a:avLst/>
+          </a:prstGeom>
+          <a:solidFill>
+            <a:srgbClr val="F0F1EF"/>
+          </a:solidFill>
+          <a:ln w="9525">
+            <a:solidFill>
+              <a:srgbClr val="66747C"/>
+            </a:solidFill>
+          </a:ln>
+        </p:spPr>
+        <p:style>
+          <a:lnRef idx="2">
+            <a:schemeClr val="accent1">
+              <a:shade val="15000"/>
+            </a:schemeClr>
+          </a:lnRef>
+          <a:fillRef idx="1">
+            <a:schemeClr val="accent1"/>
+          </a:fillRef>
+          <a:effectRef idx="0">
+            <a:schemeClr val="accent1"/>
+          </a:effectRef>
+          <a:fontRef idx="minor">
+            <a:schemeClr val="lt1"/>
+          </a:fontRef>
+        </p:style>
+        <p:txBody>
+          <a:bodyPr rtlCol="0" anchor="ctr"/>
+          <a:lstStyle/>
+          <a:p>
+            <a:pPr algn="ctr"/>
+            <a:endParaRPr lang="zh-CN" altLang="en-US"/>
+          </a:p>
+        </p:txBody>
+      </p:sp>
+      <p:sp>
+        <p:nvSpPr>
+          <p:cNvPr id="22" name="ACT_03_OBJECT">
+            <a:extLst>
+              <a:ext uri="{FF2B5EF4-FFF2-40B4-BE49-F238E27FC236}">
+                <a16:creationId xmlns:a16="http://schemas.microsoft.com/office/drawing/2014/main" id="{C0739392-A6A3-7C2A-B977-006B43CA94B5}"/>
+              </a:ext>
+            </a:extLst>
+          </p:cNvPr>
+          <p:cNvSpPr txBox="1"/>
+          <p:nvPr/>
+        </p:nvSpPr>
+        <p:spPr>
+          <a:xfrm>
+            <a:off x="731520" y="3904488"/>
+            <a:ext cx="1737360" cy="369332"/>
+          </a:xfrm>
+          <a:prstGeom prst="rect">
+            <a:avLst/>
+          </a:prstGeom>
+          <a:noFill/>
+        </p:spPr>
+        <p:txBody>
+          <a:bodyPr vert="horz" wrap="square" rtlCol="0">
+            <a:noAutofit/>
+          </a:bodyPr>
+          <a:lstStyle/>
+          <a:p>
+            <a:r>
+              <a:rPr lang="en-US" altLang="zh-CN" sz="1300">
+                <a:solidFill>
+                  <a:srgbClr val="172A3A"/>
+                </a:solidFill>
+                <a:latin typeface="Microsoft YaHei" panose="020B0503020204020204" pitchFamily="34" charset="-122"/>
+                <a:ea typeface="Microsoft YaHei" panose="020B0503020204020204" pitchFamily="34" charset="-122"/>
+              </a:rPr>
+              <a:t>____</a:t>
+            </a:r>
+            <a:endParaRPr lang="zh-CN" altLang="en-US" sz="1300">
+              <a:solidFill>
+                <a:srgbClr val="172A3A"/>
+              </a:solidFill>
+              <a:latin typeface="Microsoft YaHei" panose="020B0503020204020204" pitchFamily="34" charset="-122"/>
+              <a:ea typeface="Microsoft YaHei" panose="020B0503020204020204" pitchFamily="34" charset="-122"/>
+            </a:endParaRPr>
+          </a:p>
+        </p:txBody>
+      </p:sp>
+      <p:sp>
+        <p:nvSpPr>
+          <p:cNvPr id="23" name="ACT_03_ACTION">
+            <a:extLst>
+              <a:ext uri="{FF2B5EF4-FFF2-40B4-BE49-F238E27FC236}">
+                <a16:creationId xmlns:a16="http://schemas.microsoft.com/office/drawing/2014/main" id="{19E4104F-62EB-BC13-756C-21A7D3BCCD65}"/>
+              </a:ext>
+            </a:extLst>
+          </p:cNvPr>
+          <p:cNvSpPr txBox="1"/>
+          <p:nvPr/>
+        </p:nvSpPr>
+        <p:spPr>
+          <a:xfrm>
+            <a:off x="2606040" y="3904488"/>
+            <a:ext cx="3840480" cy="369332"/>
+          </a:xfrm>
+          <a:prstGeom prst="rect">
+            <a:avLst/>
+          </a:prstGeom>
+          <a:noFill/>
+        </p:spPr>
+        <p:txBody>
+          <a:bodyPr vert="horz" wrap="square" rtlCol="0">
+            <a:noAutofit/>
+          </a:bodyPr>
+          <a:lstStyle/>
+          <a:p>
+            <a:r>
+              <a:rPr lang="en-US" altLang="zh-CN" sz="1300">
+                <a:solidFill>
+                  <a:srgbClr val="172A3A"/>
+                </a:solidFill>
+                <a:latin typeface="Microsoft YaHei" panose="020B0503020204020204" pitchFamily="34" charset="-122"/>
+                <a:ea typeface="Microsoft YaHei" panose="020B0503020204020204" pitchFamily="34" charset="-122"/>
+              </a:rPr>
+              <a:t>____</a:t>
+            </a:r>
+            <a:endParaRPr lang="zh-CN" altLang="en-US" sz="1300">
+              <a:solidFill>
+                <a:srgbClr val="172A3A"/>
+              </a:solidFill>
+              <a:latin typeface="Microsoft YaHei" panose="020B0503020204020204" pitchFamily="34" charset="-122"/>
+              <a:ea typeface="Microsoft YaHei" panose="020B0503020204020204" pitchFamily="34" charset="-122"/>
+            </a:endParaRPr>
+          </a:p>
+        </p:txBody>
+      </p:sp>
+      <p:sp>
+        <p:nvSpPr>
+          <p:cNvPr id="24" name="ACT_03_OWNER">
+            <a:extLst>
+              <a:ext uri="{FF2B5EF4-FFF2-40B4-BE49-F238E27FC236}">
+                <a16:creationId xmlns:a16="http://schemas.microsoft.com/office/drawing/2014/main" id="{0518CA2B-93CE-A458-FF90-898AABA98595}"/>
+              </a:ext>
+            </a:extLst>
+          </p:cNvPr>
+          <p:cNvSpPr txBox="1"/>
+          <p:nvPr/>
+        </p:nvSpPr>
+        <p:spPr>
+          <a:xfrm>
+            <a:off x="6583680" y="3904488"/>
+            <a:ext cx="1554480" cy="369332"/>
+          </a:xfrm>
+          <a:prstGeom prst="rect">
+            <a:avLst/>
+          </a:prstGeom>
+          <a:noFill/>
+        </p:spPr>
+        <p:txBody>
+          <a:bodyPr vert="horz" wrap="square" rtlCol="0">
+            <a:noAutofit/>
+          </a:bodyPr>
+          <a:lstStyle/>
+          <a:p>
+            <a:r>
+              <a:rPr lang="en-US" altLang="zh-CN" sz="1300">
+                <a:solidFill>
+                  <a:srgbClr val="172A3A"/>
+                </a:solidFill>
+                <a:latin typeface="Microsoft YaHei" panose="020B0503020204020204" pitchFamily="34" charset="-122"/>
+                <a:ea typeface="Microsoft YaHei" panose="020B0503020204020204" pitchFamily="34" charset="-122"/>
+              </a:rPr>
+              <a:t>____</a:t>
+            </a:r>
+            <a:endParaRPr lang="zh-CN" altLang="en-US" sz="1300">
+              <a:solidFill>
+                <a:srgbClr val="172A3A"/>
+              </a:solidFill>
+              <a:latin typeface="Microsoft YaHei" panose="020B0503020204020204" pitchFamily="34" charset="-122"/>
+              <a:ea typeface="Microsoft YaHei" panose="020B0503020204020204" pitchFamily="34" charset="-122"/>
+            </a:endParaRPr>
+          </a:p>
+        </p:txBody>
+      </p:sp>
+      <p:sp>
+        <p:nvSpPr>
+          <p:cNvPr id="25" name="ACT_03_DATE">
+            <a:extLst>
+              <a:ext uri="{FF2B5EF4-FFF2-40B4-BE49-F238E27FC236}">
+                <a16:creationId xmlns:a16="http://schemas.microsoft.com/office/drawing/2014/main" id="{680635C2-C852-4268-9158-476B1365D8A7}"/>
+              </a:ext>
+            </a:extLst>
+          </p:cNvPr>
+          <p:cNvSpPr txBox="1"/>
+          <p:nvPr/>
+        </p:nvSpPr>
+        <p:spPr>
+          <a:xfrm>
+            <a:off x="8229600" y="3904488"/>
+            <a:ext cx="1554480" cy="369332"/>
+          </a:xfrm>
+          <a:prstGeom prst="rect">
+            <a:avLst/>
+          </a:prstGeom>
+          <a:noFill/>
+        </p:spPr>
+        <p:txBody>
+          <a:bodyPr vert="horz" wrap="square" rtlCol="0">
+            <a:noAutofit/>
+          </a:bodyPr>
+          <a:lstStyle/>
+          <a:p>
+            <a:r>
+              <a:rPr lang="en-US" altLang="zh-CN" sz="1300">
+                <a:solidFill>
+                  <a:srgbClr val="172A3A"/>
+                </a:solidFill>
+                <a:latin typeface="Microsoft YaHei" panose="020B0503020204020204" pitchFamily="34" charset="-122"/>
+                <a:ea typeface="Microsoft YaHei" panose="020B0503020204020204" pitchFamily="34" charset="-122"/>
+              </a:rPr>
+              <a:t>____</a:t>
+            </a:r>
+            <a:endParaRPr lang="zh-CN" altLang="en-US" sz="1300">
+              <a:solidFill>
+                <a:srgbClr val="172A3A"/>
+              </a:solidFill>
+              <a:latin typeface="Microsoft YaHei" panose="020B0503020204020204" pitchFamily="34" charset="-122"/>
+              <a:ea typeface="Microsoft YaHei" panose="020B0503020204020204" pitchFamily="34" charset="-122"/>
+            </a:endParaRPr>
+          </a:p>
+        </p:txBody>
+      </p:sp>
+      <p:sp>
+        <p:nvSpPr>
+          <p:cNvPr id="26" name="ACT_03_METRIC">
+            <a:extLst>
+              <a:ext uri="{FF2B5EF4-FFF2-40B4-BE49-F238E27FC236}">
+                <a16:creationId xmlns:a16="http://schemas.microsoft.com/office/drawing/2014/main" id="{E870A316-96BC-DA7A-6CFC-0307EB96123F}"/>
+              </a:ext>
+            </a:extLst>
+          </p:cNvPr>
+          <p:cNvSpPr txBox="1"/>
+          <p:nvPr/>
+        </p:nvSpPr>
+        <p:spPr>
+          <a:xfrm>
+            <a:off x="9921240" y="3904488"/>
+            <a:ext cx="2011680" cy="369332"/>
+          </a:xfrm>
+          <a:prstGeom prst="rect">
+            <a:avLst/>
+          </a:prstGeom>
+          <a:noFill/>
+        </p:spPr>
+        <p:txBody>
+          <a:bodyPr vert="horz" wrap="square" rtlCol="0">
+            <a:noAutofit/>
+          </a:bodyPr>
+          <a:lstStyle/>
+          <a:p>
+            <a:r>
+              <a:rPr lang="en-US" altLang="zh-CN" sz="1300">
+                <a:solidFill>
+                  <a:srgbClr val="172A3A"/>
+                </a:solidFill>
+                <a:latin typeface="Microsoft YaHei" panose="020B0503020204020204" pitchFamily="34" charset="-122"/>
+                <a:ea typeface="Microsoft YaHei" panose="020B0503020204020204" pitchFamily="34" charset="-122"/>
+              </a:rPr>
+              <a:t>____</a:t>
+            </a:r>
+            <a:endParaRPr lang="zh-CN" altLang="en-US" sz="1300">
+              <a:solidFill>
+                <a:srgbClr val="172A3A"/>
+              </a:solidFill>
+              <a:latin typeface="Microsoft YaHei" panose="020B0503020204020204" pitchFamily="34" charset="-122"/>
+              <a:ea typeface="Microsoft YaHei" panose="020B0503020204020204" pitchFamily="34" charset="-122"/>
+            </a:endParaRPr>
+          </a:p>
+        </p:txBody>
+      </p:sp>
+      <p:sp>
+        <p:nvSpPr>
+          <p:cNvPr id="27" name="ROW_BAND_4">
+            <a:extLst>
+              <a:ext uri="{FF2B5EF4-FFF2-40B4-BE49-F238E27FC236}">
+                <a16:creationId xmlns:a16="http://schemas.microsoft.com/office/drawing/2014/main" id="{9ABC7208-5992-CD0E-6BF1-AFA849EAC77A}"/>
+              </a:ext>
+            </a:extLst>
+          </p:cNvPr>
+          <p:cNvSpPr/>
+          <p:nvPr/>
+        </p:nvSpPr>
+        <p:spPr>
+          <a:xfrm>
+            <a:off x="594360" y="4572000"/>
+            <a:ext cx="11155680" cy="822960"/>
+          </a:xfrm>
+          <a:prstGeom prst="rect">
+            <a:avLst/>
+          </a:prstGeom>
+          <a:solidFill>
+            <a:srgbClr val="F7E6E6"/>
+          </a:solidFill>
+          <a:ln w="9525">
+            <a:solidFill>
+              <a:srgbClr val="66747C"/>
+            </a:solidFill>
+          </a:ln>
+        </p:spPr>
+        <p:style>
+          <a:lnRef idx="2">
+            <a:schemeClr val="accent1">
+              <a:shade val="15000"/>
+            </a:schemeClr>
+          </a:lnRef>
+          <a:fillRef idx="1">
+            <a:schemeClr val="accent1"/>
+          </a:fillRef>
+          <a:effectRef idx="0">
+            <a:schemeClr val="accent1"/>
+          </a:effectRef>
+          <a:fontRef idx="minor">
+            <a:schemeClr val="lt1"/>
+          </a:fontRef>
+        </p:style>
+        <p:txBody>
+          <a:bodyPr rtlCol="0" anchor="ctr"/>
+          <a:lstStyle/>
+          <a:p>
+            <a:pPr algn="ctr"/>
+            <a:endParaRPr lang="zh-CN" altLang="en-US"/>
+          </a:p>
+        </p:txBody>
+      </p:sp>
+      <p:sp>
+        <p:nvSpPr>
+          <p:cNvPr id="28" name="ACT_04_OBJECT">
+            <a:extLst>
+              <a:ext uri="{FF2B5EF4-FFF2-40B4-BE49-F238E27FC236}">
+                <a16:creationId xmlns:a16="http://schemas.microsoft.com/office/drawing/2014/main" id="{C6C1D7FE-C4EE-81F2-02D2-B37629AC0CA0}"/>
+              </a:ext>
+            </a:extLst>
+          </p:cNvPr>
+          <p:cNvSpPr txBox="1"/>
+          <p:nvPr/>
+        </p:nvSpPr>
+        <p:spPr>
+          <a:xfrm>
+            <a:off x="731520" y="4773168"/>
+            <a:ext cx="1737360" cy="369332"/>
+          </a:xfrm>
+          <a:prstGeom prst="rect">
+            <a:avLst/>
+          </a:prstGeom>
+          <a:noFill/>
+        </p:spPr>
+        <p:txBody>
+          <a:bodyPr vert="horz" wrap="square" rtlCol="0">
+            <a:noAutofit/>
+          </a:bodyPr>
+          <a:lstStyle/>
+          <a:p>
+            <a:r>
+              <a:rPr lang="en-US" altLang="zh-CN" sz="1300">
+                <a:solidFill>
+                  <a:srgbClr val="172A3A"/>
+                </a:solidFill>
+                <a:latin typeface="Microsoft YaHei" panose="020B0503020204020204" pitchFamily="34" charset="-122"/>
+                <a:ea typeface="Microsoft YaHei" panose="020B0503020204020204" pitchFamily="34" charset="-122"/>
+              </a:rPr>
+              <a:t>____</a:t>
+            </a:r>
+            <a:endParaRPr lang="zh-CN" altLang="en-US" sz="1300">
+              <a:solidFill>
+                <a:srgbClr val="172A3A"/>
+              </a:solidFill>
+              <a:latin typeface="Microsoft YaHei" panose="020B0503020204020204" pitchFamily="34" charset="-122"/>
+              <a:ea typeface="Microsoft YaHei" panose="020B0503020204020204" pitchFamily="34" charset="-122"/>
+            </a:endParaRPr>
+          </a:p>
+        </p:txBody>
+      </p:sp>
+      <p:sp>
+        <p:nvSpPr>
+          <p:cNvPr id="29" name="ACT_04_ACTION">
+            <a:extLst>
+              <a:ext uri="{FF2B5EF4-FFF2-40B4-BE49-F238E27FC236}">
+                <a16:creationId xmlns:a16="http://schemas.microsoft.com/office/drawing/2014/main" id="{53A36BB2-06CD-751C-12CC-413C419861FE}"/>
+              </a:ext>
+            </a:extLst>
+          </p:cNvPr>
+          <p:cNvSpPr txBox="1"/>
+          <p:nvPr/>
+        </p:nvSpPr>
+        <p:spPr>
+          <a:xfrm>
+            <a:off x="2606040" y="4773168"/>
+            <a:ext cx="3840480" cy="369332"/>
+          </a:xfrm>
+          <a:prstGeom prst="rect">
+            <a:avLst/>
+          </a:prstGeom>
+          <a:noFill/>
+        </p:spPr>
+        <p:txBody>
+          <a:bodyPr vert="horz" wrap="square" rtlCol="0">
+            <a:noAutofit/>
+          </a:bodyPr>
+          <a:lstStyle/>
+          <a:p>
+            <a:r>
+              <a:rPr lang="en-US" altLang="zh-CN" sz="1300">
+                <a:solidFill>
+                  <a:srgbClr val="172A3A"/>
+                </a:solidFill>
+                <a:latin typeface="Microsoft YaHei" panose="020B0503020204020204" pitchFamily="34" charset="-122"/>
+                <a:ea typeface="Microsoft YaHei" panose="020B0503020204020204" pitchFamily="34" charset="-122"/>
+              </a:rPr>
+              <a:t>____</a:t>
+            </a:r>
+            <a:endParaRPr lang="zh-CN" altLang="en-US" sz="1300">
+              <a:solidFill>
+                <a:srgbClr val="172A3A"/>
+              </a:solidFill>
+              <a:latin typeface="Microsoft YaHei" panose="020B0503020204020204" pitchFamily="34" charset="-122"/>
+              <a:ea typeface="Microsoft YaHei" panose="020B0503020204020204" pitchFamily="34" charset="-122"/>
+            </a:endParaRPr>
+          </a:p>
+        </p:txBody>
+      </p:sp>
+      <p:sp>
+        <p:nvSpPr>
+          <p:cNvPr id="30" name="ACT_04_OWNER">
+            <a:extLst>
+              <a:ext uri="{FF2B5EF4-FFF2-40B4-BE49-F238E27FC236}">
+                <a16:creationId xmlns:a16="http://schemas.microsoft.com/office/drawing/2014/main" id="{D2D885C9-1138-7797-4175-D9EA483C33EA}"/>
+              </a:ext>
+            </a:extLst>
+          </p:cNvPr>
+          <p:cNvSpPr txBox="1"/>
+          <p:nvPr/>
+        </p:nvSpPr>
+        <p:spPr>
+          <a:xfrm>
+            <a:off x="6583680" y="4773168"/>
+            <a:ext cx="1554480" cy="369332"/>
+          </a:xfrm>
+          <a:prstGeom prst="rect">
+            <a:avLst/>
+          </a:prstGeom>
+          <a:noFill/>
+        </p:spPr>
+        <p:txBody>
+          <a:bodyPr vert="horz" wrap="square" rtlCol="0">
+            <a:noAutofit/>
+          </a:bodyPr>
+          <a:lstStyle/>
+          <a:p>
+            <a:r>
+              <a:rPr lang="en-US" altLang="zh-CN" sz="1300">
+                <a:solidFill>
+                  <a:srgbClr val="172A3A"/>
+                </a:solidFill>
+                <a:latin typeface="Microsoft YaHei" panose="020B0503020204020204" pitchFamily="34" charset="-122"/>
+                <a:ea typeface="Microsoft YaHei" panose="020B0503020204020204" pitchFamily="34" charset="-122"/>
+              </a:rPr>
+              <a:t>____</a:t>
+            </a:r>
+            <a:endParaRPr lang="zh-CN" altLang="en-US" sz="1300">
+              <a:solidFill>
+                <a:srgbClr val="172A3A"/>
+              </a:solidFill>
+              <a:latin typeface="Microsoft YaHei" panose="020B0503020204020204" pitchFamily="34" charset="-122"/>
+              <a:ea typeface="Microsoft YaHei" panose="020B0503020204020204" pitchFamily="34" charset="-122"/>
+            </a:endParaRPr>
+          </a:p>
+        </p:txBody>
+      </p:sp>
+      <p:sp>
+        <p:nvSpPr>
+          <p:cNvPr id="31" name="ACT_04_DATE">
+            <a:extLst>
+              <a:ext uri="{FF2B5EF4-FFF2-40B4-BE49-F238E27FC236}">
+                <a16:creationId xmlns:a16="http://schemas.microsoft.com/office/drawing/2014/main" id="{E3486880-9BF6-E87F-77B7-272834862148}"/>
+              </a:ext>
+            </a:extLst>
+          </p:cNvPr>
+          <p:cNvSpPr txBox="1"/>
+          <p:nvPr/>
+        </p:nvSpPr>
+        <p:spPr>
+          <a:xfrm>
+            <a:off x="8229600" y="4773168"/>
+            <a:ext cx="1554480" cy="369332"/>
+          </a:xfrm>
+          <a:prstGeom prst="rect">
+            <a:avLst/>
+          </a:prstGeom>
+          <a:noFill/>
+        </p:spPr>
+        <p:txBody>
+          <a:bodyPr vert="horz" wrap="square" rtlCol="0">
+            <a:noAutofit/>
+          </a:bodyPr>
+          <a:lstStyle/>
+          <a:p>
+            <a:r>
+              <a:rPr lang="en-US" altLang="zh-CN" sz="1300">
+                <a:solidFill>
+                  <a:srgbClr val="172A3A"/>
+                </a:solidFill>
+                <a:latin typeface="Microsoft YaHei" panose="020B0503020204020204" pitchFamily="34" charset="-122"/>
+                <a:ea typeface="Microsoft YaHei" panose="020B0503020204020204" pitchFamily="34" charset="-122"/>
+              </a:rPr>
+              <a:t>____</a:t>
+            </a:r>
+            <a:endParaRPr lang="zh-CN" altLang="en-US" sz="1300">
+              <a:solidFill>
+                <a:srgbClr val="172A3A"/>
+              </a:solidFill>
+              <a:latin typeface="Microsoft YaHei" panose="020B0503020204020204" pitchFamily="34" charset="-122"/>
+              <a:ea typeface="Microsoft YaHei" panose="020B0503020204020204" pitchFamily="34" charset="-122"/>
+            </a:endParaRPr>
+          </a:p>
+        </p:txBody>
+      </p:sp>
+      <p:sp>
+        <p:nvSpPr>
+          <p:cNvPr id="32" name="ACT_04_METRIC">
+            <a:extLst>
+              <a:ext uri="{FF2B5EF4-FFF2-40B4-BE49-F238E27FC236}">
+                <a16:creationId xmlns:a16="http://schemas.microsoft.com/office/drawing/2014/main" id="{AA140A7B-5EE9-39E5-79FE-F57D3DFF28EC}"/>
+              </a:ext>
+            </a:extLst>
+          </p:cNvPr>
+          <p:cNvSpPr txBox="1"/>
+          <p:nvPr/>
+        </p:nvSpPr>
+        <p:spPr>
+          <a:xfrm>
+            <a:off x="9921240" y="4773168"/>
+            <a:ext cx="2011680" cy="369332"/>
+          </a:xfrm>
+          <a:prstGeom prst="rect">
+            <a:avLst/>
+          </a:prstGeom>
+          <a:noFill/>
+        </p:spPr>
+        <p:txBody>
+          <a:bodyPr vert="horz" wrap="square" rtlCol="0">
+            <a:noAutofit/>
+          </a:bodyPr>
+          <a:lstStyle/>
+          <a:p>
+            <a:r>
+              <a:rPr lang="en-US" altLang="zh-CN" sz="1300">
+                <a:solidFill>
+                  <a:srgbClr val="172A3A"/>
+                </a:solidFill>
+                <a:latin typeface="Microsoft YaHei" panose="020B0503020204020204" pitchFamily="34" charset="-122"/>
+                <a:ea typeface="Microsoft YaHei" panose="020B0503020204020204" pitchFamily="34" charset="-122"/>
+              </a:rPr>
+              <a:t>____</a:t>
+            </a:r>
+            <a:endParaRPr lang="zh-CN" altLang="en-US" sz="1300">
+              <a:solidFill>
+                <a:srgbClr val="172A3A"/>
+              </a:solidFill>
+              <a:latin typeface="Microsoft YaHei" panose="020B0503020204020204" pitchFamily="34" charset="-122"/>
+              <a:ea typeface="Microsoft YaHei" panose="020B0503020204020204" pitchFamily="34" charset="-122"/>
+            </a:endParaRPr>
+          </a:p>
+        </p:txBody>
+      </p:sp>
+      <p:sp>
+        <p:nvSpPr>
+          <p:cNvPr id="33" name="TEACHING_CUE">
+            <a:extLst>
+              <a:ext uri="{FF2B5EF4-FFF2-40B4-BE49-F238E27FC236}">
+                <a16:creationId xmlns:a16="http://schemas.microsoft.com/office/drawing/2014/main" id="{D197A33E-186C-9514-EB8B-6044E8C02DB0}"/>
+              </a:ext>
+            </a:extLst>
+          </p:cNvPr>
+          <p:cNvSpPr txBox="1"/>
+          <p:nvPr/>
+        </p:nvSpPr>
+        <p:spPr>
+          <a:xfrm>
+            <a:off x="548640" y="5806440"/>
+            <a:ext cx="11064240" cy="369332"/>
+          </a:xfrm>
+          <a:prstGeom prst="rect">
+            <a:avLst/>
+          </a:prstGeom>
+          <a:noFill/>
+        </p:spPr>
+        <p:txBody>
+          <a:bodyPr vert="horz" wrap="square" rtlCol="0">
+            <a:noAutofit/>
+          </a:bodyPr>
+          <a:lstStyle/>
+          <a:p>
+            <a:r>
+              <a:rPr lang="zh-CN" altLang="en-US" sz="1200">
+                <a:solidFill>
+                  <a:srgbClr val="66747C"/>
+                </a:solidFill>
+                <a:latin typeface="Microsoft YaHei" panose="020B0503020204020204" pitchFamily="34" charset="-122"/>
+                <a:ea typeface="Microsoft YaHei" panose="020B0503020204020204" pitchFamily="34" charset="-122"/>
+              </a:rPr>
+              <a:t>行动必须连接前面诊断出的短板或机会；最多 </a:t>
+            </a:r>
+            <a:r>
+              <a:rPr lang="en-US" altLang="zh-CN" sz="1200">
+                <a:solidFill>
+                  <a:srgbClr val="66747C"/>
+                </a:solidFill>
+                <a:latin typeface="Microsoft YaHei" panose="020B0503020204020204" pitchFamily="34" charset="-122"/>
+                <a:ea typeface="Microsoft YaHei" panose="020B0503020204020204" pitchFamily="34" charset="-122"/>
+              </a:rPr>
+              <a:t>3 </a:t>
+            </a:r>
+            <a:r>
+              <a:rPr lang="zh-CN" altLang="en-US" sz="1200">
+                <a:solidFill>
+                  <a:srgbClr val="66747C"/>
+                </a:solidFill>
+                <a:latin typeface="Microsoft YaHei" panose="020B0503020204020204" pitchFamily="34" charset="-122"/>
+                <a:ea typeface="Microsoft YaHei" panose="020B0503020204020204" pitchFamily="34" charset="-122"/>
+              </a:rPr>
+              <a:t>项，选最重要的。</a:t>
+            </a:r>
+          </a:p>
+        </p:txBody>
+      </p:sp>
+    </p:spTree>
+    <p:extLst>
+      <p:ext uri="{BB962C8B-B14F-4D97-AF65-F5344CB8AC3E}">
+        <p14:creationId xmlns:p14="http://schemas.microsoft.com/office/powerpoint/2010/main" val="652020401"/>
       </p:ext>
     </p:extLst>
   </p:cSld>

</xml_diff>

<commit_message>
Add DC-05 channel driver board as executable component (slide 8) with full pipeline
- Source page: built via work-copy pipeline (build-dc05.ps1 + dc05-content.json) on the branded deck; official deck now 8 slides, SHA 9EC9E58E (was EAC0CD92)
- Color system unified to template theme1 tokens (ink #505046 / red #E84C22 / grey #6F6F6A) in build-dc05.ps1 and build-county-course.ps1; scripts kept pure ASCII per PS5.1 rule
- Slot contract: component-slots.json + DC-05 entry (22 replaceable objects, slide 8, id 263#)
- Preview component-08.png, contact sheet regenerated (8 cells), component-index.json rebuilt (module: channel cultivation)
- Bridge catalog.json: DC-05 entry + deck SHA updated
- decision-component-store.md DC-05 card + executable-component-store.md table (added DC-08 row too)
</commit_message>
<xml_diff>
--- a/domains/yuhong/assets/components/yuhong-county-course-components-branded.pptx
+++ b/domains/yuhong/assets/components/yuhong-county-course-components-branded.pptx
@@ -5,7 +5,7 @@
     <p:sldMasterId id="2147483648" r:id="rId1"/>
   </p:sldMasterIdLst>
   <p:notesMasterIdLst>
-    <p:notesMasterId r:id="rId9"/>
+    <p:notesMasterId r:id="rId10"/>
   </p:notesMasterIdLst>
   <p:sldIdLst>
     <p:sldId id="256" r:id="rId2"/>
@@ -15,6 +15,7 @@
     <p:sldId id="260" r:id="rId6"/>
     <p:sldId id="261" r:id="rId7"/>
     <p:sldId id="262" r:id="rId8"/>
+    <p:sldId id="263" r:id="rId9"/>
   </p:sldIdLst>
   <p:sldSz cx="12192000" cy="6858000"/>
   <p:notesSz cx="6858000" cy="9144000"/>
@@ -12415,6 +12416,1363 @@
     <p:extLst>
       <p:ext uri="{BB962C8B-B14F-4D97-AF65-F5344CB8AC3E}">
         <p14:creationId xmlns:p14="http://schemas.microsoft.com/office/powerpoint/2010/main" val="652020401"/>
+      </p:ext>
+    </p:extLst>
+  </p:cSld>
+  <p:clrMapOvr>
+    <a:masterClrMapping/>
+  </p:clrMapOvr>
+</p:sld>
+</file>
+
+<file path=ppt/slides/slide8.xml><?xml version="1.0" encoding="utf-8"?>
+<p:sld xmlns:a="http://schemas.openxmlformats.org/drawingml/2006/main" xmlns:r="http://schemas.openxmlformats.org/officeDocument/2006/relationships" xmlns:p="http://schemas.openxmlformats.org/presentationml/2006/main">
+  <p:cSld>
+    <p:spTree>
+      <p:nvGrpSpPr>
+        <p:cNvPr id="1" name=""/>
+        <p:cNvGrpSpPr/>
+        <p:nvPr/>
+      </p:nvGrpSpPr>
+      <p:grpSpPr>
+        <a:xfrm>
+          <a:off x="0" y="0"/>
+          <a:ext cx="0" cy="0"/>
+          <a:chOff x="0" y="0"/>
+          <a:chExt cx="0" cy="0"/>
+        </a:xfrm>
+      </p:grpSpPr>
+      <p:sp>
+        <p:nvSpPr>
+          <p:cNvPr id="2" name="TITLE">
+            <a:extLst>
+              <a:ext uri="{FF2B5EF4-FFF2-40B4-BE49-F238E27FC236}">
+                <a16:creationId xmlns:a16="http://schemas.microsoft.com/office/drawing/2014/main" id="{C2B4CD45-9413-140C-6E54-A612BEDFAD34}"/>
+              </a:ext>
+            </a:extLst>
+          </p:cNvPr>
+          <p:cNvSpPr txBox="1"/>
+          <p:nvPr/>
+        </p:nvSpPr>
+        <p:spPr>
+          <a:xfrm>
+            <a:off x="548640" y="384048"/>
+            <a:ext cx="10789920" cy="369332"/>
+          </a:xfrm>
+          <a:prstGeom prst="rect">
+            <a:avLst/>
+          </a:prstGeom>
+          <a:noFill/>
+        </p:spPr>
+        <p:txBody>
+          <a:bodyPr vert="horz" wrap="square" rtlCol="0">
+            <a:noAutofit/>
+          </a:bodyPr>
+          <a:lstStyle/>
+          <a:p>
+            <a:r>
+              <a:rPr lang="zh-CN" altLang="en-US" sz="2600" b="1">
+                <a:solidFill>
+                  <a:srgbClr val="505046"/>
+                </a:solidFill>
+                <a:latin typeface="Microsoft YaHei" panose="020B0503020204020204" pitchFamily="34" charset="-122"/>
+                <a:ea typeface="Microsoft YaHei" panose="020B0503020204020204" pitchFamily="34" charset="-122"/>
+              </a:rPr>
+              <a:t>渠道增长卡在哪：覆盖、活跃，还是单店产出？</a:t>
+            </a:r>
+          </a:p>
+        </p:txBody>
+      </p:sp>
+      <p:sp>
+        <p:nvSpPr>
+          <p:cNvPr id="3" name="SUBTITLE">
+            <a:extLst>
+              <a:ext uri="{FF2B5EF4-FFF2-40B4-BE49-F238E27FC236}">
+                <a16:creationId xmlns:a16="http://schemas.microsoft.com/office/drawing/2014/main" id="{A8540BC9-D356-9D3D-1FD9-F90DA4805716}"/>
+              </a:ext>
+            </a:extLst>
+          </p:cNvPr>
+          <p:cNvSpPr txBox="1"/>
+          <p:nvPr/>
+        </p:nvSpPr>
+        <p:spPr>
+          <a:xfrm>
+            <a:off x="548640" y="987552"/>
+            <a:ext cx="10789920" cy="369332"/>
+          </a:xfrm>
+          <a:prstGeom prst="rect">
+            <a:avLst/>
+          </a:prstGeom>
+          <a:noFill/>
+        </p:spPr>
+        <p:txBody>
+          <a:bodyPr vert="horz" wrap="square" rtlCol="0">
+            <a:noAutofit/>
+          </a:bodyPr>
+          <a:lstStyle/>
+          <a:p>
+            <a:r>
+              <a:rPr lang="zh-CN" altLang="en-US" sz="1400">
+                <a:solidFill>
+                  <a:srgbClr val="6F6F6A"/>
+                </a:solidFill>
+                <a:latin typeface="Microsoft YaHei" panose="020B0503020204020204" pitchFamily="34" charset="-122"/>
+                <a:ea typeface="Microsoft YaHei" panose="020B0503020204020204" pitchFamily="34" charset="-122"/>
+              </a:rPr>
+              <a:t>渠道增长 </a:t>
+            </a:r>
+            <a:r>
+              <a:rPr lang="en-US" altLang="zh-CN" sz="1400">
+                <a:solidFill>
+                  <a:srgbClr val="6F6F6A"/>
+                </a:solidFill>
+                <a:latin typeface="Microsoft YaHei" panose="020B0503020204020204" pitchFamily="34" charset="-122"/>
+                <a:ea typeface="Microsoft YaHei" panose="020B0503020204020204" pitchFamily="34" charset="-122"/>
+              </a:rPr>
+              <a:t>= </a:t>
+            </a:r>
+            <a:r>
+              <a:rPr lang="zh-CN" altLang="en-US" sz="1400">
+                <a:solidFill>
+                  <a:srgbClr val="6F6F6A"/>
+                </a:solidFill>
+                <a:latin typeface="Microsoft YaHei" panose="020B0503020204020204" pitchFamily="34" charset="-122"/>
+                <a:ea typeface="Microsoft YaHei" panose="020B0503020204020204" pitchFamily="34" charset="-122"/>
+              </a:rPr>
+              <a:t>覆盖 </a:t>
+            </a:r>
+            <a:r>
+              <a:rPr lang="en-US" altLang="zh-CN" sz="1400">
+                <a:solidFill>
+                  <a:srgbClr val="6F6F6A"/>
+                </a:solidFill>
+                <a:latin typeface="Microsoft YaHei" panose="020B0503020204020204" pitchFamily="34" charset="-122"/>
+                <a:ea typeface="Microsoft YaHei" panose="020B0503020204020204" pitchFamily="34" charset="-122"/>
+              </a:rPr>
+              <a:t>× </a:t>
+            </a:r>
+            <a:r>
+              <a:rPr lang="zh-CN" altLang="en-US" sz="1400">
+                <a:solidFill>
+                  <a:srgbClr val="6F6F6A"/>
+                </a:solidFill>
+                <a:latin typeface="Microsoft YaHei" panose="020B0503020204020204" pitchFamily="34" charset="-122"/>
+                <a:ea typeface="Microsoft YaHei" panose="020B0503020204020204" pitchFamily="34" charset="-122"/>
+              </a:rPr>
+              <a:t>活跃 </a:t>
+            </a:r>
+            <a:r>
+              <a:rPr lang="en-US" altLang="zh-CN" sz="1400">
+                <a:solidFill>
+                  <a:srgbClr val="6F6F6A"/>
+                </a:solidFill>
+                <a:latin typeface="Microsoft YaHei" panose="020B0503020204020204" pitchFamily="34" charset="-122"/>
+                <a:ea typeface="Microsoft YaHei" panose="020B0503020204020204" pitchFamily="34" charset="-122"/>
+              </a:rPr>
+              <a:t>× </a:t>
+            </a:r>
+            <a:r>
+              <a:rPr lang="zh-CN" altLang="en-US" sz="1400">
+                <a:solidFill>
+                  <a:srgbClr val="6F6F6A"/>
+                </a:solidFill>
+                <a:latin typeface="Microsoft YaHei" panose="020B0503020204020204" pitchFamily="34" charset="-122"/>
+                <a:ea typeface="Microsoft YaHei" panose="020B0503020204020204" pitchFamily="34" charset="-122"/>
+              </a:rPr>
+              <a:t>单店产出</a:t>
+            </a:r>
+            <a:r>
+              <a:rPr lang="en-US" altLang="zh-CN" sz="1400">
+                <a:solidFill>
+                  <a:srgbClr val="6F6F6A"/>
+                </a:solidFill>
+                <a:latin typeface="Microsoft YaHei" panose="020B0503020204020204" pitchFamily="34" charset="-122"/>
+                <a:ea typeface="Microsoft YaHei" panose="020B0503020204020204" pitchFamily="34" charset="-122"/>
+              </a:rPr>
+              <a:t>——</a:t>
+            </a:r>
+            <a:r>
+              <a:rPr lang="zh-CN" altLang="en-US" sz="1400">
+                <a:solidFill>
+                  <a:srgbClr val="6F6F6A"/>
+                </a:solidFill>
+                <a:latin typeface="Microsoft YaHei" panose="020B0503020204020204" pitchFamily="34" charset="-122"/>
+                <a:ea typeface="Microsoft YaHei" panose="020B0503020204020204" pitchFamily="34" charset="-122"/>
+              </a:rPr>
+              <a:t>先判断卡在哪个杠杆</a:t>
+            </a:r>
+          </a:p>
+        </p:txBody>
+      </p:sp>
+      <p:sp>
+        <p:nvSpPr>
+          <p:cNvPr id="4" name="LEVER_BAND_1">
+            <a:extLst>
+              <a:ext uri="{FF2B5EF4-FFF2-40B4-BE49-F238E27FC236}">
+                <a16:creationId xmlns:a16="http://schemas.microsoft.com/office/drawing/2014/main" id="{2CB47E7C-E2D1-33A5-D7E6-3C874AB0000F}"/>
+              </a:ext>
+            </a:extLst>
+          </p:cNvPr>
+          <p:cNvSpPr/>
+          <p:nvPr/>
+        </p:nvSpPr>
+        <p:spPr>
+          <a:xfrm>
+            <a:off x="548640" y="1600200"/>
+            <a:ext cx="3474720" cy="2148840"/>
+          </a:xfrm>
+          <a:prstGeom prst="rect">
+            <a:avLst/>
+          </a:prstGeom>
+          <a:solidFill>
+            <a:srgbClr val="F7F7F8"/>
+          </a:solidFill>
+          <a:ln w="9525">
+            <a:solidFill>
+              <a:srgbClr val="6F6F6A"/>
+            </a:solidFill>
+          </a:ln>
+        </p:spPr>
+        <p:style>
+          <a:lnRef idx="2">
+            <a:schemeClr val="accent1">
+              <a:shade val="15000"/>
+            </a:schemeClr>
+          </a:lnRef>
+          <a:fillRef idx="1">
+            <a:schemeClr val="accent1"/>
+          </a:fillRef>
+          <a:effectRef idx="0">
+            <a:schemeClr val="accent1"/>
+          </a:effectRef>
+          <a:fontRef idx="minor">
+            <a:schemeClr val="lt1"/>
+          </a:fontRef>
+        </p:style>
+        <p:txBody>
+          <a:bodyPr rtlCol="0" anchor="ctr"/>
+          <a:lstStyle/>
+          <a:p>
+            <a:pPr algn="ctr"/>
+            <a:endParaRPr lang="zh-CN" altLang="en-US"/>
+          </a:p>
+        </p:txBody>
+      </p:sp>
+      <p:sp>
+        <p:nvSpPr>
+          <p:cNvPr id="5" name="L1_NAME">
+            <a:extLst>
+              <a:ext uri="{FF2B5EF4-FFF2-40B4-BE49-F238E27FC236}">
+                <a16:creationId xmlns:a16="http://schemas.microsoft.com/office/drawing/2014/main" id="{2B34EE29-2A52-BD47-178B-4F6B3651D15C}"/>
+              </a:ext>
+            </a:extLst>
+          </p:cNvPr>
+          <p:cNvSpPr txBox="1"/>
+          <p:nvPr/>
+        </p:nvSpPr>
+        <p:spPr>
+          <a:xfrm>
+            <a:off x="777240" y="1783080"/>
+            <a:ext cx="3017520" cy="369332"/>
+          </a:xfrm>
+          <a:prstGeom prst="rect">
+            <a:avLst/>
+          </a:prstGeom>
+          <a:noFill/>
+        </p:spPr>
+        <p:txBody>
+          <a:bodyPr vert="horz" wrap="square" rtlCol="0">
+            <a:noAutofit/>
+          </a:bodyPr>
+          <a:lstStyle/>
+          <a:p>
+            <a:r>
+              <a:rPr lang="zh-CN" altLang="en-US" sz="1500" b="1">
+                <a:solidFill>
+                  <a:srgbClr val="E84C22"/>
+                </a:solidFill>
+                <a:latin typeface="Microsoft YaHei" panose="020B0503020204020204" pitchFamily="34" charset="-122"/>
+                <a:ea typeface="Microsoft YaHei" panose="020B0503020204020204" pitchFamily="34" charset="-122"/>
+              </a:rPr>
+              <a:t>杠杆一 </a:t>
+            </a:r>
+            <a:r>
+              <a:rPr lang="en-US" altLang="zh-CN" sz="1500" b="1">
+                <a:solidFill>
+                  <a:srgbClr val="E84C22"/>
+                </a:solidFill>
+                <a:latin typeface="Microsoft YaHei" panose="020B0503020204020204" pitchFamily="34" charset="-122"/>
+                <a:ea typeface="Microsoft YaHei" panose="020B0503020204020204" pitchFamily="34" charset="-122"/>
+              </a:rPr>
+              <a:t>· </a:t>
+            </a:r>
+            <a:r>
+              <a:rPr lang="zh-CN" altLang="en-US" sz="1500" b="1">
+                <a:solidFill>
+                  <a:srgbClr val="E84C22"/>
+                </a:solidFill>
+                <a:latin typeface="Microsoft YaHei" panose="020B0503020204020204" pitchFamily="34" charset="-122"/>
+                <a:ea typeface="Microsoft YaHei" panose="020B0503020204020204" pitchFamily="34" charset="-122"/>
+              </a:rPr>
+              <a:t>覆盖</a:t>
+            </a:r>
+          </a:p>
+        </p:txBody>
+      </p:sp>
+      <p:sp>
+        <p:nvSpPr>
+          <p:cNvPr id="6" name="L1_QUESTION">
+            <a:extLst>
+              <a:ext uri="{FF2B5EF4-FFF2-40B4-BE49-F238E27FC236}">
+                <a16:creationId xmlns:a16="http://schemas.microsoft.com/office/drawing/2014/main" id="{7CEC918B-6D4C-35F7-9BC7-1A42D26C2F58}"/>
+              </a:ext>
+            </a:extLst>
+          </p:cNvPr>
+          <p:cNvSpPr txBox="1"/>
+          <p:nvPr/>
+        </p:nvSpPr>
+        <p:spPr>
+          <a:xfrm>
+            <a:off x="777240" y="2286000"/>
+            <a:ext cx="3017520" cy="369332"/>
+          </a:xfrm>
+          <a:prstGeom prst="rect">
+            <a:avLst/>
+          </a:prstGeom>
+          <a:noFill/>
+        </p:spPr>
+        <p:txBody>
+          <a:bodyPr vert="horz" wrap="square" rtlCol="0">
+            <a:noAutofit/>
+          </a:bodyPr>
+          <a:lstStyle/>
+          <a:p>
+            <a:r>
+              <a:rPr lang="zh-CN" altLang="en-US" sz="1300" b="1">
+                <a:solidFill>
+                  <a:srgbClr val="505046"/>
+                </a:solidFill>
+                <a:latin typeface="Microsoft YaHei" panose="020B0503020204020204" pitchFamily="34" charset="-122"/>
+                <a:ea typeface="Microsoft YaHei" panose="020B0503020204020204" pitchFamily="34" charset="-122"/>
+              </a:rPr>
+              <a:t>网点铺够了吗？</a:t>
+            </a:r>
+          </a:p>
+        </p:txBody>
+      </p:sp>
+      <p:sp>
+        <p:nvSpPr>
+          <p:cNvPr id="7" name="L1_VALUE">
+            <a:extLst>
+              <a:ext uri="{FF2B5EF4-FFF2-40B4-BE49-F238E27FC236}">
+                <a16:creationId xmlns:a16="http://schemas.microsoft.com/office/drawing/2014/main" id="{8F205A6D-82FD-BFE1-A449-0ADF3E21EBF2}"/>
+              </a:ext>
+            </a:extLst>
+          </p:cNvPr>
+          <p:cNvSpPr txBox="1"/>
+          <p:nvPr/>
+        </p:nvSpPr>
+        <p:spPr>
+          <a:xfrm>
+            <a:off x="777240" y="2880360"/>
+            <a:ext cx="3017520" cy="369332"/>
+          </a:xfrm>
+          <a:prstGeom prst="rect">
+            <a:avLst/>
+          </a:prstGeom>
+          <a:noFill/>
+        </p:spPr>
+        <p:txBody>
+          <a:bodyPr vert="horz" wrap="square" rtlCol="0">
+            <a:noAutofit/>
+          </a:bodyPr>
+          <a:lstStyle/>
+          <a:p>
+            <a:r>
+              <a:rPr lang="zh-CN" altLang="en-US" sz="1200">
+                <a:solidFill>
+                  <a:srgbClr val="505046"/>
+                </a:solidFill>
+                <a:latin typeface="Microsoft YaHei" panose="020B0503020204020204" pitchFamily="34" charset="-122"/>
+                <a:ea typeface="Microsoft YaHei" panose="020B0503020204020204" pitchFamily="34" charset="-122"/>
+              </a:rPr>
+              <a:t>目标</a:t>
+            </a:r>
+            <a:r>
+              <a:rPr lang="en-US" altLang="zh-CN" sz="1200">
+                <a:solidFill>
+                  <a:srgbClr val="505046"/>
+                </a:solidFill>
+                <a:latin typeface="Microsoft YaHei" panose="020B0503020204020204" pitchFamily="34" charset="-122"/>
+                <a:ea typeface="Microsoft YaHei" panose="020B0503020204020204" pitchFamily="34" charset="-122"/>
+              </a:rPr>
+              <a:t>____</a:t>
+            </a:r>
+            <a:r>
+              <a:rPr lang="zh-CN" altLang="en-US" sz="1200">
+                <a:solidFill>
+                  <a:srgbClr val="505046"/>
+                </a:solidFill>
+                <a:latin typeface="Microsoft YaHei" panose="020B0503020204020204" pitchFamily="34" charset="-122"/>
+                <a:ea typeface="Microsoft YaHei" panose="020B0503020204020204" pitchFamily="34" charset="-122"/>
+              </a:rPr>
+              <a:t>家 ｜ 覆盖</a:t>
+            </a:r>
+            <a:r>
+              <a:rPr lang="en-US" altLang="zh-CN" sz="1200">
+                <a:solidFill>
+                  <a:srgbClr val="505046"/>
+                </a:solidFill>
+                <a:latin typeface="Microsoft YaHei" panose="020B0503020204020204" pitchFamily="34" charset="-122"/>
+                <a:ea typeface="Microsoft YaHei" panose="020B0503020204020204" pitchFamily="34" charset="-122"/>
+              </a:rPr>
+              <a:t>____</a:t>
+            </a:r>
+            <a:r>
+              <a:rPr lang="zh-CN" altLang="en-US" sz="1200">
+                <a:solidFill>
+                  <a:srgbClr val="505046"/>
+                </a:solidFill>
+                <a:latin typeface="Microsoft YaHei" panose="020B0503020204020204" pitchFamily="34" charset="-122"/>
+                <a:ea typeface="Microsoft YaHei" panose="020B0503020204020204" pitchFamily="34" charset="-122"/>
+              </a:rPr>
+              <a:t>家</a:t>
+            </a:r>
+          </a:p>
+        </p:txBody>
+      </p:sp>
+      <p:sp>
+        <p:nvSpPr>
+          <p:cNvPr id="8" name="MULT_1">
+            <a:extLst>
+              <a:ext uri="{FF2B5EF4-FFF2-40B4-BE49-F238E27FC236}">
+                <a16:creationId xmlns:a16="http://schemas.microsoft.com/office/drawing/2014/main" id="{11CF328E-A325-614B-76A3-BBE96E27C1C3}"/>
+              </a:ext>
+            </a:extLst>
+          </p:cNvPr>
+          <p:cNvSpPr txBox="1"/>
+          <p:nvPr/>
+        </p:nvSpPr>
+        <p:spPr>
+          <a:xfrm>
+            <a:off x="4041648" y="2377440"/>
+            <a:ext cx="274320" cy="369332"/>
+          </a:xfrm>
+          <a:prstGeom prst="rect">
+            <a:avLst/>
+          </a:prstGeom>
+          <a:noFill/>
+        </p:spPr>
+        <p:txBody>
+          <a:bodyPr vert="horz" wrap="square" rtlCol="0">
+            <a:noAutofit/>
+          </a:bodyPr>
+          <a:lstStyle/>
+          <a:p>
+            <a:pPr algn="ctr"/>
+            <a:r>
+              <a:rPr lang="en-US" altLang="zh-CN" sz="2000" b="1">
+                <a:solidFill>
+                  <a:srgbClr val="E84C22"/>
+                </a:solidFill>
+                <a:latin typeface="Microsoft YaHei" panose="020B0503020204020204" pitchFamily="34" charset="-122"/>
+                <a:ea typeface="Microsoft YaHei" panose="020B0503020204020204" pitchFamily="34" charset="-122"/>
+              </a:rPr>
+              <a:t>x</a:t>
+            </a:r>
+            <a:endParaRPr lang="zh-CN" altLang="en-US" sz="2000" b="1">
+              <a:solidFill>
+                <a:srgbClr val="E84C22"/>
+              </a:solidFill>
+              <a:latin typeface="Microsoft YaHei" panose="020B0503020204020204" pitchFamily="34" charset="-122"/>
+              <a:ea typeface="Microsoft YaHei" panose="020B0503020204020204" pitchFamily="34" charset="-122"/>
+            </a:endParaRPr>
+          </a:p>
+        </p:txBody>
+      </p:sp>
+      <p:sp>
+        <p:nvSpPr>
+          <p:cNvPr id="9" name="LEVER_BAND_2">
+            <a:extLst>
+              <a:ext uri="{FF2B5EF4-FFF2-40B4-BE49-F238E27FC236}">
+                <a16:creationId xmlns:a16="http://schemas.microsoft.com/office/drawing/2014/main" id="{28FBAEB3-BAB6-2F46-4D67-FEC9DE35C1A9}"/>
+              </a:ext>
+            </a:extLst>
+          </p:cNvPr>
+          <p:cNvSpPr/>
+          <p:nvPr/>
+        </p:nvSpPr>
+        <p:spPr>
+          <a:xfrm>
+            <a:off x="4297680" y="1600200"/>
+            <a:ext cx="3474720" cy="2148840"/>
+          </a:xfrm>
+          <a:prstGeom prst="rect">
+            <a:avLst/>
+          </a:prstGeom>
+          <a:solidFill>
+            <a:srgbClr val="EEECE1"/>
+          </a:solidFill>
+          <a:ln w="9525">
+            <a:solidFill>
+              <a:srgbClr val="6F6F6A"/>
+            </a:solidFill>
+          </a:ln>
+        </p:spPr>
+        <p:style>
+          <a:lnRef idx="2">
+            <a:schemeClr val="accent1">
+              <a:shade val="15000"/>
+            </a:schemeClr>
+          </a:lnRef>
+          <a:fillRef idx="1">
+            <a:schemeClr val="accent1"/>
+          </a:fillRef>
+          <a:effectRef idx="0">
+            <a:schemeClr val="accent1"/>
+          </a:effectRef>
+          <a:fontRef idx="minor">
+            <a:schemeClr val="lt1"/>
+          </a:fontRef>
+        </p:style>
+        <p:txBody>
+          <a:bodyPr rtlCol="0" anchor="ctr"/>
+          <a:lstStyle/>
+          <a:p>
+            <a:pPr algn="ctr"/>
+            <a:endParaRPr lang="zh-CN" altLang="en-US"/>
+          </a:p>
+        </p:txBody>
+      </p:sp>
+      <p:sp>
+        <p:nvSpPr>
+          <p:cNvPr id="10" name="L2_NAME">
+            <a:extLst>
+              <a:ext uri="{FF2B5EF4-FFF2-40B4-BE49-F238E27FC236}">
+                <a16:creationId xmlns:a16="http://schemas.microsoft.com/office/drawing/2014/main" id="{1700F865-CA7E-A91F-9075-691FE62909A8}"/>
+              </a:ext>
+            </a:extLst>
+          </p:cNvPr>
+          <p:cNvSpPr txBox="1"/>
+          <p:nvPr/>
+        </p:nvSpPr>
+        <p:spPr>
+          <a:xfrm>
+            <a:off x="4526280" y="1783080"/>
+            <a:ext cx="3017520" cy="369332"/>
+          </a:xfrm>
+          <a:prstGeom prst="rect">
+            <a:avLst/>
+          </a:prstGeom>
+          <a:noFill/>
+        </p:spPr>
+        <p:txBody>
+          <a:bodyPr vert="horz" wrap="square" rtlCol="0">
+            <a:noAutofit/>
+          </a:bodyPr>
+          <a:lstStyle/>
+          <a:p>
+            <a:r>
+              <a:rPr lang="zh-CN" altLang="en-US" sz="1500" b="1">
+                <a:solidFill>
+                  <a:srgbClr val="E84C22"/>
+                </a:solidFill>
+                <a:latin typeface="Microsoft YaHei" panose="020B0503020204020204" pitchFamily="34" charset="-122"/>
+                <a:ea typeface="Microsoft YaHei" panose="020B0503020204020204" pitchFamily="34" charset="-122"/>
+              </a:rPr>
+              <a:t>杠杆二 </a:t>
+            </a:r>
+            <a:r>
+              <a:rPr lang="en-US" altLang="zh-CN" sz="1500" b="1">
+                <a:solidFill>
+                  <a:srgbClr val="E84C22"/>
+                </a:solidFill>
+                <a:latin typeface="Microsoft YaHei" panose="020B0503020204020204" pitchFamily="34" charset="-122"/>
+                <a:ea typeface="Microsoft YaHei" panose="020B0503020204020204" pitchFamily="34" charset="-122"/>
+              </a:rPr>
+              <a:t>· </a:t>
+            </a:r>
+            <a:r>
+              <a:rPr lang="zh-CN" altLang="en-US" sz="1500" b="1">
+                <a:solidFill>
+                  <a:srgbClr val="E84C22"/>
+                </a:solidFill>
+                <a:latin typeface="Microsoft YaHei" panose="020B0503020204020204" pitchFamily="34" charset="-122"/>
+                <a:ea typeface="Microsoft YaHei" panose="020B0503020204020204" pitchFamily="34" charset="-122"/>
+              </a:rPr>
+              <a:t>活跃</a:t>
+            </a:r>
+          </a:p>
+        </p:txBody>
+      </p:sp>
+      <p:sp>
+        <p:nvSpPr>
+          <p:cNvPr id="11" name="L2_QUESTION">
+            <a:extLst>
+              <a:ext uri="{FF2B5EF4-FFF2-40B4-BE49-F238E27FC236}">
+                <a16:creationId xmlns:a16="http://schemas.microsoft.com/office/drawing/2014/main" id="{2EDAD1D4-16FA-3CCA-7C0F-A78ACC424195}"/>
+              </a:ext>
+            </a:extLst>
+          </p:cNvPr>
+          <p:cNvSpPr txBox="1"/>
+          <p:nvPr/>
+        </p:nvSpPr>
+        <p:spPr>
+          <a:xfrm>
+            <a:off x="4526280" y="2286000"/>
+            <a:ext cx="3017520" cy="369332"/>
+          </a:xfrm>
+          <a:prstGeom prst="rect">
+            <a:avLst/>
+          </a:prstGeom>
+          <a:noFill/>
+        </p:spPr>
+        <p:txBody>
+          <a:bodyPr vert="horz" wrap="square" rtlCol="0">
+            <a:noAutofit/>
+          </a:bodyPr>
+          <a:lstStyle/>
+          <a:p>
+            <a:r>
+              <a:rPr lang="zh-CN" altLang="en-US" sz="1300" b="1">
+                <a:solidFill>
+                  <a:srgbClr val="505046"/>
+                </a:solidFill>
+                <a:latin typeface="Microsoft YaHei" panose="020B0503020204020204" pitchFamily="34" charset="-122"/>
+                <a:ea typeface="Microsoft YaHei" panose="020B0503020204020204" pitchFamily="34" charset="-122"/>
+              </a:rPr>
+              <a:t>铺了，动销了吗？</a:t>
+            </a:r>
+          </a:p>
+        </p:txBody>
+      </p:sp>
+      <p:sp>
+        <p:nvSpPr>
+          <p:cNvPr id="12" name="L2_VALUE">
+            <a:extLst>
+              <a:ext uri="{FF2B5EF4-FFF2-40B4-BE49-F238E27FC236}">
+                <a16:creationId xmlns:a16="http://schemas.microsoft.com/office/drawing/2014/main" id="{5CE25A41-1FC9-84AB-614C-1327F1D7E803}"/>
+              </a:ext>
+            </a:extLst>
+          </p:cNvPr>
+          <p:cNvSpPr txBox="1"/>
+          <p:nvPr/>
+        </p:nvSpPr>
+        <p:spPr>
+          <a:xfrm>
+            <a:off x="4526280" y="2880360"/>
+            <a:ext cx="3017520" cy="369332"/>
+          </a:xfrm>
+          <a:prstGeom prst="rect">
+            <a:avLst/>
+          </a:prstGeom>
+          <a:noFill/>
+        </p:spPr>
+        <p:txBody>
+          <a:bodyPr vert="horz" wrap="square" rtlCol="0">
+            <a:noAutofit/>
+          </a:bodyPr>
+          <a:lstStyle/>
+          <a:p>
+            <a:r>
+              <a:rPr lang="zh-CN" altLang="en-US" sz="1200">
+                <a:solidFill>
+                  <a:srgbClr val="505046"/>
+                </a:solidFill>
+                <a:latin typeface="Microsoft YaHei" panose="020B0503020204020204" pitchFamily="34" charset="-122"/>
+                <a:ea typeface="Microsoft YaHei" panose="020B0503020204020204" pitchFamily="34" charset="-122"/>
+              </a:rPr>
+              <a:t>覆盖</a:t>
+            </a:r>
+            <a:r>
+              <a:rPr lang="en-US" altLang="zh-CN" sz="1200">
+                <a:solidFill>
+                  <a:srgbClr val="505046"/>
+                </a:solidFill>
+                <a:latin typeface="Microsoft YaHei" panose="020B0503020204020204" pitchFamily="34" charset="-122"/>
+                <a:ea typeface="Microsoft YaHei" panose="020B0503020204020204" pitchFamily="34" charset="-122"/>
+              </a:rPr>
+              <a:t>____</a:t>
+            </a:r>
+            <a:r>
+              <a:rPr lang="zh-CN" altLang="en-US" sz="1200">
+                <a:solidFill>
+                  <a:srgbClr val="505046"/>
+                </a:solidFill>
+                <a:latin typeface="Microsoft YaHei" panose="020B0503020204020204" pitchFamily="34" charset="-122"/>
+                <a:ea typeface="Microsoft YaHei" panose="020B0503020204020204" pitchFamily="34" charset="-122"/>
+              </a:rPr>
+              <a:t>家 ｜ 活跃</a:t>
+            </a:r>
+            <a:r>
+              <a:rPr lang="en-US" altLang="zh-CN" sz="1200">
+                <a:solidFill>
+                  <a:srgbClr val="505046"/>
+                </a:solidFill>
+                <a:latin typeface="Microsoft YaHei" panose="020B0503020204020204" pitchFamily="34" charset="-122"/>
+                <a:ea typeface="Microsoft YaHei" panose="020B0503020204020204" pitchFamily="34" charset="-122"/>
+              </a:rPr>
+              <a:t>____</a:t>
+            </a:r>
+            <a:r>
+              <a:rPr lang="zh-CN" altLang="en-US" sz="1200">
+                <a:solidFill>
+                  <a:srgbClr val="505046"/>
+                </a:solidFill>
+                <a:latin typeface="Microsoft YaHei" panose="020B0503020204020204" pitchFamily="34" charset="-122"/>
+                <a:ea typeface="Microsoft YaHei" panose="020B0503020204020204" pitchFamily="34" charset="-122"/>
+              </a:rPr>
+              <a:t>家</a:t>
+            </a:r>
+          </a:p>
+        </p:txBody>
+      </p:sp>
+      <p:sp>
+        <p:nvSpPr>
+          <p:cNvPr id="13" name="MULT_2">
+            <a:extLst>
+              <a:ext uri="{FF2B5EF4-FFF2-40B4-BE49-F238E27FC236}">
+                <a16:creationId xmlns:a16="http://schemas.microsoft.com/office/drawing/2014/main" id="{4E5FFA9A-487A-23C7-8EDE-34B4A6D904F2}"/>
+              </a:ext>
+            </a:extLst>
+          </p:cNvPr>
+          <p:cNvSpPr txBox="1"/>
+          <p:nvPr/>
+        </p:nvSpPr>
+        <p:spPr>
+          <a:xfrm>
+            <a:off x="7790688" y="2377440"/>
+            <a:ext cx="274320" cy="369332"/>
+          </a:xfrm>
+          <a:prstGeom prst="rect">
+            <a:avLst/>
+          </a:prstGeom>
+          <a:noFill/>
+        </p:spPr>
+        <p:txBody>
+          <a:bodyPr vert="horz" wrap="square" rtlCol="0">
+            <a:noAutofit/>
+          </a:bodyPr>
+          <a:lstStyle/>
+          <a:p>
+            <a:pPr algn="ctr"/>
+            <a:r>
+              <a:rPr lang="en-US" altLang="zh-CN" sz="2000" b="1">
+                <a:solidFill>
+                  <a:srgbClr val="E84C22"/>
+                </a:solidFill>
+                <a:latin typeface="Microsoft YaHei" panose="020B0503020204020204" pitchFamily="34" charset="-122"/>
+                <a:ea typeface="Microsoft YaHei" panose="020B0503020204020204" pitchFamily="34" charset="-122"/>
+              </a:rPr>
+              <a:t>x</a:t>
+            </a:r>
+            <a:endParaRPr lang="zh-CN" altLang="en-US" sz="2000" b="1">
+              <a:solidFill>
+                <a:srgbClr val="E84C22"/>
+              </a:solidFill>
+              <a:latin typeface="Microsoft YaHei" panose="020B0503020204020204" pitchFamily="34" charset="-122"/>
+              <a:ea typeface="Microsoft YaHei" panose="020B0503020204020204" pitchFamily="34" charset="-122"/>
+            </a:endParaRPr>
+          </a:p>
+        </p:txBody>
+      </p:sp>
+      <p:sp>
+        <p:nvSpPr>
+          <p:cNvPr id="14" name="LEVER_BAND_3">
+            <a:extLst>
+              <a:ext uri="{FF2B5EF4-FFF2-40B4-BE49-F238E27FC236}">
+                <a16:creationId xmlns:a16="http://schemas.microsoft.com/office/drawing/2014/main" id="{C5C4B1E0-975F-B6CF-C735-1E06BCFEFDF9}"/>
+              </a:ext>
+            </a:extLst>
+          </p:cNvPr>
+          <p:cNvSpPr/>
+          <p:nvPr/>
+        </p:nvSpPr>
+        <p:spPr>
+          <a:xfrm>
+            <a:off x="8046720" y="1600200"/>
+            <a:ext cx="3474719" cy="2148840"/>
+          </a:xfrm>
+          <a:prstGeom prst="rect">
+            <a:avLst/>
+          </a:prstGeom>
+          <a:solidFill>
+            <a:srgbClr val="F7F7F8"/>
+          </a:solidFill>
+          <a:ln w="9525">
+            <a:solidFill>
+              <a:srgbClr val="6F6F6A"/>
+            </a:solidFill>
+          </a:ln>
+        </p:spPr>
+        <p:style>
+          <a:lnRef idx="2">
+            <a:schemeClr val="accent1">
+              <a:shade val="15000"/>
+            </a:schemeClr>
+          </a:lnRef>
+          <a:fillRef idx="1">
+            <a:schemeClr val="accent1"/>
+          </a:fillRef>
+          <a:effectRef idx="0">
+            <a:schemeClr val="accent1"/>
+          </a:effectRef>
+          <a:fontRef idx="minor">
+            <a:schemeClr val="lt1"/>
+          </a:fontRef>
+        </p:style>
+        <p:txBody>
+          <a:bodyPr rtlCol="0" anchor="ctr"/>
+          <a:lstStyle/>
+          <a:p>
+            <a:pPr algn="ctr"/>
+            <a:endParaRPr lang="zh-CN" altLang="en-US"/>
+          </a:p>
+        </p:txBody>
+      </p:sp>
+      <p:sp>
+        <p:nvSpPr>
+          <p:cNvPr id="15" name="L3_NAME">
+            <a:extLst>
+              <a:ext uri="{FF2B5EF4-FFF2-40B4-BE49-F238E27FC236}">
+                <a16:creationId xmlns:a16="http://schemas.microsoft.com/office/drawing/2014/main" id="{D6086B7A-8EF1-75BE-F62E-1CCD1ACE35F5}"/>
+              </a:ext>
+            </a:extLst>
+          </p:cNvPr>
+          <p:cNvSpPr txBox="1"/>
+          <p:nvPr/>
+        </p:nvSpPr>
+        <p:spPr>
+          <a:xfrm>
+            <a:off x="8275320" y="1783080"/>
+            <a:ext cx="3017520" cy="369332"/>
+          </a:xfrm>
+          <a:prstGeom prst="rect">
+            <a:avLst/>
+          </a:prstGeom>
+          <a:noFill/>
+        </p:spPr>
+        <p:txBody>
+          <a:bodyPr vert="horz" wrap="square" rtlCol="0">
+            <a:noAutofit/>
+          </a:bodyPr>
+          <a:lstStyle/>
+          <a:p>
+            <a:r>
+              <a:rPr lang="zh-CN" altLang="en-US" sz="1500" b="1">
+                <a:solidFill>
+                  <a:srgbClr val="E84C22"/>
+                </a:solidFill>
+                <a:latin typeface="Microsoft YaHei" panose="020B0503020204020204" pitchFamily="34" charset="-122"/>
+                <a:ea typeface="Microsoft YaHei" panose="020B0503020204020204" pitchFamily="34" charset="-122"/>
+              </a:rPr>
+              <a:t>杠杆三 </a:t>
+            </a:r>
+            <a:r>
+              <a:rPr lang="en-US" altLang="zh-CN" sz="1500" b="1">
+                <a:solidFill>
+                  <a:srgbClr val="E84C22"/>
+                </a:solidFill>
+                <a:latin typeface="Microsoft YaHei" panose="020B0503020204020204" pitchFamily="34" charset="-122"/>
+                <a:ea typeface="Microsoft YaHei" panose="020B0503020204020204" pitchFamily="34" charset="-122"/>
+              </a:rPr>
+              <a:t>· </a:t>
+            </a:r>
+            <a:r>
+              <a:rPr lang="zh-CN" altLang="en-US" sz="1500" b="1">
+                <a:solidFill>
+                  <a:srgbClr val="E84C22"/>
+                </a:solidFill>
+                <a:latin typeface="Microsoft YaHei" panose="020B0503020204020204" pitchFamily="34" charset="-122"/>
+                <a:ea typeface="Microsoft YaHei" panose="020B0503020204020204" pitchFamily="34" charset="-122"/>
+              </a:rPr>
+              <a:t>单店产出</a:t>
+            </a:r>
+          </a:p>
+        </p:txBody>
+      </p:sp>
+      <p:sp>
+        <p:nvSpPr>
+          <p:cNvPr id="16" name="L3_QUESTION">
+            <a:extLst>
+              <a:ext uri="{FF2B5EF4-FFF2-40B4-BE49-F238E27FC236}">
+                <a16:creationId xmlns:a16="http://schemas.microsoft.com/office/drawing/2014/main" id="{1149446F-1555-3C00-B6D5-5A9ECE094789}"/>
+              </a:ext>
+            </a:extLst>
+          </p:cNvPr>
+          <p:cNvSpPr txBox="1"/>
+          <p:nvPr/>
+        </p:nvSpPr>
+        <p:spPr>
+          <a:xfrm>
+            <a:off x="8275320" y="2286000"/>
+            <a:ext cx="3017520" cy="369332"/>
+          </a:xfrm>
+          <a:prstGeom prst="rect">
+            <a:avLst/>
+          </a:prstGeom>
+          <a:noFill/>
+        </p:spPr>
+        <p:txBody>
+          <a:bodyPr vert="horz" wrap="square" rtlCol="0">
+            <a:noAutofit/>
+          </a:bodyPr>
+          <a:lstStyle/>
+          <a:p>
+            <a:r>
+              <a:rPr lang="zh-CN" altLang="en-US" sz="1300" b="1">
+                <a:solidFill>
+                  <a:srgbClr val="505046"/>
+                </a:solidFill>
+                <a:latin typeface="Microsoft YaHei" panose="020B0503020204020204" pitchFamily="34" charset="-122"/>
+                <a:ea typeface="Microsoft YaHei" panose="020B0503020204020204" pitchFamily="34" charset="-122"/>
+              </a:rPr>
+              <a:t>单店卖得够吗？</a:t>
+            </a:r>
+          </a:p>
+        </p:txBody>
+      </p:sp>
+      <p:sp>
+        <p:nvSpPr>
+          <p:cNvPr id="17" name="L3_VALUE">
+            <a:extLst>
+              <a:ext uri="{FF2B5EF4-FFF2-40B4-BE49-F238E27FC236}">
+                <a16:creationId xmlns:a16="http://schemas.microsoft.com/office/drawing/2014/main" id="{4327F205-F649-CD3D-9C9E-9D5CE798799C}"/>
+              </a:ext>
+            </a:extLst>
+          </p:cNvPr>
+          <p:cNvSpPr txBox="1"/>
+          <p:nvPr/>
+        </p:nvSpPr>
+        <p:spPr>
+          <a:xfrm>
+            <a:off x="8275320" y="2880360"/>
+            <a:ext cx="3017520" cy="369332"/>
+          </a:xfrm>
+          <a:prstGeom prst="rect">
+            <a:avLst/>
+          </a:prstGeom>
+          <a:noFill/>
+        </p:spPr>
+        <p:txBody>
+          <a:bodyPr vert="horz" wrap="square" rtlCol="0">
+            <a:noAutofit/>
+          </a:bodyPr>
+          <a:lstStyle/>
+          <a:p>
+            <a:r>
+              <a:rPr lang="zh-CN" altLang="en-US" sz="1200">
+                <a:solidFill>
+                  <a:srgbClr val="505046"/>
+                </a:solidFill>
+                <a:latin typeface="Microsoft YaHei" panose="020B0503020204020204" pitchFamily="34" charset="-122"/>
+                <a:ea typeface="Microsoft YaHei" panose="020B0503020204020204" pitchFamily="34" charset="-122"/>
+              </a:rPr>
+              <a:t>活跃</a:t>
+            </a:r>
+            <a:r>
+              <a:rPr lang="en-US" altLang="zh-CN" sz="1200">
+                <a:solidFill>
+                  <a:srgbClr val="505046"/>
+                </a:solidFill>
+                <a:latin typeface="Microsoft YaHei" panose="020B0503020204020204" pitchFamily="34" charset="-122"/>
+                <a:ea typeface="Microsoft YaHei" panose="020B0503020204020204" pitchFamily="34" charset="-122"/>
+              </a:rPr>
+              <a:t>____</a:t>
+            </a:r>
+            <a:r>
+              <a:rPr lang="zh-CN" altLang="en-US" sz="1200">
+                <a:solidFill>
+                  <a:srgbClr val="505046"/>
+                </a:solidFill>
+                <a:latin typeface="Microsoft YaHei" panose="020B0503020204020204" pitchFamily="34" charset="-122"/>
+                <a:ea typeface="Microsoft YaHei" panose="020B0503020204020204" pitchFamily="34" charset="-122"/>
+              </a:rPr>
+              <a:t>家 </a:t>
+            </a:r>
+            <a:r>
+              <a:rPr lang="en-US" altLang="zh-CN" sz="1200">
+                <a:solidFill>
+                  <a:srgbClr val="505046"/>
+                </a:solidFill>
+                <a:latin typeface="Microsoft YaHei" panose="020B0503020204020204" pitchFamily="34" charset="-122"/>
+                <a:ea typeface="Microsoft YaHei" panose="020B0503020204020204" pitchFamily="34" charset="-122"/>
+              </a:rPr>
+              <a:t>× </a:t>
+            </a:r>
+            <a:r>
+              <a:rPr lang="zh-CN" altLang="en-US" sz="1200">
+                <a:solidFill>
+                  <a:srgbClr val="505046"/>
+                </a:solidFill>
+                <a:latin typeface="Microsoft YaHei" panose="020B0503020204020204" pitchFamily="34" charset="-122"/>
+                <a:ea typeface="Microsoft YaHei" panose="020B0503020204020204" pitchFamily="34" charset="-122"/>
+              </a:rPr>
+              <a:t>单店</a:t>
+            </a:r>
+            <a:r>
+              <a:rPr lang="en-US" altLang="zh-CN" sz="1200">
+                <a:solidFill>
+                  <a:srgbClr val="505046"/>
+                </a:solidFill>
+                <a:latin typeface="Microsoft YaHei" panose="020B0503020204020204" pitchFamily="34" charset="-122"/>
+                <a:ea typeface="Microsoft YaHei" panose="020B0503020204020204" pitchFamily="34" charset="-122"/>
+              </a:rPr>
+              <a:t>____</a:t>
+            </a:r>
+            <a:r>
+              <a:rPr lang="zh-CN" altLang="en-US" sz="1200">
+                <a:solidFill>
+                  <a:srgbClr val="505046"/>
+                </a:solidFill>
+                <a:latin typeface="Microsoft YaHei" panose="020B0503020204020204" pitchFamily="34" charset="-122"/>
+                <a:ea typeface="Microsoft YaHei" panose="020B0503020204020204" pitchFamily="34" charset="-122"/>
+              </a:rPr>
+              <a:t>元</a:t>
+            </a:r>
+          </a:p>
+        </p:txBody>
+      </p:sp>
+      <p:sp>
+        <p:nvSpPr>
+          <p:cNvPr id="18" name="CORE_BAND">
+            <a:extLst>
+              <a:ext uri="{FF2B5EF4-FFF2-40B4-BE49-F238E27FC236}">
+                <a16:creationId xmlns:a16="http://schemas.microsoft.com/office/drawing/2014/main" id="{944E7E92-4CA7-FA8A-CDAF-DC82532CFD77}"/>
+              </a:ext>
+            </a:extLst>
+          </p:cNvPr>
+          <p:cNvSpPr/>
+          <p:nvPr/>
+        </p:nvSpPr>
+        <p:spPr>
+          <a:xfrm>
+            <a:off x="548640" y="4023360"/>
+            <a:ext cx="11064240" cy="1143000"/>
+          </a:xfrm>
+          <a:prstGeom prst="rect">
+            <a:avLst/>
+          </a:prstGeom>
+          <a:solidFill>
+            <a:srgbClr val="505046"/>
+          </a:solidFill>
+          <a:ln w="9525">
+            <a:solidFill>
+              <a:srgbClr val="505046"/>
+            </a:solidFill>
+          </a:ln>
+        </p:spPr>
+        <p:style>
+          <a:lnRef idx="2">
+            <a:schemeClr val="accent1">
+              <a:shade val="15000"/>
+            </a:schemeClr>
+          </a:lnRef>
+          <a:fillRef idx="1">
+            <a:schemeClr val="accent1"/>
+          </a:fillRef>
+          <a:effectRef idx="0">
+            <a:schemeClr val="accent1"/>
+          </a:effectRef>
+          <a:fontRef idx="minor">
+            <a:schemeClr val="lt1"/>
+          </a:fontRef>
+        </p:style>
+        <p:txBody>
+          <a:bodyPr rtlCol="0" anchor="ctr"/>
+          <a:lstStyle/>
+          <a:p>
+            <a:pPr algn="ctr"/>
+            <a:endParaRPr lang="zh-CN" altLang="en-US"/>
+          </a:p>
+        </p:txBody>
+      </p:sp>
+      <p:sp>
+        <p:nvSpPr>
+          <p:cNvPr id="19" name="CORE_TITLE">
+            <a:extLst>
+              <a:ext uri="{FF2B5EF4-FFF2-40B4-BE49-F238E27FC236}">
+                <a16:creationId xmlns:a16="http://schemas.microsoft.com/office/drawing/2014/main" id="{A83C6291-D2E9-3192-ACFA-48A8570C0EF1}"/>
+              </a:ext>
+            </a:extLst>
+          </p:cNvPr>
+          <p:cNvSpPr txBox="1"/>
+          <p:nvPr/>
+        </p:nvSpPr>
+        <p:spPr>
+          <a:xfrm>
+            <a:off x="777240" y="4187952"/>
+            <a:ext cx="2377440" cy="369332"/>
+          </a:xfrm>
+          <a:prstGeom prst="rect">
+            <a:avLst/>
+          </a:prstGeom>
+          <a:noFill/>
+        </p:spPr>
+        <p:txBody>
+          <a:bodyPr vert="horz" wrap="square" rtlCol="0">
+            <a:noAutofit/>
+          </a:bodyPr>
+          <a:lstStyle/>
+          <a:p>
+            <a:r>
+              <a:rPr lang="zh-CN" altLang="en-US" sz="1500" b="1">
+                <a:solidFill>
+                  <a:srgbClr val="FFFFFF"/>
+                </a:solidFill>
+                <a:latin typeface="Microsoft YaHei" panose="020B0503020204020204" pitchFamily="34" charset="-122"/>
+                <a:ea typeface="Microsoft YaHei" panose="020B0503020204020204" pitchFamily="34" charset="-122"/>
+              </a:rPr>
+              <a:t>主矛盾判断</a:t>
+            </a:r>
+          </a:p>
+        </p:txBody>
+      </p:sp>
+      <p:sp>
+        <p:nvSpPr>
+          <p:cNvPr id="20" name="CORE_FINDING">
+            <a:extLst>
+              <a:ext uri="{FF2B5EF4-FFF2-40B4-BE49-F238E27FC236}">
+                <a16:creationId xmlns:a16="http://schemas.microsoft.com/office/drawing/2014/main" id="{D1FB3717-3834-6744-AF3F-72730F2336B0}"/>
+              </a:ext>
+            </a:extLst>
+          </p:cNvPr>
+          <p:cNvSpPr txBox="1"/>
+          <p:nvPr/>
+        </p:nvSpPr>
+        <p:spPr>
+          <a:xfrm>
+            <a:off x="3291840" y="4224528"/>
+            <a:ext cx="8138160" cy="369332"/>
+          </a:xfrm>
+          <a:prstGeom prst="rect">
+            <a:avLst/>
+          </a:prstGeom>
+          <a:noFill/>
+        </p:spPr>
+        <p:txBody>
+          <a:bodyPr vert="horz" wrap="square" rtlCol="0">
+            <a:noAutofit/>
+          </a:bodyPr>
+          <a:lstStyle/>
+          <a:p>
+            <a:r>
+              <a:rPr lang="zh-CN" altLang="en-US" sz="1500">
+                <a:solidFill>
+                  <a:srgbClr val="FFFFFF"/>
+                </a:solidFill>
+                <a:latin typeface="Microsoft YaHei" panose="020B0503020204020204" pitchFamily="34" charset="-122"/>
+                <a:ea typeface="Microsoft YaHei" panose="020B0503020204020204" pitchFamily="34" charset="-122"/>
+              </a:rPr>
+              <a:t>当前最卡：</a:t>
+            </a:r>
+            <a:r>
+              <a:rPr lang="en-US" altLang="zh-CN" sz="1500">
+                <a:solidFill>
+                  <a:srgbClr val="FFFFFF"/>
+                </a:solidFill>
+                <a:latin typeface="Microsoft YaHei" panose="020B0503020204020204" pitchFamily="34" charset="-122"/>
+                <a:ea typeface="Microsoft YaHei" panose="020B0503020204020204" pitchFamily="34" charset="-122"/>
+              </a:rPr>
+              <a:t>____</a:t>
+            </a:r>
+            <a:r>
+              <a:rPr lang="zh-CN" altLang="en-US" sz="1500">
+                <a:solidFill>
+                  <a:srgbClr val="FFFFFF"/>
+                </a:solidFill>
+                <a:latin typeface="Microsoft YaHei" panose="020B0503020204020204" pitchFamily="34" charset="-122"/>
+                <a:ea typeface="Microsoft YaHei" panose="020B0503020204020204" pitchFamily="34" charset="-122"/>
+              </a:rPr>
+              <a:t>杠杆（依据：</a:t>
+            </a:r>
+            <a:r>
+              <a:rPr lang="en-US" altLang="zh-CN" sz="1500">
+                <a:solidFill>
+                  <a:srgbClr val="FFFFFF"/>
+                </a:solidFill>
+                <a:latin typeface="Microsoft YaHei" panose="020B0503020204020204" pitchFamily="34" charset="-122"/>
+                <a:ea typeface="Microsoft YaHei" panose="020B0503020204020204" pitchFamily="34" charset="-122"/>
+              </a:rPr>
+              <a:t>____</a:t>
+            </a:r>
+            <a:r>
+              <a:rPr lang="zh-CN" altLang="en-US" sz="1500">
+                <a:solidFill>
+                  <a:srgbClr val="FFFFFF"/>
+                </a:solidFill>
+                <a:latin typeface="Microsoft YaHei" panose="020B0503020204020204" pitchFamily="34" charset="-122"/>
+                <a:ea typeface="Microsoft YaHei" panose="020B0503020204020204" pitchFamily="34" charset="-122"/>
+              </a:rPr>
+              <a:t>）</a:t>
+            </a:r>
+          </a:p>
+        </p:txBody>
+      </p:sp>
+      <p:sp>
+        <p:nvSpPr>
+          <p:cNvPr id="21" name="POOL_TITLE">
+            <a:extLst>
+              <a:ext uri="{FF2B5EF4-FFF2-40B4-BE49-F238E27FC236}">
+                <a16:creationId xmlns:a16="http://schemas.microsoft.com/office/drawing/2014/main" id="{79757373-5D87-C86D-15D7-B127F74AA623}"/>
+              </a:ext>
+            </a:extLst>
+          </p:cNvPr>
+          <p:cNvSpPr txBox="1"/>
+          <p:nvPr/>
+        </p:nvSpPr>
+        <p:spPr>
+          <a:xfrm>
+            <a:off x="548640" y="5394960"/>
+            <a:ext cx="2194560" cy="369332"/>
+          </a:xfrm>
+          <a:prstGeom prst="rect">
+            <a:avLst/>
+          </a:prstGeom>
+          <a:noFill/>
+        </p:spPr>
+        <p:txBody>
+          <a:bodyPr vert="horz" wrap="square" rtlCol="0">
+            <a:noAutofit/>
+          </a:bodyPr>
+          <a:lstStyle/>
+          <a:p>
+            <a:r>
+              <a:rPr lang="zh-CN" altLang="en-US" sz="1500" b="1">
+                <a:solidFill>
+                  <a:srgbClr val="E84C22"/>
+                </a:solidFill>
+                <a:latin typeface="Microsoft YaHei" panose="020B0503020204020204" pitchFamily="34" charset="-122"/>
+                <a:ea typeface="Microsoft YaHei" panose="020B0503020204020204" pitchFamily="34" charset="-122"/>
+              </a:rPr>
+              <a:t>重点网点池</a:t>
+            </a:r>
+          </a:p>
+        </p:txBody>
+      </p:sp>
+      <p:sp>
+        <p:nvSpPr>
+          <p:cNvPr id="22" name="POOL_TEXT">
+            <a:extLst>
+              <a:ext uri="{FF2B5EF4-FFF2-40B4-BE49-F238E27FC236}">
+                <a16:creationId xmlns:a16="http://schemas.microsoft.com/office/drawing/2014/main" id="{5F7505BF-E2B7-1B78-46B2-BBF238174989}"/>
+              </a:ext>
+            </a:extLst>
+          </p:cNvPr>
+          <p:cNvSpPr txBox="1"/>
+          <p:nvPr/>
+        </p:nvSpPr>
+        <p:spPr>
+          <a:xfrm>
+            <a:off x="2834640" y="5394960"/>
+            <a:ext cx="8778240" cy="369332"/>
+          </a:xfrm>
+          <a:prstGeom prst="rect">
+            <a:avLst/>
+          </a:prstGeom>
+          <a:noFill/>
+        </p:spPr>
+        <p:txBody>
+          <a:bodyPr vert="horz" wrap="square" rtlCol="0">
+            <a:noAutofit/>
+          </a:bodyPr>
+          <a:lstStyle/>
+          <a:p>
+            <a:r>
+              <a:rPr lang="zh-CN" altLang="en-US" sz="1400">
+                <a:solidFill>
+                  <a:srgbClr val="505046"/>
+                </a:solidFill>
+                <a:latin typeface="Microsoft YaHei" panose="020B0503020204020204" pitchFamily="34" charset="-122"/>
+                <a:ea typeface="Microsoft YaHei" panose="020B0503020204020204" pitchFamily="34" charset="-122"/>
+              </a:rPr>
+              <a:t>圈定</a:t>
+            </a:r>
+            <a:r>
+              <a:rPr lang="en-US" altLang="zh-CN" sz="1400">
+                <a:solidFill>
+                  <a:srgbClr val="505046"/>
+                </a:solidFill>
+                <a:latin typeface="Microsoft YaHei" panose="020B0503020204020204" pitchFamily="34" charset="-122"/>
+                <a:ea typeface="Microsoft YaHei" panose="020B0503020204020204" pitchFamily="34" charset="-122"/>
+              </a:rPr>
+              <a:t>____</a:t>
+            </a:r>
+            <a:r>
+              <a:rPr lang="zh-CN" altLang="en-US" sz="1400">
+                <a:solidFill>
+                  <a:srgbClr val="505046"/>
+                </a:solidFill>
+                <a:latin typeface="Microsoft YaHei" panose="020B0503020204020204" pitchFamily="34" charset="-122"/>
+                <a:ea typeface="Microsoft YaHei" panose="020B0503020204020204" pitchFamily="34" charset="-122"/>
+              </a:rPr>
+              <a:t>个重点网点：</a:t>
+            </a:r>
+            <a:r>
+              <a:rPr lang="en-US" altLang="zh-CN" sz="1400">
+                <a:solidFill>
+                  <a:srgbClr val="505046"/>
+                </a:solidFill>
+                <a:latin typeface="Microsoft YaHei" panose="020B0503020204020204" pitchFamily="34" charset="-122"/>
+                <a:ea typeface="Microsoft YaHei" panose="020B0503020204020204" pitchFamily="34" charset="-122"/>
+              </a:rPr>
+              <a:t>____</a:t>
+            </a:r>
+            <a:endParaRPr lang="zh-CN" altLang="en-US" sz="1400">
+              <a:solidFill>
+                <a:srgbClr val="505046"/>
+              </a:solidFill>
+              <a:latin typeface="Microsoft YaHei" panose="020B0503020204020204" pitchFamily="34" charset="-122"/>
+              <a:ea typeface="Microsoft YaHei" panose="020B0503020204020204" pitchFamily="34" charset="-122"/>
+            </a:endParaRPr>
+          </a:p>
+        </p:txBody>
+      </p:sp>
+      <p:sp>
+        <p:nvSpPr>
+          <p:cNvPr id="23" name="TEACHING_CUE">
+            <a:extLst>
+              <a:ext uri="{FF2B5EF4-FFF2-40B4-BE49-F238E27FC236}">
+                <a16:creationId xmlns:a16="http://schemas.microsoft.com/office/drawing/2014/main" id="{E0D39E11-AA9E-1E34-B985-6856B0AAB740}"/>
+              </a:ext>
+            </a:extLst>
+          </p:cNvPr>
+          <p:cNvSpPr txBox="1"/>
+          <p:nvPr/>
+        </p:nvSpPr>
+        <p:spPr>
+          <a:xfrm>
+            <a:off x="548640" y="6126480"/>
+            <a:ext cx="11064240" cy="369332"/>
+          </a:xfrm>
+          <a:prstGeom prst="rect">
+            <a:avLst/>
+          </a:prstGeom>
+          <a:noFill/>
+        </p:spPr>
+        <p:txBody>
+          <a:bodyPr vert="horz" wrap="square" rtlCol="0">
+            <a:noAutofit/>
+          </a:bodyPr>
+          <a:lstStyle/>
+          <a:p>
+            <a:r>
+              <a:rPr lang="zh-CN" altLang="en-US" sz="1200">
+                <a:solidFill>
+                  <a:srgbClr val="6F6F6A"/>
+                </a:solidFill>
+                <a:latin typeface="Microsoft YaHei" panose="020B0503020204020204" pitchFamily="34" charset="-122"/>
+                <a:ea typeface="Microsoft YaHei" panose="020B0503020204020204" pitchFamily="34" charset="-122"/>
+              </a:rPr>
+              <a:t>根据数据只突出一个主杠杆，其余作为约束项；指标口径必须一致，口径不一致会产生伪诊断。</a:t>
+            </a:r>
+          </a:p>
+        </p:txBody>
+      </p:sp>
+    </p:spTree>
+    <p:extLst>
+      <p:ext uri="{BB962C8B-B14F-4D97-AF65-F5344CB8AC3E}">
+        <p14:creationId xmlns:p14="http://schemas.microsoft.com/office/powerpoint/2010/main" val="2180636942"/>
       </p:ext>
     </p:extLst>
   </p:cSld>

</xml_diff>

<commit_message>
End-to-end pipeline validation: I1 Ask-Then-Reveal as first interactive source page
Full production line run: registry one-line change (I1 card -> executable) -> build-i1.ps1 (ASCII script, theme tokens) on work copy -> slide 9 (id 264#) -> structural verify (12 objects, token colors only) -> render preview component-09.png -> generator updates index (25) + catalog (9 executable, deck SHA 1DD3E475) -> contact sheet 9 cells -> promote to official deck -> slot contract + build contract SHA synced. Validates: one registry edit + three commands now yields a fully registered executable component.
</commit_message>
<xml_diff>
--- a/domains/yuhong/assets/components/yuhong-county-course-components-branded.pptx
+++ b/domains/yuhong/assets/components/yuhong-county-course-components-branded.pptx
@@ -5,7 +5,7 @@
     <p:sldMasterId id="2147483648" r:id="rId1"/>
   </p:sldMasterIdLst>
   <p:notesMasterIdLst>
-    <p:notesMasterId r:id="rId10"/>
+    <p:notesMasterId r:id="rId11"/>
   </p:notesMasterIdLst>
   <p:sldIdLst>
     <p:sldId id="256" r:id="rId2"/>
@@ -16,6 +16,7 @@
     <p:sldId id="261" r:id="rId7"/>
     <p:sldId id="262" r:id="rId8"/>
     <p:sldId id="263" r:id="rId9"/>
+    <p:sldId id="264" r:id="rId10"/>
   </p:sldIdLst>
   <p:sldSz cx="12192000" cy="6858000"/>
   <p:notesSz cx="6858000" cy="9144000"/>
@@ -13773,6 +13774,600 @@
     <p:extLst>
       <p:ext uri="{BB962C8B-B14F-4D97-AF65-F5344CB8AC3E}">
         <p14:creationId xmlns:p14="http://schemas.microsoft.com/office/powerpoint/2010/main" val="2180636942"/>
+      </p:ext>
+    </p:extLst>
+  </p:cSld>
+  <p:clrMapOvr>
+    <a:masterClrMapping/>
+  </p:clrMapOvr>
+</p:sld>
+</file>
+
+<file path=ppt/slides/slide9.xml><?xml version="1.0" encoding="utf-8"?>
+<p:sld xmlns:a="http://schemas.openxmlformats.org/drawingml/2006/main" xmlns:r="http://schemas.openxmlformats.org/officeDocument/2006/relationships" xmlns:p="http://schemas.openxmlformats.org/presentationml/2006/main">
+  <p:cSld>
+    <p:spTree>
+      <p:nvGrpSpPr>
+        <p:cNvPr id="1" name=""/>
+        <p:cNvGrpSpPr/>
+        <p:nvPr/>
+      </p:nvGrpSpPr>
+      <p:grpSpPr>
+        <a:xfrm>
+          <a:off x="0" y="0"/>
+          <a:ext cx="0" cy="0"/>
+          <a:chOff x="0" y="0"/>
+          <a:chExt cx="0" cy="0"/>
+        </a:xfrm>
+      </p:grpSpPr>
+      <p:sp>
+        <p:nvSpPr>
+          <p:cNvPr id="2" name="TITLE">
+            <a:extLst>
+              <a:ext uri="{FF2B5EF4-FFF2-40B4-BE49-F238E27FC236}">
+                <a16:creationId xmlns:a16="http://schemas.microsoft.com/office/drawing/2014/main" id="{ACBC54E2-9E63-8162-495E-35E6515F33B8}"/>
+              </a:ext>
+            </a:extLst>
+          </p:cNvPr>
+          <p:cNvSpPr txBox="1"/>
+          <p:nvPr/>
+        </p:nvSpPr>
+        <p:spPr>
+          <a:xfrm>
+            <a:off x="548640" y="384048"/>
+            <a:ext cx="10789920" cy="369332"/>
+          </a:xfrm>
+          <a:prstGeom prst="rect">
+            <a:avLst/>
+          </a:prstGeom>
+          <a:noFill/>
+        </p:spPr>
+        <p:txBody>
+          <a:bodyPr vert="horz" wrap="square" rtlCol="0">
+            <a:noAutofit/>
+          </a:bodyPr>
+          <a:lstStyle/>
+          <a:p>
+            <a:r>
+              <a:rPr lang="zh-CN" altLang="en-US" sz="2800" b="1">
+                <a:solidFill>
+                  <a:srgbClr val="505046"/>
+                </a:solidFill>
+                <a:latin typeface="Microsoft YaHei" panose="020B0503020204020204" pitchFamily="34" charset="-122"/>
+                <a:ea typeface="Microsoft YaHei" panose="020B0503020204020204" pitchFamily="34" charset="-122"/>
+              </a:rPr>
+              <a:t>国家资源是不是离开县域了？</a:t>
+            </a:r>
+          </a:p>
+        </p:txBody>
+      </p:sp>
+      <p:sp>
+        <p:nvSpPr>
+          <p:cNvPr id="3" name="ASK_PROMPT">
+            <a:extLst>
+              <a:ext uri="{FF2B5EF4-FFF2-40B4-BE49-F238E27FC236}">
+                <a16:creationId xmlns:a16="http://schemas.microsoft.com/office/drawing/2014/main" id="{48762A02-FA42-56BB-CE51-1EBBF0035643}"/>
+              </a:ext>
+            </a:extLst>
+          </p:cNvPr>
+          <p:cNvSpPr txBox="1"/>
+          <p:nvPr/>
+        </p:nvSpPr>
+        <p:spPr>
+          <a:xfrm>
+            <a:off x="548640" y="1554480"/>
+            <a:ext cx="10789920" cy="369332"/>
+          </a:xfrm>
+          <a:prstGeom prst="rect">
+            <a:avLst/>
+          </a:prstGeom>
+          <a:noFill/>
+        </p:spPr>
+        <p:txBody>
+          <a:bodyPr vert="horz" wrap="square" rtlCol="0">
+            <a:noAutofit/>
+          </a:bodyPr>
+          <a:lstStyle/>
+          <a:p>
+            <a:r>
+              <a:rPr lang="zh-CN" altLang="en-US" sz="1600" b="1">
+                <a:solidFill>
+                  <a:srgbClr val="E84C22"/>
+                </a:solidFill>
+                <a:latin typeface="Microsoft YaHei" panose="020B0503020204020204" pitchFamily="34" charset="-122"/>
+                <a:ea typeface="Microsoft YaHei" panose="020B0503020204020204" pitchFamily="34" charset="-122"/>
+              </a:rPr>
+              <a:t>先表态：国家资源离开县域了吗？</a:t>
+            </a:r>
+          </a:p>
+        </p:txBody>
+      </p:sp>
+      <p:sp>
+        <p:nvSpPr>
+          <p:cNvPr id="4" name="OPT_BAND_1">
+            <a:extLst>
+              <a:ext uri="{FF2B5EF4-FFF2-40B4-BE49-F238E27FC236}">
+                <a16:creationId xmlns:a16="http://schemas.microsoft.com/office/drawing/2014/main" id="{8DF92F48-4AB2-897E-70C5-DBBD2B435AFC}"/>
+              </a:ext>
+            </a:extLst>
+          </p:cNvPr>
+          <p:cNvSpPr/>
+          <p:nvPr/>
+        </p:nvSpPr>
+        <p:spPr>
+          <a:xfrm>
+            <a:off x="548640" y="2148840"/>
+            <a:ext cx="10789920" cy="566928"/>
+          </a:xfrm>
+          <a:prstGeom prst="rect">
+            <a:avLst/>
+          </a:prstGeom>
+          <a:solidFill>
+            <a:srgbClr val="F7F7F8"/>
+          </a:solidFill>
+          <a:ln w="9525">
+            <a:solidFill>
+              <a:srgbClr val="6F6F6A"/>
+            </a:solidFill>
+          </a:ln>
+        </p:spPr>
+        <p:style>
+          <a:lnRef idx="2">
+            <a:schemeClr val="accent1">
+              <a:shade val="15000"/>
+            </a:schemeClr>
+          </a:lnRef>
+          <a:fillRef idx="1">
+            <a:schemeClr val="accent1"/>
+          </a:fillRef>
+          <a:effectRef idx="0">
+            <a:schemeClr val="accent1"/>
+          </a:effectRef>
+          <a:fontRef idx="minor">
+            <a:schemeClr val="lt1"/>
+          </a:fontRef>
+        </p:style>
+        <p:txBody>
+          <a:bodyPr rtlCol="0" anchor="ctr"/>
+          <a:lstStyle/>
+          <a:p>
+            <a:pPr algn="ctr"/>
+            <a:endParaRPr lang="zh-CN" altLang="en-US"/>
+          </a:p>
+        </p:txBody>
+      </p:sp>
+      <p:sp>
+        <p:nvSpPr>
+          <p:cNvPr id="5" name="OPT_1_TEXT">
+            <a:extLst>
+              <a:ext uri="{FF2B5EF4-FFF2-40B4-BE49-F238E27FC236}">
+                <a16:creationId xmlns:a16="http://schemas.microsoft.com/office/drawing/2014/main" id="{E051D4F4-C95F-411B-09B1-2CC24C18104D}"/>
+              </a:ext>
+            </a:extLst>
+          </p:cNvPr>
+          <p:cNvSpPr txBox="1"/>
+          <p:nvPr/>
+        </p:nvSpPr>
+        <p:spPr>
+          <a:xfrm>
+            <a:off x="822960" y="2240280"/>
+            <a:ext cx="10241280" cy="369332"/>
+          </a:xfrm>
+          <a:prstGeom prst="rect">
+            <a:avLst/>
+          </a:prstGeom>
+          <a:noFill/>
+        </p:spPr>
+        <p:txBody>
+          <a:bodyPr vert="horz" wrap="square" rtlCol="0">
+            <a:noAutofit/>
+          </a:bodyPr>
+          <a:lstStyle/>
+          <a:p>
+            <a:r>
+              <a:rPr lang="zh-CN" altLang="en-US" sz="1400">
+                <a:solidFill>
+                  <a:srgbClr val="505046"/>
+                </a:solidFill>
+                <a:latin typeface="Microsoft YaHei" panose="020B0503020204020204" pitchFamily="34" charset="-122"/>
+                <a:ea typeface="Microsoft YaHei" panose="020B0503020204020204" pitchFamily="34" charset="-122"/>
+              </a:rPr>
+              <a:t>离开了，资源都在大城市</a:t>
+            </a:r>
+          </a:p>
+        </p:txBody>
+      </p:sp>
+      <p:sp>
+        <p:nvSpPr>
+          <p:cNvPr id="6" name="OPT_BAND_2">
+            <a:extLst>
+              <a:ext uri="{FF2B5EF4-FFF2-40B4-BE49-F238E27FC236}">
+                <a16:creationId xmlns:a16="http://schemas.microsoft.com/office/drawing/2014/main" id="{D6EBE1B6-3014-E2C5-6A91-DECAA312CE11}"/>
+              </a:ext>
+            </a:extLst>
+          </p:cNvPr>
+          <p:cNvSpPr/>
+          <p:nvPr/>
+        </p:nvSpPr>
+        <p:spPr>
+          <a:xfrm>
+            <a:off x="548640" y="2880360"/>
+            <a:ext cx="10789920" cy="566928"/>
+          </a:xfrm>
+          <a:prstGeom prst="rect">
+            <a:avLst/>
+          </a:prstGeom>
+          <a:solidFill>
+            <a:srgbClr val="EEECE1"/>
+          </a:solidFill>
+          <a:ln w="9525">
+            <a:solidFill>
+              <a:srgbClr val="6F6F6A"/>
+            </a:solidFill>
+          </a:ln>
+        </p:spPr>
+        <p:style>
+          <a:lnRef idx="2">
+            <a:schemeClr val="accent1">
+              <a:shade val="15000"/>
+            </a:schemeClr>
+          </a:lnRef>
+          <a:fillRef idx="1">
+            <a:schemeClr val="accent1"/>
+          </a:fillRef>
+          <a:effectRef idx="0">
+            <a:schemeClr val="accent1"/>
+          </a:effectRef>
+          <a:fontRef idx="minor">
+            <a:schemeClr val="lt1"/>
+          </a:fontRef>
+        </p:style>
+        <p:txBody>
+          <a:bodyPr rtlCol="0" anchor="ctr"/>
+          <a:lstStyle/>
+          <a:p>
+            <a:pPr algn="ctr"/>
+            <a:endParaRPr lang="zh-CN" altLang="en-US"/>
+          </a:p>
+        </p:txBody>
+      </p:sp>
+      <p:sp>
+        <p:nvSpPr>
+          <p:cNvPr id="7" name="OPT_2_TEXT">
+            <a:extLst>
+              <a:ext uri="{FF2B5EF4-FFF2-40B4-BE49-F238E27FC236}">
+                <a16:creationId xmlns:a16="http://schemas.microsoft.com/office/drawing/2014/main" id="{6E51E0B5-18EA-2EAA-2453-03A77C6492D9}"/>
+              </a:ext>
+            </a:extLst>
+          </p:cNvPr>
+          <p:cNvSpPr txBox="1"/>
+          <p:nvPr/>
+        </p:nvSpPr>
+        <p:spPr>
+          <a:xfrm>
+            <a:off x="822960" y="2971800"/>
+            <a:ext cx="10241280" cy="369332"/>
+          </a:xfrm>
+          <a:prstGeom prst="rect">
+            <a:avLst/>
+          </a:prstGeom>
+          <a:noFill/>
+        </p:spPr>
+        <p:txBody>
+          <a:bodyPr vert="horz" wrap="square" rtlCol="0">
+            <a:noAutofit/>
+          </a:bodyPr>
+          <a:lstStyle/>
+          <a:p>
+            <a:r>
+              <a:rPr lang="zh-CN" altLang="en-US" sz="1400">
+                <a:solidFill>
+                  <a:srgbClr val="505046"/>
+                </a:solidFill>
+                <a:latin typeface="Microsoft YaHei" panose="020B0503020204020204" pitchFamily="34" charset="-122"/>
+                <a:ea typeface="Microsoft YaHei" panose="020B0503020204020204" pitchFamily="34" charset="-122"/>
+              </a:rPr>
+              <a:t>没离开，但和政策无关</a:t>
+            </a:r>
+          </a:p>
+        </p:txBody>
+      </p:sp>
+      <p:sp>
+        <p:nvSpPr>
+          <p:cNvPr id="8" name="OPT_BAND_3">
+            <a:extLst>
+              <a:ext uri="{FF2B5EF4-FFF2-40B4-BE49-F238E27FC236}">
+                <a16:creationId xmlns:a16="http://schemas.microsoft.com/office/drawing/2014/main" id="{84ED1604-B9E3-1406-5907-DD91D4E9383C}"/>
+              </a:ext>
+            </a:extLst>
+          </p:cNvPr>
+          <p:cNvSpPr/>
+          <p:nvPr/>
+        </p:nvSpPr>
+        <p:spPr>
+          <a:xfrm>
+            <a:off x="548640" y="3611880"/>
+            <a:ext cx="10789920" cy="566928"/>
+          </a:xfrm>
+          <a:prstGeom prst="rect">
+            <a:avLst/>
+          </a:prstGeom>
+          <a:solidFill>
+            <a:srgbClr val="F7F7F8"/>
+          </a:solidFill>
+          <a:ln w="9525">
+            <a:solidFill>
+              <a:srgbClr val="6F6F6A"/>
+            </a:solidFill>
+          </a:ln>
+        </p:spPr>
+        <p:style>
+          <a:lnRef idx="2">
+            <a:schemeClr val="accent1">
+              <a:shade val="15000"/>
+            </a:schemeClr>
+          </a:lnRef>
+          <a:fillRef idx="1">
+            <a:schemeClr val="accent1"/>
+          </a:fillRef>
+          <a:effectRef idx="0">
+            <a:schemeClr val="accent1"/>
+          </a:effectRef>
+          <a:fontRef idx="minor">
+            <a:schemeClr val="lt1"/>
+          </a:fontRef>
+        </p:style>
+        <p:txBody>
+          <a:bodyPr rtlCol="0" anchor="ctr"/>
+          <a:lstStyle/>
+          <a:p>
+            <a:pPr algn="ctr"/>
+            <a:endParaRPr lang="zh-CN" altLang="en-US"/>
+          </a:p>
+        </p:txBody>
+      </p:sp>
+      <p:sp>
+        <p:nvSpPr>
+          <p:cNvPr id="9" name="OPT_3_TEXT">
+            <a:extLst>
+              <a:ext uri="{FF2B5EF4-FFF2-40B4-BE49-F238E27FC236}">
+                <a16:creationId xmlns:a16="http://schemas.microsoft.com/office/drawing/2014/main" id="{6AC1E4E6-8E1D-C303-D605-18775B001804}"/>
+              </a:ext>
+            </a:extLst>
+          </p:cNvPr>
+          <p:cNvSpPr txBox="1"/>
+          <p:nvPr/>
+        </p:nvSpPr>
+        <p:spPr>
+          <a:xfrm>
+            <a:off x="822960" y="3703320"/>
+            <a:ext cx="10241280" cy="369332"/>
+          </a:xfrm>
+          <a:prstGeom prst="rect">
+            <a:avLst/>
+          </a:prstGeom>
+          <a:noFill/>
+        </p:spPr>
+        <p:txBody>
+          <a:bodyPr vert="horz" wrap="square" rtlCol="0">
+            <a:noAutofit/>
+          </a:bodyPr>
+          <a:lstStyle/>
+          <a:p>
+            <a:r>
+              <a:rPr lang="zh-CN" altLang="en-US" sz="1400">
+                <a:solidFill>
+                  <a:srgbClr val="505046"/>
+                </a:solidFill>
+                <a:latin typeface="Microsoft YaHei" panose="020B0503020204020204" pitchFamily="34" charset="-122"/>
+                <a:ea typeface="Microsoft YaHei" panose="020B0503020204020204" pitchFamily="34" charset="-122"/>
+              </a:rPr>
+              <a:t>没离开，政策会带来真实场景</a:t>
+            </a:r>
+          </a:p>
+        </p:txBody>
+      </p:sp>
+      <p:sp>
+        <p:nvSpPr>
+          <p:cNvPr id="10" name="REVEAL_BAND">
+            <a:extLst>
+              <a:ext uri="{FF2B5EF4-FFF2-40B4-BE49-F238E27FC236}">
+                <a16:creationId xmlns:a16="http://schemas.microsoft.com/office/drawing/2014/main" id="{70C4870A-E77E-AB3C-63BE-E805A22B8F6E}"/>
+              </a:ext>
+            </a:extLst>
+          </p:cNvPr>
+          <p:cNvSpPr/>
+          <p:nvPr/>
+        </p:nvSpPr>
+        <p:spPr>
+          <a:xfrm>
+            <a:off x="548640" y="4526280"/>
+            <a:ext cx="11064240" cy="1463040"/>
+          </a:xfrm>
+          <a:prstGeom prst="rect">
+            <a:avLst/>
+          </a:prstGeom>
+          <a:solidFill>
+            <a:srgbClr val="505046"/>
+          </a:solidFill>
+          <a:ln w="9525">
+            <a:solidFill>
+              <a:srgbClr val="505046"/>
+            </a:solidFill>
+          </a:ln>
+        </p:spPr>
+        <p:style>
+          <a:lnRef idx="2">
+            <a:schemeClr val="accent1">
+              <a:shade val="15000"/>
+            </a:schemeClr>
+          </a:lnRef>
+          <a:fillRef idx="1">
+            <a:schemeClr val="accent1"/>
+          </a:fillRef>
+          <a:effectRef idx="0">
+            <a:schemeClr val="accent1"/>
+          </a:effectRef>
+          <a:fontRef idx="minor">
+            <a:schemeClr val="lt1"/>
+          </a:fontRef>
+        </p:style>
+        <p:txBody>
+          <a:bodyPr rtlCol="0" anchor="ctr"/>
+          <a:lstStyle/>
+          <a:p>
+            <a:pPr algn="ctr"/>
+            <a:endParaRPr lang="zh-CN" altLang="en-US"/>
+          </a:p>
+        </p:txBody>
+      </p:sp>
+      <p:sp>
+        <p:nvSpPr>
+          <p:cNvPr id="11" name="REVEAL_TITLE">
+            <a:extLst>
+              <a:ext uri="{FF2B5EF4-FFF2-40B4-BE49-F238E27FC236}">
+                <a16:creationId xmlns:a16="http://schemas.microsoft.com/office/drawing/2014/main" id="{DA45E95A-6755-09BA-9CAC-042B84BC0009}"/>
+              </a:ext>
+            </a:extLst>
+          </p:cNvPr>
+          <p:cNvSpPr txBox="1"/>
+          <p:nvPr/>
+        </p:nvSpPr>
+        <p:spPr>
+          <a:xfrm>
+            <a:off x="777240" y="4709160"/>
+            <a:ext cx="10058400" cy="369332"/>
+          </a:xfrm>
+          <a:prstGeom prst="rect">
+            <a:avLst/>
+          </a:prstGeom>
+          <a:noFill/>
+        </p:spPr>
+        <p:txBody>
+          <a:bodyPr vert="horz" wrap="square" rtlCol="0">
+            <a:noAutofit/>
+          </a:bodyPr>
+          <a:lstStyle/>
+          <a:p>
+            <a:r>
+              <a:rPr lang="zh-CN" altLang="en-US" sz="1600" b="1">
+                <a:solidFill>
+                  <a:srgbClr val="FFFFFF"/>
+                </a:solidFill>
+                <a:latin typeface="Microsoft YaHei" panose="020B0503020204020204" pitchFamily="34" charset="-122"/>
+                <a:ea typeface="Microsoft YaHei" panose="020B0503020204020204" pitchFamily="34" charset="-122"/>
+              </a:rPr>
+              <a:t>国家资源没有离开县域</a:t>
+            </a:r>
+          </a:p>
+        </p:txBody>
+      </p:sp>
+      <p:sp>
+        <p:nvSpPr>
+          <p:cNvPr id="12" name="REVEAL_TEXT">
+            <a:extLst>
+              <a:ext uri="{FF2B5EF4-FFF2-40B4-BE49-F238E27FC236}">
+                <a16:creationId xmlns:a16="http://schemas.microsoft.com/office/drawing/2014/main" id="{B3FC26CC-DC3B-89D8-12F9-E8BB6C393E1C}"/>
+              </a:ext>
+            </a:extLst>
+          </p:cNvPr>
+          <p:cNvSpPr txBox="1"/>
+          <p:nvPr/>
+        </p:nvSpPr>
+        <p:spPr>
+          <a:xfrm>
+            <a:off x="777240" y="5212080"/>
+            <a:ext cx="10058400" cy="369332"/>
+          </a:xfrm>
+          <a:prstGeom prst="rect">
+            <a:avLst/>
+          </a:prstGeom>
+          <a:noFill/>
+        </p:spPr>
+        <p:txBody>
+          <a:bodyPr vert="horz" wrap="square" rtlCol="0">
+            <a:noAutofit/>
+          </a:bodyPr>
+          <a:lstStyle/>
+          <a:p>
+            <a:r>
+              <a:rPr lang="zh-CN" altLang="en-US" sz="1300">
+                <a:solidFill>
+                  <a:srgbClr val="FFFFFF"/>
+                </a:solidFill>
+                <a:latin typeface="Microsoft YaHei" panose="020B0503020204020204" pitchFamily="34" charset="-122"/>
+                <a:ea typeface="Microsoft YaHei" panose="020B0503020204020204" pitchFamily="34" charset="-122"/>
+              </a:rPr>
+              <a:t>政策方向会翻译成真实场景：县城更新、中心镇集聚、乡村建设、绿色建材下乡。不要只问政策有没有补贴，更要问政策会让哪些地方发生建设、哪些房子需要改善。</a:t>
+            </a:r>
+          </a:p>
+        </p:txBody>
+      </p:sp>
+      <p:sp>
+        <p:nvSpPr>
+          <p:cNvPr id="13" name="TEACHING_CUE">
+            <a:extLst>
+              <a:ext uri="{FF2B5EF4-FFF2-40B4-BE49-F238E27FC236}">
+                <a16:creationId xmlns:a16="http://schemas.microsoft.com/office/drawing/2014/main" id="{82F0EA86-9312-827D-7FAE-CEC56B018354}"/>
+              </a:ext>
+            </a:extLst>
+          </p:cNvPr>
+          <p:cNvSpPr txBox="1"/>
+          <p:nvPr/>
+        </p:nvSpPr>
+        <p:spPr>
+          <a:xfrm>
+            <a:off x="548640" y="6217920"/>
+            <a:ext cx="11064240" cy="369332"/>
+          </a:xfrm>
+          <a:prstGeom prst="rect">
+            <a:avLst/>
+          </a:prstGeom>
+          <a:noFill/>
+        </p:spPr>
+        <p:txBody>
+          <a:bodyPr vert="horz" wrap="square" rtlCol="0">
+            <a:noAutofit/>
+          </a:bodyPr>
+          <a:lstStyle/>
+          <a:p>
+            <a:r>
+              <a:rPr lang="zh-CN" altLang="en-US" sz="1200">
+                <a:solidFill>
+                  <a:srgbClr val="6F6F6A"/>
+                </a:solidFill>
+                <a:latin typeface="Microsoft YaHei" panose="020B0503020204020204" pitchFamily="34" charset="-122"/>
+                <a:ea typeface="Microsoft YaHei" panose="020B0503020204020204" pitchFamily="34" charset="-122"/>
+              </a:rPr>
+              <a:t>先让学员表态（举手</a:t>
+            </a:r>
+            <a:r>
+              <a:rPr lang="en-US" altLang="zh-CN" sz="1200">
+                <a:solidFill>
+                  <a:srgbClr val="6F6F6A"/>
+                </a:solidFill>
+                <a:latin typeface="Microsoft YaHei" panose="020B0503020204020204" pitchFamily="34" charset="-122"/>
+                <a:ea typeface="Microsoft YaHei" panose="020B0503020204020204" pitchFamily="34" charset="-122"/>
+              </a:rPr>
+              <a:t>/</a:t>
+            </a:r>
+            <a:r>
+              <a:rPr lang="zh-CN" altLang="en-US" sz="1200">
+                <a:solidFill>
+                  <a:srgbClr val="6F6F6A"/>
+                </a:solidFill>
+                <a:latin typeface="Microsoft YaHei" panose="020B0503020204020204" pitchFamily="34" charset="-122"/>
+                <a:ea typeface="Microsoft YaHei" panose="020B0503020204020204" pitchFamily="34" charset="-122"/>
+              </a:rPr>
+              <a:t>分组），再揭示；本页不提前讲答案。</a:t>
+            </a:r>
+          </a:p>
+        </p:txBody>
+      </p:sp>
+    </p:spTree>
+    <p:extLst>
+      <p:ext uri="{BB962C8B-B14F-4D97-AF65-F5344CB8AC3E}">
+        <p14:creationId xmlns:p14="http://schemas.microsoft.com/office/powerpoint/2010/main" val="307532519"/>
       </p:ext>
     </p:extLst>
   </p:cSld>

</xml_diff>

<commit_message>
Add DC-16 township priority component (slide 10) via production line; push guideline
Decision-loop gap (region) closed: DC-16 executable (source slide 10, id 265#), candidate evidence cards + 2x2 value-difficulty matrix + resource bet lanes, 38 named objects, token colors only. Full pipeline: build-dc16.ps1 -> verify -> preview component-10.png -> registry update -> generator (index/catalog SHA E84FD46C) -> contact sheet -> promote -> slot contract + build contract synced. Also push component-library-guideline.md (057651d, previously blocked).
</commit_message>
<xml_diff>
--- a/domains/yuhong/assets/components/yuhong-county-course-components-branded.pptx
+++ b/domains/yuhong/assets/components/yuhong-county-course-components-branded.pptx
@@ -5,7 +5,7 @@
     <p:sldMasterId id="2147483648" r:id="rId1"/>
   </p:sldMasterIdLst>
   <p:notesMasterIdLst>
-    <p:notesMasterId r:id="rId11"/>
+    <p:notesMasterId r:id="rId12"/>
   </p:notesMasterIdLst>
   <p:sldIdLst>
     <p:sldId id="256" r:id="rId2"/>
@@ -17,6 +17,7 @@
     <p:sldId id="262" r:id="rId8"/>
     <p:sldId id="263" r:id="rId9"/>
     <p:sldId id="264" r:id="rId10"/>
+    <p:sldId id="265" r:id="rId11"/>
   </p:sldIdLst>
   <p:sldSz cx="12192000" cy="6858000"/>
   <p:notesSz cx="6858000" cy="9144000"/>
@@ -2543,6 +2544,2096 @@
     <p:extLst>
       <p:ext uri="{BB962C8B-B14F-4D97-AF65-F5344CB8AC3E}">
         <p14:creationId xmlns:p14="http://schemas.microsoft.com/office/powerpoint/2010/main" val="822948679"/>
+      </p:ext>
+    </p:extLst>
+  </p:cSld>
+  <p:clrMapOvr>
+    <a:masterClrMapping/>
+  </p:clrMapOvr>
+</p:sld>
+</file>
+
+<file path=ppt/slides/slide10.xml><?xml version="1.0" encoding="utf-8"?>
+<p:sld xmlns:a="http://schemas.openxmlformats.org/drawingml/2006/main" xmlns:r="http://schemas.openxmlformats.org/officeDocument/2006/relationships" xmlns:p="http://schemas.openxmlformats.org/presentationml/2006/main">
+  <p:cSld>
+    <p:spTree>
+      <p:nvGrpSpPr>
+        <p:cNvPr id="1" name=""/>
+        <p:cNvGrpSpPr/>
+        <p:nvPr/>
+      </p:nvGrpSpPr>
+      <p:grpSpPr>
+        <a:xfrm>
+          <a:off x="0" y="0"/>
+          <a:ext cx="0" cy="0"/>
+          <a:chOff x="0" y="0"/>
+          <a:chExt cx="0" cy="0"/>
+        </a:xfrm>
+      </p:grpSpPr>
+      <p:sp>
+        <p:nvSpPr>
+          <p:cNvPr id="2" name="TITLE">
+            <a:extLst>
+              <a:ext uri="{FF2B5EF4-FFF2-40B4-BE49-F238E27FC236}">
+                <a16:creationId xmlns:a16="http://schemas.microsoft.com/office/drawing/2014/main" id="{29A3791F-A759-464A-AAA9-9A49798F3BDD}"/>
+              </a:ext>
+            </a:extLst>
+          </p:cNvPr>
+          <p:cNvSpPr txBox="1"/>
+          <p:nvPr/>
+        </p:nvSpPr>
+        <p:spPr>
+          <a:xfrm>
+            <a:off x="548640" y="384048"/>
+            <a:ext cx="10789920" cy="369332"/>
+          </a:xfrm>
+          <a:prstGeom prst="rect">
+            <a:avLst/>
+          </a:prstGeom>
+          <a:noFill/>
+        </p:spPr>
+        <p:txBody>
+          <a:bodyPr vert="horz" wrap="square" rtlCol="0">
+            <a:noAutofit/>
+          </a:bodyPr>
+          <a:lstStyle/>
+          <a:p>
+            <a:r>
+              <a:rPr lang="zh-CN" altLang="en-US" sz="2600" b="1">
+                <a:solidFill>
+                  <a:srgbClr val="505046"/>
+                </a:solidFill>
+                <a:latin typeface="Microsoft YaHei" panose="020B0503020204020204" pitchFamily="34" charset="-122"/>
+                <a:ea typeface="Microsoft YaHei" panose="020B0503020204020204" pitchFamily="34" charset="-122"/>
+              </a:rPr>
+              <a:t>资源有限，先投哪个乡镇？</a:t>
+            </a:r>
+          </a:p>
+        </p:txBody>
+      </p:sp>
+      <p:sp>
+        <p:nvSpPr>
+          <p:cNvPr id="3" name="SUBTITLE">
+            <a:extLst>
+              <a:ext uri="{FF2B5EF4-FFF2-40B4-BE49-F238E27FC236}">
+                <a16:creationId xmlns:a16="http://schemas.microsoft.com/office/drawing/2014/main" id="{E451F756-0A7D-69C0-C525-584CC5B535C2}"/>
+              </a:ext>
+            </a:extLst>
+          </p:cNvPr>
+          <p:cNvSpPr txBox="1"/>
+          <p:nvPr/>
+        </p:nvSpPr>
+        <p:spPr>
+          <a:xfrm>
+            <a:off x="548640" y="960120"/>
+            <a:ext cx="10789920" cy="369332"/>
+          </a:xfrm>
+          <a:prstGeom prst="rect">
+            <a:avLst/>
+          </a:prstGeom>
+          <a:noFill/>
+        </p:spPr>
+        <p:txBody>
+          <a:bodyPr vert="horz" wrap="square" rtlCol="0">
+            <a:noAutofit/>
+          </a:bodyPr>
+          <a:lstStyle/>
+          <a:p>
+            <a:r>
+              <a:rPr lang="zh-CN" altLang="en-US" sz="1400">
+                <a:solidFill>
+                  <a:srgbClr val="6F6F6A"/>
+                </a:solidFill>
+                <a:latin typeface="Microsoft YaHei" panose="020B0503020204020204" pitchFamily="34" charset="-122"/>
+                <a:ea typeface="Microsoft YaHei" panose="020B0503020204020204" pitchFamily="34" charset="-122"/>
+              </a:rPr>
+              <a:t>按「经营价值 </a:t>
+            </a:r>
+            <a:r>
+              <a:rPr lang="en-US" altLang="zh-CN" sz="1400">
+                <a:solidFill>
+                  <a:srgbClr val="6F6F6A"/>
+                </a:solidFill>
+                <a:latin typeface="Microsoft YaHei" panose="020B0503020204020204" pitchFamily="34" charset="-122"/>
+                <a:ea typeface="Microsoft YaHei" panose="020B0503020204020204" pitchFamily="34" charset="-122"/>
+              </a:rPr>
+              <a:t>× </a:t>
+            </a:r>
+            <a:r>
+              <a:rPr lang="zh-CN" altLang="en-US" sz="1400">
+                <a:solidFill>
+                  <a:srgbClr val="6F6F6A"/>
+                </a:solidFill>
+                <a:latin typeface="Microsoft YaHei" panose="020B0503020204020204" pitchFamily="34" charset="-122"/>
+                <a:ea typeface="Microsoft YaHei" panose="020B0503020204020204" pitchFamily="34" charset="-122"/>
+              </a:rPr>
+              <a:t>攻坚难度」两阶段排序：先看价值，再加难度，最后下注</a:t>
+            </a:r>
+          </a:p>
+        </p:txBody>
+      </p:sp>
+      <p:sp>
+        <p:nvSpPr>
+          <p:cNvPr id="4" name="CAN_TITLE">
+            <a:extLst>
+              <a:ext uri="{FF2B5EF4-FFF2-40B4-BE49-F238E27FC236}">
+                <a16:creationId xmlns:a16="http://schemas.microsoft.com/office/drawing/2014/main" id="{151DC87A-1E68-CB1A-40B3-0D66749257DC}"/>
+              </a:ext>
+            </a:extLst>
+          </p:cNvPr>
+          <p:cNvSpPr txBox="1"/>
+          <p:nvPr/>
+        </p:nvSpPr>
+        <p:spPr>
+          <a:xfrm>
+            <a:off x="548640" y="1463040"/>
+            <a:ext cx="4572000" cy="365760"/>
+          </a:xfrm>
+          <a:prstGeom prst="rect">
+            <a:avLst/>
+          </a:prstGeom>
+          <a:noFill/>
+        </p:spPr>
+        <p:txBody>
+          <a:bodyPr vert="horz" wrap="square" rtlCol="0">
+            <a:noAutofit/>
+          </a:bodyPr>
+          <a:lstStyle/>
+          <a:p>
+            <a:r>
+              <a:rPr lang="zh-CN" altLang="en-US" sz="1500" b="1">
+                <a:solidFill>
+                  <a:srgbClr val="E84C22"/>
+                </a:solidFill>
+                <a:latin typeface="Microsoft YaHei" panose="020B0503020204020204" pitchFamily="34" charset="-122"/>
+                <a:ea typeface="Microsoft YaHei" panose="020B0503020204020204" pitchFamily="34" charset="-122"/>
+              </a:rPr>
+              <a:t>候选证据卡（先按经营价值排序）</a:t>
+            </a:r>
+          </a:p>
+        </p:txBody>
+      </p:sp>
+      <p:sp>
+        <p:nvSpPr>
+          <p:cNvPr id="5" name="CAN_BAND_1">
+            <a:extLst>
+              <a:ext uri="{FF2B5EF4-FFF2-40B4-BE49-F238E27FC236}">
+                <a16:creationId xmlns:a16="http://schemas.microsoft.com/office/drawing/2014/main" id="{F401AAAB-7B58-4FFE-B351-D2B4ABFE90F9}"/>
+              </a:ext>
+            </a:extLst>
+          </p:cNvPr>
+          <p:cNvSpPr/>
+          <p:nvPr/>
+        </p:nvSpPr>
+        <p:spPr>
+          <a:xfrm>
+            <a:off x="548640" y="1920240"/>
+            <a:ext cx="3931920" cy="548640"/>
+          </a:xfrm>
+          <a:prstGeom prst="rect">
+            <a:avLst/>
+          </a:prstGeom>
+          <a:solidFill>
+            <a:srgbClr val="F7F7F8"/>
+          </a:solidFill>
+          <a:ln w="9525">
+            <a:solidFill>
+              <a:srgbClr val="6F6F6A"/>
+            </a:solidFill>
+          </a:ln>
+        </p:spPr>
+        <p:style>
+          <a:lnRef idx="2">
+            <a:schemeClr val="accent1">
+              <a:shade val="15000"/>
+            </a:schemeClr>
+          </a:lnRef>
+          <a:fillRef idx="1">
+            <a:schemeClr val="accent1"/>
+          </a:fillRef>
+          <a:effectRef idx="0">
+            <a:schemeClr val="accent1"/>
+          </a:effectRef>
+          <a:fontRef idx="minor">
+            <a:schemeClr val="lt1"/>
+          </a:fontRef>
+        </p:style>
+        <p:txBody>
+          <a:bodyPr rtlCol="0" anchor="ctr"/>
+          <a:lstStyle/>
+          <a:p>
+            <a:pPr algn="ctr"/>
+            <a:endParaRPr lang="zh-CN" altLang="en-US"/>
+          </a:p>
+        </p:txBody>
+      </p:sp>
+      <p:sp>
+        <p:nvSpPr>
+          <p:cNvPr id="6" name="CAN_1_NAME">
+            <a:extLst>
+              <a:ext uri="{FF2B5EF4-FFF2-40B4-BE49-F238E27FC236}">
+                <a16:creationId xmlns:a16="http://schemas.microsoft.com/office/drawing/2014/main" id="{ED1C3FDA-4564-7895-30D8-7068ED20F4FC}"/>
+              </a:ext>
+            </a:extLst>
+          </p:cNvPr>
+          <p:cNvSpPr txBox="1"/>
+          <p:nvPr/>
+        </p:nvSpPr>
+        <p:spPr>
+          <a:xfrm>
+            <a:off x="731520" y="1920240"/>
+            <a:ext cx="3566160" cy="369332"/>
+          </a:xfrm>
+          <a:prstGeom prst="rect">
+            <a:avLst/>
+          </a:prstGeom>
+          <a:noFill/>
+        </p:spPr>
+        <p:txBody>
+          <a:bodyPr vert="horz" wrap="square" rtlCol="0">
+            <a:noAutofit/>
+          </a:bodyPr>
+          <a:lstStyle/>
+          <a:p>
+            <a:r>
+              <a:rPr lang="zh-CN" altLang="en-US" sz="1300" b="1">
+                <a:solidFill>
+                  <a:srgbClr val="505046"/>
+                </a:solidFill>
+                <a:latin typeface="Microsoft YaHei" panose="020B0503020204020204" pitchFamily="34" charset="-122"/>
+                <a:ea typeface="Microsoft YaHei" panose="020B0503020204020204" pitchFamily="34" charset="-122"/>
+              </a:rPr>
+              <a:t>候选 </a:t>
+            </a:r>
+            <a:r>
+              <a:rPr lang="en-US" altLang="zh-CN" sz="1300" b="1">
+                <a:solidFill>
+                  <a:srgbClr val="505046"/>
+                </a:solidFill>
+                <a:latin typeface="Microsoft YaHei" panose="020B0503020204020204" pitchFamily="34" charset="-122"/>
+                <a:ea typeface="Microsoft YaHei" panose="020B0503020204020204" pitchFamily="34" charset="-122"/>
+              </a:rPr>
+              <a:t>A · </a:t>
+            </a:r>
+            <a:r>
+              <a:rPr lang="zh-CN" altLang="en-US" sz="1300" b="1">
+                <a:solidFill>
+                  <a:srgbClr val="505046"/>
+                </a:solidFill>
+                <a:latin typeface="Microsoft YaHei" panose="020B0503020204020204" pitchFamily="34" charset="-122"/>
+                <a:ea typeface="Microsoft YaHei" panose="020B0503020204020204" pitchFamily="34" charset="-122"/>
+              </a:rPr>
+              <a:t>中心镇</a:t>
+            </a:r>
+          </a:p>
+        </p:txBody>
+      </p:sp>
+      <p:sp>
+        <p:nvSpPr>
+          <p:cNvPr id="7" name="CAN_1_EVIDENCE">
+            <a:extLst>
+              <a:ext uri="{FF2B5EF4-FFF2-40B4-BE49-F238E27FC236}">
+                <a16:creationId xmlns:a16="http://schemas.microsoft.com/office/drawing/2014/main" id="{A28A0FDF-D904-56DF-FCD6-FEC3636209D8}"/>
+              </a:ext>
+            </a:extLst>
+          </p:cNvPr>
+          <p:cNvSpPr txBox="1"/>
+          <p:nvPr/>
+        </p:nvSpPr>
+        <p:spPr>
+          <a:xfrm>
+            <a:off x="731520" y="2194560"/>
+            <a:ext cx="3566160" cy="369332"/>
+          </a:xfrm>
+          <a:prstGeom prst="rect">
+            <a:avLst/>
+          </a:prstGeom>
+          <a:noFill/>
+        </p:spPr>
+        <p:txBody>
+          <a:bodyPr vert="horz" wrap="square" rtlCol="0">
+            <a:noAutofit/>
+          </a:bodyPr>
+          <a:lstStyle/>
+          <a:p>
+            <a:r>
+              <a:rPr lang="zh-CN" altLang="en-US" sz="1100">
+                <a:solidFill>
+                  <a:srgbClr val="6F6F6A"/>
+                </a:solidFill>
+                <a:latin typeface="Microsoft YaHei" panose="020B0503020204020204" pitchFamily="34" charset="-122"/>
+                <a:ea typeface="Microsoft YaHei" panose="020B0503020204020204" pitchFamily="34" charset="-122"/>
+              </a:rPr>
+              <a:t>人口与商业集聚，</a:t>
+            </a:r>
+            <a:r>
+              <a:rPr lang="en-US" altLang="zh-CN" sz="1100">
+                <a:solidFill>
+                  <a:srgbClr val="6F6F6A"/>
+                </a:solidFill>
+                <a:latin typeface="Microsoft YaHei" panose="020B0503020204020204" pitchFamily="34" charset="-122"/>
+                <a:ea typeface="Microsoft YaHei" panose="020B0503020204020204" pitchFamily="34" charset="-122"/>
+              </a:rPr>
+              <a:t>3 </a:t>
+            </a:r>
+            <a:r>
+              <a:rPr lang="zh-CN" altLang="en-US" sz="1100">
+                <a:solidFill>
+                  <a:srgbClr val="6F6F6A"/>
+                </a:solidFill>
+                <a:latin typeface="Microsoft YaHei" panose="020B0503020204020204" pitchFamily="34" charset="-122"/>
+                <a:ea typeface="Microsoft YaHei" panose="020B0503020204020204" pitchFamily="34" charset="-122"/>
+              </a:rPr>
+              <a:t>家活跃网点，有项目线索</a:t>
+            </a:r>
+          </a:p>
+        </p:txBody>
+      </p:sp>
+      <p:sp>
+        <p:nvSpPr>
+          <p:cNvPr id="8" name="CAN_BAND_2">
+            <a:extLst>
+              <a:ext uri="{FF2B5EF4-FFF2-40B4-BE49-F238E27FC236}">
+                <a16:creationId xmlns:a16="http://schemas.microsoft.com/office/drawing/2014/main" id="{F61BD6D6-0074-53D5-2AC3-4C332A354CFD}"/>
+              </a:ext>
+            </a:extLst>
+          </p:cNvPr>
+          <p:cNvSpPr/>
+          <p:nvPr/>
+        </p:nvSpPr>
+        <p:spPr>
+          <a:xfrm>
+            <a:off x="548640" y="2606040"/>
+            <a:ext cx="3931920" cy="548640"/>
+          </a:xfrm>
+          <a:prstGeom prst="rect">
+            <a:avLst/>
+          </a:prstGeom>
+          <a:solidFill>
+            <a:srgbClr val="EEECE1"/>
+          </a:solidFill>
+          <a:ln w="9525">
+            <a:solidFill>
+              <a:srgbClr val="6F6F6A"/>
+            </a:solidFill>
+          </a:ln>
+        </p:spPr>
+        <p:style>
+          <a:lnRef idx="2">
+            <a:schemeClr val="accent1">
+              <a:shade val="15000"/>
+            </a:schemeClr>
+          </a:lnRef>
+          <a:fillRef idx="1">
+            <a:schemeClr val="accent1"/>
+          </a:fillRef>
+          <a:effectRef idx="0">
+            <a:schemeClr val="accent1"/>
+          </a:effectRef>
+          <a:fontRef idx="minor">
+            <a:schemeClr val="lt1"/>
+          </a:fontRef>
+        </p:style>
+        <p:txBody>
+          <a:bodyPr rtlCol="0" anchor="ctr"/>
+          <a:lstStyle/>
+          <a:p>
+            <a:pPr algn="ctr"/>
+            <a:endParaRPr lang="zh-CN" altLang="en-US"/>
+          </a:p>
+        </p:txBody>
+      </p:sp>
+      <p:sp>
+        <p:nvSpPr>
+          <p:cNvPr id="9" name="CAN_2_NAME">
+            <a:extLst>
+              <a:ext uri="{FF2B5EF4-FFF2-40B4-BE49-F238E27FC236}">
+                <a16:creationId xmlns:a16="http://schemas.microsoft.com/office/drawing/2014/main" id="{3712C16E-5CB7-9681-41D8-10E5124F15E1}"/>
+              </a:ext>
+            </a:extLst>
+          </p:cNvPr>
+          <p:cNvSpPr txBox="1"/>
+          <p:nvPr/>
+        </p:nvSpPr>
+        <p:spPr>
+          <a:xfrm>
+            <a:off x="731520" y="2606040"/>
+            <a:ext cx="3566160" cy="369332"/>
+          </a:xfrm>
+          <a:prstGeom prst="rect">
+            <a:avLst/>
+          </a:prstGeom>
+          <a:noFill/>
+        </p:spPr>
+        <p:txBody>
+          <a:bodyPr vert="horz" wrap="square" rtlCol="0">
+            <a:noAutofit/>
+          </a:bodyPr>
+          <a:lstStyle/>
+          <a:p>
+            <a:r>
+              <a:rPr lang="zh-CN" altLang="en-US" sz="1300" b="1">
+                <a:solidFill>
+                  <a:srgbClr val="505046"/>
+                </a:solidFill>
+                <a:latin typeface="Microsoft YaHei" panose="020B0503020204020204" pitchFamily="34" charset="-122"/>
+                <a:ea typeface="Microsoft YaHei" panose="020B0503020204020204" pitchFamily="34" charset="-122"/>
+              </a:rPr>
+              <a:t>候选 </a:t>
+            </a:r>
+            <a:r>
+              <a:rPr lang="en-US" altLang="zh-CN" sz="1300" b="1">
+                <a:solidFill>
+                  <a:srgbClr val="505046"/>
+                </a:solidFill>
+                <a:latin typeface="Microsoft YaHei" panose="020B0503020204020204" pitchFamily="34" charset="-122"/>
+                <a:ea typeface="Microsoft YaHei" panose="020B0503020204020204" pitchFamily="34" charset="-122"/>
+              </a:rPr>
+              <a:t>B · </a:t>
+            </a:r>
+            <a:r>
+              <a:rPr lang="zh-CN" altLang="en-US" sz="1300" b="1">
+                <a:solidFill>
+                  <a:srgbClr val="505046"/>
+                </a:solidFill>
+                <a:latin typeface="Microsoft YaHei" panose="020B0503020204020204" pitchFamily="34" charset="-122"/>
+                <a:ea typeface="Microsoft YaHei" panose="020B0503020204020204" pitchFamily="34" charset="-122"/>
+              </a:rPr>
+              <a:t>乡镇</a:t>
+            </a:r>
+          </a:p>
+        </p:txBody>
+      </p:sp>
+      <p:sp>
+        <p:nvSpPr>
+          <p:cNvPr id="10" name="CAN_2_EVIDENCE">
+            <a:extLst>
+              <a:ext uri="{FF2B5EF4-FFF2-40B4-BE49-F238E27FC236}">
+                <a16:creationId xmlns:a16="http://schemas.microsoft.com/office/drawing/2014/main" id="{64BE933B-4CD2-2B29-DB16-9CBF5DDE7E90}"/>
+              </a:ext>
+            </a:extLst>
+          </p:cNvPr>
+          <p:cNvSpPr txBox="1"/>
+          <p:nvPr/>
+        </p:nvSpPr>
+        <p:spPr>
+          <a:xfrm>
+            <a:off x="731520" y="2880360"/>
+            <a:ext cx="3566160" cy="369332"/>
+          </a:xfrm>
+          <a:prstGeom prst="rect">
+            <a:avLst/>
+          </a:prstGeom>
+          <a:noFill/>
+        </p:spPr>
+        <p:txBody>
+          <a:bodyPr vert="horz" wrap="square" rtlCol="0">
+            <a:noAutofit/>
+          </a:bodyPr>
+          <a:lstStyle/>
+          <a:p>
+            <a:r>
+              <a:rPr lang="zh-CN" altLang="en-US" sz="1100">
+                <a:solidFill>
+                  <a:srgbClr val="6F6F6A"/>
+                </a:solidFill>
+                <a:latin typeface="Microsoft YaHei" panose="020B0503020204020204" pitchFamily="34" charset="-122"/>
+                <a:ea typeface="Microsoft YaHei" panose="020B0503020204020204" pitchFamily="34" charset="-122"/>
+              </a:rPr>
+              <a:t>自建房多，无网点，老板有熟人关系</a:t>
+            </a:r>
+          </a:p>
+        </p:txBody>
+      </p:sp>
+      <p:sp>
+        <p:nvSpPr>
+          <p:cNvPr id="11" name="CAN_BAND_3">
+            <a:extLst>
+              <a:ext uri="{FF2B5EF4-FFF2-40B4-BE49-F238E27FC236}">
+                <a16:creationId xmlns:a16="http://schemas.microsoft.com/office/drawing/2014/main" id="{E9B95C12-E444-1035-AEC6-9BBB5146B23D}"/>
+              </a:ext>
+            </a:extLst>
+          </p:cNvPr>
+          <p:cNvSpPr/>
+          <p:nvPr/>
+        </p:nvSpPr>
+        <p:spPr>
+          <a:xfrm>
+            <a:off x="548640" y="3291840"/>
+            <a:ext cx="3931920" cy="548640"/>
+          </a:xfrm>
+          <a:prstGeom prst="rect">
+            <a:avLst/>
+          </a:prstGeom>
+          <a:solidFill>
+            <a:srgbClr val="F7F7F8"/>
+          </a:solidFill>
+          <a:ln w="9525">
+            <a:solidFill>
+              <a:srgbClr val="6F6F6A"/>
+            </a:solidFill>
+          </a:ln>
+        </p:spPr>
+        <p:style>
+          <a:lnRef idx="2">
+            <a:schemeClr val="accent1">
+              <a:shade val="15000"/>
+            </a:schemeClr>
+          </a:lnRef>
+          <a:fillRef idx="1">
+            <a:schemeClr val="accent1"/>
+          </a:fillRef>
+          <a:effectRef idx="0">
+            <a:schemeClr val="accent1"/>
+          </a:effectRef>
+          <a:fontRef idx="minor">
+            <a:schemeClr val="lt1"/>
+          </a:fontRef>
+        </p:style>
+        <p:txBody>
+          <a:bodyPr rtlCol="0" anchor="ctr"/>
+          <a:lstStyle/>
+          <a:p>
+            <a:pPr algn="ctr"/>
+            <a:endParaRPr lang="zh-CN" altLang="en-US"/>
+          </a:p>
+        </p:txBody>
+      </p:sp>
+      <p:sp>
+        <p:nvSpPr>
+          <p:cNvPr id="12" name="CAN_3_NAME">
+            <a:extLst>
+              <a:ext uri="{FF2B5EF4-FFF2-40B4-BE49-F238E27FC236}">
+                <a16:creationId xmlns:a16="http://schemas.microsoft.com/office/drawing/2014/main" id="{80CBC99B-6011-59B8-3156-F144B2AAE6CC}"/>
+              </a:ext>
+            </a:extLst>
+          </p:cNvPr>
+          <p:cNvSpPr txBox="1"/>
+          <p:nvPr/>
+        </p:nvSpPr>
+        <p:spPr>
+          <a:xfrm>
+            <a:off x="731520" y="3291840"/>
+            <a:ext cx="3566160" cy="369332"/>
+          </a:xfrm>
+          <a:prstGeom prst="rect">
+            <a:avLst/>
+          </a:prstGeom>
+          <a:noFill/>
+        </p:spPr>
+        <p:txBody>
+          <a:bodyPr vert="horz" wrap="square" rtlCol="0">
+            <a:noAutofit/>
+          </a:bodyPr>
+          <a:lstStyle/>
+          <a:p>
+            <a:r>
+              <a:rPr lang="zh-CN" altLang="en-US" sz="1300" b="1">
+                <a:solidFill>
+                  <a:srgbClr val="505046"/>
+                </a:solidFill>
+                <a:latin typeface="Microsoft YaHei" panose="020B0503020204020204" pitchFamily="34" charset="-122"/>
+                <a:ea typeface="Microsoft YaHei" panose="020B0503020204020204" pitchFamily="34" charset="-122"/>
+              </a:rPr>
+              <a:t>候选 </a:t>
+            </a:r>
+            <a:r>
+              <a:rPr lang="en-US" altLang="zh-CN" sz="1300" b="1">
+                <a:solidFill>
+                  <a:srgbClr val="505046"/>
+                </a:solidFill>
+                <a:latin typeface="Microsoft YaHei" panose="020B0503020204020204" pitchFamily="34" charset="-122"/>
+                <a:ea typeface="Microsoft YaHei" panose="020B0503020204020204" pitchFamily="34" charset="-122"/>
+              </a:rPr>
+              <a:t>C · </a:t>
+            </a:r>
+            <a:r>
+              <a:rPr lang="zh-CN" altLang="en-US" sz="1300" b="1">
+                <a:solidFill>
+                  <a:srgbClr val="505046"/>
+                </a:solidFill>
+                <a:latin typeface="Microsoft YaHei" panose="020B0503020204020204" pitchFamily="34" charset="-122"/>
+                <a:ea typeface="Microsoft YaHei" panose="020B0503020204020204" pitchFamily="34" charset="-122"/>
+              </a:rPr>
+              <a:t>乡镇</a:t>
+            </a:r>
+          </a:p>
+        </p:txBody>
+      </p:sp>
+      <p:sp>
+        <p:nvSpPr>
+          <p:cNvPr id="13" name="CAN_3_EVIDENCE">
+            <a:extLst>
+              <a:ext uri="{FF2B5EF4-FFF2-40B4-BE49-F238E27FC236}">
+                <a16:creationId xmlns:a16="http://schemas.microsoft.com/office/drawing/2014/main" id="{B57CD9E0-5029-344B-1296-5AD48D3E98AD}"/>
+              </a:ext>
+            </a:extLst>
+          </p:cNvPr>
+          <p:cNvSpPr txBox="1"/>
+          <p:nvPr/>
+        </p:nvSpPr>
+        <p:spPr>
+          <a:xfrm>
+            <a:off x="731520" y="3566160"/>
+            <a:ext cx="3566160" cy="369332"/>
+          </a:xfrm>
+          <a:prstGeom prst="rect">
+            <a:avLst/>
+          </a:prstGeom>
+          <a:noFill/>
+        </p:spPr>
+        <p:txBody>
+          <a:bodyPr vert="horz" wrap="square" rtlCol="0">
+            <a:noAutofit/>
+          </a:bodyPr>
+          <a:lstStyle/>
+          <a:p>
+            <a:r>
+              <a:rPr lang="zh-CN" altLang="en-US" sz="1100">
+                <a:solidFill>
+                  <a:srgbClr val="6F6F6A"/>
+                </a:solidFill>
+                <a:latin typeface="Microsoft YaHei" panose="020B0503020204020204" pitchFamily="34" charset="-122"/>
+                <a:ea typeface="Microsoft YaHei" panose="020B0503020204020204" pitchFamily="34" charset="-122"/>
+              </a:rPr>
+              <a:t>项目零散、依赖客情，配送半径外</a:t>
+            </a:r>
+          </a:p>
+        </p:txBody>
+      </p:sp>
+      <p:sp>
+        <p:nvSpPr>
+          <p:cNvPr id="14" name="MATRIX_TITLE">
+            <a:extLst>
+              <a:ext uri="{FF2B5EF4-FFF2-40B4-BE49-F238E27FC236}">
+                <a16:creationId xmlns:a16="http://schemas.microsoft.com/office/drawing/2014/main" id="{4D21C050-1713-EB68-5111-245BE03C9703}"/>
+              </a:ext>
+            </a:extLst>
+          </p:cNvPr>
+          <p:cNvSpPr txBox="1"/>
+          <p:nvPr/>
+        </p:nvSpPr>
+        <p:spPr>
+          <a:xfrm>
+            <a:off x="4754880" y="1463040"/>
+            <a:ext cx="5486400" cy="365760"/>
+          </a:xfrm>
+          <a:prstGeom prst="rect">
+            <a:avLst/>
+          </a:prstGeom>
+          <a:noFill/>
+        </p:spPr>
+        <p:txBody>
+          <a:bodyPr vert="horz" wrap="square" rtlCol="0">
+            <a:noAutofit/>
+          </a:bodyPr>
+          <a:lstStyle/>
+          <a:p>
+            <a:r>
+              <a:rPr lang="zh-CN" altLang="en-US" sz="1500" b="1">
+                <a:solidFill>
+                  <a:srgbClr val="E84C22"/>
+                </a:solidFill>
+                <a:latin typeface="Microsoft YaHei" panose="020B0503020204020204" pitchFamily="34" charset="-122"/>
+                <a:ea typeface="Microsoft YaHei" panose="020B0503020204020204" pitchFamily="34" charset="-122"/>
+              </a:rPr>
+              <a:t>经营价值 </a:t>
+            </a:r>
+            <a:r>
+              <a:rPr lang="en-US" altLang="zh-CN" sz="1500" b="1">
+                <a:solidFill>
+                  <a:srgbClr val="E84C22"/>
+                </a:solidFill>
+                <a:latin typeface="Microsoft YaHei" panose="020B0503020204020204" pitchFamily="34" charset="-122"/>
+                <a:ea typeface="Microsoft YaHei" panose="020B0503020204020204" pitchFamily="34" charset="-122"/>
+              </a:rPr>
+              <a:t>× </a:t>
+            </a:r>
+            <a:r>
+              <a:rPr lang="zh-CN" altLang="en-US" sz="1500" b="1">
+                <a:solidFill>
+                  <a:srgbClr val="E84C22"/>
+                </a:solidFill>
+                <a:latin typeface="Microsoft YaHei" panose="020B0503020204020204" pitchFamily="34" charset="-122"/>
+                <a:ea typeface="Microsoft YaHei" panose="020B0503020204020204" pitchFamily="34" charset="-122"/>
+              </a:rPr>
+              <a:t>攻坚难度</a:t>
+            </a:r>
+          </a:p>
+        </p:txBody>
+      </p:sp>
+      <p:sp>
+        <p:nvSpPr>
+          <p:cNvPr id="15" name="QUAD_Q1">
+            <a:extLst>
+              <a:ext uri="{FF2B5EF4-FFF2-40B4-BE49-F238E27FC236}">
+                <a16:creationId xmlns:a16="http://schemas.microsoft.com/office/drawing/2014/main" id="{602981BB-1F89-C441-673A-5AAE3DAE6AA8}"/>
+              </a:ext>
+            </a:extLst>
+          </p:cNvPr>
+          <p:cNvSpPr/>
+          <p:nvPr/>
+        </p:nvSpPr>
+        <p:spPr>
+          <a:xfrm>
+            <a:off x="4754880" y="1920240"/>
+            <a:ext cx="3200400" cy="1280160"/>
+          </a:xfrm>
+          <a:prstGeom prst="rect">
+            <a:avLst/>
+          </a:prstGeom>
+          <a:solidFill>
+            <a:srgbClr val="F7F7F8"/>
+          </a:solidFill>
+          <a:ln w="9525">
+            <a:solidFill>
+              <a:srgbClr val="6F6F6A"/>
+            </a:solidFill>
+          </a:ln>
+        </p:spPr>
+        <p:style>
+          <a:lnRef idx="2">
+            <a:schemeClr val="accent1">
+              <a:shade val="15000"/>
+            </a:schemeClr>
+          </a:lnRef>
+          <a:fillRef idx="1">
+            <a:schemeClr val="accent1"/>
+          </a:fillRef>
+          <a:effectRef idx="0">
+            <a:schemeClr val="accent1"/>
+          </a:effectRef>
+          <a:fontRef idx="minor">
+            <a:schemeClr val="lt1"/>
+          </a:fontRef>
+        </p:style>
+        <p:txBody>
+          <a:bodyPr rtlCol="0" anchor="ctr"/>
+          <a:lstStyle/>
+          <a:p>
+            <a:pPr algn="ctr"/>
+            <a:endParaRPr lang="zh-CN" altLang="en-US"/>
+          </a:p>
+        </p:txBody>
+      </p:sp>
+      <p:sp>
+        <p:nvSpPr>
+          <p:cNvPr id="16" name="QUAD_Q1_LABEL">
+            <a:extLst>
+              <a:ext uri="{FF2B5EF4-FFF2-40B4-BE49-F238E27FC236}">
+                <a16:creationId xmlns:a16="http://schemas.microsoft.com/office/drawing/2014/main" id="{87254A10-BD0A-68A3-C8B5-D7D395F43E61}"/>
+              </a:ext>
+            </a:extLst>
+          </p:cNvPr>
+          <p:cNvSpPr txBox="1"/>
+          <p:nvPr/>
+        </p:nvSpPr>
+        <p:spPr>
+          <a:xfrm>
+            <a:off x="4892040" y="2011680"/>
+            <a:ext cx="2926080" cy="369332"/>
+          </a:xfrm>
+          <a:prstGeom prst="rect">
+            <a:avLst/>
+          </a:prstGeom>
+          <a:noFill/>
+        </p:spPr>
+        <p:txBody>
+          <a:bodyPr vert="horz" wrap="square" rtlCol="0">
+            <a:noAutofit/>
+          </a:bodyPr>
+          <a:lstStyle/>
+          <a:p>
+            <a:r>
+              <a:rPr lang="zh-CN" altLang="en-US" sz="1300" b="1">
+                <a:solidFill>
+                  <a:srgbClr val="E84C22"/>
+                </a:solidFill>
+                <a:latin typeface="Microsoft YaHei" panose="020B0503020204020204" pitchFamily="34" charset="-122"/>
+                <a:ea typeface="Microsoft YaHei" panose="020B0503020204020204" pitchFamily="34" charset="-122"/>
+              </a:rPr>
+              <a:t>优先拿下</a:t>
+            </a:r>
+          </a:p>
+        </p:txBody>
+      </p:sp>
+      <p:sp>
+        <p:nvSpPr>
+          <p:cNvPr id="17" name="QUAD_Q1_HINT">
+            <a:extLst>
+              <a:ext uri="{FF2B5EF4-FFF2-40B4-BE49-F238E27FC236}">
+                <a16:creationId xmlns:a16="http://schemas.microsoft.com/office/drawing/2014/main" id="{2F6CCBB1-EF56-727E-ABC6-724FAB85C5F2}"/>
+              </a:ext>
+            </a:extLst>
+          </p:cNvPr>
+          <p:cNvSpPr txBox="1"/>
+          <p:nvPr/>
+        </p:nvSpPr>
+        <p:spPr>
+          <a:xfrm>
+            <a:off x="4892040" y="2377440"/>
+            <a:ext cx="2926080" cy="369332"/>
+          </a:xfrm>
+          <a:prstGeom prst="rect">
+            <a:avLst/>
+          </a:prstGeom>
+          <a:noFill/>
+        </p:spPr>
+        <p:txBody>
+          <a:bodyPr vert="horz" wrap="square" rtlCol="0">
+            <a:noAutofit/>
+          </a:bodyPr>
+          <a:lstStyle/>
+          <a:p>
+            <a:r>
+              <a:rPr lang="zh-CN" altLang="en-US" sz="1100">
+                <a:solidFill>
+                  <a:srgbClr val="6F6F6A"/>
+                </a:solidFill>
+                <a:latin typeface="Microsoft YaHei" panose="020B0503020204020204" pitchFamily="34" charset="-122"/>
+                <a:ea typeface="Microsoft YaHei" panose="020B0503020204020204" pitchFamily="34" charset="-122"/>
+              </a:rPr>
+              <a:t>价值高 </a:t>
+            </a:r>
+            <a:r>
+              <a:rPr lang="en-US" altLang="zh-CN" sz="1100">
+                <a:solidFill>
+                  <a:srgbClr val="6F6F6A"/>
+                </a:solidFill>
+                <a:latin typeface="Microsoft YaHei" panose="020B0503020204020204" pitchFamily="34" charset="-122"/>
+                <a:ea typeface="Microsoft YaHei" panose="020B0503020204020204" pitchFamily="34" charset="-122"/>
+              </a:rPr>
+              <a:t>· </a:t>
+            </a:r>
+            <a:r>
+              <a:rPr lang="zh-CN" altLang="en-US" sz="1100">
+                <a:solidFill>
+                  <a:srgbClr val="6F6F6A"/>
+                </a:solidFill>
+                <a:latin typeface="Microsoft YaHei" panose="020B0503020204020204" pitchFamily="34" charset="-122"/>
+                <a:ea typeface="Microsoft YaHei" panose="020B0503020204020204" pitchFamily="34" charset="-122"/>
+              </a:rPr>
+              <a:t>难度低</a:t>
+            </a:r>
+          </a:p>
+        </p:txBody>
+      </p:sp>
+      <p:sp>
+        <p:nvSpPr>
+          <p:cNvPr id="18" name="QUAD_Q1_FILL">
+            <a:extLst>
+              <a:ext uri="{FF2B5EF4-FFF2-40B4-BE49-F238E27FC236}">
+                <a16:creationId xmlns:a16="http://schemas.microsoft.com/office/drawing/2014/main" id="{E9812A0C-1BE2-112C-48E1-AE2F521A21AA}"/>
+              </a:ext>
+            </a:extLst>
+          </p:cNvPr>
+          <p:cNvSpPr txBox="1"/>
+          <p:nvPr/>
+        </p:nvSpPr>
+        <p:spPr>
+          <a:xfrm>
+            <a:off x="4892040" y="2743200"/>
+            <a:ext cx="2926080" cy="369332"/>
+          </a:xfrm>
+          <a:prstGeom prst="rect">
+            <a:avLst/>
+          </a:prstGeom>
+          <a:noFill/>
+        </p:spPr>
+        <p:txBody>
+          <a:bodyPr vert="horz" wrap="square" rtlCol="0">
+            <a:noAutofit/>
+          </a:bodyPr>
+          <a:lstStyle/>
+          <a:p>
+            <a:r>
+              <a:rPr lang="en-US" altLang="zh-CN" sz="1200">
+                <a:solidFill>
+                  <a:srgbClr val="505046"/>
+                </a:solidFill>
+                <a:latin typeface="Microsoft YaHei" panose="020B0503020204020204" pitchFamily="34" charset="-122"/>
+                <a:ea typeface="Microsoft YaHei" panose="020B0503020204020204" pitchFamily="34" charset="-122"/>
+              </a:rPr>
+              <a:t>____</a:t>
+            </a:r>
+            <a:endParaRPr lang="zh-CN" altLang="en-US" sz="1200">
+              <a:solidFill>
+                <a:srgbClr val="505046"/>
+              </a:solidFill>
+              <a:latin typeface="Microsoft YaHei" panose="020B0503020204020204" pitchFamily="34" charset="-122"/>
+              <a:ea typeface="Microsoft YaHei" panose="020B0503020204020204" pitchFamily="34" charset="-122"/>
+            </a:endParaRPr>
+          </a:p>
+        </p:txBody>
+      </p:sp>
+      <p:sp>
+        <p:nvSpPr>
+          <p:cNvPr id="19" name="QUAD_Q2">
+            <a:extLst>
+              <a:ext uri="{FF2B5EF4-FFF2-40B4-BE49-F238E27FC236}">
+                <a16:creationId xmlns:a16="http://schemas.microsoft.com/office/drawing/2014/main" id="{CCC8B029-1EBB-B5AD-544C-30FEC4FE67E4}"/>
+              </a:ext>
+            </a:extLst>
+          </p:cNvPr>
+          <p:cNvSpPr/>
+          <p:nvPr/>
+        </p:nvSpPr>
+        <p:spPr>
+          <a:xfrm>
+            <a:off x="8138160" y="1920240"/>
+            <a:ext cx="3200400" cy="1280160"/>
+          </a:xfrm>
+          <a:prstGeom prst="rect">
+            <a:avLst/>
+          </a:prstGeom>
+          <a:solidFill>
+            <a:srgbClr val="EEECE1"/>
+          </a:solidFill>
+          <a:ln w="9525">
+            <a:solidFill>
+              <a:srgbClr val="6F6F6A"/>
+            </a:solidFill>
+          </a:ln>
+        </p:spPr>
+        <p:style>
+          <a:lnRef idx="2">
+            <a:schemeClr val="accent1">
+              <a:shade val="15000"/>
+            </a:schemeClr>
+          </a:lnRef>
+          <a:fillRef idx="1">
+            <a:schemeClr val="accent1"/>
+          </a:fillRef>
+          <a:effectRef idx="0">
+            <a:schemeClr val="accent1"/>
+          </a:effectRef>
+          <a:fontRef idx="minor">
+            <a:schemeClr val="lt1"/>
+          </a:fontRef>
+        </p:style>
+        <p:txBody>
+          <a:bodyPr rtlCol="0" anchor="ctr"/>
+          <a:lstStyle/>
+          <a:p>
+            <a:pPr algn="ctr"/>
+            <a:endParaRPr lang="zh-CN" altLang="en-US"/>
+          </a:p>
+        </p:txBody>
+      </p:sp>
+      <p:sp>
+        <p:nvSpPr>
+          <p:cNvPr id="20" name="QUAD_Q2_LABEL">
+            <a:extLst>
+              <a:ext uri="{FF2B5EF4-FFF2-40B4-BE49-F238E27FC236}">
+                <a16:creationId xmlns:a16="http://schemas.microsoft.com/office/drawing/2014/main" id="{8BF87F57-4E11-B744-B51A-4D57B64179AC}"/>
+              </a:ext>
+            </a:extLst>
+          </p:cNvPr>
+          <p:cNvSpPr txBox="1"/>
+          <p:nvPr/>
+        </p:nvSpPr>
+        <p:spPr>
+          <a:xfrm>
+            <a:off x="8275320" y="2011680"/>
+            <a:ext cx="2926080" cy="369332"/>
+          </a:xfrm>
+          <a:prstGeom prst="rect">
+            <a:avLst/>
+          </a:prstGeom>
+          <a:noFill/>
+        </p:spPr>
+        <p:txBody>
+          <a:bodyPr vert="horz" wrap="square" rtlCol="0">
+            <a:noAutofit/>
+          </a:bodyPr>
+          <a:lstStyle/>
+          <a:p>
+            <a:r>
+              <a:rPr lang="zh-CN" altLang="en-US" sz="1300" b="1">
+                <a:solidFill>
+                  <a:srgbClr val="E84C22"/>
+                </a:solidFill>
+                <a:latin typeface="Microsoft YaHei" panose="020B0503020204020204" pitchFamily="34" charset="-122"/>
+                <a:ea typeface="Microsoft YaHei" panose="020B0503020204020204" pitchFamily="34" charset="-122"/>
+              </a:rPr>
+              <a:t>重点攻坚</a:t>
+            </a:r>
+          </a:p>
+        </p:txBody>
+      </p:sp>
+      <p:sp>
+        <p:nvSpPr>
+          <p:cNvPr id="21" name="QUAD_Q2_HINT">
+            <a:extLst>
+              <a:ext uri="{FF2B5EF4-FFF2-40B4-BE49-F238E27FC236}">
+                <a16:creationId xmlns:a16="http://schemas.microsoft.com/office/drawing/2014/main" id="{33D26DE7-9EE8-E762-07CB-9D78F6FC23A6}"/>
+              </a:ext>
+            </a:extLst>
+          </p:cNvPr>
+          <p:cNvSpPr txBox="1"/>
+          <p:nvPr/>
+        </p:nvSpPr>
+        <p:spPr>
+          <a:xfrm>
+            <a:off x="8275320" y="2377440"/>
+            <a:ext cx="2926080" cy="369332"/>
+          </a:xfrm>
+          <a:prstGeom prst="rect">
+            <a:avLst/>
+          </a:prstGeom>
+          <a:noFill/>
+        </p:spPr>
+        <p:txBody>
+          <a:bodyPr vert="horz" wrap="square" rtlCol="0">
+            <a:noAutofit/>
+          </a:bodyPr>
+          <a:lstStyle/>
+          <a:p>
+            <a:r>
+              <a:rPr lang="zh-CN" altLang="en-US" sz="1100">
+                <a:solidFill>
+                  <a:srgbClr val="6F6F6A"/>
+                </a:solidFill>
+                <a:latin typeface="Microsoft YaHei" panose="020B0503020204020204" pitchFamily="34" charset="-122"/>
+                <a:ea typeface="Microsoft YaHei" panose="020B0503020204020204" pitchFamily="34" charset="-122"/>
+              </a:rPr>
+              <a:t>价值高 </a:t>
+            </a:r>
+            <a:r>
+              <a:rPr lang="en-US" altLang="zh-CN" sz="1100">
+                <a:solidFill>
+                  <a:srgbClr val="6F6F6A"/>
+                </a:solidFill>
+                <a:latin typeface="Microsoft YaHei" panose="020B0503020204020204" pitchFamily="34" charset="-122"/>
+                <a:ea typeface="Microsoft YaHei" panose="020B0503020204020204" pitchFamily="34" charset="-122"/>
+              </a:rPr>
+              <a:t>· </a:t>
+            </a:r>
+            <a:r>
+              <a:rPr lang="zh-CN" altLang="en-US" sz="1100">
+                <a:solidFill>
+                  <a:srgbClr val="6F6F6A"/>
+                </a:solidFill>
+                <a:latin typeface="Microsoft YaHei" panose="020B0503020204020204" pitchFamily="34" charset="-122"/>
+                <a:ea typeface="Microsoft YaHei" panose="020B0503020204020204" pitchFamily="34" charset="-122"/>
+              </a:rPr>
+              <a:t>难度高</a:t>
+            </a:r>
+          </a:p>
+        </p:txBody>
+      </p:sp>
+      <p:sp>
+        <p:nvSpPr>
+          <p:cNvPr id="22" name="QUAD_Q2_FILL">
+            <a:extLst>
+              <a:ext uri="{FF2B5EF4-FFF2-40B4-BE49-F238E27FC236}">
+                <a16:creationId xmlns:a16="http://schemas.microsoft.com/office/drawing/2014/main" id="{B751B424-BCF7-F39A-29AB-EC7A6A4841A5}"/>
+              </a:ext>
+            </a:extLst>
+          </p:cNvPr>
+          <p:cNvSpPr txBox="1"/>
+          <p:nvPr/>
+        </p:nvSpPr>
+        <p:spPr>
+          <a:xfrm>
+            <a:off x="8275320" y="2743200"/>
+            <a:ext cx="2926080" cy="369332"/>
+          </a:xfrm>
+          <a:prstGeom prst="rect">
+            <a:avLst/>
+          </a:prstGeom>
+          <a:noFill/>
+        </p:spPr>
+        <p:txBody>
+          <a:bodyPr vert="horz" wrap="square" rtlCol="0">
+            <a:noAutofit/>
+          </a:bodyPr>
+          <a:lstStyle/>
+          <a:p>
+            <a:r>
+              <a:rPr lang="en-US" altLang="zh-CN" sz="1200">
+                <a:solidFill>
+                  <a:srgbClr val="505046"/>
+                </a:solidFill>
+                <a:latin typeface="Microsoft YaHei" panose="020B0503020204020204" pitchFamily="34" charset="-122"/>
+                <a:ea typeface="Microsoft YaHei" panose="020B0503020204020204" pitchFamily="34" charset="-122"/>
+              </a:rPr>
+              <a:t>____</a:t>
+            </a:r>
+            <a:endParaRPr lang="zh-CN" altLang="en-US" sz="1200">
+              <a:solidFill>
+                <a:srgbClr val="505046"/>
+              </a:solidFill>
+              <a:latin typeface="Microsoft YaHei" panose="020B0503020204020204" pitchFamily="34" charset="-122"/>
+              <a:ea typeface="Microsoft YaHei" panose="020B0503020204020204" pitchFamily="34" charset="-122"/>
+            </a:endParaRPr>
+          </a:p>
+        </p:txBody>
+      </p:sp>
+      <p:sp>
+        <p:nvSpPr>
+          <p:cNvPr id="23" name="QUAD_Q3">
+            <a:extLst>
+              <a:ext uri="{FF2B5EF4-FFF2-40B4-BE49-F238E27FC236}">
+                <a16:creationId xmlns:a16="http://schemas.microsoft.com/office/drawing/2014/main" id="{BCF02BF2-F431-89E8-E237-70550008A939}"/>
+              </a:ext>
+            </a:extLst>
+          </p:cNvPr>
+          <p:cNvSpPr/>
+          <p:nvPr/>
+        </p:nvSpPr>
+        <p:spPr>
+          <a:xfrm>
+            <a:off x="4754880" y="3291840"/>
+            <a:ext cx="3200400" cy="1280160"/>
+          </a:xfrm>
+          <a:prstGeom prst="rect">
+            <a:avLst/>
+          </a:prstGeom>
+          <a:solidFill>
+            <a:srgbClr val="F7F7F8"/>
+          </a:solidFill>
+          <a:ln w="9525">
+            <a:solidFill>
+              <a:srgbClr val="6F6F6A"/>
+            </a:solidFill>
+          </a:ln>
+        </p:spPr>
+        <p:style>
+          <a:lnRef idx="2">
+            <a:schemeClr val="accent1">
+              <a:shade val="15000"/>
+            </a:schemeClr>
+          </a:lnRef>
+          <a:fillRef idx="1">
+            <a:schemeClr val="accent1"/>
+          </a:fillRef>
+          <a:effectRef idx="0">
+            <a:schemeClr val="accent1"/>
+          </a:effectRef>
+          <a:fontRef idx="minor">
+            <a:schemeClr val="lt1"/>
+          </a:fontRef>
+        </p:style>
+        <p:txBody>
+          <a:bodyPr rtlCol="0" anchor="ctr"/>
+          <a:lstStyle/>
+          <a:p>
+            <a:pPr algn="ctr"/>
+            <a:endParaRPr lang="zh-CN" altLang="en-US"/>
+          </a:p>
+        </p:txBody>
+      </p:sp>
+      <p:sp>
+        <p:nvSpPr>
+          <p:cNvPr id="24" name="QUAD_Q3_LABEL">
+            <a:extLst>
+              <a:ext uri="{FF2B5EF4-FFF2-40B4-BE49-F238E27FC236}">
+                <a16:creationId xmlns:a16="http://schemas.microsoft.com/office/drawing/2014/main" id="{AFB5AE1D-43AD-004C-8B6D-4A58C46683DC}"/>
+              </a:ext>
+            </a:extLst>
+          </p:cNvPr>
+          <p:cNvSpPr txBox="1"/>
+          <p:nvPr/>
+        </p:nvSpPr>
+        <p:spPr>
+          <a:xfrm>
+            <a:off x="4892040" y="3383280"/>
+            <a:ext cx="2926080" cy="369332"/>
+          </a:xfrm>
+          <a:prstGeom prst="rect">
+            <a:avLst/>
+          </a:prstGeom>
+          <a:noFill/>
+        </p:spPr>
+        <p:txBody>
+          <a:bodyPr vert="horz" wrap="square" rtlCol="0">
+            <a:noAutofit/>
+          </a:bodyPr>
+          <a:lstStyle/>
+          <a:p>
+            <a:r>
+              <a:rPr lang="zh-CN" altLang="en-US" sz="1300" b="1">
+                <a:solidFill>
+                  <a:srgbClr val="E84C22"/>
+                </a:solidFill>
+                <a:latin typeface="Microsoft YaHei" panose="020B0503020204020204" pitchFamily="34" charset="-122"/>
+                <a:ea typeface="Microsoft YaHei" panose="020B0503020204020204" pitchFamily="34" charset="-122"/>
+              </a:rPr>
+              <a:t>观察验证</a:t>
+            </a:r>
+          </a:p>
+        </p:txBody>
+      </p:sp>
+      <p:sp>
+        <p:nvSpPr>
+          <p:cNvPr id="25" name="QUAD_Q3_HINT">
+            <a:extLst>
+              <a:ext uri="{FF2B5EF4-FFF2-40B4-BE49-F238E27FC236}">
+                <a16:creationId xmlns:a16="http://schemas.microsoft.com/office/drawing/2014/main" id="{1E8D4B5B-951F-429C-AE51-33F64ED0BAE0}"/>
+              </a:ext>
+            </a:extLst>
+          </p:cNvPr>
+          <p:cNvSpPr txBox="1"/>
+          <p:nvPr/>
+        </p:nvSpPr>
+        <p:spPr>
+          <a:xfrm>
+            <a:off x="4892040" y="3749040"/>
+            <a:ext cx="2926080" cy="369332"/>
+          </a:xfrm>
+          <a:prstGeom prst="rect">
+            <a:avLst/>
+          </a:prstGeom>
+          <a:noFill/>
+        </p:spPr>
+        <p:txBody>
+          <a:bodyPr vert="horz" wrap="square" rtlCol="0">
+            <a:noAutofit/>
+          </a:bodyPr>
+          <a:lstStyle/>
+          <a:p>
+            <a:r>
+              <a:rPr lang="zh-CN" altLang="en-US" sz="1100">
+                <a:solidFill>
+                  <a:srgbClr val="6F6F6A"/>
+                </a:solidFill>
+                <a:latin typeface="Microsoft YaHei" panose="020B0503020204020204" pitchFamily="34" charset="-122"/>
+                <a:ea typeface="Microsoft YaHei" panose="020B0503020204020204" pitchFamily="34" charset="-122"/>
+              </a:rPr>
+              <a:t>价值低 </a:t>
+            </a:r>
+            <a:r>
+              <a:rPr lang="en-US" altLang="zh-CN" sz="1100">
+                <a:solidFill>
+                  <a:srgbClr val="6F6F6A"/>
+                </a:solidFill>
+                <a:latin typeface="Microsoft YaHei" panose="020B0503020204020204" pitchFamily="34" charset="-122"/>
+                <a:ea typeface="Microsoft YaHei" panose="020B0503020204020204" pitchFamily="34" charset="-122"/>
+              </a:rPr>
+              <a:t>· </a:t>
+            </a:r>
+            <a:r>
+              <a:rPr lang="zh-CN" altLang="en-US" sz="1100">
+                <a:solidFill>
+                  <a:srgbClr val="6F6F6A"/>
+                </a:solidFill>
+                <a:latin typeface="Microsoft YaHei" panose="020B0503020204020204" pitchFamily="34" charset="-122"/>
+                <a:ea typeface="Microsoft YaHei" panose="020B0503020204020204" pitchFamily="34" charset="-122"/>
+              </a:rPr>
+              <a:t>难度低</a:t>
+            </a:r>
+          </a:p>
+        </p:txBody>
+      </p:sp>
+      <p:sp>
+        <p:nvSpPr>
+          <p:cNvPr id="26" name="QUAD_Q3_FILL">
+            <a:extLst>
+              <a:ext uri="{FF2B5EF4-FFF2-40B4-BE49-F238E27FC236}">
+                <a16:creationId xmlns:a16="http://schemas.microsoft.com/office/drawing/2014/main" id="{25653AA1-AD51-E037-8607-C85034A24C94}"/>
+              </a:ext>
+            </a:extLst>
+          </p:cNvPr>
+          <p:cNvSpPr txBox="1"/>
+          <p:nvPr/>
+        </p:nvSpPr>
+        <p:spPr>
+          <a:xfrm>
+            <a:off x="4892040" y="4114800"/>
+            <a:ext cx="2926080" cy="369332"/>
+          </a:xfrm>
+          <a:prstGeom prst="rect">
+            <a:avLst/>
+          </a:prstGeom>
+          <a:noFill/>
+        </p:spPr>
+        <p:txBody>
+          <a:bodyPr vert="horz" wrap="square" rtlCol="0">
+            <a:noAutofit/>
+          </a:bodyPr>
+          <a:lstStyle/>
+          <a:p>
+            <a:r>
+              <a:rPr lang="en-US" altLang="zh-CN" sz="1200">
+                <a:solidFill>
+                  <a:srgbClr val="505046"/>
+                </a:solidFill>
+                <a:latin typeface="Microsoft YaHei" panose="020B0503020204020204" pitchFamily="34" charset="-122"/>
+                <a:ea typeface="Microsoft YaHei" panose="020B0503020204020204" pitchFamily="34" charset="-122"/>
+              </a:rPr>
+              <a:t>____</a:t>
+            </a:r>
+            <a:endParaRPr lang="zh-CN" altLang="en-US" sz="1200">
+              <a:solidFill>
+                <a:srgbClr val="505046"/>
+              </a:solidFill>
+              <a:latin typeface="Microsoft YaHei" panose="020B0503020204020204" pitchFamily="34" charset="-122"/>
+              <a:ea typeface="Microsoft YaHei" panose="020B0503020204020204" pitchFamily="34" charset="-122"/>
+            </a:endParaRPr>
+          </a:p>
+        </p:txBody>
+      </p:sp>
+      <p:sp>
+        <p:nvSpPr>
+          <p:cNvPr id="27" name="QUAD_Q4">
+            <a:extLst>
+              <a:ext uri="{FF2B5EF4-FFF2-40B4-BE49-F238E27FC236}">
+                <a16:creationId xmlns:a16="http://schemas.microsoft.com/office/drawing/2014/main" id="{CC6F5EC0-751C-88AF-8E6C-253BDCB98CBD}"/>
+              </a:ext>
+            </a:extLst>
+          </p:cNvPr>
+          <p:cNvSpPr/>
+          <p:nvPr/>
+        </p:nvSpPr>
+        <p:spPr>
+          <a:xfrm>
+            <a:off x="8138160" y="3291840"/>
+            <a:ext cx="3200400" cy="1280160"/>
+          </a:xfrm>
+          <a:prstGeom prst="rect">
+            <a:avLst/>
+          </a:prstGeom>
+          <a:solidFill>
+            <a:srgbClr val="EEECE1"/>
+          </a:solidFill>
+          <a:ln w="9525">
+            <a:solidFill>
+              <a:srgbClr val="6F6F6A"/>
+            </a:solidFill>
+          </a:ln>
+        </p:spPr>
+        <p:style>
+          <a:lnRef idx="2">
+            <a:schemeClr val="accent1">
+              <a:shade val="15000"/>
+            </a:schemeClr>
+          </a:lnRef>
+          <a:fillRef idx="1">
+            <a:schemeClr val="accent1"/>
+          </a:fillRef>
+          <a:effectRef idx="0">
+            <a:schemeClr val="accent1"/>
+          </a:effectRef>
+          <a:fontRef idx="minor">
+            <a:schemeClr val="lt1"/>
+          </a:fontRef>
+        </p:style>
+        <p:txBody>
+          <a:bodyPr rtlCol="0" anchor="ctr"/>
+          <a:lstStyle/>
+          <a:p>
+            <a:pPr algn="ctr"/>
+            <a:endParaRPr lang="zh-CN" altLang="en-US"/>
+          </a:p>
+        </p:txBody>
+      </p:sp>
+      <p:sp>
+        <p:nvSpPr>
+          <p:cNvPr id="28" name="QUAD_Q4_LABEL">
+            <a:extLst>
+              <a:ext uri="{FF2B5EF4-FFF2-40B4-BE49-F238E27FC236}">
+                <a16:creationId xmlns:a16="http://schemas.microsoft.com/office/drawing/2014/main" id="{DC112707-C82B-252A-34B3-1F95C8CE9EED}"/>
+              </a:ext>
+            </a:extLst>
+          </p:cNvPr>
+          <p:cNvSpPr txBox="1"/>
+          <p:nvPr/>
+        </p:nvSpPr>
+        <p:spPr>
+          <a:xfrm>
+            <a:off x="8275320" y="3383280"/>
+            <a:ext cx="2926080" cy="369332"/>
+          </a:xfrm>
+          <a:prstGeom prst="rect">
+            <a:avLst/>
+          </a:prstGeom>
+          <a:noFill/>
+        </p:spPr>
+        <p:txBody>
+          <a:bodyPr vert="horz" wrap="square" rtlCol="0">
+            <a:noAutofit/>
+          </a:bodyPr>
+          <a:lstStyle/>
+          <a:p>
+            <a:r>
+              <a:rPr lang="zh-CN" altLang="en-US" sz="1300" b="1">
+                <a:solidFill>
+                  <a:srgbClr val="E84C22"/>
+                </a:solidFill>
+                <a:latin typeface="Microsoft YaHei" panose="020B0503020204020204" pitchFamily="34" charset="-122"/>
+                <a:ea typeface="Microsoft YaHei" panose="020B0503020204020204" pitchFamily="34" charset="-122"/>
+              </a:rPr>
+              <a:t>暂缓投入</a:t>
+            </a:r>
+          </a:p>
+        </p:txBody>
+      </p:sp>
+      <p:sp>
+        <p:nvSpPr>
+          <p:cNvPr id="29" name="QUAD_Q4_HINT">
+            <a:extLst>
+              <a:ext uri="{FF2B5EF4-FFF2-40B4-BE49-F238E27FC236}">
+                <a16:creationId xmlns:a16="http://schemas.microsoft.com/office/drawing/2014/main" id="{289539D4-1019-4E57-45EF-C4195335465B}"/>
+              </a:ext>
+            </a:extLst>
+          </p:cNvPr>
+          <p:cNvSpPr txBox="1"/>
+          <p:nvPr/>
+        </p:nvSpPr>
+        <p:spPr>
+          <a:xfrm>
+            <a:off x="8275320" y="3749040"/>
+            <a:ext cx="2926080" cy="369332"/>
+          </a:xfrm>
+          <a:prstGeom prst="rect">
+            <a:avLst/>
+          </a:prstGeom>
+          <a:noFill/>
+        </p:spPr>
+        <p:txBody>
+          <a:bodyPr vert="horz" wrap="square" rtlCol="0">
+            <a:noAutofit/>
+          </a:bodyPr>
+          <a:lstStyle/>
+          <a:p>
+            <a:r>
+              <a:rPr lang="zh-CN" altLang="en-US" sz="1100">
+                <a:solidFill>
+                  <a:srgbClr val="6F6F6A"/>
+                </a:solidFill>
+                <a:latin typeface="Microsoft YaHei" panose="020B0503020204020204" pitchFamily="34" charset="-122"/>
+                <a:ea typeface="Microsoft YaHei" panose="020B0503020204020204" pitchFamily="34" charset="-122"/>
+              </a:rPr>
+              <a:t>价值低 </a:t>
+            </a:r>
+            <a:r>
+              <a:rPr lang="en-US" altLang="zh-CN" sz="1100">
+                <a:solidFill>
+                  <a:srgbClr val="6F6F6A"/>
+                </a:solidFill>
+                <a:latin typeface="Microsoft YaHei" panose="020B0503020204020204" pitchFamily="34" charset="-122"/>
+                <a:ea typeface="Microsoft YaHei" panose="020B0503020204020204" pitchFamily="34" charset="-122"/>
+              </a:rPr>
+              <a:t>· </a:t>
+            </a:r>
+            <a:r>
+              <a:rPr lang="zh-CN" altLang="en-US" sz="1100">
+                <a:solidFill>
+                  <a:srgbClr val="6F6F6A"/>
+                </a:solidFill>
+                <a:latin typeface="Microsoft YaHei" panose="020B0503020204020204" pitchFamily="34" charset="-122"/>
+                <a:ea typeface="Microsoft YaHei" panose="020B0503020204020204" pitchFamily="34" charset="-122"/>
+              </a:rPr>
+              <a:t>难度高</a:t>
+            </a:r>
+          </a:p>
+        </p:txBody>
+      </p:sp>
+      <p:sp>
+        <p:nvSpPr>
+          <p:cNvPr id="30" name="QUAD_Q4_FILL">
+            <a:extLst>
+              <a:ext uri="{FF2B5EF4-FFF2-40B4-BE49-F238E27FC236}">
+                <a16:creationId xmlns:a16="http://schemas.microsoft.com/office/drawing/2014/main" id="{FF931194-BD25-44DA-92FE-E5ABCC67ED1F}"/>
+              </a:ext>
+            </a:extLst>
+          </p:cNvPr>
+          <p:cNvSpPr txBox="1"/>
+          <p:nvPr/>
+        </p:nvSpPr>
+        <p:spPr>
+          <a:xfrm>
+            <a:off x="8275320" y="4114800"/>
+            <a:ext cx="2926080" cy="369332"/>
+          </a:xfrm>
+          <a:prstGeom prst="rect">
+            <a:avLst/>
+          </a:prstGeom>
+          <a:noFill/>
+        </p:spPr>
+        <p:txBody>
+          <a:bodyPr vert="horz" wrap="square" rtlCol="0">
+            <a:noAutofit/>
+          </a:bodyPr>
+          <a:lstStyle/>
+          <a:p>
+            <a:r>
+              <a:rPr lang="en-US" altLang="zh-CN" sz="1200">
+                <a:solidFill>
+                  <a:srgbClr val="505046"/>
+                </a:solidFill>
+                <a:latin typeface="Microsoft YaHei" panose="020B0503020204020204" pitchFamily="34" charset="-122"/>
+                <a:ea typeface="Microsoft YaHei" panose="020B0503020204020204" pitchFamily="34" charset="-122"/>
+              </a:rPr>
+              <a:t>____</a:t>
+            </a:r>
+            <a:endParaRPr lang="zh-CN" altLang="en-US" sz="1200">
+              <a:solidFill>
+                <a:srgbClr val="505046"/>
+              </a:solidFill>
+              <a:latin typeface="Microsoft YaHei" panose="020B0503020204020204" pitchFamily="34" charset="-122"/>
+              <a:ea typeface="Microsoft YaHei" panose="020B0503020204020204" pitchFamily="34" charset="-122"/>
+            </a:endParaRPr>
+          </a:p>
+        </p:txBody>
+      </p:sp>
+      <p:sp>
+        <p:nvSpPr>
+          <p:cNvPr id="31" name="BET_BAND">
+            <a:extLst>
+              <a:ext uri="{FF2B5EF4-FFF2-40B4-BE49-F238E27FC236}">
+                <a16:creationId xmlns:a16="http://schemas.microsoft.com/office/drawing/2014/main" id="{D013884A-E625-04CF-3742-0E43FACB85BB}"/>
+              </a:ext>
+            </a:extLst>
+          </p:cNvPr>
+          <p:cNvSpPr/>
+          <p:nvPr/>
+        </p:nvSpPr>
+        <p:spPr>
+          <a:xfrm>
+            <a:off x="548640" y="4892040"/>
+            <a:ext cx="11064240" cy="1143000"/>
+          </a:xfrm>
+          <a:prstGeom prst="rect">
+            <a:avLst/>
+          </a:prstGeom>
+          <a:solidFill>
+            <a:srgbClr val="505046"/>
+          </a:solidFill>
+          <a:ln w="9525">
+            <a:solidFill>
+              <a:srgbClr val="505046"/>
+            </a:solidFill>
+          </a:ln>
+        </p:spPr>
+        <p:style>
+          <a:lnRef idx="2">
+            <a:schemeClr val="accent1">
+              <a:shade val="15000"/>
+            </a:schemeClr>
+          </a:lnRef>
+          <a:fillRef idx="1">
+            <a:schemeClr val="accent1"/>
+          </a:fillRef>
+          <a:effectRef idx="0">
+            <a:schemeClr val="accent1"/>
+          </a:effectRef>
+          <a:fontRef idx="minor">
+            <a:schemeClr val="lt1"/>
+          </a:fontRef>
+        </p:style>
+        <p:txBody>
+          <a:bodyPr rtlCol="0" anchor="ctr"/>
+          <a:lstStyle/>
+          <a:p>
+            <a:pPr algn="ctr"/>
+            <a:endParaRPr lang="zh-CN" altLang="en-US"/>
+          </a:p>
+        </p:txBody>
+      </p:sp>
+      <p:sp>
+        <p:nvSpPr>
+          <p:cNvPr id="32" name="BET_TITLE">
+            <a:extLst>
+              <a:ext uri="{FF2B5EF4-FFF2-40B4-BE49-F238E27FC236}">
+                <a16:creationId xmlns:a16="http://schemas.microsoft.com/office/drawing/2014/main" id="{72019D6E-EA05-300E-E175-8C8E2DA90B81}"/>
+              </a:ext>
+            </a:extLst>
+          </p:cNvPr>
+          <p:cNvSpPr txBox="1"/>
+          <p:nvPr/>
+        </p:nvSpPr>
+        <p:spPr>
+          <a:xfrm>
+            <a:off x="777240" y="5029200"/>
+            <a:ext cx="1828800" cy="365760"/>
+          </a:xfrm>
+          <a:prstGeom prst="rect">
+            <a:avLst/>
+          </a:prstGeom>
+          <a:noFill/>
+        </p:spPr>
+        <p:txBody>
+          <a:bodyPr vert="horz" wrap="square" rtlCol="0">
+            <a:noAutofit/>
+          </a:bodyPr>
+          <a:lstStyle/>
+          <a:p>
+            <a:r>
+              <a:rPr lang="zh-CN" altLang="en-US" sz="1500" b="1">
+                <a:solidFill>
+                  <a:srgbClr val="FFFFFF"/>
+                </a:solidFill>
+                <a:latin typeface="Microsoft YaHei" panose="020B0503020204020204" pitchFamily="34" charset="-122"/>
+                <a:ea typeface="Microsoft YaHei" panose="020B0503020204020204" pitchFamily="34" charset="-122"/>
+              </a:rPr>
+              <a:t>资源下注</a:t>
+            </a:r>
+          </a:p>
+        </p:txBody>
+      </p:sp>
+      <p:sp>
+        <p:nvSpPr>
+          <p:cNvPr id="33" name="BET_1_LABEL">
+            <a:extLst>
+              <a:ext uri="{FF2B5EF4-FFF2-40B4-BE49-F238E27FC236}">
+                <a16:creationId xmlns:a16="http://schemas.microsoft.com/office/drawing/2014/main" id="{786E9C03-D23A-EC23-1787-13C5BE70457D}"/>
+              </a:ext>
+            </a:extLst>
+          </p:cNvPr>
+          <p:cNvSpPr txBox="1"/>
+          <p:nvPr/>
+        </p:nvSpPr>
+        <p:spPr>
+          <a:xfrm>
+            <a:off x="2743200" y="5029200"/>
+            <a:ext cx="1645920" cy="369332"/>
+          </a:xfrm>
+          <a:prstGeom prst="rect">
+            <a:avLst/>
+          </a:prstGeom>
+          <a:noFill/>
+        </p:spPr>
+        <p:txBody>
+          <a:bodyPr vert="horz" wrap="square" rtlCol="0">
+            <a:noAutofit/>
+          </a:bodyPr>
+          <a:lstStyle/>
+          <a:p>
+            <a:r>
+              <a:rPr lang="zh-CN" altLang="en-US" sz="1300" b="1">
+                <a:solidFill>
+                  <a:srgbClr val="FFFFFF"/>
+                </a:solidFill>
+                <a:latin typeface="Microsoft YaHei" panose="020B0503020204020204" pitchFamily="34" charset="-122"/>
+                <a:ea typeface="Microsoft YaHei" panose="020B0503020204020204" pitchFamily="34" charset="-122"/>
+              </a:rPr>
+              <a:t>首战</a:t>
+            </a:r>
+          </a:p>
+        </p:txBody>
+      </p:sp>
+      <p:sp>
+        <p:nvSpPr>
+          <p:cNvPr id="34" name="BET_1_TARGET">
+            <a:extLst>
+              <a:ext uri="{FF2B5EF4-FFF2-40B4-BE49-F238E27FC236}">
+                <a16:creationId xmlns:a16="http://schemas.microsoft.com/office/drawing/2014/main" id="{DDAD1189-109D-3637-A9B4-E26A3933BC62}"/>
+              </a:ext>
+            </a:extLst>
+          </p:cNvPr>
+          <p:cNvSpPr txBox="1"/>
+          <p:nvPr/>
+        </p:nvSpPr>
+        <p:spPr>
+          <a:xfrm>
+            <a:off x="2743200" y="5440680"/>
+            <a:ext cx="2377440" cy="365760"/>
+          </a:xfrm>
+          <a:prstGeom prst="rect">
+            <a:avLst/>
+          </a:prstGeom>
+          <a:noFill/>
+        </p:spPr>
+        <p:txBody>
+          <a:bodyPr vert="horz" wrap="square" rtlCol="0">
+            <a:noAutofit/>
+          </a:bodyPr>
+          <a:lstStyle/>
+          <a:p>
+            <a:r>
+              <a:rPr lang="en-US" altLang="zh-CN" sz="1200">
+                <a:solidFill>
+                  <a:srgbClr val="FFFFFF"/>
+                </a:solidFill>
+                <a:latin typeface="Microsoft YaHei" panose="020B0503020204020204" pitchFamily="34" charset="-122"/>
+                <a:ea typeface="Microsoft YaHei" panose="020B0503020204020204" pitchFamily="34" charset="-122"/>
+              </a:rPr>
+              <a:t>____</a:t>
+            </a:r>
+            <a:r>
+              <a:rPr lang="zh-CN" altLang="en-US" sz="1200">
+                <a:solidFill>
+                  <a:srgbClr val="FFFFFF"/>
+                </a:solidFill>
+                <a:latin typeface="Microsoft YaHei" panose="020B0503020204020204" pitchFamily="34" charset="-122"/>
+                <a:ea typeface="Microsoft YaHei" panose="020B0503020204020204" pitchFamily="34" charset="-122"/>
+              </a:rPr>
+              <a:t>（选 </a:t>
+            </a:r>
+            <a:r>
+              <a:rPr lang="en-US" altLang="zh-CN" sz="1200">
+                <a:solidFill>
+                  <a:srgbClr val="FFFFFF"/>
+                </a:solidFill>
+                <a:latin typeface="Microsoft YaHei" panose="020B0503020204020204" pitchFamily="34" charset="-122"/>
+                <a:ea typeface="Microsoft YaHei" panose="020B0503020204020204" pitchFamily="34" charset="-122"/>
+              </a:rPr>
+              <a:t>1 </a:t>
+            </a:r>
+            <a:r>
+              <a:rPr lang="zh-CN" altLang="en-US" sz="1200">
+                <a:solidFill>
+                  <a:srgbClr val="FFFFFF"/>
+                </a:solidFill>
+                <a:latin typeface="Microsoft YaHei" panose="020B0503020204020204" pitchFamily="34" charset="-122"/>
+                <a:ea typeface="Microsoft YaHei" panose="020B0503020204020204" pitchFamily="34" charset="-122"/>
+              </a:rPr>
+              <a:t>个）</a:t>
+            </a:r>
+          </a:p>
+        </p:txBody>
+      </p:sp>
+      <p:sp>
+        <p:nvSpPr>
+          <p:cNvPr id="35" name="BET_2_LABEL">
+            <a:extLst>
+              <a:ext uri="{FF2B5EF4-FFF2-40B4-BE49-F238E27FC236}">
+                <a16:creationId xmlns:a16="http://schemas.microsoft.com/office/drawing/2014/main" id="{BFFD6B03-C8A5-93A0-5FB9-7FCD27928AA6}"/>
+              </a:ext>
+            </a:extLst>
+          </p:cNvPr>
+          <p:cNvSpPr txBox="1"/>
+          <p:nvPr/>
+        </p:nvSpPr>
+        <p:spPr>
+          <a:xfrm>
+            <a:off x="5486400" y="5029200"/>
+            <a:ext cx="1645920" cy="369332"/>
+          </a:xfrm>
+          <a:prstGeom prst="rect">
+            <a:avLst/>
+          </a:prstGeom>
+          <a:noFill/>
+        </p:spPr>
+        <p:txBody>
+          <a:bodyPr vert="horz" wrap="square" rtlCol="0">
+            <a:noAutofit/>
+          </a:bodyPr>
+          <a:lstStyle/>
+          <a:p>
+            <a:r>
+              <a:rPr lang="zh-CN" altLang="en-US" sz="1300" b="1">
+                <a:solidFill>
+                  <a:srgbClr val="FFFFFF"/>
+                </a:solidFill>
+                <a:latin typeface="Microsoft YaHei" panose="020B0503020204020204" pitchFamily="34" charset="-122"/>
+                <a:ea typeface="Microsoft YaHei" panose="020B0503020204020204" pitchFamily="34" charset="-122"/>
+              </a:rPr>
+              <a:t>候补</a:t>
+            </a:r>
+          </a:p>
+        </p:txBody>
+      </p:sp>
+      <p:sp>
+        <p:nvSpPr>
+          <p:cNvPr id="36" name="BET_2_TARGET">
+            <a:extLst>
+              <a:ext uri="{FF2B5EF4-FFF2-40B4-BE49-F238E27FC236}">
+                <a16:creationId xmlns:a16="http://schemas.microsoft.com/office/drawing/2014/main" id="{20C6796D-60B7-787B-4CF3-64AD15D0A9A1}"/>
+              </a:ext>
+            </a:extLst>
+          </p:cNvPr>
+          <p:cNvSpPr txBox="1"/>
+          <p:nvPr/>
+        </p:nvSpPr>
+        <p:spPr>
+          <a:xfrm>
+            <a:off x="5486400" y="5440680"/>
+            <a:ext cx="2377440" cy="365760"/>
+          </a:xfrm>
+          <a:prstGeom prst="rect">
+            <a:avLst/>
+          </a:prstGeom>
+          <a:noFill/>
+        </p:spPr>
+        <p:txBody>
+          <a:bodyPr vert="horz" wrap="square" rtlCol="0">
+            <a:noAutofit/>
+          </a:bodyPr>
+          <a:lstStyle/>
+          <a:p>
+            <a:r>
+              <a:rPr lang="en-US" altLang="zh-CN" sz="1200">
+                <a:solidFill>
+                  <a:srgbClr val="FFFFFF"/>
+                </a:solidFill>
+                <a:latin typeface="Microsoft YaHei" panose="020B0503020204020204" pitchFamily="34" charset="-122"/>
+                <a:ea typeface="Microsoft YaHei" panose="020B0503020204020204" pitchFamily="34" charset="-122"/>
+              </a:rPr>
+              <a:t>____</a:t>
+            </a:r>
+            <a:r>
+              <a:rPr lang="zh-CN" altLang="en-US" sz="1200">
+                <a:solidFill>
+                  <a:srgbClr val="FFFFFF"/>
+                </a:solidFill>
+                <a:latin typeface="Microsoft YaHei" panose="020B0503020204020204" pitchFamily="34" charset="-122"/>
+                <a:ea typeface="Microsoft YaHei" panose="020B0503020204020204" pitchFamily="34" charset="-122"/>
+              </a:rPr>
+              <a:t>（选 </a:t>
+            </a:r>
+            <a:r>
+              <a:rPr lang="en-US" altLang="zh-CN" sz="1200">
+                <a:solidFill>
+                  <a:srgbClr val="FFFFFF"/>
+                </a:solidFill>
+                <a:latin typeface="Microsoft YaHei" panose="020B0503020204020204" pitchFamily="34" charset="-122"/>
+                <a:ea typeface="Microsoft YaHei" panose="020B0503020204020204" pitchFamily="34" charset="-122"/>
+              </a:rPr>
+              <a:t>1 </a:t>
+            </a:r>
+            <a:r>
+              <a:rPr lang="zh-CN" altLang="en-US" sz="1200">
+                <a:solidFill>
+                  <a:srgbClr val="FFFFFF"/>
+                </a:solidFill>
+                <a:latin typeface="Microsoft YaHei" panose="020B0503020204020204" pitchFamily="34" charset="-122"/>
+                <a:ea typeface="Microsoft YaHei" panose="020B0503020204020204" pitchFamily="34" charset="-122"/>
+              </a:rPr>
+              <a:t>个）</a:t>
+            </a:r>
+          </a:p>
+        </p:txBody>
+      </p:sp>
+      <p:sp>
+        <p:nvSpPr>
+          <p:cNvPr id="37" name="BET_3_LABEL">
+            <a:extLst>
+              <a:ext uri="{FF2B5EF4-FFF2-40B4-BE49-F238E27FC236}">
+                <a16:creationId xmlns:a16="http://schemas.microsoft.com/office/drawing/2014/main" id="{B2810A25-749D-D4E8-04A4-9B4DADE29AB6}"/>
+              </a:ext>
+            </a:extLst>
+          </p:cNvPr>
+          <p:cNvSpPr txBox="1"/>
+          <p:nvPr/>
+        </p:nvSpPr>
+        <p:spPr>
+          <a:xfrm>
+            <a:off x="8229600" y="5029200"/>
+            <a:ext cx="1645920" cy="369332"/>
+          </a:xfrm>
+          <a:prstGeom prst="rect">
+            <a:avLst/>
+          </a:prstGeom>
+          <a:noFill/>
+        </p:spPr>
+        <p:txBody>
+          <a:bodyPr vert="horz" wrap="square" rtlCol="0">
+            <a:noAutofit/>
+          </a:bodyPr>
+          <a:lstStyle/>
+          <a:p>
+            <a:r>
+              <a:rPr lang="zh-CN" altLang="en-US" sz="1300" b="1">
+                <a:solidFill>
+                  <a:srgbClr val="FFFFFF"/>
+                </a:solidFill>
+                <a:latin typeface="Microsoft YaHei" panose="020B0503020204020204" pitchFamily="34" charset="-122"/>
+                <a:ea typeface="Microsoft YaHei" panose="020B0503020204020204" pitchFamily="34" charset="-122"/>
+              </a:rPr>
+              <a:t>暂缓</a:t>
+            </a:r>
+          </a:p>
+        </p:txBody>
+      </p:sp>
+      <p:sp>
+        <p:nvSpPr>
+          <p:cNvPr id="38" name="BET_3_TARGET">
+            <a:extLst>
+              <a:ext uri="{FF2B5EF4-FFF2-40B4-BE49-F238E27FC236}">
+                <a16:creationId xmlns:a16="http://schemas.microsoft.com/office/drawing/2014/main" id="{BF29331E-D7FA-AD22-9850-32330DB686D1}"/>
+              </a:ext>
+            </a:extLst>
+          </p:cNvPr>
+          <p:cNvSpPr txBox="1"/>
+          <p:nvPr/>
+        </p:nvSpPr>
+        <p:spPr>
+          <a:xfrm>
+            <a:off x="8229600" y="5440680"/>
+            <a:ext cx="2377440" cy="365760"/>
+          </a:xfrm>
+          <a:prstGeom prst="rect">
+            <a:avLst/>
+          </a:prstGeom>
+          <a:noFill/>
+        </p:spPr>
+        <p:txBody>
+          <a:bodyPr vert="horz" wrap="square" rtlCol="0">
+            <a:noAutofit/>
+          </a:bodyPr>
+          <a:lstStyle/>
+          <a:p>
+            <a:r>
+              <a:rPr lang="en-US" altLang="zh-CN" sz="1200">
+                <a:solidFill>
+                  <a:srgbClr val="FFFFFF"/>
+                </a:solidFill>
+                <a:latin typeface="Microsoft YaHei" panose="020B0503020204020204" pitchFamily="34" charset="-122"/>
+                <a:ea typeface="Microsoft YaHei" panose="020B0503020204020204" pitchFamily="34" charset="-122"/>
+              </a:rPr>
+              <a:t>____</a:t>
+            </a:r>
+            <a:r>
+              <a:rPr lang="zh-CN" altLang="en-US" sz="1200">
+                <a:solidFill>
+                  <a:srgbClr val="FFFFFF"/>
+                </a:solidFill>
+                <a:latin typeface="Microsoft YaHei" panose="020B0503020204020204" pitchFamily="34" charset="-122"/>
+                <a:ea typeface="Microsoft YaHei" panose="020B0503020204020204" pitchFamily="34" charset="-122"/>
+              </a:rPr>
+              <a:t>（选 </a:t>
+            </a:r>
+            <a:r>
+              <a:rPr lang="en-US" altLang="zh-CN" sz="1200">
+                <a:solidFill>
+                  <a:srgbClr val="FFFFFF"/>
+                </a:solidFill>
+                <a:latin typeface="Microsoft YaHei" panose="020B0503020204020204" pitchFamily="34" charset="-122"/>
+                <a:ea typeface="Microsoft YaHei" panose="020B0503020204020204" pitchFamily="34" charset="-122"/>
+              </a:rPr>
+              <a:t>1 </a:t>
+            </a:r>
+            <a:r>
+              <a:rPr lang="zh-CN" altLang="en-US" sz="1200">
+                <a:solidFill>
+                  <a:srgbClr val="FFFFFF"/>
+                </a:solidFill>
+                <a:latin typeface="Microsoft YaHei" panose="020B0503020204020204" pitchFamily="34" charset="-122"/>
+                <a:ea typeface="Microsoft YaHei" panose="020B0503020204020204" pitchFamily="34" charset="-122"/>
+              </a:rPr>
+              <a:t>个）</a:t>
+            </a:r>
+          </a:p>
+        </p:txBody>
+      </p:sp>
+      <p:sp>
+        <p:nvSpPr>
+          <p:cNvPr id="39" name="TEACHING_CUE">
+            <a:extLst>
+              <a:ext uri="{FF2B5EF4-FFF2-40B4-BE49-F238E27FC236}">
+                <a16:creationId xmlns:a16="http://schemas.microsoft.com/office/drawing/2014/main" id="{8C34CACC-2A17-882E-E2E3-05E617781765}"/>
+              </a:ext>
+            </a:extLst>
+          </p:cNvPr>
+          <p:cNvSpPr txBox="1"/>
+          <p:nvPr/>
+        </p:nvSpPr>
+        <p:spPr>
+          <a:xfrm>
+            <a:off x="548640" y="6263640"/>
+            <a:ext cx="11064240" cy="365760"/>
+          </a:xfrm>
+          <a:prstGeom prst="rect">
+            <a:avLst/>
+          </a:prstGeom>
+          <a:noFill/>
+        </p:spPr>
+        <p:txBody>
+          <a:bodyPr vert="horz" wrap="square" rtlCol="0">
+            <a:noAutofit/>
+          </a:bodyPr>
+          <a:lstStyle/>
+          <a:p>
+            <a:r>
+              <a:rPr lang="zh-CN" altLang="en-US" sz="1200">
+                <a:solidFill>
+                  <a:srgbClr val="6F6F6A"/>
+                </a:solidFill>
+                <a:latin typeface="Microsoft YaHei" panose="020B0503020204020204" pitchFamily="34" charset="-122"/>
+                <a:ea typeface="Microsoft YaHei" panose="020B0503020204020204" pitchFamily="34" charset="-122"/>
+              </a:rPr>
+              <a:t>先按经营价值排序，再加实施难度；用「高</a:t>
+            </a:r>
+            <a:r>
+              <a:rPr lang="en-US" altLang="zh-CN" sz="1200">
+                <a:solidFill>
+                  <a:srgbClr val="6F6F6A"/>
+                </a:solidFill>
+                <a:latin typeface="Microsoft YaHei" panose="020B0503020204020204" pitchFamily="34" charset="-122"/>
+                <a:ea typeface="Microsoft YaHei" panose="020B0503020204020204" pitchFamily="34" charset="-122"/>
+              </a:rPr>
+              <a:t>/</a:t>
+            </a:r>
+            <a:r>
+              <a:rPr lang="zh-CN" altLang="en-US" sz="1200">
+                <a:solidFill>
+                  <a:srgbClr val="6F6F6A"/>
+                </a:solidFill>
+                <a:latin typeface="Microsoft YaHei" panose="020B0503020204020204" pitchFamily="34" charset="-122"/>
+                <a:ea typeface="Microsoft YaHei" panose="020B0503020204020204" pitchFamily="34" charset="-122"/>
+              </a:rPr>
+              <a:t>中</a:t>
+            </a:r>
+            <a:r>
+              <a:rPr lang="en-US" altLang="zh-CN" sz="1200">
+                <a:solidFill>
+                  <a:srgbClr val="6F6F6A"/>
+                </a:solidFill>
+                <a:latin typeface="Microsoft YaHei" panose="020B0503020204020204" pitchFamily="34" charset="-122"/>
+                <a:ea typeface="Microsoft YaHei" panose="020B0503020204020204" pitchFamily="34" charset="-122"/>
+              </a:rPr>
+              <a:t>/</a:t>
+            </a:r>
+            <a:r>
+              <a:rPr lang="zh-CN" altLang="en-US" sz="1200">
+                <a:solidFill>
+                  <a:srgbClr val="6F6F6A"/>
+                </a:solidFill>
+                <a:latin typeface="Microsoft YaHei" panose="020B0503020204020204" pitchFamily="34" charset="-122"/>
+                <a:ea typeface="Microsoft YaHei" panose="020B0503020204020204" pitchFamily="34" charset="-122"/>
+              </a:rPr>
+              <a:t>低 </a:t>
+            </a:r>
+            <a:r>
+              <a:rPr lang="en-US" altLang="zh-CN" sz="1200">
+                <a:solidFill>
+                  <a:srgbClr val="6F6F6A"/>
+                </a:solidFill>
+                <a:latin typeface="Microsoft YaHei" panose="020B0503020204020204" pitchFamily="34" charset="-122"/>
+                <a:ea typeface="Microsoft YaHei" panose="020B0503020204020204" pitchFamily="34" charset="-122"/>
+              </a:rPr>
+              <a:t>+ </a:t>
+            </a:r>
+            <a:r>
+              <a:rPr lang="zh-CN" altLang="en-US" sz="1200">
+                <a:solidFill>
+                  <a:srgbClr val="6F6F6A"/>
+                </a:solidFill>
+                <a:latin typeface="Microsoft YaHei" panose="020B0503020204020204" pitchFamily="34" charset="-122"/>
+                <a:ea typeface="Microsoft YaHei" panose="020B0503020204020204" pitchFamily="34" charset="-122"/>
+              </a:rPr>
+              <a:t>证据 </a:t>
+            </a:r>
+            <a:r>
+              <a:rPr lang="en-US" altLang="zh-CN" sz="1200">
+                <a:solidFill>
+                  <a:srgbClr val="6F6F6A"/>
+                </a:solidFill>
+                <a:latin typeface="Microsoft YaHei" panose="020B0503020204020204" pitchFamily="34" charset="-122"/>
+                <a:ea typeface="Microsoft YaHei" panose="020B0503020204020204" pitchFamily="34" charset="-122"/>
+              </a:rPr>
+              <a:t>+ </a:t>
+            </a:r>
+            <a:r>
+              <a:rPr lang="zh-CN" altLang="en-US" sz="1200">
+                <a:solidFill>
+                  <a:srgbClr val="6F6F6A"/>
+                </a:solidFill>
+                <a:latin typeface="Microsoft YaHei" panose="020B0503020204020204" pitchFamily="34" charset="-122"/>
+                <a:ea typeface="Microsoft YaHei" panose="020B0503020204020204" pitchFamily="34" charset="-122"/>
+              </a:rPr>
+              <a:t>待验证字段」，不打精确分数。</a:t>
+            </a:r>
+          </a:p>
+        </p:txBody>
+      </p:sp>
+    </p:spTree>
+    <p:extLst>
+      <p:ext uri="{BB962C8B-B14F-4D97-AF65-F5344CB8AC3E}">
+        <p14:creationId xmlns:p14="http://schemas.microsoft.com/office/powerpoint/2010/main" val="1518005111"/>
       </p:ext>
     </p:extLst>
   </p:cSld>

</xml_diff>

<commit_message>
Add DC-06 product battle board (slide 11) via production line
Opportunity (find) loop now complete: DC-06 executable (slide 11, id 266#), three-lever driver board (铺货×动销×核心品项产出) + core contradiction + SKU strategy band (守/扩/育/淘汰), 33 named objects, token colors, same visual family as DC-05. Full pipeline: build-dc06.ps1 -> verify -> preview component-11.png -> registry -> generator (index/catalog SHA CECA243C) -> contact sheet -> promote -> slot contract + build contract synced.
</commit_message>
<xml_diff>
--- a/domains/yuhong/assets/components/yuhong-county-course-components-branded.pptx
+++ b/domains/yuhong/assets/components/yuhong-county-course-components-branded.pptx
@@ -5,7 +5,7 @@
     <p:sldMasterId id="2147483648" r:id="rId1"/>
   </p:sldMasterIdLst>
   <p:notesMasterIdLst>
-    <p:notesMasterId r:id="rId12"/>
+    <p:notesMasterId r:id="rId13"/>
   </p:notesMasterIdLst>
   <p:sldIdLst>
     <p:sldId id="256" r:id="rId2"/>
@@ -18,6 +18,7 @@
     <p:sldId id="263" r:id="rId9"/>
     <p:sldId id="264" r:id="rId10"/>
     <p:sldId id="265" r:id="rId11"/>
+    <p:sldId id="266" r:id="rId12"/>
   </p:sldIdLst>
   <p:sldSz cx="12192000" cy="6858000"/>
   <p:notesSz cx="6858000" cy="9144000"/>
@@ -4634,6 +4635,1829 @@
     <p:extLst>
       <p:ext uri="{BB962C8B-B14F-4D97-AF65-F5344CB8AC3E}">
         <p14:creationId xmlns:p14="http://schemas.microsoft.com/office/powerpoint/2010/main" val="1518005111"/>
+      </p:ext>
+    </p:extLst>
+  </p:cSld>
+  <p:clrMapOvr>
+    <a:masterClrMapping/>
+  </p:clrMapOvr>
+</p:sld>
+</file>
+
+<file path=ppt/slides/slide11.xml><?xml version="1.0" encoding="utf-8"?>
+<p:sld xmlns:a="http://schemas.openxmlformats.org/drawingml/2006/main" xmlns:r="http://schemas.openxmlformats.org/officeDocument/2006/relationships" xmlns:p="http://schemas.openxmlformats.org/presentationml/2006/main">
+  <p:cSld>
+    <p:spTree>
+      <p:nvGrpSpPr>
+        <p:cNvPr id="1" name=""/>
+        <p:cNvGrpSpPr/>
+        <p:nvPr/>
+      </p:nvGrpSpPr>
+      <p:grpSpPr>
+        <a:xfrm>
+          <a:off x="0" y="0"/>
+          <a:ext cx="0" cy="0"/>
+          <a:chOff x="0" y="0"/>
+          <a:chExt cx="0" cy="0"/>
+        </a:xfrm>
+      </p:grpSpPr>
+      <p:sp>
+        <p:nvSpPr>
+          <p:cNvPr id="2" name="TITLE">
+            <a:extLst>
+              <a:ext uri="{FF2B5EF4-FFF2-40B4-BE49-F238E27FC236}">
+                <a16:creationId xmlns:a16="http://schemas.microsoft.com/office/drawing/2014/main" id="{13233FEB-5B3F-7EDC-FEF0-59E330411D99}"/>
+              </a:ext>
+            </a:extLst>
+          </p:cNvPr>
+          <p:cNvSpPr txBox="1"/>
+          <p:nvPr/>
+        </p:nvSpPr>
+        <p:spPr>
+          <a:xfrm>
+            <a:off x="548640" y="384048"/>
+            <a:ext cx="10789920" cy="369332"/>
+          </a:xfrm>
+          <a:prstGeom prst="rect">
+            <a:avLst/>
+          </a:prstGeom>
+          <a:noFill/>
+        </p:spPr>
+        <p:txBody>
+          <a:bodyPr vert="horz" wrap="square" rtlCol="0">
+            <a:noAutofit/>
+          </a:bodyPr>
+          <a:lstStyle/>
+          <a:p>
+            <a:r>
+              <a:rPr lang="zh-CN" altLang="en-US" sz="2600" b="1">
+                <a:solidFill>
+                  <a:srgbClr val="505046"/>
+                </a:solidFill>
+                <a:latin typeface="Microsoft YaHei" panose="020B0503020204020204" pitchFamily="34" charset="-122"/>
+                <a:ea typeface="Microsoft YaHei" panose="020B0503020204020204" pitchFamily="34" charset="-122"/>
+              </a:rPr>
+              <a:t>产品增长卡在哪：铺得更广、卖得更动，还是核心品项产出？</a:t>
+            </a:r>
+          </a:p>
+        </p:txBody>
+      </p:sp>
+      <p:sp>
+        <p:nvSpPr>
+          <p:cNvPr id="3" name="SUBTITLE">
+            <a:extLst>
+              <a:ext uri="{FF2B5EF4-FFF2-40B4-BE49-F238E27FC236}">
+                <a16:creationId xmlns:a16="http://schemas.microsoft.com/office/drawing/2014/main" id="{6914DCF3-D917-3A0C-FC85-06723E57DA52}"/>
+              </a:ext>
+            </a:extLst>
+          </p:cNvPr>
+          <p:cNvSpPr txBox="1"/>
+          <p:nvPr/>
+        </p:nvSpPr>
+        <p:spPr>
+          <a:xfrm>
+            <a:off x="548640" y="987552"/>
+            <a:ext cx="10789920" cy="369332"/>
+          </a:xfrm>
+          <a:prstGeom prst="rect">
+            <a:avLst/>
+          </a:prstGeom>
+          <a:noFill/>
+        </p:spPr>
+        <p:txBody>
+          <a:bodyPr vert="horz" wrap="square" rtlCol="0">
+            <a:noAutofit/>
+          </a:bodyPr>
+          <a:lstStyle/>
+          <a:p>
+            <a:r>
+              <a:rPr lang="zh-CN" altLang="en-US" sz="1400">
+                <a:solidFill>
+                  <a:srgbClr val="6F6F6A"/>
+                </a:solidFill>
+                <a:latin typeface="Microsoft YaHei" panose="020B0503020204020204" pitchFamily="34" charset="-122"/>
+                <a:ea typeface="Microsoft YaHei" panose="020B0503020204020204" pitchFamily="34" charset="-122"/>
+              </a:rPr>
+              <a:t>产品增长 </a:t>
+            </a:r>
+            <a:r>
+              <a:rPr lang="en-US" altLang="zh-CN" sz="1400">
+                <a:solidFill>
+                  <a:srgbClr val="6F6F6A"/>
+                </a:solidFill>
+                <a:latin typeface="Microsoft YaHei" panose="020B0503020204020204" pitchFamily="34" charset="-122"/>
+                <a:ea typeface="Microsoft YaHei" panose="020B0503020204020204" pitchFamily="34" charset="-122"/>
+              </a:rPr>
+              <a:t>= </a:t>
+            </a:r>
+            <a:r>
+              <a:rPr lang="zh-CN" altLang="en-US" sz="1400">
+                <a:solidFill>
+                  <a:srgbClr val="6F6F6A"/>
+                </a:solidFill>
+                <a:latin typeface="Microsoft YaHei" panose="020B0503020204020204" pitchFamily="34" charset="-122"/>
+                <a:ea typeface="Microsoft YaHei" panose="020B0503020204020204" pitchFamily="34" charset="-122"/>
+              </a:rPr>
+              <a:t>铺货网点 </a:t>
+            </a:r>
+            <a:r>
+              <a:rPr lang="en-US" altLang="zh-CN" sz="1400">
+                <a:solidFill>
+                  <a:srgbClr val="6F6F6A"/>
+                </a:solidFill>
+                <a:latin typeface="Microsoft YaHei" panose="020B0503020204020204" pitchFamily="34" charset="-122"/>
+                <a:ea typeface="Microsoft YaHei" panose="020B0503020204020204" pitchFamily="34" charset="-122"/>
+              </a:rPr>
+              <a:t>× </a:t>
+            </a:r>
+            <a:r>
+              <a:rPr lang="zh-CN" altLang="en-US" sz="1400">
+                <a:solidFill>
+                  <a:srgbClr val="6F6F6A"/>
+                </a:solidFill>
+                <a:latin typeface="Microsoft YaHei" panose="020B0503020204020204" pitchFamily="34" charset="-122"/>
+                <a:ea typeface="Microsoft YaHei" panose="020B0503020204020204" pitchFamily="34" charset="-122"/>
+              </a:rPr>
+              <a:t>动销回转 </a:t>
+            </a:r>
+            <a:r>
+              <a:rPr lang="en-US" altLang="zh-CN" sz="1400">
+                <a:solidFill>
+                  <a:srgbClr val="6F6F6A"/>
+                </a:solidFill>
+                <a:latin typeface="Microsoft YaHei" panose="020B0503020204020204" pitchFamily="34" charset="-122"/>
+                <a:ea typeface="Microsoft YaHei" panose="020B0503020204020204" pitchFamily="34" charset="-122"/>
+              </a:rPr>
+              <a:t>× </a:t>
+            </a:r>
+            <a:r>
+              <a:rPr lang="zh-CN" altLang="en-US" sz="1400">
+                <a:solidFill>
+                  <a:srgbClr val="6F6F6A"/>
+                </a:solidFill>
+                <a:latin typeface="Microsoft YaHei" panose="020B0503020204020204" pitchFamily="34" charset="-122"/>
+                <a:ea typeface="Microsoft YaHei" panose="020B0503020204020204" pitchFamily="34" charset="-122"/>
+              </a:rPr>
+              <a:t>核心品项产出</a:t>
+            </a:r>
+            <a:r>
+              <a:rPr lang="en-US" altLang="zh-CN" sz="1400">
+                <a:solidFill>
+                  <a:srgbClr val="6F6F6A"/>
+                </a:solidFill>
+                <a:latin typeface="Microsoft YaHei" panose="020B0503020204020204" pitchFamily="34" charset="-122"/>
+                <a:ea typeface="Microsoft YaHei" panose="020B0503020204020204" pitchFamily="34" charset="-122"/>
+              </a:rPr>
+              <a:t>——</a:t>
+            </a:r>
+            <a:r>
+              <a:rPr lang="zh-CN" altLang="en-US" sz="1400">
+                <a:solidFill>
+                  <a:srgbClr val="6F6F6A"/>
+                </a:solidFill>
+                <a:latin typeface="Microsoft YaHei" panose="020B0503020204020204" pitchFamily="34" charset="-122"/>
+                <a:ea typeface="Microsoft YaHei" panose="020B0503020204020204" pitchFamily="34" charset="-122"/>
+              </a:rPr>
+              <a:t>先判断卡在哪个杠杆</a:t>
+            </a:r>
+          </a:p>
+        </p:txBody>
+      </p:sp>
+      <p:sp>
+        <p:nvSpPr>
+          <p:cNvPr id="4" name="LEVER_BAND_1">
+            <a:extLst>
+              <a:ext uri="{FF2B5EF4-FFF2-40B4-BE49-F238E27FC236}">
+                <a16:creationId xmlns:a16="http://schemas.microsoft.com/office/drawing/2014/main" id="{FEDEE5C4-7BC9-9CC7-B327-C8FEF12B8919}"/>
+              </a:ext>
+            </a:extLst>
+          </p:cNvPr>
+          <p:cNvSpPr/>
+          <p:nvPr/>
+        </p:nvSpPr>
+        <p:spPr>
+          <a:xfrm>
+            <a:off x="548640" y="1600200"/>
+            <a:ext cx="3474720" cy="2148840"/>
+          </a:xfrm>
+          <a:prstGeom prst="rect">
+            <a:avLst/>
+          </a:prstGeom>
+          <a:solidFill>
+            <a:srgbClr val="F7F7F8"/>
+          </a:solidFill>
+          <a:ln w="9525">
+            <a:solidFill>
+              <a:srgbClr val="6F6F6A"/>
+            </a:solidFill>
+          </a:ln>
+        </p:spPr>
+        <p:style>
+          <a:lnRef idx="2">
+            <a:schemeClr val="accent1">
+              <a:shade val="15000"/>
+            </a:schemeClr>
+          </a:lnRef>
+          <a:fillRef idx="1">
+            <a:schemeClr val="accent1"/>
+          </a:fillRef>
+          <a:effectRef idx="0">
+            <a:schemeClr val="accent1"/>
+          </a:effectRef>
+          <a:fontRef idx="minor">
+            <a:schemeClr val="lt1"/>
+          </a:fontRef>
+        </p:style>
+        <p:txBody>
+          <a:bodyPr rtlCol="0" anchor="ctr"/>
+          <a:lstStyle/>
+          <a:p>
+            <a:pPr algn="ctr"/>
+            <a:endParaRPr lang="zh-CN" altLang="en-US"/>
+          </a:p>
+        </p:txBody>
+      </p:sp>
+      <p:sp>
+        <p:nvSpPr>
+          <p:cNvPr id="5" name="L1_NAME">
+            <a:extLst>
+              <a:ext uri="{FF2B5EF4-FFF2-40B4-BE49-F238E27FC236}">
+                <a16:creationId xmlns:a16="http://schemas.microsoft.com/office/drawing/2014/main" id="{05AC0F55-E458-C52F-786F-087C6EB21846}"/>
+              </a:ext>
+            </a:extLst>
+          </p:cNvPr>
+          <p:cNvSpPr txBox="1"/>
+          <p:nvPr/>
+        </p:nvSpPr>
+        <p:spPr>
+          <a:xfrm>
+            <a:off x="777240" y="1783080"/>
+            <a:ext cx="3017520" cy="369332"/>
+          </a:xfrm>
+          <a:prstGeom prst="rect">
+            <a:avLst/>
+          </a:prstGeom>
+          <a:noFill/>
+        </p:spPr>
+        <p:txBody>
+          <a:bodyPr vert="horz" wrap="square" rtlCol="0">
+            <a:noAutofit/>
+          </a:bodyPr>
+          <a:lstStyle/>
+          <a:p>
+            <a:r>
+              <a:rPr lang="zh-CN" altLang="en-US" sz="1500" b="1">
+                <a:solidFill>
+                  <a:srgbClr val="E84C22"/>
+                </a:solidFill>
+                <a:latin typeface="Microsoft YaHei" panose="020B0503020204020204" pitchFamily="34" charset="-122"/>
+                <a:ea typeface="Microsoft YaHei" panose="020B0503020204020204" pitchFamily="34" charset="-122"/>
+              </a:rPr>
+              <a:t>杠杆一 </a:t>
+            </a:r>
+            <a:r>
+              <a:rPr lang="en-US" altLang="zh-CN" sz="1500" b="1">
+                <a:solidFill>
+                  <a:srgbClr val="E84C22"/>
+                </a:solidFill>
+                <a:latin typeface="Microsoft YaHei" panose="020B0503020204020204" pitchFamily="34" charset="-122"/>
+                <a:ea typeface="Microsoft YaHei" panose="020B0503020204020204" pitchFamily="34" charset="-122"/>
+              </a:rPr>
+              <a:t>· </a:t>
+            </a:r>
+            <a:r>
+              <a:rPr lang="zh-CN" altLang="en-US" sz="1500" b="1">
+                <a:solidFill>
+                  <a:srgbClr val="E84C22"/>
+                </a:solidFill>
+                <a:latin typeface="Microsoft YaHei" panose="020B0503020204020204" pitchFamily="34" charset="-122"/>
+                <a:ea typeface="Microsoft YaHei" panose="020B0503020204020204" pitchFamily="34" charset="-122"/>
+              </a:rPr>
+              <a:t>铺货</a:t>
+            </a:r>
+          </a:p>
+        </p:txBody>
+      </p:sp>
+      <p:sp>
+        <p:nvSpPr>
+          <p:cNvPr id="6" name="L1_QUESTION">
+            <a:extLst>
+              <a:ext uri="{FF2B5EF4-FFF2-40B4-BE49-F238E27FC236}">
+                <a16:creationId xmlns:a16="http://schemas.microsoft.com/office/drawing/2014/main" id="{750BBAC5-6861-6C70-5AC5-A748A54B9D42}"/>
+              </a:ext>
+            </a:extLst>
+          </p:cNvPr>
+          <p:cNvSpPr txBox="1"/>
+          <p:nvPr/>
+        </p:nvSpPr>
+        <p:spPr>
+          <a:xfrm>
+            <a:off x="777240" y="2286000"/>
+            <a:ext cx="3017520" cy="369332"/>
+          </a:xfrm>
+          <a:prstGeom prst="rect">
+            <a:avLst/>
+          </a:prstGeom>
+          <a:noFill/>
+        </p:spPr>
+        <p:txBody>
+          <a:bodyPr vert="horz" wrap="square" rtlCol="0">
+            <a:noAutofit/>
+          </a:bodyPr>
+          <a:lstStyle/>
+          <a:p>
+            <a:r>
+              <a:rPr lang="zh-CN" altLang="en-US" sz="1300" b="1">
+                <a:solidFill>
+                  <a:srgbClr val="505046"/>
+                </a:solidFill>
+                <a:latin typeface="Microsoft YaHei" panose="020B0503020204020204" pitchFamily="34" charset="-122"/>
+                <a:ea typeface="Microsoft YaHei" panose="020B0503020204020204" pitchFamily="34" charset="-122"/>
+              </a:rPr>
+              <a:t>铺得广吗？</a:t>
+            </a:r>
+          </a:p>
+        </p:txBody>
+      </p:sp>
+      <p:sp>
+        <p:nvSpPr>
+          <p:cNvPr id="7" name="L1_VALUE">
+            <a:extLst>
+              <a:ext uri="{FF2B5EF4-FFF2-40B4-BE49-F238E27FC236}">
+                <a16:creationId xmlns:a16="http://schemas.microsoft.com/office/drawing/2014/main" id="{8E8A664A-A2AA-6F94-49EA-F8F0841A504B}"/>
+              </a:ext>
+            </a:extLst>
+          </p:cNvPr>
+          <p:cNvSpPr txBox="1"/>
+          <p:nvPr/>
+        </p:nvSpPr>
+        <p:spPr>
+          <a:xfrm>
+            <a:off x="777240" y="2880360"/>
+            <a:ext cx="3017520" cy="369332"/>
+          </a:xfrm>
+          <a:prstGeom prst="rect">
+            <a:avLst/>
+          </a:prstGeom>
+          <a:noFill/>
+        </p:spPr>
+        <p:txBody>
+          <a:bodyPr vert="horz" wrap="square" rtlCol="0">
+            <a:noAutofit/>
+          </a:bodyPr>
+          <a:lstStyle/>
+          <a:p>
+            <a:r>
+              <a:rPr lang="zh-CN" altLang="en-US" sz="1200">
+                <a:solidFill>
+                  <a:srgbClr val="505046"/>
+                </a:solidFill>
+                <a:latin typeface="Microsoft YaHei" panose="020B0503020204020204" pitchFamily="34" charset="-122"/>
+                <a:ea typeface="Microsoft YaHei" panose="020B0503020204020204" pitchFamily="34" charset="-122"/>
+              </a:rPr>
+              <a:t>目标</a:t>
+            </a:r>
+            <a:r>
+              <a:rPr lang="en-US" altLang="zh-CN" sz="1200">
+                <a:solidFill>
+                  <a:srgbClr val="505046"/>
+                </a:solidFill>
+                <a:latin typeface="Microsoft YaHei" panose="020B0503020204020204" pitchFamily="34" charset="-122"/>
+                <a:ea typeface="Microsoft YaHei" panose="020B0503020204020204" pitchFamily="34" charset="-122"/>
+              </a:rPr>
+              <a:t>____</a:t>
+            </a:r>
+            <a:r>
+              <a:rPr lang="zh-CN" altLang="en-US" sz="1200">
+                <a:solidFill>
+                  <a:srgbClr val="505046"/>
+                </a:solidFill>
+                <a:latin typeface="Microsoft YaHei" panose="020B0503020204020204" pitchFamily="34" charset="-122"/>
+                <a:ea typeface="Microsoft YaHei" panose="020B0503020204020204" pitchFamily="34" charset="-122"/>
+              </a:rPr>
+              <a:t>个网点 ｜ 铺货</a:t>
+            </a:r>
+            <a:r>
+              <a:rPr lang="en-US" altLang="zh-CN" sz="1200">
+                <a:solidFill>
+                  <a:srgbClr val="505046"/>
+                </a:solidFill>
+                <a:latin typeface="Microsoft YaHei" panose="020B0503020204020204" pitchFamily="34" charset="-122"/>
+                <a:ea typeface="Microsoft YaHei" panose="020B0503020204020204" pitchFamily="34" charset="-122"/>
+              </a:rPr>
+              <a:t>____</a:t>
+            </a:r>
+            <a:r>
+              <a:rPr lang="zh-CN" altLang="en-US" sz="1200">
+                <a:solidFill>
+                  <a:srgbClr val="505046"/>
+                </a:solidFill>
+                <a:latin typeface="Microsoft YaHei" panose="020B0503020204020204" pitchFamily="34" charset="-122"/>
+                <a:ea typeface="Microsoft YaHei" panose="020B0503020204020204" pitchFamily="34" charset="-122"/>
+              </a:rPr>
+              <a:t>个</a:t>
+            </a:r>
+          </a:p>
+        </p:txBody>
+      </p:sp>
+      <p:sp>
+        <p:nvSpPr>
+          <p:cNvPr id="8" name="MULT_1">
+            <a:extLst>
+              <a:ext uri="{FF2B5EF4-FFF2-40B4-BE49-F238E27FC236}">
+                <a16:creationId xmlns:a16="http://schemas.microsoft.com/office/drawing/2014/main" id="{E244A3C0-CEC7-45B1-4AFF-E3B4ED6360FF}"/>
+              </a:ext>
+            </a:extLst>
+          </p:cNvPr>
+          <p:cNvSpPr txBox="1"/>
+          <p:nvPr/>
+        </p:nvSpPr>
+        <p:spPr>
+          <a:xfrm>
+            <a:off x="4041648" y="2377440"/>
+            <a:ext cx="274320" cy="369332"/>
+          </a:xfrm>
+          <a:prstGeom prst="rect">
+            <a:avLst/>
+          </a:prstGeom>
+          <a:noFill/>
+        </p:spPr>
+        <p:txBody>
+          <a:bodyPr vert="horz" wrap="square" rtlCol="0">
+            <a:noAutofit/>
+          </a:bodyPr>
+          <a:lstStyle/>
+          <a:p>
+            <a:pPr algn="ctr"/>
+            <a:r>
+              <a:rPr lang="en-US" altLang="zh-CN" sz="2000" b="1">
+                <a:solidFill>
+                  <a:srgbClr val="E84C22"/>
+                </a:solidFill>
+                <a:latin typeface="Microsoft YaHei" panose="020B0503020204020204" pitchFamily="34" charset="-122"/>
+                <a:ea typeface="Microsoft YaHei" panose="020B0503020204020204" pitchFamily="34" charset="-122"/>
+              </a:rPr>
+              <a:t>x</a:t>
+            </a:r>
+            <a:endParaRPr lang="zh-CN" altLang="en-US" sz="2000" b="1">
+              <a:solidFill>
+                <a:srgbClr val="E84C22"/>
+              </a:solidFill>
+              <a:latin typeface="Microsoft YaHei" panose="020B0503020204020204" pitchFamily="34" charset="-122"/>
+              <a:ea typeface="Microsoft YaHei" panose="020B0503020204020204" pitchFamily="34" charset="-122"/>
+            </a:endParaRPr>
+          </a:p>
+        </p:txBody>
+      </p:sp>
+      <p:sp>
+        <p:nvSpPr>
+          <p:cNvPr id="9" name="LEVER_BAND_2">
+            <a:extLst>
+              <a:ext uri="{FF2B5EF4-FFF2-40B4-BE49-F238E27FC236}">
+                <a16:creationId xmlns:a16="http://schemas.microsoft.com/office/drawing/2014/main" id="{D32A23FB-72AF-8AFB-83F9-AEA45C987028}"/>
+              </a:ext>
+            </a:extLst>
+          </p:cNvPr>
+          <p:cNvSpPr/>
+          <p:nvPr/>
+        </p:nvSpPr>
+        <p:spPr>
+          <a:xfrm>
+            <a:off x="4297680" y="1600200"/>
+            <a:ext cx="3474720" cy="2148840"/>
+          </a:xfrm>
+          <a:prstGeom prst="rect">
+            <a:avLst/>
+          </a:prstGeom>
+          <a:solidFill>
+            <a:srgbClr val="EEECE1"/>
+          </a:solidFill>
+          <a:ln w="9525">
+            <a:solidFill>
+              <a:srgbClr val="6F6F6A"/>
+            </a:solidFill>
+          </a:ln>
+        </p:spPr>
+        <p:style>
+          <a:lnRef idx="2">
+            <a:schemeClr val="accent1">
+              <a:shade val="15000"/>
+            </a:schemeClr>
+          </a:lnRef>
+          <a:fillRef idx="1">
+            <a:schemeClr val="accent1"/>
+          </a:fillRef>
+          <a:effectRef idx="0">
+            <a:schemeClr val="accent1"/>
+          </a:effectRef>
+          <a:fontRef idx="minor">
+            <a:schemeClr val="lt1"/>
+          </a:fontRef>
+        </p:style>
+        <p:txBody>
+          <a:bodyPr rtlCol="0" anchor="ctr"/>
+          <a:lstStyle/>
+          <a:p>
+            <a:pPr algn="ctr"/>
+            <a:endParaRPr lang="zh-CN" altLang="en-US"/>
+          </a:p>
+        </p:txBody>
+      </p:sp>
+      <p:sp>
+        <p:nvSpPr>
+          <p:cNvPr id="10" name="L2_NAME">
+            <a:extLst>
+              <a:ext uri="{FF2B5EF4-FFF2-40B4-BE49-F238E27FC236}">
+                <a16:creationId xmlns:a16="http://schemas.microsoft.com/office/drawing/2014/main" id="{E2036FE0-5401-8A45-26B7-BA892BBFBC7C}"/>
+              </a:ext>
+            </a:extLst>
+          </p:cNvPr>
+          <p:cNvSpPr txBox="1"/>
+          <p:nvPr/>
+        </p:nvSpPr>
+        <p:spPr>
+          <a:xfrm>
+            <a:off x="4526280" y="1783080"/>
+            <a:ext cx="3017520" cy="369332"/>
+          </a:xfrm>
+          <a:prstGeom prst="rect">
+            <a:avLst/>
+          </a:prstGeom>
+          <a:noFill/>
+        </p:spPr>
+        <p:txBody>
+          <a:bodyPr vert="horz" wrap="square" rtlCol="0">
+            <a:noAutofit/>
+          </a:bodyPr>
+          <a:lstStyle/>
+          <a:p>
+            <a:r>
+              <a:rPr lang="zh-CN" altLang="en-US" sz="1500" b="1">
+                <a:solidFill>
+                  <a:srgbClr val="E84C22"/>
+                </a:solidFill>
+                <a:latin typeface="Microsoft YaHei" panose="020B0503020204020204" pitchFamily="34" charset="-122"/>
+                <a:ea typeface="Microsoft YaHei" panose="020B0503020204020204" pitchFamily="34" charset="-122"/>
+              </a:rPr>
+              <a:t>杠杆二 </a:t>
+            </a:r>
+            <a:r>
+              <a:rPr lang="en-US" altLang="zh-CN" sz="1500" b="1">
+                <a:solidFill>
+                  <a:srgbClr val="E84C22"/>
+                </a:solidFill>
+                <a:latin typeface="Microsoft YaHei" panose="020B0503020204020204" pitchFamily="34" charset="-122"/>
+                <a:ea typeface="Microsoft YaHei" panose="020B0503020204020204" pitchFamily="34" charset="-122"/>
+              </a:rPr>
+              <a:t>· </a:t>
+            </a:r>
+            <a:r>
+              <a:rPr lang="zh-CN" altLang="en-US" sz="1500" b="1">
+                <a:solidFill>
+                  <a:srgbClr val="E84C22"/>
+                </a:solidFill>
+                <a:latin typeface="Microsoft YaHei" panose="020B0503020204020204" pitchFamily="34" charset="-122"/>
+                <a:ea typeface="Microsoft YaHei" panose="020B0503020204020204" pitchFamily="34" charset="-122"/>
+              </a:rPr>
+              <a:t>动销</a:t>
+            </a:r>
+          </a:p>
+        </p:txBody>
+      </p:sp>
+      <p:sp>
+        <p:nvSpPr>
+          <p:cNvPr id="11" name="L2_QUESTION">
+            <a:extLst>
+              <a:ext uri="{FF2B5EF4-FFF2-40B4-BE49-F238E27FC236}">
+                <a16:creationId xmlns:a16="http://schemas.microsoft.com/office/drawing/2014/main" id="{33F524A9-C071-4F99-0750-20F59B6F198E}"/>
+              </a:ext>
+            </a:extLst>
+          </p:cNvPr>
+          <p:cNvSpPr txBox="1"/>
+          <p:nvPr/>
+        </p:nvSpPr>
+        <p:spPr>
+          <a:xfrm>
+            <a:off x="4526280" y="2286000"/>
+            <a:ext cx="3017520" cy="369332"/>
+          </a:xfrm>
+          <a:prstGeom prst="rect">
+            <a:avLst/>
+          </a:prstGeom>
+          <a:noFill/>
+        </p:spPr>
+        <p:txBody>
+          <a:bodyPr vert="horz" wrap="square" rtlCol="0">
+            <a:noAutofit/>
+          </a:bodyPr>
+          <a:lstStyle/>
+          <a:p>
+            <a:r>
+              <a:rPr lang="zh-CN" altLang="en-US" sz="1300" b="1">
+                <a:solidFill>
+                  <a:srgbClr val="505046"/>
+                </a:solidFill>
+                <a:latin typeface="Microsoft YaHei" panose="020B0503020204020204" pitchFamily="34" charset="-122"/>
+                <a:ea typeface="Microsoft YaHei" panose="020B0503020204020204" pitchFamily="34" charset="-122"/>
+              </a:rPr>
+              <a:t>铺了，回转了吗？</a:t>
+            </a:r>
+          </a:p>
+        </p:txBody>
+      </p:sp>
+      <p:sp>
+        <p:nvSpPr>
+          <p:cNvPr id="12" name="L2_VALUE">
+            <a:extLst>
+              <a:ext uri="{FF2B5EF4-FFF2-40B4-BE49-F238E27FC236}">
+                <a16:creationId xmlns:a16="http://schemas.microsoft.com/office/drawing/2014/main" id="{A823C6AE-CA59-5623-702A-0D0E62A79D9C}"/>
+              </a:ext>
+            </a:extLst>
+          </p:cNvPr>
+          <p:cNvSpPr txBox="1"/>
+          <p:nvPr/>
+        </p:nvSpPr>
+        <p:spPr>
+          <a:xfrm>
+            <a:off x="4526280" y="2880360"/>
+            <a:ext cx="3017520" cy="369332"/>
+          </a:xfrm>
+          <a:prstGeom prst="rect">
+            <a:avLst/>
+          </a:prstGeom>
+          <a:noFill/>
+        </p:spPr>
+        <p:txBody>
+          <a:bodyPr vert="horz" wrap="square" rtlCol="0">
+            <a:noAutofit/>
+          </a:bodyPr>
+          <a:lstStyle/>
+          <a:p>
+            <a:r>
+              <a:rPr lang="zh-CN" altLang="en-US" sz="1200">
+                <a:solidFill>
+                  <a:srgbClr val="505046"/>
+                </a:solidFill>
+                <a:latin typeface="Microsoft YaHei" panose="020B0503020204020204" pitchFamily="34" charset="-122"/>
+                <a:ea typeface="Microsoft YaHei" panose="020B0503020204020204" pitchFamily="34" charset="-122"/>
+              </a:rPr>
+              <a:t>铺货</a:t>
+            </a:r>
+            <a:r>
+              <a:rPr lang="en-US" altLang="zh-CN" sz="1200">
+                <a:solidFill>
+                  <a:srgbClr val="505046"/>
+                </a:solidFill>
+                <a:latin typeface="Microsoft YaHei" panose="020B0503020204020204" pitchFamily="34" charset="-122"/>
+                <a:ea typeface="Microsoft YaHei" panose="020B0503020204020204" pitchFamily="34" charset="-122"/>
+              </a:rPr>
+              <a:t>____</a:t>
+            </a:r>
+            <a:r>
+              <a:rPr lang="zh-CN" altLang="en-US" sz="1200">
+                <a:solidFill>
+                  <a:srgbClr val="505046"/>
+                </a:solidFill>
+                <a:latin typeface="Microsoft YaHei" panose="020B0503020204020204" pitchFamily="34" charset="-122"/>
+                <a:ea typeface="Microsoft YaHei" panose="020B0503020204020204" pitchFamily="34" charset="-122"/>
+              </a:rPr>
+              <a:t>个 ｜ 回转</a:t>
+            </a:r>
+            <a:r>
+              <a:rPr lang="en-US" altLang="zh-CN" sz="1200">
+                <a:solidFill>
+                  <a:srgbClr val="505046"/>
+                </a:solidFill>
+                <a:latin typeface="Microsoft YaHei" panose="020B0503020204020204" pitchFamily="34" charset="-122"/>
+                <a:ea typeface="Microsoft YaHei" panose="020B0503020204020204" pitchFamily="34" charset="-122"/>
+              </a:rPr>
+              <a:t>____</a:t>
+            </a:r>
+            <a:r>
+              <a:rPr lang="zh-CN" altLang="en-US" sz="1200">
+                <a:solidFill>
+                  <a:srgbClr val="505046"/>
+                </a:solidFill>
+                <a:latin typeface="Microsoft YaHei" panose="020B0503020204020204" pitchFamily="34" charset="-122"/>
+                <a:ea typeface="Microsoft YaHei" panose="020B0503020204020204" pitchFamily="34" charset="-122"/>
+              </a:rPr>
+              <a:t>个</a:t>
+            </a:r>
+          </a:p>
+        </p:txBody>
+      </p:sp>
+      <p:sp>
+        <p:nvSpPr>
+          <p:cNvPr id="13" name="MULT_2">
+            <a:extLst>
+              <a:ext uri="{FF2B5EF4-FFF2-40B4-BE49-F238E27FC236}">
+                <a16:creationId xmlns:a16="http://schemas.microsoft.com/office/drawing/2014/main" id="{E59B378A-A4F3-32EF-5D87-2C7860BB8672}"/>
+              </a:ext>
+            </a:extLst>
+          </p:cNvPr>
+          <p:cNvSpPr txBox="1"/>
+          <p:nvPr/>
+        </p:nvSpPr>
+        <p:spPr>
+          <a:xfrm>
+            <a:off x="7790688" y="2377440"/>
+            <a:ext cx="274320" cy="369332"/>
+          </a:xfrm>
+          <a:prstGeom prst="rect">
+            <a:avLst/>
+          </a:prstGeom>
+          <a:noFill/>
+        </p:spPr>
+        <p:txBody>
+          <a:bodyPr vert="horz" wrap="square" rtlCol="0">
+            <a:noAutofit/>
+          </a:bodyPr>
+          <a:lstStyle/>
+          <a:p>
+            <a:pPr algn="ctr"/>
+            <a:r>
+              <a:rPr lang="en-US" altLang="zh-CN" sz="2000" b="1">
+                <a:solidFill>
+                  <a:srgbClr val="E84C22"/>
+                </a:solidFill>
+                <a:latin typeface="Microsoft YaHei" panose="020B0503020204020204" pitchFamily="34" charset="-122"/>
+                <a:ea typeface="Microsoft YaHei" panose="020B0503020204020204" pitchFamily="34" charset="-122"/>
+              </a:rPr>
+              <a:t>x</a:t>
+            </a:r>
+            <a:endParaRPr lang="zh-CN" altLang="en-US" sz="2000" b="1">
+              <a:solidFill>
+                <a:srgbClr val="E84C22"/>
+              </a:solidFill>
+              <a:latin typeface="Microsoft YaHei" panose="020B0503020204020204" pitchFamily="34" charset="-122"/>
+              <a:ea typeface="Microsoft YaHei" panose="020B0503020204020204" pitchFamily="34" charset="-122"/>
+            </a:endParaRPr>
+          </a:p>
+        </p:txBody>
+      </p:sp>
+      <p:sp>
+        <p:nvSpPr>
+          <p:cNvPr id="14" name="LEVER_BAND_3">
+            <a:extLst>
+              <a:ext uri="{FF2B5EF4-FFF2-40B4-BE49-F238E27FC236}">
+                <a16:creationId xmlns:a16="http://schemas.microsoft.com/office/drawing/2014/main" id="{D1A5C50C-29E0-38EC-3F61-B9116115DBCA}"/>
+              </a:ext>
+            </a:extLst>
+          </p:cNvPr>
+          <p:cNvSpPr/>
+          <p:nvPr/>
+        </p:nvSpPr>
+        <p:spPr>
+          <a:xfrm>
+            <a:off x="8046720" y="1600200"/>
+            <a:ext cx="3474719" cy="2148840"/>
+          </a:xfrm>
+          <a:prstGeom prst="rect">
+            <a:avLst/>
+          </a:prstGeom>
+          <a:solidFill>
+            <a:srgbClr val="F7F7F8"/>
+          </a:solidFill>
+          <a:ln w="9525">
+            <a:solidFill>
+              <a:srgbClr val="6F6F6A"/>
+            </a:solidFill>
+          </a:ln>
+        </p:spPr>
+        <p:style>
+          <a:lnRef idx="2">
+            <a:schemeClr val="accent1">
+              <a:shade val="15000"/>
+            </a:schemeClr>
+          </a:lnRef>
+          <a:fillRef idx="1">
+            <a:schemeClr val="accent1"/>
+          </a:fillRef>
+          <a:effectRef idx="0">
+            <a:schemeClr val="accent1"/>
+          </a:effectRef>
+          <a:fontRef idx="minor">
+            <a:schemeClr val="lt1"/>
+          </a:fontRef>
+        </p:style>
+        <p:txBody>
+          <a:bodyPr rtlCol="0" anchor="ctr"/>
+          <a:lstStyle/>
+          <a:p>
+            <a:pPr algn="ctr"/>
+            <a:endParaRPr lang="zh-CN" altLang="en-US"/>
+          </a:p>
+        </p:txBody>
+      </p:sp>
+      <p:sp>
+        <p:nvSpPr>
+          <p:cNvPr id="15" name="L3_NAME">
+            <a:extLst>
+              <a:ext uri="{FF2B5EF4-FFF2-40B4-BE49-F238E27FC236}">
+                <a16:creationId xmlns:a16="http://schemas.microsoft.com/office/drawing/2014/main" id="{6E579A35-6578-EA7C-31D4-2B8083AFCB39}"/>
+              </a:ext>
+            </a:extLst>
+          </p:cNvPr>
+          <p:cNvSpPr txBox="1"/>
+          <p:nvPr/>
+        </p:nvSpPr>
+        <p:spPr>
+          <a:xfrm>
+            <a:off x="8275320" y="1783080"/>
+            <a:ext cx="3017520" cy="369332"/>
+          </a:xfrm>
+          <a:prstGeom prst="rect">
+            <a:avLst/>
+          </a:prstGeom>
+          <a:noFill/>
+        </p:spPr>
+        <p:txBody>
+          <a:bodyPr vert="horz" wrap="square" rtlCol="0">
+            <a:noAutofit/>
+          </a:bodyPr>
+          <a:lstStyle/>
+          <a:p>
+            <a:r>
+              <a:rPr lang="zh-CN" altLang="en-US" sz="1500" b="1">
+                <a:solidFill>
+                  <a:srgbClr val="E84C22"/>
+                </a:solidFill>
+                <a:latin typeface="Microsoft YaHei" panose="020B0503020204020204" pitchFamily="34" charset="-122"/>
+                <a:ea typeface="Microsoft YaHei" panose="020B0503020204020204" pitchFamily="34" charset="-122"/>
+              </a:rPr>
+              <a:t>杠杆三 </a:t>
+            </a:r>
+            <a:r>
+              <a:rPr lang="en-US" altLang="zh-CN" sz="1500" b="1">
+                <a:solidFill>
+                  <a:srgbClr val="E84C22"/>
+                </a:solidFill>
+                <a:latin typeface="Microsoft YaHei" panose="020B0503020204020204" pitchFamily="34" charset="-122"/>
+                <a:ea typeface="Microsoft YaHei" panose="020B0503020204020204" pitchFamily="34" charset="-122"/>
+              </a:rPr>
+              <a:t>· </a:t>
+            </a:r>
+            <a:r>
+              <a:rPr lang="zh-CN" altLang="en-US" sz="1500" b="1">
+                <a:solidFill>
+                  <a:srgbClr val="E84C22"/>
+                </a:solidFill>
+                <a:latin typeface="Microsoft YaHei" panose="020B0503020204020204" pitchFamily="34" charset="-122"/>
+                <a:ea typeface="Microsoft YaHei" panose="020B0503020204020204" pitchFamily="34" charset="-122"/>
+              </a:rPr>
+              <a:t>核心品项产出</a:t>
+            </a:r>
+          </a:p>
+        </p:txBody>
+      </p:sp>
+      <p:sp>
+        <p:nvSpPr>
+          <p:cNvPr id="16" name="L3_QUESTION">
+            <a:extLst>
+              <a:ext uri="{FF2B5EF4-FFF2-40B4-BE49-F238E27FC236}">
+                <a16:creationId xmlns:a16="http://schemas.microsoft.com/office/drawing/2014/main" id="{1D041BAD-D1D0-B507-A9FE-56EA7655F466}"/>
+              </a:ext>
+            </a:extLst>
+          </p:cNvPr>
+          <p:cNvSpPr txBox="1"/>
+          <p:nvPr/>
+        </p:nvSpPr>
+        <p:spPr>
+          <a:xfrm>
+            <a:off x="8275320" y="2286000"/>
+            <a:ext cx="3017520" cy="369332"/>
+          </a:xfrm>
+          <a:prstGeom prst="rect">
+            <a:avLst/>
+          </a:prstGeom>
+          <a:noFill/>
+        </p:spPr>
+        <p:txBody>
+          <a:bodyPr vert="horz" wrap="square" rtlCol="0">
+            <a:noAutofit/>
+          </a:bodyPr>
+          <a:lstStyle/>
+          <a:p>
+            <a:r>
+              <a:rPr lang="zh-CN" altLang="en-US" sz="1300" b="1">
+                <a:solidFill>
+                  <a:srgbClr val="505046"/>
+                </a:solidFill>
+                <a:latin typeface="Microsoft YaHei" panose="020B0503020204020204" pitchFamily="34" charset="-122"/>
+                <a:ea typeface="Microsoft YaHei" panose="020B0503020204020204" pitchFamily="34" charset="-122"/>
+              </a:rPr>
+              <a:t>品项卖得动吗？</a:t>
+            </a:r>
+          </a:p>
+        </p:txBody>
+      </p:sp>
+      <p:sp>
+        <p:nvSpPr>
+          <p:cNvPr id="17" name="L3_VALUE">
+            <a:extLst>
+              <a:ext uri="{FF2B5EF4-FFF2-40B4-BE49-F238E27FC236}">
+                <a16:creationId xmlns:a16="http://schemas.microsoft.com/office/drawing/2014/main" id="{A2E973F4-4FD7-C5F0-6F4C-4E1FCC965ADD}"/>
+              </a:ext>
+            </a:extLst>
+          </p:cNvPr>
+          <p:cNvSpPr txBox="1"/>
+          <p:nvPr/>
+        </p:nvSpPr>
+        <p:spPr>
+          <a:xfrm>
+            <a:off x="8275320" y="2880360"/>
+            <a:ext cx="3017520" cy="369332"/>
+          </a:xfrm>
+          <a:prstGeom prst="rect">
+            <a:avLst/>
+          </a:prstGeom>
+          <a:noFill/>
+        </p:spPr>
+        <p:txBody>
+          <a:bodyPr vert="horz" wrap="square" rtlCol="0">
+            <a:noAutofit/>
+          </a:bodyPr>
+          <a:lstStyle/>
+          <a:p>
+            <a:r>
+              <a:rPr lang="zh-CN" altLang="en-US" sz="1200">
+                <a:solidFill>
+                  <a:srgbClr val="505046"/>
+                </a:solidFill>
+                <a:latin typeface="Microsoft YaHei" panose="020B0503020204020204" pitchFamily="34" charset="-122"/>
+                <a:ea typeface="Microsoft YaHei" panose="020B0503020204020204" pitchFamily="34" charset="-122"/>
+              </a:rPr>
+              <a:t>回转</a:t>
+            </a:r>
+            <a:r>
+              <a:rPr lang="en-US" altLang="zh-CN" sz="1200">
+                <a:solidFill>
+                  <a:srgbClr val="505046"/>
+                </a:solidFill>
+                <a:latin typeface="Microsoft YaHei" panose="020B0503020204020204" pitchFamily="34" charset="-122"/>
+                <a:ea typeface="Microsoft YaHei" panose="020B0503020204020204" pitchFamily="34" charset="-122"/>
+              </a:rPr>
+              <a:t>____</a:t>
+            </a:r>
+            <a:r>
+              <a:rPr lang="zh-CN" altLang="en-US" sz="1200">
+                <a:solidFill>
+                  <a:srgbClr val="505046"/>
+                </a:solidFill>
+                <a:latin typeface="Microsoft YaHei" panose="020B0503020204020204" pitchFamily="34" charset="-122"/>
+                <a:ea typeface="Microsoft YaHei" panose="020B0503020204020204" pitchFamily="34" charset="-122"/>
+              </a:rPr>
+              <a:t>个 </a:t>
+            </a:r>
+            <a:r>
+              <a:rPr lang="en-US" altLang="zh-CN" sz="1200">
+                <a:solidFill>
+                  <a:srgbClr val="505046"/>
+                </a:solidFill>
+                <a:latin typeface="Microsoft YaHei" panose="020B0503020204020204" pitchFamily="34" charset="-122"/>
+                <a:ea typeface="Microsoft YaHei" panose="020B0503020204020204" pitchFamily="34" charset="-122"/>
+              </a:rPr>
+              <a:t>× </a:t>
+            </a:r>
+            <a:r>
+              <a:rPr lang="zh-CN" altLang="en-US" sz="1200">
+                <a:solidFill>
+                  <a:srgbClr val="505046"/>
+                </a:solidFill>
+                <a:latin typeface="Microsoft YaHei" panose="020B0503020204020204" pitchFamily="34" charset="-122"/>
+                <a:ea typeface="Microsoft YaHei" panose="020B0503020204020204" pitchFamily="34" charset="-122"/>
+              </a:rPr>
+              <a:t>单品</a:t>
+            </a:r>
+            <a:r>
+              <a:rPr lang="en-US" altLang="zh-CN" sz="1200">
+                <a:solidFill>
+                  <a:srgbClr val="505046"/>
+                </a:solidFill>
+                <a:latin typeface="Microsoft YaHei" panose="020B0503020204020204" pitchFamily="34" charset="-122"/>
+                <a:ea typeface="Microsoft YaHei" panose="020B0503020204020204" pitchFamily="34" charset="-122"/>
+              </a:rPr>
+              <a:t>____</a:t>
+            </a:r>
+            <a:r>
+              <a:rPr lang="zh-CN" altLang="en-US" sz="1200">
+                <a:solidFill>
+                  <a:srgbClr val="505046"/>
+                </a:solidFill>
+                <a:latin typeface="Microsoft YaHei" panose="020B0503020204020204" pitchFamily="34" charset="-122"/>
+                <a:ea typeface="Microsoft YaHei" panose="020B0503020204020204" pitchFamily="34" charset="-122"/>
+              </a:rPr>
+              <a:t>元</a:t>
+            </a:r>
+          </a:p>
+        </p:txBody>
+      </p:sp>
+      <p:sp>
+        <p:nvSpPr>
+          <p:cNvPr id="18" name="CORE_BAND">
+            <a:extLst>
+              <a:ext uri="{FF2B5EF4-FFF2-40B4-BE49-F238E27FC236}">
+                <a16:creationId xmlns:a16="http://schemas.microsoft.com/office/drawing/2014/main" id="{F42265E0-5BF6-A670-52D2-57B9D0E8E288}"/>
+              </a:ext>
+            </a:extLst>
+          </p:cNvPr>
+          <p:cNvSpPr/>
+          <p:nvPr/>
+        </p:nvSpPr>
+        <p:spPr>
+          <a:xfrm>
+            <a:off x="548640" y="4023360"/>
+            <a:ext cx="11064240" cy="1143000"/>
+          </a:xfrm>
+          <a:prstGeom prst="rect">
+            <a:avLst/>
+          </a:prstGeom>
+          <a:solidFill>
+            <a:srgbClr val="505046"/>
+          </a:solidFill>
+          <a:ln w="9525">
+            <a:solidFill>
+              <a:srgbClr val="505046"/>
+            </a:solidFill>
+          </a:ln>
+        </p:spPr>
+        <p:style>
+          <a:lnRef idx="2">
+            <a:schemeClr val="accent1">
+              <a:shade val="15000"/>
+            </a:schemeClr>
+          </a:lnRef>
+          <a:fillRef idx="1">
+            <a:schemeClr val="accent1"/>
+          </a:fillRef>
+          <a:effectRef idx="0">
+            <a:schemeClr val="accent1"/>
+          </a:effectRef>
+          <a:fontRef idx="minor">
+            <a:schemeClr val="lt1"/>
+          </a:fontRef>
+        </p:style>
+        <p:txBody>
+          <a:bodyPr rtlCol="0" anchor="ctr"/>
+          <a:lstStyle/>
+          <a:p>
+            <a:pPr algn="ctr"/>
+            <a:endParaRPr lang="zh-CN" altLang="en-US"/>
+          </a:p>
+        </p:txBody>
+      </p:sp>
+      <p:sp>
+        <p:nvSpPr>
+          <p:cNvPr id="19" name="CORE_TITLE">
+            <a:extLst>
+              <a:ext uri="{FF2B5EF4-FFF2-40B4-BE49-F238E27FC236}">
+                <a16:creationId xmlns:a16="http://schemas.microsoft.com/office/drawing/2014/main" id="{88FA4898-8BB5-1A3B-AD7F-BC7424E8992E}"/>
+              </a:ext>
+            </a:extLst>
+          </p:cNvPr>
+          <p:cNvSpPr txBox="1"/>
+          <p:nvPr/>
+        </p:nvSpPr>
+        <p:spPr>
+          <a:xfrm>
+            <a:off x="777240" y="4187952"/>
+            <a:ext cx="2377440" cy="369332"/>
+          </a:xfrm>
+          <a:prstGeom prst="rect">
+            <a:avLst/>
+          </a:prstGeom>
+          <a:noFill/>
+        </p:spPr>
+        <p:txBody>
+          <a:bodyPr vert="horz" wrap="square" rtlCol="0">
+            <a:noAutofit/>
+          </a:bodyPr>
+          <a:lstStyle/>
+          <a:p>
+            <a:r>
+              <a:rPr lang="zh-CN" altLang="en-US" sz="1500" b="1">
+                <a:solidFill>
+                  <a:srgbClr val="FFFFFF"/>
+                </a:solidFill>
+                <a:latin typeface="Microsoft YaHei" panose="020B0503020204020204" pitchFamily="34" charset="-122"/>
+                <a:ea typeface="Microsoft YaHei" panose="020B0503020204020204" pitchFamily="34" charset="-122"/>
+              </a:rPr>
+              <a:t>主矛盾判断</a:t>
+            </a:r>
+          </a:p>
+        </p:txBody>
+      </p:sp>
+      <p:sp>
+        <p:nvSpPr>
+          <p:cNvPr id="20" name="CORE_FINDING">
+            <a:extLst>
+              <a:ext uri="{FF2B5EF4-FFF2-40B4-BE49-F238E27FC236}">
+                <a16:creationId xmlns:a16="http://schemas.microsoft.com/office/drawing/2014/main" id="{54550F49-ECFE-13D3-F09B-CBC5F1117AA0}"/>
+              </a:ext>
+            </a:extLst>
+          </p:cNvPr>
+          <p:cNvSpPr txBox="1"/>
+          <p:nvPr/>
+        </p:nvSpPr>
+        <p:spPr>
+          <a:xfrm>
+            <a:off x="3291840" y="4224528"/>
+            <a:ext cx="8138160" cy="369332"/>
+          </a:xfrm>
+          <a:prstGeom prst="rect">
+            <a:avLst/>
+          </a:prstGeom>
+          <a:noFill/>
+        </p:spPr>
+        <p:txBody>
+          <a:bodyPr vert="horz" wrap="square" rtlCol="0">
+            <a:noAutofit/>
+          </a:bodyPr>
+          <a:lstStyle/>
+          <a:p>
+            <a:r>
+              <a:rPr lang="zh-CN" altLang="en-US" sz="1500">
+                <a:solidFill>
+                  <a:srgbClr val="FFFFFF"/>
+                </a:solidFill>
+                <a:latin typeface="Microsoft YaHei" panose="020B0503020204020204" pitchFamily="34" charset="-122"/>
+                <a:ea typeface="Microsoft YaHei" panose="020B0503020204020204" pitchFamily="34" charset="-122"/>
+              </a:rPr>
+              <a:t>当前最卡：</a:t>
+            </a:r>
+            <a:r>
+              <a:rPr lang="en-US" altLang="zh-CN" sz="1500">
+                <a:solidFill>
+                  <a:srgbClr val="FFFFFF"/>
+                </a:solidFill>
+                <a:latin typeface="Microsoft YaHei" panose="020B0503020204020204" pitchFamily="34" charset="-122"/>
+                <a:ea typeface="Microsoft YaHei" panose="020B0503020204020204" pitchFamily="34" charset="-122"/>
+              </a:rPr>
+              <a:t>____</a:t>
+            </a:r>
+            <a:r>
+              <a:rPr lang="zh-CN" altLang="en-US" sz="1500">
+                <a:solidFill>
+                  <a:srgbClr val="FFFFFF"/>
+                </a:solidFill>
+                <a:latin typeface="Microsoft YaHei" panose="020B0503020204020204" pitchFamily="34" charset="-122"/>
+                <a:ea typeface="Microsoft YaHei" panose="020B0503020204020204" pitchFamily="34" charset="-122"/>
+              </a:rPr>
+              <a:t>杠杆（依据：</a:t>
+            </a:r>
+            <a:r>
+              <a:rPr lang="en-US" altLang="zh-CN" sz="1500">
+                <a:solidFill>
+                  <a:srgbClr val="FFFFFF"/>
+                </a:solidFill>
+                <a:latin typeface="Microsoft YaHei" panose="020B0503020204020204" pitchFamily="34" charset="-122"/>
+                <a:ea typeface="Microsoft YaHei" panose="020B0503020204020204" pitchFamily="34" charset="-122"/>
+              </a:rPr>
+              <a:t>____</a:t>
+            </a:r>
+            <a:r>
+              <a:rPr lang="zh-CN" altLang="en-US" sz="1500">
+                <a:solidFill>
+                  <a:srgbClr val="FFFFFF"/>
+                </a:solidFill>
+                <a:latin typeface="Microsoft YaHei" panose="020B0503020204020204" pitchFamily="34" charset="-122"/>
+                <a:ea typeface="Microsoft YaHei" panose="020B0503020204020204" pitchFamily="34" charset="-122"/>
+              </a:rPr>
+              <a:t>）</a:t>
+            </a:r>
+          </a:p>
+        </p:txBody>
+      </p:sp>
+      <p:sp>
+        <p:nvSpPr>
+          <p:cNvPr id="21" name="SKU_TITLE">
+            <a:extLst>
+              <a:ext uri="{FF2B5EF4-FFF2-40B4-BE49-F238E27FC236}">
+                <a16:creationId xmlns:a16="http://schemas.microsoft.com/office/drawing/2014/main" id="{38F04CB4-60C4-B623-D175-F63997849F5B}"/>
+              </a:ext>
+            </a:extLst>
+          </p:cNvPr>
+          <p:cNvSpPr txBox="1"/>
+          <p:nvPr/>
+        </p:nvSpPr>
+        <p:spPr>
+          <a:xfrm>
+            <a:off x="548640" y="5394960"/>
+            <a:ext cx="2194560" cy="369332"/>
+          </a:xfrm>
+          <a:prstGeom prst="rect">
+            <a:avLst/>
+          </a:prstGeom>
+          <a:noFill/>
+        </p:spPr>
+        <p:txBody>
+          <a:bodyPr vert="horz" wrap="square" rtlCol="0">
+            <a:noAutofit/>
+          </a:bodyPr>
+          <a:lstStyle/>
+          <a:p>
+            <a:r>
+              <a:rPr lang="zh-CN" altLang="en-US" sz="1500" b="1">
+                <a:solidFill>
+                  <a:srgbClr val="E84C22"/>
+                </a:solidFill>
+                <a:latin typeface="Microsoft YaHei" panose="020B0503020204020204" pitchFamily="34" charset="-122"/>
+                <a:ea typeface="Microsoft YaHei" panose="020B0503020204020204" pitchFamily="34" charset="-122"/>
+              </a:rPr>
+              <a:t>核心品项策略</a:t>
+            </a:r>
+          </a:p>
+        </p:txBody>
+      </p:sp>
+      <p:sp>
+        <p:nvSpPr>
+          <p:cNvPr id="22" name="SKU_BAND_1">
+            <a:extLst>
+              <a:ext uri="{FF2B5EF4-FFF2-40B4-BE49-F238E27FC236}">
+                <a16:creationId xmlns:a16="http://schemas.microsoft.com/office/drawing/2014/main" id="{BABB55BF-8E45-4362-EC7F-04A0558CD713}"/>
+              </a:ext>
+            </a:extLst>
+          </p:cNvPr>
+          <p:cNvSpPr/>
+          <p:nvPr/>
+        </p:nvSpPr>
+        <p:spPr>
+          <a:xfrm>
+            <a:off x="548640" y="5394960"/>
+            <a:ext cx="2468880" cy="914400"/>
+          </a:xfrm>
+          <a:prstGeom prst="rect">
+            <a:avLst/>
+          </a:prstGeom>
+          <a:solidFill>
+            <a:srgbClr val="F7F7F8"/>
+          </a:solidFill>
+          <a:ln w="9525">
+            <a:solidFill>
+              <a:srgbClr val="6F6F6A"/>
+            </a:solidFill>
+          </a:ln>
+        </p:spPr>
+        <p:style>
+          <a:lnRef idx="2">
+            <a:schemeClr val="accent1">
+              <a:shade val="15000"/>
+            </a:schemeClr>
+          </a:lnRef>
+          <a:fillRef idx="1">
+            <a:schemeClr val="accent1"/>
+          </a:fillRef>
+          <a:effectRef idx="0">
+            <a:schemeClr val="accent1"/>
+          </a:effectRef>
+          <a:fontRef idx="minor">
+            <a:schemeClr val="lt1"/>
+          </a:fontRef>
+        </p:style>
+        <p:txBody>
+          <a:bodyPr rtlCol="0" anchor="ctr"/>
+          <a:lstStyle/>
+          <a:p>
+            <a:pPr algn="ctr"/>
+            <a:endParaRPr lang="zh-CN" altLang="en-US"/>
+          </a:p>
+        </p:txBody>
+      </p:sp>
+      <p:sp>
+        <p:nvSpPr>
+          <p:cNvPr id="23" name="SKU_1_LABEL">
+            <a:extLst>
+              <a:ext uri="{FF2B5EF4-FFF2-40B4-BE49-F238E27FC236}">
+                <a16:creationId xmlns:a16="http://schemas.microsoft.com/office/drawing/2014/main" id="{9C2271AB-D720-355C-DBF5-BC865266B3F3}"/>
+              </a:ext>
+            </a:extLst>
+          </p:cNvPr>
+          <p:cNvSpPr txBox="1"/>
+          <p:nvPr/>
+        </p:nvSpPr>
+        <p:spPr>
+          <a:xfrm>
+            <a:off x="685800" y="5440680"/>
+            <a:ext cx="914400" cy="369332"/>
+          </a:xfrm>
+          <a:prstGeom prst="rect">
+            <a:avLst/>
+          </a:prstGeom>
+          <a:noFill/>
+        </p:spPr>
+        <p:txBody>
+          <a:bodyPr vert="horz" wrap="square" rtlCol="0">
+            <a:noAutofit/>
+          </a:bodyPr>
+          <a:lstStyle/>
+          <a:p>
+            <a:r>
+              <a:rPr lang="zh-CN" altLang="en-US" sz="1300" b="1">
+                <a:solidFill>
+                  <a:srgbClr val="E84C22"/>
+                </a:solidFill>
+                <a:latin typeface="Microsoft YaHei" panose="020B0503020204020204" pitchFamily="34" charset="-122"/>
+                <a:ea typeface="Microsoft YaHei" panose="020B0503020204020204" pitchFamily="34" charset="-122"/>
+              </a:rPr>
+              <a:t>守</a:t>
+            </a:r>
+          </a:p>
+        </p:txBody>
+      </p:sp>
+      <p:sp>
+        <p:nvSpPr>
+          <p:cNvPr id="24" name="SKU_1_TEXT">
+            <a:extLst>
+              <a:ext uri="{FF2B5EF4-FFF2-40B4-BE49-F238E27FC236}">
+                <a16:creationId xmlns:a16="http://schemas.microsoft.com/office/drawing/2014/main" id="{E1D7ADB7-68AA-0B96-D23D-60E6A01B703A}"/>
+              </a:ext>
+            </a:extLst>
+          </p:cNvPr>
+          <p:cNvSpPr txBox="1"/>
+          <p:nvPr/>
+        </p:nvSpPr>
+        <p:spPr>
+          <a:xfrm>
+            <a:off x="685800" y="5806440"/>
+            <a:ext cx="2194560" cy="369332"/>
+          </a:xfrm>
+          <a:prstGeom prst="rect">
+            <a:avLst/>
+          </a:prstGeom>
+          <a:noFill/>
+        </p:spPr>
+        <p:txBody>
+          <a:bodyPr vert="horz" wrap="square" rtlCol="0">
+            <a:noAutofit/>
+          </a:bodyPr>
+          <a:lstStyle/>
+          <a:p>
+            <a:r>
+              <a:rPr lang="zh-CN" altLang="en-US" sz="1100">
+                <a:solidFill>
+                  <a:srgbClr val="505046"/>
+                </a:solidFill>
+                <a:latin typeface="Microsoft YaHei" panose="020B0503020204020204" pitchFamily="34" charset="-122"/>
+                <a:ea typeface="Microsoft YaHei" panose="020B0503020204020204" pitchFamily="34" charset="-122"/>
+              </a:rPr>
+              <a:t>爆品做深：保覆盖、追复购</a:t>
+            </a:r>
+          </a:p>
+        </p:txBody>
+      </p:sp>
+      <p:sp>
+        <p:nvSpPr>
+          <p:cNvPr id="25" name="SKU_BAND_2">
+            <a:extLst>
+              <a:ext uri="{FF2B5EF4-FFF2-40B4-BE49-F238E27FC236}">
+                <a16:creationId xmlns:a16="http://schemas.microsoft.com/office/drawing/2014/main" id="{90DC4061-6732-C0D0-BD74-173CDAFBAA1B}"/>
+              </a:ext>
+            </a:extLst>
+          </p:cNvPr>
+          <p:cNvSpPr/>
+          <p:nvPr/>
+        </p:nvSpPr>
+        <p:spPr>
+          <a:xfrm>
+            <a:off x="3291840" y="5394960"/>
+            <a:ext cx="2468880" cy="914400"/>
+          </a:xfrm>
+          <a:prstGeom prst="rect">
+            <a:avLst/>
+          </a:prstGeom>
+          <a:solidFill>
+            <a:srgbClr val="EEECE1"/>
+          </a:solidFill>
+          <a:ln w="9525">
+            <a:solidFill>
+              <a:srgbClr val="6F6F6A"/>
+            </a:solidFill>
+          </a:ln>
+        </p:spPr>
+        <p:style>
+          <a:lnRef idx="2">
+            <a:schemeClr val="accent1">
+              <a:shade val="15000"/>
+            </a:schemeClr>
+          </a:lnRef>
+          <a:fillRef idx="1">
+            <a:schemeClr val="accent1"/>
+          </a:fillRef>
+          <a:effectRef idx="0">
+            <a:schemeClr val="accent1"/>
+          </a:effectRef>
+          <a:fontRef idx="minor">
+            <a:schemeClr val="lt1"/>
+          </a:fontRef>
+        </p:style>
+        <p:txBody>
+          <a:bodyPr rtlCol="0" anchor="ctr"/>
+          <a:lstStyle/>
+          <a:p>
+            <a:pPr algn="ctr"/>
+            <a:endParaRPr lang="zh-CN" altLang="en-US"/>
+          </a:p>
+        </p:txBody>
+      </p:sp>
+      <p:sp>
+        <p:nvSpPr>
+          <p:cNvPr id="26" name="SKU_2_LABEL">
+            <a:extLst>
+              <a:ext uri="{FF2B5EF4-FFF2-40B4-BE49-F238E27FC236}">
+                <a16:creationId xmlns:a16="http://schemas.microsoft.com/office/drawing/2014/main" id="{D5919042-9605-5FA2-ED02-3D33838816DB}"/>
+              </a:ext>
+            </a:extLst>
+          </p:cNvPr>
+          <p:cNvSpPr txBox="1"/>
+          <p:nvPr/>
+        </p:nvSpPr>
+        <p:spPr>
+          <a:xfrm>
+            <a:off x="3429000" y="5440680"/>
+            <a:ext cx="914400" cy="369332"/>
+          </a:xfrm>
+          <a:prstGeom prst="rect">
+            <a:avLst/>
+          </a:prstGeom>
+          <a:noFill/>
+        </p:spPr>
+        <p:txBody>
+          <a:bodyPr vert="horz" wrap="square" rtlCol="0">
+            <a:noAutofit/>
+          </a:bodyPr>
+          <a:lstStyle/>
+          <a:p>
+            <a:r>
+              <a:rPr lang="zh-CN" altLang="en-US" sz="1300" b="1">
+                <a:solidFill>
+                  <a:srgbClr val="E84C22"/>
+                </a:solidFill>
+                <a:latin typeface="Microsoft YaHei" panose="020B0503020204020204" pitchFamily="34" charset="-122"/>
+                <a:ea typeface="Microsoft YaHei" panose="020B0503020204020204" pitchFamily="34" charset="-122"/>
+              </a:rPr>
+              <a:t>扩</a:t>
+            </a:r>
+          </a:p>
+        </p:txBody>
+      </p:sp>
+      <p:sp>
+        <p:nvSpPr>
+          <p:cNvPr id="27" name="SKU_2_TEXT">
+            <a:extLst>
+              <a:ext uri="{FF2B5EF4-FFF2-40B4-BE49-F238E27FC236}">
+                <a16:creationId xmlns:a16="http://schemas.microsoft.com/office/drawing/2014/main" id="{0142CF99-C39B-1B1A-E4B7-16218236D99F}"/>
+              </a:ext>
+            </a:extLst>
+          </p:cNvPr>
+          <p:cNvSpPr txBox="1"/>
+          <p:nvPr/>
+        </p:nvSpPr>
+        <p:spPr>
+          <a:xfrm>
+            <a:off x="3429000" y="5806440"/>
+            <a:ext cx="2194560" cy="369332"/>
+          </a:xfrm>
+          <a:prstGeom prst="rect">
+            <a:avLst/>
+          </a:prstGeom>
+          <a:noFill/>
+        </p:spPr>
+        <p:txBody>
+          <a:bodyPr vert="horz" wrap="square" rtlCol="0">
+            <a:noAutofit/>
+          </a:bodyPr>
+          <a:lstStyle/>
+          <a:p>
+            <a:r>
+              <a:rPr lang="zh-CN" altLang="en-US" sz="1100">
+                <a:solidFill>
+                  <a:srgbClr val="505046"/>
+                </a:solidFill>
+                <a:latin typeface="Microsoft YaHei" panose="020B0503020204020204" pitchFamily="34" charset="-122"/>
+                <a:ea typeface="Microsoft YaHei" panose="020B0503020204020204" pitchFamily="34" charset="-122"/>
+              </a:rPr>
+              <a:t>潜力品项铺开到匹配网点</a:t>
+            </a:r>
+          </a:p>
+        </p:txBody>
+      </p:sp>
+      <p:sp>
+        <p:nvSpPr>
+          <p:cNvPr id="28" name="SKU_BAND_3">
+            <a:extLst>
+              <a:ext uri="{FF2B5EF4-FFF2-40B4-BE49-F238E27FC236}">
+                <a16:creationId xmlns:a16="http://schemas.microsoft.com/office/drawing/2014/main" id="{9280703C-1259-BFB8-E7A1-C2213B16BBD9}"/>
+              </a:ext>
+            </a:extLst>
+          </p:cNvPr>
+          <p:cNvSpPr/>
+          <p:nvPr/>
+        </p:nvSpPr>
+        <p:spPr>
+          <a:xfrm>
+            <a:off x="6035040" y="5394960"/>
+            <a:ext cx="2468880" cy="914400"/>
+          </a:xfrm>
+          <a:prstGeom prst="rect">
+            <a:avLst/>
+          </a:prstGeom>
+          <a:solidFill>
+            <a:srgbClr val="F7F7F8"/>
+          </a:solidFill>
+          <a:ln w="9525">
+            <a:solidFill>
+              <a:srgbClr val="6F6F6A"/>
+            </a:solidFill>
+          </a:ln>
+        </p:spPr>
+        <p:style>
+          <a:lnRef idx="2">
+            <a:schemeClr val="accent1">
+              <a:shade val="15000"/>
+            </a:schemeClr>
+          </a:lnRef>
+          <a:fillRef idx="1">
+            <a:schemeClr val="accent1"/>
+          </a:fillRef>
+          <a:effectRef idx="0">
+            <a:schemeClr val="accent1"/>
+          </a:effectRef>
+          <a:fontRef idx="minor">
+            <a:schemeClr val="lt1"/>
+          </a:fontRef>
+        </p:style>
+        <p:txBody>
+          <a:bodyPr rtlCol="0" anchor="ctr"/>
+          <a:lstStyle/>
+          <a:p>
+            <a:pPr algn="ctr"/>
+            <a:endParaRPr lang="zh-CN" altLang="en-US"/>
+          </a:p>
+        </p:txBody>
+      </p:sp>
+      <p:sp>
+        <p:nvSpPr>
+          <p:cNvPr id="29" name="SKU_3_LABEL">
+            <a:extLst>
+              <a:ext uri="{FF2B5EF4-FFF2-40B4-BE49-F238E27FC236}">
+                <a16:creationId xmlns:a16="http://schemas.microsoft.com/office/drawing/2014/main" id="{DC01EA15-4709-96D5-2B1E-81D7AA6BFD94}"/>
+              </a:ext>
+            </a:extLst>
+          </p:cNvPr>
+          <p:cNvSpPr txBox="1"/>
+          <p:nvPr/>
+        </p:nvSpPr>
+        <p:spPr>
+          <a:xfrm>
+            <a:off x="6172200" y="5440680"/>
+            <a:ext cx="914400" cy="369332"/>
+          </a:xfrm>
+          <a:prstGeom prst="rect">
+            <a:avLst/>
+          </a:prstGeom>
+          <a:noFill/>
+        </p:spPr>
+        <p:txBody>
+          <a:bodyPr vert="horz" wrap="square" rtlCol="0">
+            <a:noAutofit/>
+          </a:bodyPr>
+          <a:lstStyle/>
+          <a:p>
+            <a:r>
+              <a:rPr lang="zh-CN" altLang="en-US" sz="1300" b="1">
+                <a:solidFill>
+                  <a:srgbClr val="E84C22"/>
+                </a:solidFill>
+                <a:latin typeface="Microsoft YaHei" panose="020B0503020204020204" pitchFamily="34" charset="-122"/>
+                <a:ea typeface="Microsoft YaHei" panose="020B0503020204020204" pitchFamily="34" charset="-122"/>
+              </a:rPr>
+              <a:t>育</a:t>
+            </a:r>
+          </a:p>
+        </p:txBody>
+      </p:sp>
+      <p:sp>
+        <p:nvSpPr>
+          <p:cNvPr id="30" name="SKU_3_TEXT">
+            <a:extLst>
+              <a:ext uri="{FF2B5EF4-FFF2-40B4-BE49-F238E27FC236}">
+                <a16:creationId xmlns:a16="http://schemas.microsoft.com/office/drawing/2014/main" id="{A61A1836-475F-5557-EB7C-3D75470FA52D}"/>
+              </a:ext>
+            </a:extLst>
+          </p:cNvPr>
+          <p:cNvSpPr txBox="1"/>
+          <p:nvPr/>
+        </p:nvSpPr>
+        <p:spPr>
+          <a:xfrm>
+            <a:off x="6172200" y="5806440"/>
+            <a:ext cx="2194560" cy="369332"/>
+          </a:xfrm>
+          <a:prstGeom prst="rect">
+            <a:avLst/>
+          </a:prstGeom>
+          <a:noFill/>
+        </p:spPr>
+        <p:txBody>
+          <a:bodyPr vert="horz" wrap="square" rtlCol="0">
+            <a:noAutofit/>
+          </a:bodyPr>
+          <a:lstStyle/>
+          <a:p>
+            <a:r>
+              <a:rPr lang="zh-CN" altLang="en-US" sz="1100">
+                <a:solidFill>
+                  <a:srgbClr val="505046"/>
+                </a:solidFill>
+                <a:latin typeface="Microsoft YaHei" panose="020B0503020204020204" pitchFamily="34" charset="-122"/>
+                <a:ea typeface="Microsoft YaHei" panose="020B0503020204020204" pitchFamily="34" charset="-122"/>
+              </a:rPr>
+              <a:t>孵化新品项：小批量验证</a:t>
+            </a:r>
+          </a:p>
+        </p:txBody>
+      </p:sp>
+      <p:sp>
+        <p:nvSpPr>
+          <p:cNvPr id="31" name="SKU_BAND_4">
+            <a:extLst>
+              <a:ext uri="{FF2B5EF4-FFF2-40B4-BE49-F238E27FC236}">
+                <a16:creationId xmlns:a16="http://schemas.microsoft.com/office/drawing/2014/main" id="{6A83717F-4A4D-BAC9-62B5-C545C7E8EB5A}"/>
+              </a:ext>
+            </a:extLst>
+          </p:cNvPr>
+          <p:cNvSpPr/>
+          <p:nvPr/>
+        </p:nvSpPr>
+        <p:spPr>
+          <a:xfrm>
+            <a:off x="8778240" y="5394960"/>
+            <a:ext cx="2468880" cy="914400"/>
+          </a:xfrm>
+          <a:prstGeom prst="rect">
+            <a:avLst/>
+          </a:prstGeom>
+          <a:solidFill>
+            <a:srgbClr val="EEECE1"/>
+          </a:solidFill>
+          <a:ln w="9525">
+            <a:solidFill>
+              <a:srgbClr val="6F6F6A"/>
+            </a:solidFill>
+          </a:ln>
+        </p:spPr>
+        <p:style>
+          <a:lnRef idx="2">
+            <a:schemeClr val="accent1">
+              <a:shade val="15000"/>
+            </a:schemeClr>
+          </a:lnRef>
+          <a:fillRef idx="1">
+            <a:schemeClr val="accent1"/>
+          </a:fillRef>
+          <a:effectRef idx="0">
+            <a:schemeClr val="accent1"/>
+          </a:effectRef>
+          <a:fontRef idx="minor">
+            <a:schemeClr val="lt1"/>
+          </a:fontRef>
+        </p:style>
+        <p:txBody>
+          <a:bodyPr rtlCol="0" anchor="ctr"/>
+          <a:lstStyle/>
+          <a:p>
+            <a:pPr algn="ctr"/>
+            <a:endParaRPr lang="zh-CN" altLang="en-US"/>
+          </a:p>
+        </p:txBody>
+      </p:sp>
+      <p:sp>
+        <p:nvSpPr>
+          <p:cNvPr id="32" name="SKU_4_LABEL">
+            <a:extLst>
+              <a:ext uri="{FF2B5EF4-FFF2-40B4-BE49-F238E27FC236}">
+                <a16:creationId xmlns:a16="http://schemas.microsoft.com/office/drawing/2014/main" id="{5A7F105B-61E0-65DF-0BE8-49C8A65A57B3}"/>
+              </a:ext>
+            </a:extLst>
+          </p:cNvPr>
+          <p:cNvSpPr txBox="1"/>
+          <p:nvPr/>
+        </p:nvSpPr>
+        <p:spPr>
+          <a:xfrm>
+            <a:off x="8915400" y="5440680"/>
+            <a:ext cx="914400" cy="369332"/>
+          </a:xfrm>
+          <a:prstGeom prst="rect">
+            <a:avLst/>
+          </a:prstGeom>
+          <a:noFill/>
+        </p:spPr>
+        <p:txBody>
+          <a:bodyPr vert="horz" wrap="square" rtlCol="0">
+            <a:noAutofit/>
+          </a:bodyPr>
+          <a:lstStyle/>
+          <a:p>
+            <a:r>
+              <a:rPr lang="zh-CN" altLang="en-US" sz="1300" b="1">
+                <a:solidFill>
+                  <a:srgbClr val="E84C22"/>
+                </a:solidFill>
+                <a:latin typeface="Microsoft YaHei" panose="020B0503020204020204" pitchFamily="34" charset="-122"/>
+                <a:ea typeface="Microsoft YaHei" panose="020B0503020204020204" pitchFamily="34" charset="-122"/>
+              </a:rPr>
+              <a:t>淘汰</a:t>
+            </a:r>
+          </a:p>
+        </p:txBody>
+      </p:sp>
+      <p:sp>
+        <p:nvSpPr>
+          <p:cNvPr id="33" name="SKU_4_TEXT">
+            <a:extLst>
+              <a:ext uri="{FF2B5EF4-FFF2-40B4-BE49-F238E27FC236}">
+                <a16:creationId xmlns:a16="http://schemas.microsoft.com/office/drawing/2014/main" id="{2770535A-2758-2C64-F43D-8DD51D09CBBF}"/>
+              </a:ext>
+            </a:extLst>
+          </p:cNvPr>
+          <p:cNvSpPr txBox="1"/>
+          <p:nvPr/>
+        </p:nvSpPr>
+        <p:spPr>
+          <a:xfrm>
+            <a:off x="8915400" y="5806440"/>
+            <a:ext cx="2194560" cy="369332"/>
+          </a:xfrm>
+          <a:prstGeom prst="rect">
+            <a:avLst/>
+          </a:prstGeom>
+          <a:noFill/>
+        </p:spPr>
+        <p:txBody>
+          <a:bodyPr vert="horz" wrap="square" rtlCol="0">
+            <a:noAutofit/>
+          </a:bodyPr>
+          <a:lstStyle/>
+          <a:p>
+            <a:r>
+              <a:rPr lang="zh-CN" altLang="en-US" sz="1100">
+                <a:solidFill>
+                  <a:srgbClr val="505046"/>
+                </a:solidFill>
+                <a:latin typeface="Microsoft YaHei" panose="020B0503020204020204" pitchFamily="34" charset="-122"/>
+                <a:ea typeface="Microsoft YaHei" panose="020B0503020204020204" pitchFamily="34" charset="-122"/>
+              </a:rPr>
+              <a:t>低效品项退出或换品</a:t>
+            </a:r>
+          </a:p>
+        </p:txBody>
+      </p:sp>
+      <p:sp>
+        <p:nvSpPr>
+          <p:cNvPr id="34" name="TEACHING_CUE">
+            <a:extLst>
+              <a:ext uri="{FF2B5EF4-FFF2-40B4-BE49-F238E27FC236}">
+                <a16:creationId xmlns:a16="http://schemas.microsoft.com/office/drawing/2014/main" id="{44FE768B-F44F-362A-09BB-79B9C6E7897C}"/>
+              </a:ext>
+            </a:extLst>
+          </p:cNvPr>
+          <p:cNvSpPr txBox="1"/>
+          <p:nvPr/>
+        </p:nvSpPr>
+        <p:spPr>
+          <a:xfrm>
+            <a:off x="548640" y="6400800"/>
+            <a:ext cx="11064240" cy="365760"/>
+          </a:xfrm>
+          <a:prstGeom prst="rect">
+            <a:avLst/>
+          </a:prstGeom>
+          <a:noFill/>
+        </p:spPr>
+        <p:txBody>
+          <a:bodyPr vert="horz" wrap="square" rtlCol="0">
+            <a:noAutofit/>
+          </a:bodyPr>
+          <a:lstStyle/>
+          <a:p>
+            <a:r>
+              <a:rPr lang="zh-CN" altLang="en-US" sz="1200">
+                <a:solidFill>
+                  <a:srgbClr val="6F6F6A"/>
+                </a:solidFill>
+                <a:latin typeface="Microsoft YaHei" panose="020B0503020204020204" pitchFamily="34" charset="-122"/>
+                <a:ea typeface="Microsoft YaHei" panose="020B0503020204020204" pitchFamily="34" charset="-122"/>
+              </a:rPr>
+              <a:t>一次销量≠爆品：检查覆盖、回转与复购；缺数据用低置信度代理并标注缺失。</a:t>
+            </a:r>
+          </a:p>
+        </p:txBody>
+      </p:sp>
+    </p:spTree>
+    <p:extLst>
+      <p:ext uri="{BB962C8B-B14F-4D97-AF65-F5344CB8AC3E}">
+        <p14:creationId xmlns:p14="http://schemas.microsoft.com/office/powerpoint/2010/main" val="3332818378"/>
       </p:ext>
     </p:extLst>
   </p:cSld>

</xml_diff>

<commit_message>
Add I3 dealer scenario choice (slide 12) via production line
Interactive family second source page: scenario card -> choice prompt -> four equal choice bands -> debrief cue (instructor-paced, no answer revealed), 15 named objects, token colors. Full pipeline: build-i3.ps1 -> verify -> preview component-12.png -> registry -> generator (index/catalog SHA 9622BE2F) -> contact sheet -> promote -> slot contract + build contract synced.
</commit_message>
<xml_diff>
--- a/domains/yuhong/assets/components/yuhong-county-course-components-branded.pptx
+++ b/domains/yuhong/assets/components/yuhong-county-course-components-branded.pptx
@@ -5,7 +5,7 @@
     <p:sldMasterId id="2147483648" r:id="rId1"/>
   </p:sldMasterIdLst>
   <p:notesMasterIdLst>
-    <p:notesMasterId r:id="rId13"/>
+    <p:notesMasterId r:id="rId14"/>
   </p:notesMasterIdLst>
   <p:sldIdLst>
     <p:sldId id="256" r:id="rId2"/>
@@ -19,6 +19,7 @@
     <p:sldId id="264" r:id="rId10"/>
     <p:sldId id="265" r:id="rId11"/>
     <p:sldId id="266" r:id="rId12"/>
+    <p:sldId id="267" r:id="rId13"/>
   </p:sldIdLst>
   <p:sldSz cx="12192000" cy="6858000"/>
   <p:notesSz cx="6858000" cy="9144000"/>
@@ -6458,6 +6459,776 @@
     <p:extLst>
       <p:ext uri="{BB962C8B-B14F-4D97-AF65-F5344CB8AC3E}">
         <p14:creationId xmlns:p14="http://schemas.microsoft.com/office/powerpoint/2010/main" val="3332818378"/>
+      </p:ext>
+    </p:extLst>
+  </p:cSld>
+  <p:clrMapOvr>
+    <a:masterClrMapping/>
+  </p:clrMapOvr>
+</p:sld>
+</file>
+
+<file path=ppt/slides/slide12.xml><?xml version="1.0" encoding="utf-8"?>
+<p:sld xmlns:a="http://schemas.openxmlformats.org/drawingml/2006/main" xmlns:r="http://schemas.openxmlformats.org/officeDocument/2006/relationships" xmlns:p="http://schemas.openxmlformats.org/presentationml/2006/main">
+  <p:cSld>
+    <p:spTree>
+      <p:nvGrpSpPr>
+        <p:cNvPr id="1" name=""/>
+        <p:cNvGrpSpPr/>
+        <p:nvPr/>
+      </p:nvGrpSpPr>
+      <p:grpSpPr>
+        <a:xfrm>
+          <a:off x="0" y="0"/>
+          <a:ext cx="0" cy="0"/>
+          <a:chOff x="0" y="0"/>
+          <a:chExt cx="0" cy="0"/>
+        </a:xfrm>
+      </p:grpSpPr>
+      <p:sp>
+        <p:nvSpPr>
+          <p:cNvPr id="2" name="TITLE">
+            <a:extLst>
+              <a:ext uri="{FF2B5EF4-FFF2-40B4-BE49-F238E27FC236}">
+                <a16:creationId xmlns:a16="http://schemas.microsoft.com/office/drawing/2014/main" id="{5C9C48DE-3B72-13E3-A3FD-D1ACA3E18004}"/>
+              </a:ext>
+            </a:extLst>
+          </p:cNvPr>
+          <p:cNvSpPr txBox="1"/>
+          <p:nvPr/>
+        </p:nvSpPr>
+        <p:spPr>
+          <a:xfrm>
+            <a:off x="548640" y="384048"/>
+            <a:ext cx="10789920" cy="369332"/>
+          </a:xfrm>
+          <a:prstGeom prst="rect">
+            <a:avLst/>
+          </a:prstGeom>
+          <a:noFill/>
+        </p:spPr>
+        <p:txBody>
+          <a:bodyPr vert="horz" wrap="square" rtlCol="0">
+            <a:noAutofit/>
+          </a:bodyPr>
+          <a:lstStyle/>
+          <a:p>
+            <a:r>
+              <a:rPr lang="zh-CN" altLang="en-US" sz="2600" b="1">
+                <a:solidFill>
+                  <a:srgbClr val="505046"/>
+                </a:solidFill>
+                <a:latin typeface="Microsoft YaHei" panose="020B0503020204020204" pitchFamily="34" charset="-122"/>
+                <a:ea typeface="Microsoft YaHei" panose="020B0503020204020204" pitchFamily="34" charset="-122"/>
+              </a:rPr>
+              <a:t>如果你是这位经销商，你会先怎么做？</a:t>
+            </a:r>
+          </a:p>
+        </p:txBody>
+      </p:sp>
+      <p:sp>
+        <p:nvSpPr>
+          <p:cNvPr id="3" name="SCENARIO_BAND">
+            <a:extLst>
+              <a:ext uri="{FF2B5EF4-FFF2-40B4-BE49-F238E27FC236}">
+                <a16:creationId xmlns:a16="http://schemas.microsoft.com/office/drawing/2014/main" id="{66847BD6-1832-5631-2A4F-8BB802A90B03}"/>
+              </a:ext>
+            </a:extLst>
+          </p:cNvPr>
+          <p:cNvSpPr/>
+          <p:nvPr/>
+        </p:nvSpPr>
+        <p:spPr>
+          <a:xfrm>
+            <a:off x="548640" y="1143000"/>
+            <a:ext cx="11064240" cy="1417320"/>
+          </a:xfrm>
+          <a:prstGeom prst="rect">
+            <a:avLst/>
+          </a:prstGeom>
+          <a:solidFill>
+            <a:srgbClr val="F7F7F8"/>
+          </a:solidFill>
+          <a:ln w="9525">
+            <a:solidFill>
+              <a:srgbClr val="6F6F6A"/>
+            </a:solidFill>
+          </a:ln>
+        </p:spPr>
+        <p:style>
+          <a:lnRef idx="2">
+            <a:schemeClr val="accent1">
+              <a:shade val="15000"/>
+            </a:schemeClr>
+          </a:lnRef>
+          <a:fillRef idx="1">
+            <a:schemeClr val="accent1"/>
+          </a:fillRef>
+          <a:effectRef idx="0">
+            <a:schemeClr val="accent1"/>
+          </a:effectRef>
+          <a:fontRef idx="minor">
+            <a:schemeClr val="lt1"/>
+          </a:fontRef>
+        </p:style>
+        <p:txBody>
+          <a:bodyPr rtlCol="0" anchor="ctr"/>
+          <a:lstStyle/>
+          <a:p>
+            <a:pPr algn="ctr"/>
+            <a:endParaRPr lang="zh-CN" altLang="en-US"/>
+          </a:p>
+        </p:txBody>
+      </p:sp>
+      <p:sp>
+        <p:nvSpPr>
+          <p:cNvPr id="4" name="SCENARIO_TITLE">
+            <a:extLst>
+              <a:ext uri="{FF2B5EF4-FFF2-40B4-BE49-F238E27FC236}">
+                <a16:creationId xmlns:a16="http://schemas.microsoft.com/office/drawing/2014/main" id="{99016AF5-FD60-3394-9DDC-B3790F813EFB}"/>
+              </a:ext>
+            </a:extLst>
+          </p:cNvPr>
+          <p:cNvSpPr txBox="1"/>
+          <p:nvPr/>
+        </p:nvSpPr>
+        <p:spPr>
+          <a:xfrm>
+            <a:off x="777240" y="1280160"/>
+            <a:ext cx="3657600" cy="365760"/>
+          </a:xfrm>
+          <a:prstGeom prst="rect">
+            <a:avLst/>
+          </a:prstGeom>
+          <a:noFill/>
+        </p:spPr>
+        <p:txBody>
+          <a:bodyPr vert="horz" wrap="square" rtlCol="0">
+            <a:noAutofit/>
+          </a:bodyPr>
+          <a:lstStyle/>
+          <a:p>
+            <a:r>
+              <a:rPr lang="zh-CN" altLang="en-US" sz="1400" b="1">
+                <a:solidFill>
+                  <a:srgbClr val="E84C22"/>
+                </a:solidFill>
+                <a:latin typeface="Microsoft YaHei" panose="020B0503020204020204" pitchFamily="34" charset="-122"/>
+                <a:ea typeface="Microsoft YaHei" panose="020B0503020204020204" pitchFamily="34" charset="-122"/>
+              </a:rPr>
+              <a:t>情景（匿名综合案例）</a:t>
+            </a:r>
+          </a:p>
+        </p:txBody>
+      </p:sp>
+      <p:sp>
+        <p:nvSpPr>
+          <p:cNvPr id="5" name="SCENARIO_TEXT">
+            <a:extLst>
+              <a:ext uri="{FF2B5EF4-FFF2-40B4-BE49-F238E27FC236}">
+                <a16:creationId xmlns:a16="http://schemas.microsoft.com/office/drawing/2014/main" id="{22C2228F-0C31-17A4-3CFF-D7F53A20673C}"/>
+              </a:ext>
+            </a:extLst>
+          </p:cNvPr>
+          <p:cNvSpPr txBox="1"/>
+          <p:nvPr/>
+        </p:nvSpPr>
+        <p:spPr>
+          <a:xfrm>
+            <a:off x="777240" y="1691640"/>
+            <a:ext cx="10607040" cy="369332"/>
+          </a:xfrm>
+          <a:prstGeom prst="rect">
+            <a:avLst/>
+          </a:prstGeom>
+          <a:noFill/>
+        </p:spPr>
+        <p:txBody>
+          <a:bodyPr vert="horz" wrap="square" rtlCol="0">
+            <a:noAutofit/>
+          </a:bodyPr>
+          <a:lstStyle/>
+          <a:p>
+            <a:r>
+              <a:rPr lang="zh-CN" altLang="en-US" sz="1300">
+                <a:solidFill>
+                  <a:srgbClr val="505046"/>
+                </a:solidFill>
+                <a:latin typeface="Microsoft YaHei" panose="020B0503020204020204" pitchFamily="34" charset="-122"/>
+                <a:ea typeface="Microsoft YaHei" panose="020B0503020204020204" pitchFamily="34" charset="-122"/>
+              </a:rPr>
+              <a:t>某县经销商：县城新房交付减少，已在 </a:t>
+            </a:r>
+            <a:r>
+              <a:rPr lang="en-US" altLang="zh-CN" sz="1300">
+                <a:solidFill>
+                  <a:srgbClr val="505046"/>
+                </a:solidFill>
+                <a:latin typeface="Microsoft YaHei" panose="020B0503020204020204" pitchFamily="34" charset="-122"/>
+                <a:ea typeface="Microsoft YaHei" panose="020B0503020204020204" pitchFamily="34" charset="-122"/>
+              </a:rPr>
+              <a:t>3 </a:t>
+            </a:r>
+            <a:r>
+              <a:rPr lang="zh-CN" altLang="en-US" sz="1300">
+                <a:solidFill>
+                  <a:srgbClr val="505046"/>
+                </a:solidFill>
+                <a:latin typeface="Microsoft YaHei" panose="020B0503020204020204" pitchFamily="34" charset="-122"/>
+                <a:ea typeface="Microsoft YaHei" panose="020B0503020204020204" pitchFamily="34" charset="-122"/>
+              </a:rPr>
+              <a:t>个乡镇铺过货但动销一般；手上有 </a:t>
+            </a:r>
+            <a:r>
+              <a:rPr lang="en-US" altLang="zh-CN" sz="1300">
+                <a:solidFill>
+                  <a:srgbClr val="505046"/>
+                </a:solidFill>
+                <a:latin typeface="Microsoft YaHei" panose="020B0503020204020204" pitchFamily="34" charset="-122"/>
+                <a:ea typeface="Microsoft YaHei" panose="020B0503020204020204" pitchFamily="34" charset="-122"/>
+              </a:rPr>
+              <a:t>2 </a:t>
+            </a:r>
+            <a:r>
+              <a:rPr lang="zh-CN" altLang="en-US" sz="1300">
+                <a:solidFill>
+                  <a:srgbClr val="505046"/>
+                </a:solidFill>
+                <a:latin typeface="Microsoft YaHei" panose="020B0503020204020204" pitchFamily="34" charset="-122"/>
+                <a:ea typeface="Microsoft YaHei" panose="020B0503020204020204" pitchFamily="34" charset="-122"/>
+              </a:rPr>
+              <a:t>个业务员，资金有限。刚听说邻县中心镇有一个大型安置房项目正在启动。</a:t>
+            </a:r>
+          </a:p>
+        </p:txBody>
+      </p:sp>
+      <p:sp>
+        <p:nvSpPr>
+          <p:cNvPr id="6" name="CHOICE_TITLE">
+            <a:extLst>
+              <a:ext uri="{FF2B5EF4-FFF2-40B4-BE49-F238E27FC236}">
+                <a16:creationId xmlns:a16="http://schemas.microsoft.com/office/drawing/2014/main" id="{139D36BB-CF5C-23B7-63E6-AC44DCCFFEA0}"/>
+              </a:ext>
+            </a:extLst>
+          </p:cNvPr>
+          <p:cNvSpPr txBox="1"/>
+          <p:nvPr/>
+        </p:nvSpPr>
+        <p:spPr>
+          <a:xfrm>
+            <a:off x="548640" y="2788920"/>
+            <a:ext cx="7315200" cy="369332"/>
+          </a:xfrm>
+          <a:prstGeom prst="rect">
+            <a:avLst/>
+          </a:prstGeom>
+          <a:noFill/>
+        </p:spPr>
+        <p:txBody>
+          <a:bodyPr vert="horz" wrap="square" rtlCol="0">
+            <a:noAutofit/>
+          </a:bodyPr>
+          <a:lstStyle/>
+          <a:p>
+            <a:r>
+              <a:rPr lang="zh-CN" altLang="en-US" sz="1600" b="1">
+                <a:solidFill>
+                  <a:srgbClr val="E84C22"/>
+                </a:solidFill>
+                <a:latin typeface="Microsoft YaHei" panose="020B0503020204020204" pitchFamily="34" charset="-122"/>
+                <a:ea typeface="Microsoft YaHei" panose="020B0503020204020204" pitchFamily="34" charset="-122"/>
+              </a:rPr>
+              <a:t>你会先怎么做？</a:t>
+            </a:r>
+          </a:p>
+        </p:txBody>
+      </p:sp>
+      <p:sp>
+        <p:nvSpPr>
+          <p:cNvPr id="7" name="CHOICE_BAND_1">
+            <a:extLst>
+              <a:ext uri="{FF2B5EF4-FFF2-40B4-BE49-F238E27FC236}">
+                <a16:creationId xmlns:a16="http://schemas.microsoft.com/office/drawing/2014/main" id="{BBFC4A4E-9086-F238-69A2-DA5852D8DF3A}"/>
+              </a:ext>
+            </a:extLst>
+          </p:cNvPr>
+          <p:cNvSpPr/>
+          <p:nvPr/>
+        </p:nvSpPr>
+        <p:spPr>
+          <a:xfrm>
+            <a:off x="548640" y="3337560"/>
+            <a:ext cx="11064240" cy="502920"/>
+          </a:xfrm>
+          <a:prstGeom prst="rect">
+            <a:avLst/>
+          </a:prstGeom>
+          <a:solidFill>
+            <a:srgbClr val="F7F7F8"/>
+          </a:solidFill>
+          <a:ln w="9525">
+            <a:solidFill>
+              <a:srgbClr val="6F6F6A"/>
+            </a:solidFill>
+          </a:ln>
+        </p:spPr>
+        <p:style>
+          <a:lnRef idx="2">
+            <a:schemeClr val="accent1">
+              <a:shade val="15000"/>
+            </a:schemeClr>
+          </a:lnRef>
+          <a:fillRef idx="1">
+            <a:schemeClr val="accent1"/>
+          </a:fillRef>
+          <a:effectRef idx="0">
+            <a:schemeClr val="accent1"/>
+          </a:effectRef>
+          <a:fontRef idx="minor">
+            <a:schemeClr val="lt1"/>
+          </a:fontRef>
+        </p:style>
+        <p:txBody>
+          <a:bodyPr rtlCol="0" anchor="ctr"/>
+          <a:lstStyle/>
+          <a:p>
+            <a:pPr algn="ctr"/>
+            <a:endParaRPr lang="zh-CN" altLang="en-US"/>
+          </a:p>
+        </p:txBody>
+      </p:sp>
+      <p:sp>
+        <p:nvSpPr>
+          <p:cNvPr id="8" name="CHOICE_1_TEXT">
+            <a:extLst>
+              <a:ext uri="{FF2B5EF4-FFF2-40B4-BE49-F238E27FC236}">
+                <a16:creationId xmlns:a16="http://schemas.microsoft.com/office/drawing/2014/main" id="{519F2A7A-CAE7-1405-19F2-088D4352D8DC}"/>
+              </a:ext>
+            </a:extLst>
+          </p:cNvPr>
+          <p:cNvSpPr txBox="1"/>
+          <p:nvPr/>
+        </p:nvSpPr>
+        <p:spPr>
+          <a:xfrm>
+            <a:off x="868680" y="3337560"/>
+            <a:ext cx="10424160" cy="384048"/>
+          </a:xfrm>
+          <a:prstGeom prst="rect">
+            <a:avLst/>
+          </a:prstGeom>
+          <a:noFill/>
+        </p:spPr>
+        <p:txBody>
+          <a:bodyPr vert="horz" wrap="square" rtlCol="0">
+            <a:noAutofit/>
+          </a:bodyPr>
+          <a:lstStyle/>
+          <a:p>
+            <a:r>
+              <a:rPr lang="zh-CN" altLang="en-US" sz="1400">
+                <a:solidFill>
+                  <a:srgbClr val="505046"/>
+                </a:solidFill>
+                <a:latin typeface="Microsoft YaHei" panose="020B0503020204020204" pitchFamily="34" charset="-122"/>
+                <a:ea typeface="Microsoft YaHei" panose="020B0503020204020204" pitchFamily="34" charset="-122"/>
+              </a:rPr>
+              <a:t>先打邻县中心镇安置房项目，找关系进项目</a:t>
+            </a:r>
+          </a:p>
+        </p:txBody>
+      </p:sp>
+      <p:sp>
+        <p:nvSpPr>
+          <p:cNvPr id="9" name="CHOICE_BAND_2">
+            <a:extLst>
+              <a:ext uri="{FF2B5EF4-FFF2-40B4-BE49-F238E27FC236}">
+                <a16:creationId xmlns:a16="http://schemas.microsoft.com/office/drawing/2014/main" id="{E9BAAACE-97F5-E22A-71CA-3FFFE6F4A502}"/>
+              </a:ext>
+            </a:extLst>
+          </p:cNvPr>
+          <p:cNvSpPr/>
+          <p:nvPr/>
+        </p:nvSpPr>
+        <p:spPr>
+          <a:xfrm>
+            <a:off x="548640" y="3931920"/>
+            <a:ext cx="11064240" cy="502920"/>
+          </a:xfrm>
+          <a:prstGeom prst="rect">
+            <a:avLst/>
+          </a:prstGeom>
+          <a:solidFill>
+            <a:srgbClr val="EEECE1"/>
+          </a:solidFill>
+          <a:ln w="9525">
+            <a:solidFill>
+              <a:srgbClr val="6F6F6A"/>
+            </a:solidFill>
+          </a:ln>
+        </p:spPr>
+        <p:style>
+          <a:lnRef idx="2">
+            <a:schemeClr val="accent1">
+              <a:shade val="15000"/>
+            </a:schemeClr>
+          </a:lnRef>
+          <a:fillRef idx="1">
+            <a:schemeClr val="accent1"/>
+          </a:fillRef>
+          <a:effectRef idx="0">
+            <a:schemeClr val="accent1"/>
+          </a:effectRef>
+          <a:fontRef idx="minor">
+            <a:schemeClr val="lt1"/>
+          </a:fontRef>
+        </p:style>
+        <p:txBody>
+          <a:bodyPr rtlCol="0" anchor="ctr"/>
+          <a:lstStyle/>
+          <a:p>
+            <a:pPr algn="ctr"/>
+            <a:endParaRPr lang="zh-CN" altLang="en-US"/>
+          </a:p>
+        </p:txBody>
+      </p:sp>
+      <p:sp>
+        <p:nvSpPr>
+          <p:cNvPr id="10" name="CHOICE_2_TEXT">
+            <a:extLst>
+              <a:ext uri="{FF2B5EF4-FFF2-40B4-BE49-F238E27FC236}">
+                <a16:creationId xmlns:a16="http://schemas.microsoft.com/office/drawing/2014/main" id="{63124779-893F-56F7-4DFA-EC6464EECA45}"/>
+              </a:ext>
+            </a:extLst>
+          </p:cNvPr>
+          <p:cNvSpPr txBox="1"/>
+          <p:nvPr/>
+        </p:nvSpPr>
+        <p:spPr>
+          <a:xfrm>
+            <a:off x="868680" y="3931920"/>
+            <a:ext cx="10424160" cy="384048"/>
+          </a:xfrm>
+          <a:prstGeom prst="rect">
+            <a:avLst/>
+          </a:prstGeom>
+          <a:noFill/>
+        </p:spPr>
+        <p:txBody>
+          <a:bodyPr vert="horz" wrap="square" rtlCol="0">
+            <a:noAutofit/>
+          </a:bodyPr>
+          <a:lstStyle/>
+          <a:p>
+            <a:r>
+              <a:rPr lang="zh-CN" altLang="en-US" sz="1400">
+                <a:solidFill>
+                  <a:srgbClr val="505046"/>
+                </a:solidFill>
+                <a:latin typeface="Microsoft YaHei" panose="020B0503020204020204" pitchFamily="34" charset="-122"/>
+                <a:ea typeface="Microsoft YaHei" panose="020B0503020204020204" pitchFamily="34" charset="-122"/>
+              </a:rPr>
+              <a:t>先激活已有 </a:t>
+            </a:r>
+            <a:r>
+              <a:rPr lang="en-US" altLang="zh-CN" sz="1400">
+                <a:solidFill>
+                  <a:srgbClr val="505046"/>
+                </a:solidFill>
+                <a:latin typeface="Microsoft YaHei" panose="020B0503020204020204" pitchFamily="34" charset="-122"/>
+                <a:ea typeface="Microsoft YaHei" panose="020B0503020204020204" pitchFamily="34" charset="-122"/>
+              </a:rPr>
+              <a:t>3 </a:t>
+            </a:r>
+            <a:r>
+              <a:rPr lang="zh-CN" altLang="en-US" sz="1400">
+                <a:solidFill>
+                  <a:srgbClr val="505046"/>
+                </a:solidFill>
+                <a:latin typeface="Microsoft YaHei" panose="020B0503020204020204" pitchFamily="34" charset="-122"/>
+                <a:ea typeface="Microsoft YaHei" panose="020B0503020204020204" pitchFamily="34" charset="-122"/>
+              </a:rPr>
+              <a:t>个乡镇网点，促动销、补货</a:t>
+            </a:r>
+          </a:p>
+        </p:txBody>
+      </p:sp>
+      <p:sp>
+        <p:nvSpPr>
+          <p:cNvPr id="11" name="CHOICE_BAND_3">
+            <a:extLst>
+              <a:ext uri="{FF2B5EF4-FFF2-40B4-BE49-F238E27FC236}">
+                <a16:creationId xmlns:a16="http://schemas.microsoft.com/office/drawing/2014/main" id="{BA41100A-3526-FEE6-B14B-7B6A5CCDA214}"/>
+              </a:ext>
+            </a:extLst>
+          </p:cNvPr>
+          <p:cNvSpPr/>
+          <p:nvPr/>
+        </p:nvSpPr>
+        <p:spPr>
+          <a:xfrm>
+            <a:off x="548640" y="4526280"/>
+            <a:ext cx="11064240" cy="502920"/>
+          </a:xfrm>
+          <a:prstGeom prst="rect">
+            <a:avLst/>
+          </a:prstGeom>
+          <a:solidFill>
+            <a:srgbClr val="F7F7F8"/>
+          </a:solidFill>
+          <a:ln w="9525">
+            <a:solidFill>
+              <a:srgbClr val="6F6F6A"/>
+            </a:solidFill>
+          </a:ln>
+        </p:spPr>
+        <p:style>
+          <a:lnRef idx="2">
+            <a:schemeClr val="accent1">
+              <a:shade val="15000"/>
+            </a:schemeClr>
+          </a:lnRef>
+          <a:fillRef idx="1">
+            <a:schemeClr val="accent1"/>
+          </a:fillRef>
+          <a:effectRef idx="0">
+            <a:schemeClr val="accent1"/>
+          </a:effectRef>
+          <a:fontRef idx="minor">
+            <a:schemeClr val="lt1"/>
+          </a:fontRef>
+        </p:style>
+        <p:txBody>
+          <a:bodyPr rtlCol="0" anchor="ctr"/>
+          <a:lstStyle/>
+          <a:p>
+            <a:pPr algn="ctr"/>
+            <a:endParaRPr lang="zh-CN" altLang="en-US"/>
+          </a:p>
+        </p:txBody>
+      </p:sp>
+      <p:sp>
+        <p:nvSpPr>
+          <p:cNvPr id="12" name="CHOICE_3_TEXT">
+            <a:extLst>
+              <a:ext uri="{FF2B5EF4-FFF2-40B4-BE49-F238E27FC236}">
+                <a16:creationId xmlns:a16="http://schemas.microsoft.com/office/drawing/2014/main" id="{A1018907-D5E9-5AC9-D044-C8DD3A417D1F}"/>
+              </a:ext>
+            </a:extLst>
+          </p:cNvPr>
+          <p:cNvSpPr txBox="1"/>
+          <p:nvPr/>
+        </p:nvSpPr>
+        <p:spPr>
+          <a:xfrm>
+            <a:off x="868680" y="4526280"/>
+            <a:ext cx="10424160" cy="384048"/>
+          </a:xfrm>
+          <a:prstGeom prst="rect">
+            <a:avLst/>
+          </a:prstGeom>
+          <a:noFill/>
+        </p:spPr>
+        <p:txBody>
+          <a:bodyPr vert="horz" wrap="square" rtlCol="0">
+            <a:noAutofit/>
+          </a:bodyPr>
+          <a:lstStyle/>
+          <a:p>
+            <a:r>
+              <a:rPr lang="zh-CN" altLang="en-US" sz="1400">
+                <a:solidFill>
+                  <a:srgbClr val="505046"/>
+                </a:solidFill>
+                <a:latin typeface="Microsoft YaHei" panose="020B0503020204020204" pitchFamily="34" charset="-122"/>
+                <a:ea typeface="Microsoft YaHei" panose="020B0503020204020204" pitchFamily="34" charset="-122"/>
+              </a:rPr>
+              <a:t>先在县城做品牌展示和服务站，夯实大本营</a:t>
+            </a:r>
+          </a:p>
+        </p:txBody>
+      </p:sp>
+      <p:sp>
+        <p:nvSpPr>
+          <p:cNvPr id="13" name="CHOICE_BAND_4">
+            <a:extLst>
+              <a:ext uri="{FF2B5EF4-FFF2-40B4-BE49-F238E27FC236}">
+                <a16:creationId xmlns:a16="http://schemas.microsoft.com/office/drawing/2014/main" id="{DF86394F-7B31-58E2-014C-B573BCD56A69}"/>
+              </a:ext>
+            </a:extLst>
+          </p:cNvPr>
+          <p:cNvSpPr/>
+          <p:nvPr/>
+        </p:nvSpPr>
+        <p:spPr>
+          <a:xfrm>
+            <a:off x="548640" y="5120640"/>
+            <a:ext cx="11064240" cy="502920"/>
+          </a:xfrm>
+          <a:prstGeom prst="rect">
+            <a:avLst/>
+          </a:prstGeom>
+          <a:solidFill>
+            <a:srgbClr val="EEECE1"/>
+          </a:solidFill>
+          <a:ln w="9525">
+            <a:solidFill>
+              <a:srgbClr val="6F6F6A"/>
+            </a:solidFill>
+          </a:ln>
+        </p:spPr>
+        <p:style>
+          <a:lnRef idx="2">
+            <a:schemeClr val="accent1">
+              <a:shade val="15000"/>
+            </a:schemeClr>
+          </a:lnRef>
+          <a:fillRef idx="1">
+            <a:schemeClr val="accent1"/>
+          </a:fillRef>
+          <a:effectRef idx="0">
+            <a:schemeClr val="accent1"/>
+          </a:effectRef>
+          <a:fontRef idx="minor">
+            <a:schemeClr val="lt1"/>
+          </a:fontRef>
+        </p:style>
+        <p:txBody>
+          <a:bodyPr rtlCol="0" anchor="ctr"/>
+          <a:lstStyle/>
+          <a:p>
+            <a:pPr algn="ctr"/>
+            <a:endParaRPr lang="zh-CN" altLang="en-US"/>
+          </a:p>
+        </p:txBody>
+      </p:sp>
+      <p:sp>
+        <p:nvSpPr>
+          <p:cNvPr id="14" name="CHOICE_4_TEXT">
+            <a:extLst>
+              <a:ext uri="{FF2B5EF4-FFF2-40B4-BE49-F238E27FC236}">
+                <a16:creationId xmlns:a16="http://schemas.microsoft.com/office/drawing/2014/main" id="{8FB12730-7740-E3EC-59DF-6B2241118AFB}"/>
+              </a:ext>
+            </a:extLst>
+          </p:cNvPr>
+          <p:cNvSpPr txBox="1"/>
+          <p:nvPr/>
+        </p:nvSpPr>
+        <p:spPr>
+          <a:xfrm>
+            <a:off x="868680" y="5120640"/>
+            <a:ext cx="10424160" cy="384048"/>
+          </a:xfrm>
+          <a:prstGeom prst="rect">
+            <a:avLst/>
+          </a:prstGeom>
+          <a:noFill/>
+        </p:spPr>
+        <p:txBody>
+          <a:bodyPr vert="horz" wrap="square" rtlCol="0">
+            <a:noAutofit/>
+          </a:bodyPr>
+          <a:lstStyle/>
+          <a:p>
+            <a:r>
+              <a:rPr lang="zh-CN" altLang="en-US" sz="1400">
+                <a:solidFill>
+                  <a:srgbClr val="505046"/>
+                </a:solidFill>
+                <a:latin typeface="Microsoft YaHei" panose="020B0503020204020204" pitchFamily="34" charset="-122"/>
+                <a:ea typeface="Microsoft YaHei" panose="020B0503020204020204" pitchFamily="34" charset="-122"/>
+              </a:rPr>
+              <a:t>先加跑乡镇的业务员，增加触达和线索</a:t>
+            </a:r>
+          </a:p>
+        </p:txBody>
+      </p:sp>
+      <p:sp>
+        <p:nvSpPr>
+          <p:cNvPr id="15" name="DEBRIEF_CUE">
+            <a:extLst>
+              <a:ext uri="{FF2B5EF4-FFF2-40B4-BE49-F238E27FC236}">
+                <a16:creationId xmlns:a16="http://schemas.microsoft.com/office/drawing/2014/main" id="{7B970C88-B014-1D34-A257-D3066A911C0C}"/>
+              </a:ext>
+            </a:extLst>
+          </p:cNvPr>
+          <p:cNvSpPr txBox="1"/>
+          <p:nvPr/>
+        </p:nvSpPr>
+        <p:spPr>
+          <a:xfrm>
+            <a:off x="548640" y="5806440"/>
+            <a:ext cx="10789920" cy="369332"/>
+          </a:xfrm>
+          <a:prstGeom prst="rect">
+            <a:avLst/>
+          </a:prstGeom>
+          <a:noFill/>
+        </p:spPr>
+        <p:txBody>
+          <a:bodyPr vert="horz" wrap="square" rtlCol="0">
+            <a:noAutofit/>
+          </a:bodyPr>
+          <a:lstStyle/>
+          <a:p>
+            <a:r>
+              <a:rPr lang="zh-CN" altLang="en-US" sz="1300">
+                <a:solidFill>
+                  <a:srgbClr val="6F6F6A"/>
+                </a:solidFill>
+                <a:latin typeface="Microsoft YaHei" panose="020B0503020204020204" pitchFamily="34" charset="-122"/>
+                <a:ea typeface="Microsoft YaHei" panose="020B0503020204020204" pitchFamily="34" charset="-122"/>
+              </a:rPr>
+              <a:t>先选，再讲理由；本页不公布答案。</a:t>
+            </a:r>
+          </a:p>
+        </p:txBody>
+      </p:sp>
+      <p:sp>
+        <p:nvSpPr>
+          <p:cNvPr id="16" name="TEACHING_CUE">
+            <a:extLst>
+              <a:ext uri="{FF2B5EF4-FFF2-40B4-BE49-F238E27FC236}">
+                <a16:creationId xmlns:a16="http://schemas.microsoft.com/office/drawing/2014/main" id="{A7D14817-8851-6253-50C6-A6B12570FAB3}"/>
+              </a:ext>
+            </a:extLst>
+          </p:cNvPr>
+          <p:cNvSpPr txBox="1"/>
+          <p:nvPr/>
+        </p:nvSpPr>
+        <p:spPr>
+          <a:xfrm>
+            <a:off x="548640" y="6217920"/>
+            <a:ext cx="10789920" cy="365760"/>
+          </a:xfrm>
+          <a:prstGeom prst="rect">
+            <a:avLst/>
+          </a:prstGeom>
+          <a:noFill/>
+        </p:spPr>
+        <p:txBody>
+          <a:bodyPr vert="horz" wrap="square" rtlCol="0">
+            <a:noAutofit/>
+          </a:bodyPr>
+          <a:lstStyle/>
+          <a:p>
+            <a:r>
+              <a:rPr lang="zh-CN" altLang="en-US" sz="1200">
+                <a:solidFill>
+                  <a:srgbClr val="6F6F6A"/>
+                </a:solidFill>
+                <a:latin typeface="Microsoft YaHei" panose="020B0503020204020204" pitchFamily="34" charset="-122"/>
+                <a:ea typeface="Microsoft YaHei" panose="020B0503020204020204" pitchFamily="34" charset="-122"/>
+              </a:rPr>
+              <a:t>先收集各组的选项与理由，再引导讨论每个选项的成本与可验证依据；选项无对错，避免羞辱。</a:t>
+            </a:r>
+          </a:p>
+        </p:txBody>
+      </p:sp>
+    </p:spTree>
+    <p:extLst>
+      <p:ext uri="{BB962C8B-B14F-4D97-AF65-F5344CB8AC3E}">
+        <p14:creationId xmlns:p14="http://schemas.microsoft.com/office/powerpoint/2010/main" val="2930308214"/>
       </p:ext>
     </p:extLst>
   </p:cSld>

</xml_diff>

<commit_message>
Add I4 click-to-diagnose matrix (slide 13) via production line
Interactive family third source page: four-column matrix (维度/症状/解读/下一步) with four dimension rows, read column in red, instructor-paced reveal, 28 named objects, token colors. Fixed a PS 5.1 nested-array flattening bug in build script (call Add-Txt per cell directly). Full pipeline: build-i4.ps1 -> verify -> preview component-13.png -> registry -> generator (index/catalog SHA 0919C9A1) -> contact sheet -> promote -> slot contract + build contract synced.
</commit_message>
<xml_diff>
--- a/domains/yuhong/assets/components/yuhong-county-course-components-branded.pptx
+++ b/domains/yuhong/assets/components/yuhong-county-course-components-branded.pptx
@@ -5,7 +5,7 @@
     <p:sldMasterId id="2147483648" r:id="rId1"/>
   </p:sldMasterIdLst>
   <p:notesMasterIdLst>
-    <p:notesMasterId r:id="rId14"/>
+    <p:notesMasterId r:id="rId15"/>
   </p:notesMasterIdLst>
   <p:sldIdLst>
     <p:sldId id="256" r:id="rId2"/>
@@ -20,6 +20,7 @@
     <p:sldId id="265" r:id="rId11"/>
     <p:sldId id="266" r:id="rId12"/>
     <p:sldId id="267" r:id="rId13"/>
+    <p:sldId id="268" r:id="rId14"/>
   </p:sldIdLst>
   <p:sldSz cx="12192000" cy="6858000"/>
   <p:notesSz cx="6858000" cy="9144000"/>
@@ -7229,6 +7230,1336 @@
     <p:extLst>
       <p:ext uri="{BB962C8B-B14F-4D97-AF65-F5344CB8AC3E}">
         <p14:creationId xmlns:p14="http://schemas.microsoft.com/office/powerpoint/2010/main" val="2930308214"/>
+      </p:ext>
+    </p:extLst>
+  </p:cSld>
+  <p:clrMapOvr>
+    <a:masterClrMapping/>
+  </p:clrMapOvr>
+</p:sld>
+</file>
+
+<file path=ppt/slides/slide13.xml><?xml version="1.0" encoding="utf-8"?>
+<p:sld xmlns:a="http://schemas.openxmlformats.org/drawingml/2006/main" xmlns:r="http://schemas.openxmlformats.org/officeDocument/2006/relationships" xmlns:p="http://schemas.openxmlformats.org/presentationml/2006/main">
+  <p:cSld>
+    <p:spTree>
+      <p:nvGrpSpPr>
+        <p:cNvPr id="1" name=""/>
+        <p:cNvGrpSpPr/>
+        <p:nvPr/>
+      </p:nvGrpSpPr>
+      <p:grpSpPr>
+        <a:xfrm>
+          <a:off x="0" y="0"/>
+          <a:ext cx="0" cy="0"/>
+          <a:chOff x="0" y="0"/>
+          <a:chExt cx="0" cy="0"/>
+        </a:xfrm>
+      </p:grpSpPr>
+      <p:sp>
+        <p:nvSpPr>
+          <p:cNvPr id="2" name="TITLE">
+            <a:extLst>
+              <a:ext uri="{FF2B5EF4-FFF2-40B4-BE49-F238E27FC236}">
+                <a16:creationId xmlns:a16="http://schemas.microsoft.com/office/drawing/2014/main" id="{AD348B54-B680-DB9B-C4B6-4784A300A26A}"/>
+              </a:ext>
+            </a:extLst>
+          </p:cNvPr>
+          <p:cNvSpPr txBox="1"/>
+          <p:nvPr/>
+        </p:nvSpPr>
+        <p:spPr>
+          <a:xfrm>
+            <a:off x="548640" y="384048"/>
+            <a:ext cx="10789920" cy="369332"/>
+          </a:xfrm>
+          <a:prstGeom prst="rect">
+            <a:avLst/>
+          </a:prstGeom>
+          <a:noFill/>
+        </p:spPr>
+        <p:txBody>
+          <a:bodyPr vert="horz" wrap="square" rtlCol="0">
+            <a:noAutofit/>
+          </a:bodyPr>
+          <a:lstStyle/>
+          <a:p>
+            <a:r>
+              <a:rPr lang="zh-CN" altLang="en-US" sz="2500" b="1">
+                <a:solidFill>
+                  <a:srgbClr val="505046"/>
+                </a:solidFill>
+                <a:latin typeface="Microsoft YaHei" panose="020B0503020204020204" pitchFamily="34" charset="-122"/>
+                <a:ea typeface="Microsoft YaHei" panose="020B0503020204020204" pitchFamily="34" charset="-122"/>
+              </a:rPr>
+              <a:t>先看症状，再给解读：你的乡镇经营卡在哪？</a:t>
+            </a:r>
+          </a:p>
+        </p:txBody>
+      </p:sp>
+      <p:sp>
+        <p:nvSpPr>
+          <p:cNvPr id="3" name="SUBTITLE">
+            <a:extLst>
+              <a:ext uri="{FF2B5EF4-FFF2-40B4-BE49-F238E27FC236}">
+                <a16:creationId xmlns:a16="http://schemas.microsoft.com/office/drawing/2014/main" id="{A0CDBDFC-F762-FC87-4652-9FE9F40C76EF}"/>
+              </a:ext>
+            </a:extLst>
+          </p:cNvPr>
+          <p:cNvSpPr txBox="1"/>
+          <p:nvPr/>
+        </p:nvSpPr>
+        <p:spPr>
+          <a:xfrm>
+            <a:off x="548640" y="960120"/>
+            <a:ext cx="10789920" cy="365760"/>
+          </a:xfrm>
+          <a:prstGeom prst="rect">
+            <a:avLst/>
+          </a:prstGeom>
+          <a:noFill/>
+        </p:spPr>
+        <p:txBody>
+          <a:bodyPr vert="horz" wrap="square" rtlCol="0">
+            <a:noAutofit/>
+          </a:bodyPr>
+          <a:lstStyle/>
+          <a:p>
+            <a:r>
+              <a:rPr lang="zh-CN" altLang="en-US" sz="1400">
+                <a:solidFill>
+                  <a:srgbClr val="6F6F6A"/>
+                </a:solidFill>
+                <a:latin typeface="Microsoft YaHei" panose="020B0503020204020204" pitchFamily="34" charset="-122"/>
+                <a:ea typeface="Microsoft YaHei" panose="020B0503020204020204" pitchFamily="34" charset="-122"/>
+              </a:rPr>
+              <a:t>按维度逐行诊断：症状是事实，解读是判断，下一步是动作</a:t>
+            </a:r>
+          </a:p>
+        </p:txBody>
+      </p:sp>
+      <p:sp>
+        <p:nvSpPr>
+          <p:cNvPr id="4" name="HDR_1">
+            <a:extLst>
+              <a:ext uri="{FF2B5EF4-FFF2-40B4-BE49-F238E27FC236}">
+                <a16:creationId xmlns:a16="http://schemas.microsoft.com/office/drawing/2014/main" id="{BE52C567-7A51-F0F2-AB3D-35215106491A}"/>
+              </a:ext>
+            </a:extLst>
+          </p:cNvPr>
+          <p:cNvSpPr txBox="1"/>
+          <p:nvPr/>
+        </p:nvSpPr>
+        <p:spPr>
+          <a:xfrm>
+            <a:off x="548640" y="1463040"/>
+            <a:ext cx="2194560" cy="365760"/>
+          </a:xfrm>
+          <a:prstGeom prst="rect">
+            <a:avLst/>
+          </a:prstGeom>
+          <a:noFill/>
+        </p:spPr>
+        <p:txBody>
+          <a:bodyPr vert="horz" wrap="square" rtlCol="0">
+            <a:noAutofit/>
+          </a:bodyPr>
+          <a:lstStyle/>
+          <a:p>
+            <a:r>
+              <a:rPr lang="zh-CN" altLang="en-US" sz="1300" b="1">
+                <a:solidFill>
+                  <a:srgbClr val="E84C22"/>
+                </a:solidFill>
+                <a:latin typeface="Microsoft YaHei" panose="020B0503020204020204" pitchFamily="34" charset="-122"/>
+                <a:ea typeface="Microsoft YaHei" panose="020B0503020204020204" pitchFamily="34" charset="-122"/>
+              </a:rPr>
+              <a:t>经营维度</a:t>
+            </a:r>
+          </a:p>
+        </p:txBody>
+      </p:sp>
+      <p:sp>
+        <p:nvSpPr>
+          <p:cNvPr id="5" name="HDR_2">
+            <a:extLst>
+              <a:ext uri="{FF2B5EF4-FFF2-40B4-BE49-F238E27FC236}">
+                <a16:creationId xmlns:a16="http://schemas.microsoft.com/office/drawing/2014/main" id="{62847ADC-7C5F-3370-D193-84EAFA0AD2A3}"/>
+              </a:ext>
+            </a:extLst>
+          </p:cNvPr>
+          <p:cNvSpPr txBox="1"/>
+          <p:nvPr/>
+        </p:nvSpPr>
+        <p:spPr>
+          <a:xfrm>
+            <a:off x="2834640" y="1463040"/>
+            <a:ext cx="2560320" cy="365760"/>
+          </a:xfrm>
+          <a:prstGeom prst="rect">
+            <a:avLst/>
+          </a:prstGeom>
+          <a:noFill/>
+        </p:spPr>
+        <p:txBody>
+          <a:bodyPr vert="horz" wrap="square" rtlCol="0">
+            <a:noAutofit/>
+          </a:bodyPr>
+          <a:lstStyle/>
+          <a:p>
+            <a:r>
+              <a:rPr lang="zh-CN" altLang="en-US" sz="1300" b="1">
+                <a:solidFill>
+                  <a:srgbClr val="E84C22"/>
+                </a:solidFill>
+                <a:latin typeface="Microsoft YaHei" panose="020B0503020204020204" pitchFamily="34" charset="-122"/>
+                <a:ea typeface="Microsoft YaHei" panose="020B0503020204020204" pitchFamily="34" charset="-122"/>
+              </a:rPr>
+              <a:t>可见症状</a:t>
+            </a:r>
+          </a:p>
+        </p:txBody>
+      </p:sp>
+      <p:sp>
+        <p:nvSpPr>
+          <p:cNvPr id="6" name="HDR_3">
+            <a:extLst>
+              <a:ext uri="{FF2B5EF4-FFF2-40B4-BE49-F238E27FC236}">
+                <a16:creationId xmlns:a16="http://schemas.microsoft.com/office/drawing/2014/main" id="{4C178E36-50EF-33C0-19B2-41DF2D4E3AA5}"/>
+              </a:ext>
+            </a:extLst>
+          </p:cNvPr>
+          <p:cNvSpPr txBox="1"/>
+          <p:nvPr/>
+        </p:nvSpPr>
+        <p:spPr>
+          <a:xfrm>
+            <a:off x="5486400" y="1463040"/>
+            <a:ext cx="2560320" cy="365760"/>
+          </a:xfrm>
+          <a:prstGeom prst="rect">
+            <a:avLst/>
+          </a:prstGeom>
+          <a:noFill/>
+        </p:spPr>
+        <p:txBody>
+          <a:bodyPr vert="horz" wrap="square" rtlCol="0">
+            <a:noAutofit/>
+          </a:bodyPr>
+          <a:lstStyle/>
+          <a:p>
+            <a:r>
+              <a:rPr lang="zh-CN" altLang="en-US" sz="1300" b="1">
+                <a:solidFill>
+                  <a:srgbClr val="E84C22"/>
+                </a:solidFill>
+                <a:latin typeface="Microsoft YaHei" panose="020B0503020204020204" pitchFamily="34" charset="-122"/>
+                <a:ea typeface="Microsoft YaHei" panose="020B0503020204020204" pitchFamily="34" charset="-122"/>
+              </a:rPr>
+              <a:t>解读</a:t>
+            </a:r>
+          </a:p>
+        </p:txBody>
+      </p:sp>
+      <p:sp>
+        <p:nvSpPr>
+          <p:cNvPr id="7" name="HDR_4">
+            <a:extLst>
+              <a:ext uri="{FF2B5EF4-FFF2-40B4-BE49-F238E27FC236}">
+                <a16:creationId xmlns:a16="http://schemas.microsoft.com/office/drawing/2014/main" id="{6E15FE9A-5A22-C4D4-75D9-0F93A90F99EB}"/>
+              </a:ext>
+            </a:extLst>
+          </p:cNvPr>
+          <p:cNvSpPr txBox="1"/>
+          <p:nvPr/>
+        </p:nvSpPr>
+        <p:spPr>
+          <a:xfrm>
+            <a:off x="8138160" y="1463040"/>
+            <a:ext cx="3474720" cy="365760"/>
+          </a:xfrm>
+          <a:prstGeom prst="rect">
+            <a:avLst/>
+          </a:prstGeom>
+          <a:noFill/>
+        </p:spPr>
+        <p:txBody>
+          <a:bodyPr vert="horz" wrap="square" rtlCol="0">
+            <a:noAutofit/>
+          </a:bodyPr>
+          <a:lstStyle/>
+          <a:p>
+            <a:r>
+              <a:rPr lang="zh-CN" altLang="en-US" sz="1300" b="1">
+                <a:solidFill>
+                  <a:srgbClr val="E84C22"/>
+                </a:solidFill>
+                <a:latin typeface="Microsoft YaHei" panose="020B0503020204020204" pitchFamily="34" charset="-122"/>
+                <a:ea typeface="Microsoft YaHei" panose="020B0503020204020204" pitchFamily="34" charset="-122"/>
+              </a:rPr>
+              <a:t>下一步</a:t>
+            </a:r>
+          </a:p>
+        </p:txBody>
+      </p:sp>
+      <p:sp>
+        <p:nvSpPr>
+          <p:cNvPr id="8" name="ROW_BAND_1">
+            <a:extLst>
+              <a:ext uri="{FF2B5EF4-FFF2-40B4-BE49-F238E27FC236}">
+                <a16:creationId xmlns:a16="http://schemas.microsoft.com/office/drawing/2014/main" id="{7C186B51-50DB-7BD4-0425-68B30FC00298}"/>
+              </a:ext>
+            </a:extLst>
+          </p:cNvPr>
+          <p:cNvSpPr/>
+          <p:nvPr/>
+        </p:nvSpPr>
+        <p:spPr>
+          <a:xfrm>
+            <a:off x="548640" y="1920240"/>
+            <a:ext cx="11064240" cy="502920"/>
+          </a:xfrm>
+          <a:prstGeom prst="rect">
+            <a:avLst/>
+          </a:prstGeom>
+          <a:solidFill>
+            <a:srgbClr val="F7F7F8"/>
+          </a:solidFill>
+          <a:ln w="9525">
+            <a:solidFill>
+              <a:srgbClr val="6F6F6A"/>
+            </a:solidFill>
+          </a:ln>
+        </p:spPr>
+        <p:style>
+          <a:lnRef idx="2">
+            <a:schemeClr val="accent1">
+              <a:shade val="15000"/>
+            </a:schemeClr>
+          </a:lnRef>
+          <a:fillRef idx="1">
+            <a:schemeClr val="accent1"/>
+          </a:fillRef>
+          <a:effectRef idx="0">
+            <a:schemeClr val="accent1"/>
+          </a:effectRef>
+          <a:fontRef idx="minor">
+            <a:schemeClr val="lt1"/>
+          </a:fontRef>
+        </p:style>
+        <p:txBody>
+          <a:bodyPr rtlCol="0" anchor="ctr"/>
+          <a:lstStyle/>
+          <a:p>
+            <a:pPr algn="ctr"/>
+            <a:endParaRPr lang="zh-CN" altLang="en-US"/>
+          </a:p>
+        </p:txBody>
+      </p:sp>
+      <p:sp>
+        <p:nvSpPr>
+          <p:cNvPr id="9" name="DIM_1_NAME">
+            <a:extLst>
+              <a:ext uri="{FF2B5EF4-FFF2-40B4-BE49-F238E27FC236}">
+                <a16:creationId xmlns:a16="http://schemas.microsoft.com/office/drawing/2014/main" id="{9F34780E-5F06-32CC-1145-C4468720E266}"/>
+              </a:ext>
+            </a:extLst>
+          </p:cNvPr>
+          <p:cNvSpPr txBox="1"/>
+          <p:nvPr/>
+        </p:nvSpPr>
+        <p:spPr>
+          <a:xfrm>
+            <a:off x="685800" y="1993392"/>
+            <a:ext cx="1920240" cy="365760"/>
+          </a:xfrm>
+          <a:prstGeom prst="rect">
+            <a:avLst/>
+          </a:prstGeom>
+          <a:noFill/>
+        </p:spPr>
+        <p:txBody>
+          <a:bodyPr vert="horz" wrap="square" rtlCol="0">
+            <a:noAutofit/>
+          </a:bodyPr>
+          <a:lstStyle/>
+          <a:p>
+            <a:r>
+              <a:rPr lang="zh-CN" altLang="en-US" sz="1300" b="1">
+                <a:solidFill>
+                  <a:srgbClr val="505046"/>
+                </a:solidFill>
+                <a:latin typeface="Microsoft YaHei" panose="020B0503020204020204" pitchFamily="34" charset="-122"/>
+                <a:ea typeface="Microsoft YaHei" panose="020B0503020204020204" pitchFamily="34" charset="-122"/>
+              </a:rPr>
+              <a:t>覆盖</a:t>
+            </a:r>
+          </a:p>
+        </p:txBody>
+      </p:sp>
+      <p:sp>
+        <p:nvSpPr>
+          <p:cNvPr id="10" name="DIM_1_SYMPTOM">
+            <a:extLst>
+              <a:ext uri="{FF2B5EF4-FFF2-40B4-BE49-F238E27FC236}">
+                <a16:creationId xmlns:a16="http://schemas.microsoft.com/office/drawing/2014/main" id="{96438923-3B34-EEE7-6698-E088990D3979}"/>
+              </a:ext>
+            </a:extLst>
+          </p:cNvPr>
+          <p:cNvSpPr txBox="1"/>
+          <p:nvPr/>
+        </p:nvSpPr>
+        <p:spPr>
+          <a:xfrm>
+            <a:off x="2971800" y="1993392"/>
+            <a:ext cx="2286000" cy="365760"/>
+          </a:xfrm>
+          <a:prstGeom prst="rect">
+            <a:avLst/>
+          </a:prstGeom>
+          <a:noFill/>
+        </p:spPr>
+        <p:txBody>
+          <a:bodyPr vert="horz" wrap="square" rtlCol="0">
+            <a:noAutofit/>
+          </a:bodyPr>
+          <a:lstStyle/>
+          <a:p>
+            <a:r>
+              <a:rPr lang="zh-CN" altLang="en-US" sz="1200">
+                <a:solidFill>
+                  <a:srgbClr val="505046"/>
+                </a:solidFill>
+                <a:latin typeface="Microsoft YaHei" panose="020B0503020204020204" pitchFamily="34" charset="-122"/>
+                <a:ea typeface="Microsoft YaHei" panose="020B0503020204020204" pitchFamily="34" charset="-122"/>
+              </a:rPr>
+              <a:t>网点铺了，但不动销</a:t>
+            </a:r>
+          </a:p>
+        </p:txBody>
+      </p:sp>
+      <p:sp>
+        <p:nvSpPr>
+          <p:cNvPr id="11" name="DIM_1_READ">
+            <a:extLst>
+              <a:ext uri="{FF2B5EF4-FFF2-40B4-BE49-F238E27FC236}">
+                <a16:creationId xmlns:a16="http://schemas.microsoft.com/office/drawing/2014/main" id="{03A3FF9F-A980-AD0F-15CD-EBAD4E176935}"/>
+              </a:ext>
+            </a:extLst>
+          </p:cNvPr>
+          <p:cNvSpPr txBox="1"/>
+          <p:nvPr/>
+        </p:nvSpPr>
+        <p:spPr>
+          <a:xfrm>
+            <a:off x="5623560" y="1993392"/>
+            <a:ext cx="2286000" cy="365760"/>
+          </a:xfrm>
+          <a:prstGeom prst="rect">
+            <a:avLst/>
+          </a:prstGeom>
+          <a:noFill/>
+        </p:spPr>
+        <p:txBody>
+          <a:bodyPr vert="horz" wrap="square" rtlCol="0">
+            <a:noAutofit/>
+          </a:bodyPr>
+          <a:lstStyle/>
+          <a:p>
+            <a:r>
+              <a:rPr lang="zh-CN" altLang="en-US" sz="1200">
+                <a:solidFill>
+                  <a:srgbClr val="E84C22"/>
+                </a:solidFill>
+                <a:latin typeface="Microsoft YaHei" panose="020B0503020204020204" pitchFamily="34" charset="-122"/>
+                <a:ea typeface="Microsoft YaHei" panose="020B0503020204020204" pitchFamily="34" charset="-122"/>
+              </a:rPr>
+              <a:t>渠道力偏弱</a:t>
+            </a:r>
+          </a:p>
+        </p:txBody>
+      </p:sp>
+      <p:sp>
+        <p:nvSpPr>
+          <p:cNvPr id="12" name="DIM_1_NEXT">
+            <a:extLst>
+              <a:ext uri="{FF2B5EF4-FFF2-40B4-BE49-F238E27FC236}">
+                <a16:creationId xmlns:a16="http://schemas.microsoft.com/office/drawing/2014/main" id="{86A6E245-2D19-96C7-D7BF-E37220EE1841}"/>
+              </a:ext>
+            </a:extLst>
+          </p:cNvPr>
+          <p:cNvSpPr txBox="1"/>
+          <p:nvPr/>
+        </p:nvSpPr>
+        <p:spPr>
+          <a:xfrm>
+            <a:off x="8275320" y="1993392"/>
+            <a:ext cx="3200400" cy="365760"/>
+          </a:xfrm>
+          <a:prstGeom prst="rect">
+            <a:avLst/>
+          </a:prstGeom>
+          <a:noFill/>
+        </p:spPr>
+        <p:txBody>
+          <a:bodyPr vert="horz" wrap="square" rtlCol="0">
+            <a:noAutofit/>
+          </a:bodyPr>
+          <a:lstStyle/>
+          <a:p>
+            <a:r>
+              <a:rPr lang="zh-CN" altLang="en-US" sz="1200">
+                <a:solidFill>
+                  <a:srgbClr val="505046"/>
+                </a:solidFill>
+                <a:latin typeface="Microsoft YaHei" panose="020B0503020204020204" pitchFamily="34" charset="-122"/>
+                <a:ea typeface="Microsoft YaHei" panose="020B0503020204020204" pitchFamily="34" charset="-122"/>
+              </a:rPr>
+              <a:t>按核心</a:t>
+            </a:r>
+            <a:r>
+              <a:rPr lang="en-US" altLang="zh-CN" sz="1200">
+                <a:solidFill>
+                  <a:srgbClr val="505046"/>
+                </a:solidFill>
+                <a:latin typeface="Microsoft YaHei" panose="020B0503020204020204" pitchFamily="34" charset="-122"/>
+                <a:ea typeface="Microsoft YaHei" panose="020B0503020204020204" pitchFamily="34" charset="-122"/>
+              </a:rPr>
+              <a:t>/</a:t>
+            </a:r>
+            <a:r>
+              <a:rPr lang="zh-CN" altLang="en-US" sz="1200">
+                <a:solidFill>
+                  <a:srgbClr val="505046"/>
+                </a:solidFill>
+                <a:latin typeface="Microsoft YaHei" panose="020B0503020204020204" pitchFamily="34" charset="-122"/>
+                <a:ea typeface="Microsoft YaHei" panose="020B0503020204020204" pitchFamily="34" charset="-122"/>
+              </a:rPr>
+              <a:t>普通</a:t>
+            </a:r>
+            <a:r>
+              <a:rPr lang="en-US" altLang="zh-CN" sz="1200">
+                <a:solidFill>
+                  <a:srgbClr val="505046"/>
+                </a:solidFill>
+                <a:latin typeface="Microsoft YaHei" panose="020B0503020204020204" pitchFamily="34" charset="-122"/>
+                <a:ea typeface="Microsoft YaHei" panose="020B0503020204020204" pitchFamily="34" charset="-122"/>
+              </a:rPr>
+              <a:t>/</a:t>
+            </a:r>
+            <a:r>
+              <a:rPr lang="zh-CN" altLang="en-US" sz="1200">
+                <a:solidFill>
+                  <a:srgbClr val="505046"/>
+                </a:solidFill>
+                <a:latin typeface="Microsoft YaHei" panose="020B0503020204020204" pitchFamily="34" charset="-122"/>
+                <a:ea typeface="Microsoft YaHei" panose="020B0503020204020204" pitchFamily="34" charset="-122"/>
+              </a:rPr>
+              <a:t>低效分类，集中激活</a:t>
+            </a:r>
+          </a:p>
+        </p:txBody>
+      </p:sp>
+      <p:sp>
+        <p:nvSpPr>
+          <p:cNvPr id="13" name="ROW_BAND_2">
+            <a:extLst>
+              <a:ext uri="{FF2B5EF4-FFF2-40B4-BE49-F238E27FC236}">
+                <a16:creationId xmlns:a16="http://schemas.microsoft.com/office/drawing/2014/main" id="{55943540-F103-5EFD-0155-13E5A587367B}"/>
+              </a:ext>
+            </a:extLst>
+          </p:cNvPr>
+          <p:cNvSpPr/>
+          <p:nvPr/>
+        </p:nvSpPr>
+        <p:spPr>
+          <a:xfrm>
+            <a:off x="548640" y="2514600"/>
+            <a:ext cx="11064240" cy="502920"/>
+          </a:xfrm>
+          <a:prstGeom prst="rect">
+            <a:avLst/>
+          </a:prstGeom>
+          <a:solidFill>
+            <a:srgbClr val="EEECE1"/>
+          </a:solidFill>
+          <a:ln w="9525">
+            <a:solidFill>
+              <a:srgbClr val="6F6F6A"/>
+            </a:solidFill>
+          </a:ln>
+        </p:spPr>
+        <p:style>
+          <a:lnRef idx="2">
+            <a:schemeClr val="accent1">
+              <a:shade val="15000"/>
+            </a:schemeClr>
+          </a:lnRef>
+          <a:fillRef idx="1">
+            <a:schemeClr val="accent1"/>
+          </a:fillRef>
+          <a:effectRef idx="0">
+            <a:schemeClr val="accent1"/>
+          </a:effectRef>
+          <a:fontRef idx="minor">
+            <a:schemeClr val="lt1"/>
+          </a:fontRef>
+        </p:style>
+        <p:txBody>
+          <a:bodyPr rtlCol="0" anchor="ctr"/>
+          <a:lstStyle/>
+          <a:p>
+            <a:pPr algn="ctr"/>
+            <a:endParaRPr lang="zh-CN" altLang="en-US"/>
+          </a:p>
+        </p:txBody>
+      </p:sp>
+      <p:sp>
+        <p:nvSpPr>
+          <p:cNvPr id="14" name="DIM_2_NAME">
+            <a:extLst>
+              <a:ext uri="{FF2B5EF4-FFF2-40B4-BE49-F238E27FC236}">
+                <a16:creationId xmlns:a16="http://schemas.microsoft.com/office/drawing/2014/main" id="{9A101BCD-4D62-9E6F-6D45-2F4D3A0A337D}"/>
+              </a:ext>
+            </a:extLst>
+          </p:cNvPr>
+          <p:cNvSpPr txBox="1"/>
+          <p:nvPr/>
+        </p:nvSpPr>
+        <p:spPr>
+          <a:xfrm>
+            <a:off x="685800" y="2587752"/>
+            <a:ext cx="1920240" cy="365760"/>
+          </a:xfrm>
+          <a:prstGeom prst="rect">
+            <a:avLst/>
+          </a:prstGeom>
+          <a:noFill/>
+        </p:spPr>
+        <p:txBody>
+          <a:bodyPr vert="horz" wrap="square" rtlCol="0">
+            <a:noAutofit/>
+          </a:bodyPr>
+          <a:lstStyle/>
+          <a:p>
+            <a:r>
+              <a:rPr lang="zh-CN" altLang="en-US" sz="1300" b="1">
+                <a:solidFill>
+                  <a:srgbClr val="505046"/>
+                </a:solidFill>
+                <a:latin typeface="Microsoft YaHei" panose="020B0503020204020204" pitchFamily="34" charset="-122"/>
+                <a:ea typeface="Microsoft YaHei" panose="020B0503020204020204" pitchFamily="34" charset="-122"/>
+              </a:rPr>
+              <a:t>活跃</a:t>
+            </a:r>
+          </a:p>
+        </p:txBody>
+      </p:sp>
+      <p:sp>
+        <p:nvSpPr>
+          <p:cNvPr id="15" name="DIM_2_SYMPTOM">
+            <a:extLst>
+              <a:ext uri="{FF2B5EF4-FFF2-40B4-BE49-F238E27FC236}">
+                <a16:creationId xmlns:a16="http://schemas.microsoft.com/office/drawing/2014/main" id="{F6AF167C-568F-B747-D47B-7A914351C73B}"/>
+              </a:ext>
+            </a:extLst>
+          </p:cNvPr>
+          <p:cNvSpPr txBox="1"/>
+          <p:nvPr/>
+        </p:nvSpPr>
+        <p:spPr>
+          <a:xfrm>
+            <a:off x="2971800" y="2587752"/>
+            <a:ext cx="2286000" cy="365760"/>
+          </a:xfrm>
+          <a:prstGeom prst="rect">
+            <a:avLst/>
+          </a:prstGeom>
+          <a:noFill/>
+        </p:spPr>
+        <p:txBody>
+          <a:bodyPr vert="horz" wrap="square" rtlCol="0">
+            <a:noAutofit/>
+          </a:bodyPr>
+          <a:lstStyle/>
+          <a:p>
+            <a:r>
+              <a:rPr lang="zh-CN" altLang="en-US" sz="1200">
+                <a:solidFill>
+                  <a:srgbClr val="505046"/>
+                </a:solidFill>
+                <a:latin typeface="Microsoft YaHei" panose="020B0503020204020204" pitchFamily="34" charset="-122"/>
+                <a:ea typeface="Microsoft YaHei" panose="020B0503020204020204" pitchFamily="34" charset="-122"/>
+              </a:rPr>
+              <a:t>补货不稳定，靠促销撑</a:t>
+            </a:r>
+          </a:p>
+        </p:txBody>
+      </p:sp>
+      <p:sp>
+        <p:nvSpPr>
+          <p:cNvPr id="16" name="DIM_2_READ">
+            <a:extLst>
+              <a:ext uri="{FF2B5EF4-FFF2-40B4-BE49-F238E27FC236}">
+                <a16:creationId xmlns:a16="http://schemas.microsoft.com/office/drawing/2014/main" id="{C1398A27-6A25-020F-53CB-91DE7CF0DFCB}"/>
+              </a:ext>
+            </a:extLst>
+          </p:cNvPr>
+          <p:cNvSpPr txBox="1"/>
+          <p:nvPr/>
+        </p:nvSpPr>
+        <p:spPr>
+          <a:xfrm>
+            <a:off x="5623560" y="2587752"/>
+            <a:ext cx="2286000" cy="365760"/>
+          </a:xfrm>
+          <a:prstGeom prst="rect">
+            <a:avLst/>
+          </a:prstGeom>
+          <a:noFill/>
+        </p:spPr>
+        <p:txBody>
+          <a:bodyPr vert="horz" wrap="square" rtlCol="0">
+            <a:noAutofit/>
+          </a:bodyPr>
+          <a:lstStyle/>
+          <a:p>
+            <a:r>
+              <a:rPr lang="zh-CN" altLang="en-US" sz="1200">
+                <a:solidFill>
+                  <a:srgbClr val="E84C22"/>
+                </a:solidFill>
+                <a:latin typeface="Microsoft YaHei" panose="020B0503020204020204" pitchFamily="34" charset="-122"/>
+                <a:ea typeface="Microsoft YaHei" panose="020B0503020204020204" pitchFamily="34" charset="-122"/>
+              </a:rPr>
+              <a:t>拜访缺任务，动销未形成</a:t>
+            </a:r>
+          </a:p>
+        </p:txBody>
+      </p:sp>
+      <p:sp>
+        <p:nvSpPr>
+          <p:cNvPr id="17" name="DIM_2_NEXT">
+            <a:extLst>
+              <a:ext uri="{FF2B5EF4-FFF2-40B4-BE49-F238E27FC236}">
+                <a16:creationId xmlns:a16="http://schemas.microsoft.com/office/drawing/2014/main" id="{D5EFB405-A445-5EB2-A799-899C4670B41C}"/>
+              </a:ext>
+            </a:extLst>
+          </p:cNvPr>
+          <p:cNvSpPr txBox="1"/>
+          <p:nvPr/>
+        </p:nvSpPr>
+        <p:spPr>
+          <a:xfrm>
+            <a:off x="8275320" y="2587752"/>
+            <a:ext cx="3200400" cy="365760"/>
+          </a:xfrm>
+          <a:prstGeom prst="rect">
+            <a:avLst/>
+          </a:prstGeom>
+          <a:noFill/>
+        </p:spPr>
+        <p:txBody>
+          <a:bodyPr vert="horz" wrap="square" rtlCol="0">
+            <a:noAutofit/>
+          </a:bodyPr>
+          <a:lstStyle/>
+          <a:p>
+            <a:r>
+              <a:rPr lang="zh-CN" altLang="en-US" sz="1200">
+                <a:solidFill>
+                  <a:srgbClr val="505046"/>
+                </a:solidFill>
+                <a:latin typeface="Microsoft YaHei" panose="020B0503020204020204" pitchFamily="34" charset="-122"/>
+                <a:ea typeface="Microsoft YaHei" panose="020B0503020204020204" pitchFamily="34" charset="-122"/>
+              </a:rPr>
+              <a:t>固定路线，每次拜访带项目提问</a:t>
+            </a:r>
+          </a:p>
+        </p:txBody>
+      </p:sp>
+      <p:sp>
+        <p:nvSpPr>
+          <p:cNvPr id="18" name="ROW_BAND_3">
+            <a:extLst>
+              <a:ext uri="{FF2B5EF4-FFF2-40B4-BE49-F238E27FC236}">
+                <a16:creationId xmlns:a16="http://schemas.microsoft.com/office/drawing/2014/main" id="{63F862FA-64FB-A96E-7486-C6AD81B05089}"/>
+              </a:ext>
+            </a:extLst>
+          </p:cNvPr>
+          <p:cNvSpPr/>
+          <p:nvPr/>
+        </p:nvSpPr>
+        <p:spPr>
+          <a:xfrm>
+            <a:off x="548640" y="3108960"/>
+            <a:ext cx="11064240" cy="502920"/>
+          </a:xfrm>
+          <a:prstGeom prst="rect">
+            <a:avLst/>
+          </a:prstGeom>
+          <a:solidFill>
+            <a:srgbClr val="F7F7F8"/>
+          </a:solidFill>
+          <a:ln w="9525">
+            <a:solidFill>
+              <a:srgbClr val="6F6F6A"/>
+            </a:solidFill>
+          </a:ln>
+        </p:spPr>
+        <p:style>
+          <a:lnRef idx="2">
+            <a:schemeClr val="accent1">
+              <a:shade val="15000"/>
+            </a:schemeClr>
+          </a:lnRef>
+          <a:fillRef idx="1">
+            <a:schemeClr val="accent1"/>
+          </a:fillRef>
+          <a:effectRef idx="0">
+            <a:schemeClr val="accent1"/>
+          </a:effectRef>
+          <a:fontRef idx="minor">
+            <a:schemeClr val="lt1"/>
+          </a:fontRef>
+        </p:style>
+        <p:txBody>
+          <a:bodyPr rtlCol="0" anchor="ctr"/>
+          <a:lstStyle/>
+          <a:p>
+            <a:pPr algn="ctr"/>
+            <a:endParaRPr lang="zh-CN" altLang="en-US"/>
+          </a:p>
+        </p:txBody>
+      </p:sp>
+      <p:sp>
+        <p:nvSpPr>
+          <p:cNvPr id="19" name="DIM_3_NAME">
+            <a:extLst>
+              <a:ext uri="{FF2B5EF4-FFF2-40B4-BE49-F238E27FC236}">
+                <a16:creationId xmlns:a16="http://schemas.microsoft.com/office/drawing/2014/main" id="{BDF8D63D-3A10-D5EA-5188-F515DFD282B6}"/>
+              </a:ext>
+            </a:extLst>
+          </p:cNvPr>
+          <p:cNvSpPr txBox="1"/>
+          <p:nvPr/>
+        </p:nvSpPr>
+        <p:spPr>
+          <a:xfrm>
+            <a:off x="685800" y="3182112"/>
+            <a:ext cx="1920240" cy="365760"/>
+          </a:xfrm>
+          <a:prstGeom prst="rect">
+            <a:avLst/>
+          </a:prstGeom>
+          <a:noFill/>
+        </p:spPr>
+        <p:txBody>
+          <a:bodyPr vert="horz" wrap="square" rtlCol="0">
+            <a:noAutofit/>
+          </a:bodyPr>
+          <a:lstStyle/>
+          <a:p>
+            <a:r>
+              <a:rPr lang="zh-CN" altLang="en-US" sz="1300" b="1">
+                <a:solidFill>
+                  <a:srgbClr val="505046"/>
+                </a:solidFill>
+                <a:latin typeface="Microsoft YaHei" panose="020B0503020204020204" pitchFamily="34" charset="-122"/>
+                <a:ea typeface="Microsoft YaHei" panose="020B0503020204020204" pitchFamily="34" charset="-122"/>
+              </a:rPr>
+              <a:t>品项</a:t>
+            </a:r>
+          </a:p>
+        </p:txBody>
+      </p:sp>
+      <p:sp>
+        <p:nvSpPr>
+          <p:cNvPr id="20" name="DIM_3_SYMPTOM">
+            <a:extLst>
+              <a:ext uri="{FF2B5EF4-FFF2-40B4-BE49-F238E27FC236}">
+                <a16:creationId xmlns:a16="http://schemas.microsoft.com/office/drawing/2014/main" id="{7A1E9BA9-2E5B-7849-95E9-91833DDBA39E}"/>
+              </a:ext>
+            </a:extLst>
+          </p:cNvPr>
+          <p:cNvSpPr txBox="1"/>
+          <p:nvPr/>
+        </p:nvSpPr>
+        <p:spPr>
+          <a:xfrm>
+            <a:off x="2971800" y="3182112"/>
+            <a:ext cx="2286000" cy="365760"/>
+          </a:xfrm>
+          <a:prstGeom prst="rect">
+            <a:avLst/>
+          </a:prstGeom>
+          <a:noFill/>
+        </p:spPr>
+        <p:txBody>
+          <a:bodyPr vert="horz" wrap="square" rtlCol="0">
+            <a:noAutofit/>
+          </a:bodyPr>
+          <a:lstStyle/>
+          <a:p>
+            <a:r>
+              <a:rPr lang="zh-CN" altLang="en-US" sz="1200">
+                <a:solidFill>
+                  <a:srgbClr val="505046"/>
+                </a:solidFill>
+                <a:latin typeface="Microsoft YaHei" panose="020B0503020204020204" pitchFamily="34" charset="-122"/>
+                <a:ea typeface="Microsoft YaHei" panose="020B0503020204020204" pitchFamily="34" charset="-122"/>
+              </a:rPr>
+              <a:t>没有主推品项</a:t>
+            </a:r>
+          </a:p>
+        </p:txBody>
+      </p:sp>
+      <p:sp>
+        <p:nvSpPr>
+          <p:cNvPr id="21" name="DIM_3_READ">
+            <a:extLst>
+              <a:ext uri="{FF2B5EF4-FFF2-40B4-BE49-F238E27FC236}">
+                <a16:creationId xmlns:a16="http://schemas.microsoft.com/office/drawing/2014/main" id="{6F6EA3BF-9CA5-4DFE-FED2-5518487C6214}"/>
+              </a:ext>
+            </a:extLst>
+          </p:cNvPr>
+          <p:cNvSpPr txBox="1"/>
+          <p:nvPr/>
+        </p:nvSpPr>
+        <p:spPr>
+          <a:xfrm>
+            <a:off x="5623560" y="3182112"/>
+            <a:ext cx="2286000" cy="365760"/>
+          </a:xfrm>
+          <a:prstGeom prst="rect">
+            <a:avLst/>
+          </a:prstGeom>
+          <a:noFill/>
+        </p:spPr>
+        <p:txBody>
+          <a:bodyPr vert="horz" wrap="square" rtlCol="0">
+            <a:noAutofit/>
+          </a:bodyPr>
+          <a:lstStyle/>
+          <a:p>
+            <a:r>
+              <a:rPr lang="zh-CN" altLang="en-US" sz="1200">
+                <a:solidFill>
+                  <a:srgbClr val="E84C22"/>
+                </a:solidFill>
+                <a:latin typeface="Microsoft YaHei" panose="020B0503020204020204" pitchFamily="34" charset="-122"/>
+                <a:ea typeface="Microsoft YaHei" panose="020B0503020204020204" pitchFamily="34" charset="-122"/>
+              </a:rPr>
+              <a:t>产品力弱，上量无抓手</a:t>
+            </a:r>
+          </a:p>
+        </p:txBody>
+      </p:sp>
+      <p:sp>
+        <p:nvSpPr>
+          <p:cNvPr id="22" name="DIM_3_NEXT">
+            <a:extLst>
+              <a:ext uri="{FF2B5EF4-FFF2-40B4-BE49-F238E27FC236}">
+                <a16:creationId xmlns:a16="http://schemas.microsoft.com/office/drawing/2014/main" id="{4EB2A178-812F-6C01-E644-8BE9DCD98B61}"/>
+              </a:ext>
+            </a:extLst>
+          </p:cNvPr>
+          <p:cNvSpPr txBox="1"/>
+          <p:nvPr/>
+        </p:nvSpPr>
+        <p:spPr>
+          <a:xfrm>
+            <a:off x="8275320" y="3182112"/>
+            <a:ext cx="3200400" cy="365760"/>
+          </a:xfrm>
+          <a:prstGeom prst="rect">
+            <a:avLst/>
+          </a:prstGeom>
+          <a:noFill/>
+        </p:spPr>
+        <p:txBody>
+          <a:bodyPr vert="horz" wrap="square" rtlCol="0">
+            <a:noAutofit/>
+          </a:bodyPr>
+          <a:lstStyle/>
+          <a:p>
+            <a:r>
+              <a:rPr lang="zh-CN" altLang="en-US" sz="1200">
+                <a:solidFill>
+                  <a:srgbClr val="505046"/>
+                </a:solidFill>
+                <a:latin typeface="Microsoft YaHei" panose="020B0503020204020204" pitchFamily="34" charset="-122"/>
+                <a:ea typeface="Microsoft YaHei" panose="020B0503020204020204" pitchFamily="34" charset="-122"/>
+              </a:rPr>
+              <a:t>选 </a:t>
+            </a:r>
+            <a:r>
+              <a:rPr lang="en-US" altLang="zh-CN" sz="1200">
+                <a:solidFill>
+                  <a:srgbClr val="505046"/>
+                </a:solidFill>
+                <a:latin typeface="Microsoft YaHei" panose="020B0503020204020204" pitchFamily="34" charset="-122"/>
+                <a:ea typeface="Microsoft YaHei" panose="020B0503020204020204" pitchFamily="34" charset="-122"/>
+              </a:rPr>
+              <a:t>1-2 </a:t>
+            </a:r>
+            <a:r>
+              <a:rPr lang="zh-CN" altLang="en-US" sz="1200">
+                <a:solidFill>
+                  <a:srgbClr val="505046"/>
+                </a:solidFill>
+                <a:latin typeface="Microsoft YaHei" panose="020B0503020204020204" pitchFamily="34" charset="-122"/>
+                <a:ea typeface="Microsoft YaHei" panose="020B0503020204020204" pitchFamily="34" charset="-122"/>
+              </a:rPr>
+              <a:t>款主推，配套陈列与话术</a:t>
+            </a:r>
+          </a:p>
+        </p:txBody>
+      </p:sp>
+      <p:sp>
+        <p:nvSpPr>
+          <p:cNvPr id="23" name="ROW_BAND_4">
+            <a:extLst>
+              <a:ext uri="{FF2B5EF4-FFF2-40B4-BE49-F238E27FC236}">
+                <a16:creationId xmlns:a16="http://schemas.microsoft.com/office/drawing/2014/main" id="{DF6ACB09-3F0C-E5FD-A8CF-66F1DA8B82FF}"/>
+              </a:ext>
+            </a:extLst>
+          </p:cNvPr>
+          <p:cNvSpPr/>
+          <p:nvPr/>
+        </p:nvSpPr>
+        <p:spPr>
+          <a:xfrm>
+            <a:off x="548640" y="3703320"/>
+            <a:ext cx="11064240" cy="502920"/>
+          </a:xfrm>
+          <a:prstGeom prst="rect">
+            <a:avLst/>
+          </a:prstGeom>
+          <a:solidFill>
+            <a:srgbClr val="EEECE1"/>
+          </a:solidFill>
+          <a:ln w="9525">
+            <a:solidFill>
+              <a:srgbClr val="6F6F6A"/>
+            </a:solidFill>
+          </a:ln>
+        </p:spPr>
+        <p:style>
+          <a:lnRef idx="2">
+            <a:schemeClr val="accent1">
+              <a:shade val="15000"/>
+            </a:schemeClr>
+          </a:lnRef>
+          <a:fillRef idx="1">
+            <a:schemeClr val="accent1"/>
+          </a:fillRef>
+          <a:effectRef idx="0">
+            <a:schemeClr val="accent1"/>
+          </a:effectRef>
+          <a:fontRef idx="minor">
+            <a:schemeClr val="lt1"/>
+          </a:fontRef>
+        </p:style>
+        <p:txBody>
+          <a:bodyPr rtlCol="0" anchor="ctr"/>
+          <a:lstStyle/>
+          <a:p>
+            <a:pPr algn="ctr"/>
+            <a:endParaRPr lang="zh-CN" altLang="en-US"/>
+          </a:p>
+        </p:txBody>
+      </p:sp>
+      <p:sp>
+        <p:nvSpPr>
+          <p:cNvPr id="24" name="DIM_4_NAME">
+            <a:extLst>
+              <a:ext uri="{FF2B5EF4-FFF2-40B4-BE49-F238E27FC236}">
+                <a16:creationId xmlns:a16="http://schemas.microsoft.com/office/drawing/2014/main" id="{BBD963CA-428E-B658-21CE-B98339442A57}"/>
+              </a:ext>
+            </a:extLst>
+          </p:cNvPr>
+          <p:cNvSpPr txBox="1"/>
+          <p:nvPr/>
+        </p:nvSpPr>
+        <p:spPr>
+          <a:xfrm>
+            <a:off x="685800" y="3776472"/>
+            <a:ext cx="1920240" cy="365760"/>
+          </a:xfrm>
+          <a:prstGeom prst="rect">
+            <a:avLst/>
+          </a:prstGeom>
+          <a:noFill/>
+        </p:spPr>
+        <p:txBody>
+          <a:bodyPr vert="horz" wrap="square" rtlCol="0">
+            <a:noAutofit/>
+          </a:bodyPr>
+          <a:lstStyle/>
+          <a:p>
+            <a:r>
+              <a:rPr lang="zh-CN" altLang="en-US" sz="1300" b="1">
+                <a:solidFill>
+                  <a:srgbClr val="505046"/>
+                </a:solidFill>
+                <a:latin typeface="Microsoft YaHei" panose="020B0503020204020204" pitchFamily="34" charset="-122"/>
+                <a:ea typeface="Microsoft YaHei" panose="020B0503020204020204" pitchFamily="34" charset="-122"/>
+              </a:rPr>
+              <a:t>服务</a:t>
+            </a:r>
+          </a:p>
+        </p:txBody>
+      </p:sp>
+      <p:sp>
+        <p:nvSpPr>
+          <p:cNvPr id="25" name="DIM_4_SYMPTOM">
+            <a:extLst>
+              <a:ext uri="{FF2B5EF4-FFF2-40B4-BE49-F238E27FC236}">
+                <a16:creationId xmlns:a16="http://schemas.microsoft.com/office/drawing/2014/main" id="{1E55DDB4-5471-4059-A76E-1E3931FD26D7}"/>
+              </a:ext>
+            </a:extLst>
+          </p:cNvPr>
+          <p:cNvSpPr txBox="1"/>
+          <p:nvPr/>
+        </p:nvSpPr>
+        <p:spPr>
+          <a:xfrm>
+            <a:off x="2971800" y="3776472"/>
+            <a:ext cx="2286000" cy="365760"/>
+          </a:xfrm>
+          <a:prstGeom prst="rect">
+            <a:avLst/>
+          </a:prstGeom>
+          <a:noFill/>
+        </p:spPr>
+        <p:txBody>
+          <a:bodyPr vert="horz" wrap="square" rtlCol="0">
+            <a:noAutofit/>
+          </a:bodyPr>
+          <a:lstStyle/>
+          <a:p>
+            <a:r>
+              <a:rPr lang="zh-CN" altLang="en-US" sz="1200">
+                <a:solidFill>
+                  <a:srgbClr val="505046"/>
+                </a:solidFill>
+                <a:latin typeface="Microsoft YaHei" panose="020B0503020204020204" pitchFamily="34" charset="-122"/>
+                <a:ea typeface="Microsoft YaHei" panose="020B0503020204020204" pitchFamily="34" charset="-122"/>
+              </a:rPr>
+              <a:t>售后没人接，口碑传不动</a:t>
+            </a:r>
+          </a:p>
+        </p:txBody>
+      </p:sp>
+      <p:sp>
+        <p:nvSpPr>
+          <p:cNvPr id="26" name="DIM_4_READ">
+            <a:extLst>
+              <a:ext uri="{FF2B5EF4-FFF2-40B4-BE49-F238E27FC236}">
+                <a16:creationId xmlns:a16="http://schemas.microsoft.com/office/drawing/2014/main" id="{BF0ACD3F-6E8F-7897-61E8-535224B727D3}"/>
+              </a:ext>
+            </a:extLst>
+          </p:cNvPr>
+          <p:cNvSpPr txBox="1"/>
+          <p:nvPr/>
+        </p:nvSpPr>
+        <p:spPr>
+          <a:xfrm>
+            <a:off x="5623560" y="3776472"/>
+            <a:ext cx="2286000" cy="365760"/>
+          </a:xfrm>
+          <a:prstGeom prst="rect">
+            <a:avLst/>
+          </a:prstGeom>
+          <a:noFill/>
+        </p:spPr>
+        <p:txBody>
+          <a:bodyPr vert="horz" wrap="square" rtlCol="0">
+            <a:noAutofit/>
+          </a:bodyPr>
+          <a:lstStyle/>
+          <a:p>
+            <a:r>
+              <a:rPr lang="zh-CN" altLang="en-US" sz="1200">
+                <a:solidFill>
+                  <a:srgbClr val="E84C22"/>
+                </a:solidFill>
+                <a:latin typeface="Microsoft YaHei" panose="020B0503020204020204" pitchFamily="34" charset="-122"/>
+                <a:ea typeface="Microsoft YaHei" panose="020B0503020204020204" pitchFamily="34" charset="-122"/>
+              </a:rPr>
+              <a:t>服务力弱，复购转介绍断</a:t>
+            </a:r>
+          </a:p>
+        </p:txBody>
+      </p:sp>
+      <p:sp>
+        <p:nvSpPr>
+          <p:cNvPr id="27" name="DIM_4_NEXT">
+            <a:extLst>
+              <a:ext uri="{FF2B5EF4-FFF2-40B4-BE49-F238E27FC236}">
+                <a16:creationId xmlns:a16="http://schemas.microsoft.com/office/drawing/2014/main" id="{13F77F47-7F7F-7F3D-0879-57CB8828DA43}"/>
+              </a:ext>
+            </a:extLst>
+          </p:cNvPr>
+          <p:cNvSpPr txBox="1"/>
+          <p:nvPr/>
+        </p:nvSpPr>
+        <p:spPr>
+          <a:xfrm>
+            <a:off x="8275320" y="3776472"/>
+            <a:ext cx="3200400" cy="365760"/>
+          </a:xfrm>
+          <a:prstGeom prst="rect">
+            <a:avLst/>
+          </a:prstGeom>
+          <a:noFill/>
+        </p:spPr>
+        <p:txBody>
+          <a:bodyPr vert="horz" wrap="square" rtlCol="0">
+            <a:noAutofit/>
+          </a:bodyPr>
+          <a:lstStyle/>
+          <a:p>
+            <a:r>
+              <a:rPr lang="zh-CN" altLang="en-US" sz="1200">
+                <a:solidFill>
+                  <a:srgbClr val="505046"/>
+                </a:solidFill>
+                <a:latin typeface="Microsoft YaHei" panose="020B0503020204020204" pitchFamily="34" charset="-122"/>
+                <a:ea typeface="Microsoft YaHei" panose="020B0503020204020204" pitchFamily="34" charset="-122"/>
+              </a:rPr>
+              <a:t>明确售后责任人，回访沉淀样板</a:t>
+            </a:r>
+          </a:p>
+        </p:txBody>
+      </p:sp>
+      <p:sp>
+        <p:nvSpPr>
+          <p:cNvPr id="28" name="DEBRIEF_CUE">
+            <a:extLst>
+              <a:ext uri="{FF2B5EF4-FFF2-40B4-BE49-F238E27FC236}">
+                <a16:creationId xmlns:a16="http://schemas.microsoft.com/office/drawing/2014/main" id="{5E3593CC-71F2-5069-F8CD-3033F35665F4}"/>
+              </a:ext>
+            </a:extLst>
+          </p:cNvPr>
+          <p:cNvSpPr txBox="1"/>
+          <p:nvPr/>
+        </p:nvSpPr>
+        <p:spPr>
+          <a:xfrm>
+            <a:off x="548640" y="4526280"/>
+            <a:ext cx="10789920" cy="369332"/>
+          </a:xfrm>
+          <a:prstGeom prst="rect">
+            <a:avLst/>
+          </a:prstGeom>
+          <a:noFill/>
+        </p:spPr>
+        <p:txBody>
+          <a:bodyPr vert="horz" wrap="square" rtlCol="0">
+            <a:noAutofit/>
+          </a:bodyPr>
+          <a:lstStyle/>
+          <a:p>
+            <a:r>
+              <a:rPr lang="zh-CN" altLang="en-US" sz="1300">
+                <a:solidFill>
+                  <a:srgbClr val="6F6F6A"/>
+                </a:solidFill>
+                <a:latin typeface="Microsoft YaHei" panose="020B0503020204020204" pitchFamily="34" charset="-122"/>
+                <a:ea typeface="Microsoft YaHei" panose="020B0503020204020204" pitchFamily="34" charset="-122"/>
+              </a:rPr>
+              <a:t>先看症状，由讲师逐行揭示解读与下一步；不一次性展开全部。</a:t>
+            </a:r>
+          </a:p>
+        </p:txBody>
+      </p:sp>
+      <p:sp>
+        <p:nvSpPr>
+          <p:cNvPr id="29" name="TEACHING_CUE">
+            <a:extLst>
+              <a:ext uri="{FF2B5EF4-FFF2-40B4-BE49-F238E27FC236}">
+                <a16:creationId xmlns:a16="http://schemas.microsoft.com/office/drawing/2014/main" id="{70A3A152-65AD-F455-6D9C-8821DC7F57F1}"/>
+              </a:ext>
+            </a:extLst>
+          </p:cNvPr>
+          <p:cNvSpPr txBox="1"/>
+          <p:nvPr/>
+        </p:nvSpPr>
+        <p:spPr>
+          <a:xfrm>
+            <a:off x="548640" y="4983480"/>
+            <a:ext cx="10789920" cy="365760"/>
+          </a:xfrm>
+          <a:prstGeom prst="rect">
+            <a:avLst/>
+          </a:prstGeom>
+          <a:noFill/>
+        </p:spPr>
+        <p:txBody>
+          <a:bodyPr vert="horz" wrap="square" rtlCol="0">
+            <a:noAutofit/>
+          </a:bodyPr>
+          <a:lstStyle/>
+          <a:p>
+            <a:r>
+              <a:rPr lang="zh-CN" altLang="en-US" sz="1200">
+                <a:solidFill>
+                  <a:srgbClr val="6F6F6A"/>
+                </a:solidFill>
+                <a:latin typeface="Microsoft YaHei" panose="020B0503020204020204" pitchFamily="34" charset="-122"/>
+                <a:ea typeface="Microsoft YaHei" panose="020B0503020204020204" pitchFamily="34" charset="-122"/>
+              </a:rPr>
+              <a:t>逐行点击</a:t>
+            </a:r>
+            <a:r>
+              <a:rPr lang="en-US" altLang="zh-CN" sz="1200">
+                <a:solidFill>
+                  <a:srgbClr val="6F6F6A"/>
+                </a:solidFill>
+                <a:latin typeface="Microsoft YaHei" panose="020B0503020204020204" pitchFamily="34" charset="-122"/>
+                <a:ea typeface="Microsoft YaHei" panose="020B0503020204020204" pitchFamily="34" charset="-122"/>
+              </a:rPr>
+              <a:t>/</a:t>
+            </a:r>
+            <a:r>
+              <a:rPr lang="zh-CN" altLang="en-US" sz="1200">
+                <a:solidFill>
+                  <a:srgbClr val="6F6F6A"/>
+                </a:solidFill>
+                <a:latin typeface="Microsoft YaHei" panose="020B0503020204020204" pitchFamily="34" charset="-122"/>
+                <a:ea typeface="Microsoft YaHei" panose="020B0503020204020204" pitchFamily="34" charset="-122"/>
+              </a:rPr>
+              <a:t>揭示：先让学员只看症状并猜解读，再揭示；可点击区控制在 </a:t>
+            </a:r>
+            <a:r>
+              <a:rPr lang="en-US" altLang="zh-CN" sz="1200">
+                <a:solidFill>
+                  <a:srgbClr val="6F6F6A"/>
+                </a:solidFill>
+                <a:latin typeface="Microsoft YaHei" panose="020B0503020204020204" pitchFamily="34" charset="-122"/>
+                <a:ea typeface="Microsoft YaHei" panose="020B0503020204020204" pitchFamily="34" charset="-122"/>
+              </a:rPr>
+              <a:t>4-6 </a:t>
+            </a:r>
+            <a:r>
+              <a:rPr lang="zh-CN" altLang="en-US" sz="1200">
+                <a:solidFill>
+                  <a:srgbClr val="6F6F6A"/>
+                </a:solidFill>
+                <a:latin typeface="Microsoft YaHei" panose="020B0503020204020204" pitchFamily="34" charset="-122"/>
+                <a:ea typeface="Microsoft YaHei" panose="020B0503020204020204" pitchFamily="34" charset="-122"/>
+              </a:rPr>
+              <a:t>个。</a:t>
+            </a:r>
+          </a:p>
+        </p:txBody>
+      </p:sp>
+    </p:spTree>
+    <p:extLst>
+      <p:ext uri="{BB962C8B-B14F-4D97-AF65-F5344CB8AC3E}">
+        <p14:creationId xmlns:p14="http://schemas.microsoft.com/office/powerpoint/2010/main" val="826178183"/>
       </p:ext>
     </p:extLst>
   </p:cSld>

</xml_diff>

<commit_message>
Add I6 group voting page (slide 14) via production line
Interactive family fourth source page: prompt + four equal choice rows with right-side vote tally boxes + method/debrief rules, 21 named objects, token colors. Fixed ASCII-rule violation (hard-coded Chinese in script - moved to JSON). Full pipeline: build-i6.ps1 -> verify -> preview component-14.png -> registry -> generator (index/catalog SHA B4243762) -> contact sheet -> promote -> slot contract + build contract synced.
</commit_message>
<xml_diff>
--- a/domains/yuhong/assets/components/yuhong-county-course-components-branded.pptx
+++ b/domains/yuhong/assets/components/yuhong-county-course-components-branded.pptx
@@ -5,7 +5,7 @@
     <p:sldMasterId id="2147483648" r:id="rId1"/>
   </p:sldMasterIdLst>
   <p:notesMasterIdLst>
-    <p:notesMasterId r:id="rId15"/>
+    <p:notesMasterId r:id="rId16"/>
   </p:notesMasterIdLst>
   <p:sldIdLst>
     <p:sldId id="256" r:id="rId2"/>
@@ -21,6 +21,7 @@
     <p:sldId id="266" r:id="rId12"/>
     <p:sldId id="267" r:id="rId13"/>
     <p:sldId id="268" r:id="rId14"/>
+    <p:sldId id="269" r:id="rId15"/>
   </p:sldIdLst>
   <p:sldSz cx="12192000" cy="6858000"/>
   <p:notesSz cx="6858000" cy="9144000"/>
@@ -8560,6 +8561,1095 @@
     <p:extLst>
       <p:ext uri="{BB962C8B-B14F-4D97-AF65-F5344CB8AC3E}">
         <p14:creationId xmlns:p14="http://schemas.microsoft.com/office/powerpoint/2010/main" val="826178183"/>
+      </p:ext>
+    </p:extLst>
+  </p:cSld>
+  <p:clrMapOvr>
+    <a:masterClrMapping/>
+  </p:clrMapOvr>
+</p:sld>
+</file>
+
+<file path=ppt/slides/slide14.xml><?xml version="1.0" encoding="utf-8"?>
+<p:sld xmlns:a="http://schemas.openxmlformats.org/drawingml/2006/main" xmlns:r="http://schemas.openxmlformats.org/officeDocument/2006/relationships" xmlns:p="http://schemas.openxmlformats.org/presentationml/2006/main">
+  <p:cSld>
+    <p:spTree>
+      <p:nvGrpSpPr>
+        <p:cNvPr id="1" name=""/>
+        <p:cNvGrpSpPr/>
+        <p:nvPr/>
+      </p:nvGrpSpPr>
+      <p:grpSpPr>
+        <a:xfrm>
+          <a:off x="0" y="0"/>
+          <a:ext cx="0" cy="0"/>
+          <a:chOff x="0" y="0"/>
+          <a:chExt cx="0" cy="0"/>
+        </a:xfrm>
+      </p:grpSpPr>
+      <p:sp>
+        <p:nvSpPr>
+          <p:cNvPr id="2" name="TITLE">
+            <a:extLst>
+              <a:ext uri="{FF2B5EF4-FFF2-40B4-BE49-F238E27FC236}">
+                <a16:creationId xmlns:a16="http://schemas.microsoft.com/office/drawing/2014/main" id="{F990E70C-BC50-D6B0-4451-BC91FBCAC01B}"/>
+              </a:ext>
+            </a:extLst>
+          </p:cNvPr>
+          <p:cNvSpPr txBox="1"/>
+          <p:nvPr/>
+        </p:nvSpPr>
+        <p:spPr>
+          <a:xfrm>
+            <a:off x="548640" y="384048"/>
+            <a:ext cx="10789920" cy="369332"/>
+          </a:xfrm>
+          <a:prstGeom prst="rect">
+            <a:avLst/>
+          </a:prstGeom>
+          <a:noFill/>
+        </p:spPr>
+        <p:txBody>
+          <a:bodyPr vert="horz" wrap="square" rtlCol="0">
+            <a:noAutofit/>
+          </a:bodyPr>
+          <a:lstStyle/>
+          <a:p>
+            <a:r>
+              <a:rPr lang="zh-CN" altLang="en-US" sz="2600" b="1">
+                <a:solidFill>
+                  <a:srgbClr val="505046"/>
+                </a:solidFill>
+                <a:latin typeface="Microsoft YaHei" panose="020B0503020204020204" pitchFamily="34" charset="-122"/>
+                <a:ea typeface="Microsoft YaHei" panose="020B0503020204020204" pitchFamily="34" charset="-122"/>
+              </a:rPr>
+              <a:t>把课堂判断摆上桌：下一场仗打哪？</a:t>
+            </a:r>
+          </a:p>
+        </p:txBody>
+      </p:sp>
+      <p:sp>
+        <p:nvSpPr>
+          <p:cNvPr id="3" name="VOTE_PROMPT">
+            <a:extLst>
+              <a:ext uri="{FF2B5EF4-FFF2-40B4-BE49-F238E27FC236}">
+                <a16:creationId xmlns:a16="http://schemas.microsoft.com/office/drawing/2014/main" id="{3E3C530E-670F-CA35-1A21-DDCB9828E218}"/>
+              </a:ext>
+            </a:extLst>
+          </p:cNvPr>
+          <p:cNvSpPr txBox="1"/>
+          <p:nvPr/>
+        </p:nvSpPr>
+        <p:spPr>
+          <a:xfrm>
+            <a:off x="548640" y="1097280"/>
+            <a:ext cx="10789920" cy="369332"/>
+          </a:xfrm>
+          <a:prstGeom prst="rect">
+            <a:avLst/>
+          </a:prstGeom>
+          <a:noFill/>
+        </p:spPr>
+        <p:txBody>
+          <a:bodyPr vert="horz" wrap="square" rtlCol="0">
+            <a:noAutofit/>
+          </a:bodyPr>
+          <a:lstStyle/>
+          <a:p>
+            <a:r>
+              <a:rPr lang="zh-CN" altLang="en-US" sz="1500" b="1">
+                <a:solidFill>
+                  <a:srgbClr val="E84C22"/>
+                </a:solidFill>
+                <a:latin typeface="Microsoft YaHei" panose="020B0503020204020204" pitchFamily="34" charset="-122"/>
+                <a:ea typeface="Microsoft YaHei" panose="020B0503020204020204" pitchFamily="34" charset="-122"/>
+              </a:rPr>
+              <a:t>每人一票，选一个主攻方向，并准备一条理由</a:t>
+            </a:r>
+          </a:p>
+        </p:txBody>
+      </p:sp>
+      <p:sp>
+        <p:nvSpPr>
+          <p:cNvPr id="4" name="CHOICE_BAND_1">
+            <a:extLst>
+              <a:ext uri="{FF2B5EF4-FFF2-40B4-BE49-F238E27FC236}">
+                <a16:creationId xmlns:a16="http://schemas.microsoft.com/office/drawing/2014/main" id="{796BE12F-8ABE-90BD-EB45-9EDCB844BD21}"/>
+              </a:ext>
+            </a:extLst>
+          </p:cNvPr>
+          <p:cNvSpPr/>
+          <p:nvPr/>
+        </p:nvSpPr>
+        <p:spPr>
+          <a:xfrm>
+            <a:off x="548640" y="1691640"/>
+            <a:ext cx="8686800" cy="502920"/>
+          </a:xfrm>
+          <a:prstGeom prst="rect">
+            <a:avLst/>
+          </a:prstGeom>
+          <a:solidFill>
+            <a:srgbClr val="F7F7F8"/>
+          </a:solidFill>
+          <a:ln w="9525">
+            <a:solidFill>
+              <a:srgbClr val="6F6F6A"/>
+            </a:solidFill>
+          </a:ln>
+        </p:spPr>
+        <p:style>
+          <a:lnRef idx="2">
+            <a:schemeClr val="accent1">
+              <a:shade val="15000"/>
+            </a:schemeClr>
+          </a:lnRef>
+          <a:fillRef idx="1">
+            <a:schemeClr val="accent1"/>
+          </a:fillRef>
+          <a:effectRef idx="0">
+            <a:schemeClr val="accent1"/>
+          </a:effectRef>
+          <a:fontRef idx="minor">
+            <a:schemeClr val="lt1"/>
+          </a:fontRef>
+        </p:style>
+        <p:txBody>
+          <a:bodyPr rtlCol="0" anchor="ctr"/>
+          <a:lstStyle/>
+          <a:p>
+            <a:pPr algn="ctr"/>
+            <a:endParaRPr lang="zh-CN" altLang="en-US"/>
+          </a:p>
+        </p:txBody>
+      </p:sp>
+      <p:sp>
+        <p:nvSpPr>
+          <p:cNvPr id="5" name="CHOICE_1_TEXT">
+            <a:extLst>
+              <a:ext uri="{FF2B5EF4-FFF2-40B4-BE49-F238E27FC236}">
+                <a16:creationId xmlns:a16="http://schemas.microsoft.com/office/drawing/2014/main" id="{E6C5E98F-756F-AEC3-119C-FC3A23A65B5C}"/>
+              </a:ext>
+            </a:extLst>
+          </p:cNvPr>
+          <p:cNvSpPr txBox="1"/>
+          <p:nvPr/>
+        </p:nvSpPr>
+        <p:spPr>
+          <a:xfrm>
+            <a:off x="822960" y="1691640"/>
+            <a:ext cx="8138160" cy="384048"/>
+          </a:xfrm>
+          <a:prstGeom prst="rect">
+            <a:avLst/>
+          </a:prstGeom>
+          <a:noFill/>
+        </p:spPr>
+        <p:txBody>
+          <a:bodyPr vert="horz" wrap="square" rtlCol="0">
+            <a:noAutofit/>
+          </a:bodyPr>
+          <a:lstStyle/>
+          <a:p>
+            <a:r>
+              <a:rPr lang="zh-CN" altLang="en-US" sz="1400">
+                <a:solidFill>
+                  <a:srgbClr val="505046"/>
+                </a:solidFill>
+                <a:latin typeface="Microsoft YaHei" panose="020B0503020204020204" pitchFamily="34" charset="-122"/>
+                <a:ea typeface="Microsoft YaHei" panose="020B0503020204020204" pitchFamily="34" charset="-122"/>
+              </a:rPr>
+              <a:t>攻项目：县城安置房、翻修与维修项目</a:t>
+            </a:r>
+          </a:p>
+        </p:txBody>
+      </p:sp>
+      <p:sp>
+        <p:nvSpPr>
+          <p:cNvPr id="6" name="VOTE_BOX_1">
+            <a:extLst>
+              <a:ext uri="{FF2B5EF4-FFF2-40B4-BE49-F238E27FC236}">
+                <a16:creationId xmlns:a16="http://schemas.microsoft.com/office/drawing/2014/main" id="{F6CCACDE-5FE3-E11E-DDF5-447EFF703623}"/>
+              </a:ext>
+            </a:extLst>
+          </p:cNvPr>
+          <p:cNvSpPr/>
+          <p:nvPr/>
+        </p:nvSpPr>
+        <p:spPr>
+          <a:xfrm>
+            <a:off x="9372600" y="1691640"/>
+            <a:ext cx="2240280" cy="502920"/>
+          </a:xfrm>
+          <a:prstGeom prst="rect">
+            <a:avLst/>
+          </a:prstGeom>
+          <a:solidFill>
+            <a:srgbClr val="FFFFFF"/>
+          </a:solidFill>
+          <a:ln w="9525">
+            <a:solidFill>
+              <a:srgbClr val="6F6F6A"/>
+            </a:solidFill>
+          </a:ln>
+        </p:spPr>
+        <p:style>
+          <a:lnRef idx="2">
+            <a:schemeClr val="accent1">
+              <a:shade val="15000"/>
+            </a:schemeClr>
+          </a:lnRef>
+          <a:fillRef idx="1">
+            <a:schemeClr val="accent1"/>
+          </a:fillRef>
+          <a:effectRef idx="0">
+            <a:schemeClr val="accent1"/>
+          </a:effectRef>
+          <a:fontRef idx="minor">
+            <a:schemeClr val="lt1"/>
+          </a:fontRef>
+        </p:style>
+        <p:txBody>
+          <a:bodyPr rtlCol="0" anchor="ctr"/>
+          <a:lstStyle/>
+          <a:p>
+            <a:pPr algn="ctr"/>
+            <a:endParaRPr lang="zh-CN" altLang="en-US"/>
+          </a:p>
+        </p:txBody>
+      </p:sp>
+      <p:sp>
+        <p:nvSpPr>
+          <p:cNvPr id="7" name="VOTE_1">
+            <a:extLst>
+              <a:ext uri="{FF2B5EF4-FFF2-40B4-BE49-F238E27FC236}">
+                <a16:creationId xmlns:a16="http://schemas.microsoft.com/office/drawing/2014/main" id="{64126B27-A665-6209-E97C-FAB29655429E}"/>
+              </a:ext>
+            </a:extLst>
+          </p:cNvPr>
+          <p:cNvSpPr txBox="1"/>
+          <p:nvPr/>
+        </p:nvSpPr>
+        <p:spPr>
+          <a:xfrm>
+            <a:off x="9509760" y="1691640"/>
+            <a:ext cx="1965960" cy="384048"/>
+          </a:xfrm>
+          <a:prstGeom prst="rect">
+            <a:avLst/>
+          </a:prstGeom>
+          <a:noFill/>
+        </p:spPr>
+        <p:txBody>
+          <a:bodyPr vert="horz" wrap="square" rtlCol="0">
+            <a:noAutofit/>
+          </a:bodyPr>
+          <a:lstStyle/>
+          <a:p>
+            <a:pPr algn="ctr"/>
+            <a:r>
+              <a:rPr lang="en-US" altLang="zh-CN" sz="1400" b="1">
+                <a:solidFill>
+                  <a:srgbClr val="E84C22"/>
+                </a:solidFill>
+                <a:latin typeface="Microsoft YaHei" panose="020B0503020204020204" pitchFamily="34" charset="-122"/>
+                <a:ea typeface="Microsoft YaHei" panose="020B0503020204020204" pitchFamily="34" charset="-122"/>
+              </a:rPr>
+              <a:t>____</a:t>
+            </a:r>
+            <a:r>
+              <a:rPr lang="zh-CN" altLang="en-US" sz="1400" b="1">
+                <a:solidFill>
+                  <a:srgbClr val="E84C22"/>
+                </a:solidFill>
+                <a:latin typeface="Microsoft YaHei" panose="020B0503020204020204" pitchFamily="34" charset="-122"/>
+                <a:ea typeface="Microsoft YaHei" panose="020B0503020204020204" pitchFamily="34" charset="-122"/>
+              </a:rPr>
+              <a:t>票</a:t>
+            </a:r>
+          </a:p>
+        </p:txBody>
+      </p:sp>
+      <p:sp>
+        <p:nvSpPr>
+          <p:cNvPr id="8" name="CHOICE_BAND_2">
+            <a:extLst>
+              <a:ext uri="{FF2B5EF4-FFF2-40B4-BE49-F238E27FC236}">
+                <a16:creationId xmlns:a16="http://schemas.microsoft.com/office/drawing/2014/main" id="{F91439FC-53EB-9BDC-354B-568118E25FD3}"/>
+              </a:ext>
+            </a:extLst>
+          </p:cNvPr>
+          <p:cNvSpPr/>
+          <p:nvPr/>
+        </p:nvSpPr>
+        <p:spPr>
+          <a:xfrm>
+            <a:off x="548640" y="2286000"/>
+            <a:ext cx="8686800" cy="502920"/>
+          </a:xfrm>
+          <a:prstGeom prst="rect">
+            <a:avLst/>
+          </a:prstGeom>
+          <a:solidFill>
+            <a:srgbClr val="EEECE1"/>
+          </a:solidFill>
+          <a:ln w="9525">
+            <a:solidFill>
+              <a:srgbClr val="6F6F6A"/>
+            </a:solidFill>
+          </a:ln>
+        </p:spPr>
+        <p:style>
+          <a:lnRef idx="2">
+            <a:schemeClr val="accent1">
+              <a:shade val="15000"/>
+            </a:schemeClr>
+          </a:lnRef>
+          <a:fillRef idx="1">
+            <a:schemeClr val="accent1"/>
+          </a:fillRef>
+          <a:effectRef idx="0">
+            <a:schemeClr val="accent1"/>
+          </a:effectRef>
+          <a:fontRef idx="minor">
+            <a:schemeClr val="lt1"/>
+          </a:fontRef>
+        </p:style>
+        <p:txBody>
+          <a:bodyPr rtlCol="0" anchor="ctr"/>
+          <a:lstStyle/>
+          <a:p>
+            <a:pPr algn="ctr"/>
+            <a:endParaRPr lang="zh-CN" altLang="en-US"/>
+          </a:p>
+        </p:txBody>
+      </p:sp>
+      <p:sp>
+        <p:nvSpPr>
+          <p:cNvPr id="9" name="CHOICE_2_TEXT">
+            <a:extLst>
+              <a:ext uri="{FF2B5EF4-FFF2-40B4-BE49-F238E27FC236}">
+                <a16:creationId xmlns:a16="http://schemas.microsoft.com/office/drawing/2014/main" id="{1591448B-FE89-0198-6322-225F9651CD5F}"/>
+              </a:ext>
+            </a:extLst>
+          </p:cNvPr>
+          <p:cNvSpPr txBox="1"/>
+          <p:nvPr/>
+        </p:nvSpPr>
+        <p:spPr>
+          <a:xfrm>
+            <a:off x="822960" y="2286000"/>
+            <a:ext cx="8138160" cy="384048"/>
+          </a:xfrm>
+          <a:prstGeom prst="rect">
+            <a:avLst/>
+          </a:prstGeom>
+          <a:noFill/>
+        </p:spPr>
+        <p:txBody>
+          <a:bodyPr vert="horz" wrap="square" rtlCol="0">
+            <a:noAutofit/>
+          </a:bodyPr>
+          <a:lstStyle/>
+          <a:p>
+            <a:r>
+              <a:rPr lang="zh-CN" altLang="en-US" sz="1400">
+                <a:solidFill>
+                  <a:srgbClr val="505046"/>
+                </a:solidFill>
+                <a:latin typeface="Microsoft YaHei" panose="020B0503020204020204" pitchFamily="34" charset="-122"/>
+                <a:ea typeface="Microsoft YaHei" panose="020B0503020204020204" pitchFamily="34" charset="-122"/>
+              </a:rPr>
+              <a:t>攻渠道：中心镇核心网点激活与补货</a:t>
+            </a:r>
+          </a:p>
+        </p:txBody>
+      </p:sp>
+      <p:sp>
+        <p:nvSpPr>
+          <p:cNvPr id="10" name="VOTE_BOX_2">
+            <a:extLst>
+              <a:ext uri="{FF2B5EF4-FFF2-40B4-BE49-F238E27FC236}">
+                <a16:creationId xmlns:a16="http://schemas.microsoft.com/office/drawing/2014/main" id="{C52F5C0A-DEA7-50B1-7CDB-6C73776F55DE}"/>
+              </a:ext>
+            </a:extLst>
+          </p:cNvPr>
+          <p:cNvSpPr/>
+          <p:nvPr/>
+        </p:nvSpPr>
+        <p:spPr>
+          <a:xfrm>
+            <a:off x="9372600" y="2286000"/>
+            <a:ext cx="2240280" cy="502920"/>
+          </a:xfrm>
+          <a:prstGeom prst="rect">
+            <a:avLst/>
+          </a:prstGeom>
+          <a:solidFill>
+            <a:srgbClr val="FFFFFF"/>
+          </a:solidFill>
+          <a:ln w="9525">
+            <a:solidFill>
+              <a:srgbClr val="6F6F6A"/>
+            </a:solidFill>
+          </a:ln>
+        </p:spPr>
+        <p:style>
+          <a:lnRef idx="2">
+            <a:schemeClr val="accent1">
+              <a:shade val="15000"/>
+            </a:schemeClr>
+          </a:lnRef>
+          <a:fillRef idx="1">
+            <a:schemeClr val="accent1"/>
+          </a:fillRef>
+          <a:effectRef idx="0">
+            <a:schemeClr val="accent1"/>
+          </a:effectRef>
+          <a:fontRef idx="minor">
+            <a:schemeClr val="lt1"/>
+          </a:fontRef>
+        </p:style>
+        <p:txBody>
+          <a:bodyPr rtlCol="0" anchor="ctr"/>
+          <a:lstStyle/>
+          <a:p>
+            <a:pPr algn="ctr"/>
+            <a:endParaRPr lang="zh-CN" altLang="en-US"/>
+          </a:p>
+        </p:txBody>
+      </p:sp>
+      <p:sp>
+        <p:nvSpPr>
+          <p:cNvPr id="11" name="VOTE_2">
+            <a:extLst>
+              <a:ext uri="{FF2B5EF4-FFF2-40B4-BE49-F238E27FC236}">
+                <a16:creationId xmlns:a16="http://schemas.microsoft.com/office/drawing/2014/main" id="{C4037AE1-4276-571E-9747-B1F3047399A9}"/>
+              </a:ext>
+            </a:extLst>
+          </p:cNvPr>
+          <p:cNvSpPr txBox="1"/>
+          <p:nvPr/>
+        </p:nvSpPr>
+        <p:spPr>
+          <a:xfrm>
+            <a:off x="9509760" y="2286000"/>
+            <a:ext cx="1965960" cy="384048"/>
+          </a:xfrm>
+          <a:prstGeom prst="rect">
+            <a:avLst/>
+          </a:prstGeom>
+          <a:noFill/>
+        </p:spPr>
+        <p:txBody>
+          <a:bodyPr vert="horz" wrap="square" rtlCol="0">
+            <a:noAutofit/>
+          </a:bodyPr>
+          <a:lstStyle/>
+          <a:p>
+            <a:pPr algn="ctr"/>
+            <a:r>
+              <a:rPr lang="en-US" altLang="zh-CN" sz="1400" b="1">
+                <a:solidFill>
+                  <a:srgbClr val="E84C22"/>
+                </a:solidFill>
+                <a:latin typeface="Microsoft YaHei" panose="020B0503020204020204" pitchFamily="34" charset="-122"/>
+                <a:ea typeface="Microsoft YaHei" panose="020B0503020204020204" pitchFamily="34" charset="-122"/>
+              </a:rPr>
+              <a:t>____</a:t>
+            </a:r>
+            <a:r>
+              <a:rPr lang="zh-CN" altLang="en-US" sz="1400" b="1">
+                <a:solidFill>
+                  <a:srgbClr val="E84C22"/>
+                </a:solidFill>
+                <a:latin typeface="Microsoft YaHei" panose="020B0503020204020204" pitchFamily="34" charset="-122"/>
+                <a:ea typeface="Microsoft YaHei" panose="020B0503020204020204" pitchFamily="34" charset="-122"/>
+              </a:rPr>
+              <a:t>票</a:t>
+            </a:r>
+          </a:p>
+        </p:txBody>
+      </p:sp>
+      <p:sp>
+        <p:nvSpPr>
+          <p:cNvPr id="12" name="CHOICE_BAND_3">
+            <a:extLst>
+              <a:ext uri="{FF2B5EF4-FFF2-40B4-BE49-F238E27FC236}">
+                <a16:creationId xmlns:a16="http://schemas.microsoft.com/office/drawing/2014/main" id="{C86E395B-56EB-5293-435E-BFDB49BD0F4B}"/>
+              </a:ext>
+            </a:extLst>
+          </p:cNvPr>
+          <p:cNvSpPr/>
+          <p:nvPr/>
+        </p:nvSpPr>
+        <p:spPr>
+          <a:xfrm>
+            <a:off x="548640" y="2880360"/>
+            <a:ext cx="8686800" cy="502920"/>
+          </a:xfrm>
+          <a:prstGeom prst="rect">
+            <a:avLst/>
+          </a:prstGeom>
+          <a:solidFill>
+            <a:srgbClr val="F7F7F8"/>
+          </a:solidFill>
+          <a:ln w="9525">
+            <a:solidFill>
+              <a:srgbClr val="6F6F6A"/>
+            </a:solidFill>
+          </a:ln>
+        </p:spPr>
+        <p:style>
+          <a:lnRef idx="2">
+            <a:schemeClr val="accent1">
+              <a:shade val="15000"/>
+            </a:schemeClr>
+          </a:lnRef>
+          <a:fillRef idx="1">
+            <a:schemeClr val="accent1"/>
+          </a:fillRef>
+          <a:effectRef idx="0">
+            <a:schemeClr val="accent1"/>
+          </a:effectRef>
+          <a:fontRef idx="minor">
+            <a:schemeClr val="lt1"/>
+          </a:fontRef>
+        </p:style>
+        <p:txBody>
+          <a:bodyPr rtlCol="0" anchor="ctr"/>
+          <a:lstStyle/>
+          <a:p>
+            <a:pPr algn="ctr"/>
+            <a:endParaRPr lang="zh-CN" altLang="en-US"/>
+          </a:p>
+        </p:txBody>
+      </p:sp>
+      <p:sp>
+        <p:nvSpPr>
+          <p:cNvPr id="13" name="CHOICE_3_TEXT">
+            <a:extLst>
+              <a:ext uri="{FF2B5EF4-FFF2-40B4-BE49-F238E27FC236}">
+                <a16:creationId xmlns:a16="http://schemas.microsoft.com/office/drawing/2014/main" id="{CD8F2984-D0B1-4E8A-3A60-E520B3BD7FC8}"/>
+              </a:ext>
+            </a:extLst>
+          </p:cNvPr>
+          <p:cNvSpPr txBox="1"/>
+          <p:nvPr/>
+        </p:nvSpPr>
+        <p:spPr>
+          <a:xfrm>
+            <a:off x="822960" y="2880360"/>
+            <a:ext cx="8138160" cy="384048"/>
+          </a:xfrm>
+          <a:prstGeom prst="rect">
+            <a:avLst/>
+          </a:prstGeom>
+          <a:noFill/>
+        </p:spPr>
+        <p:txBody>
+          <a:bodyPr vert="horz" wrap="square" rtlCol="0">
+            <a:noAutofit/>
+          </a:bodyPr>
+          <a:lstStyle/>
+          <a:p>
+            <a:r>
+              <a:rPr lang="zh-CN" altLang="en-US" sz="1400">
+                <a:solidFill>
+                  <a:srgbClr val="505046"/>
+                </a:solidFill>
+                <a:latin typeface="Microsoft YaHei" panose="020B0503020204020204" pitchFamily="34" charset="-122"/>
+                <a:ea typeface="Microsoft YaHei" panose="020B0503020204020204" pitchFamily="34" charset="-122"/>
+              </a:rPr>
+              <a:t>攻产品：主推品项铺开与动销</a:t>
+            </a:r>
+          </a:p>
+        </p:txBody>
+      </p:sp>
+      <p:sp>
+        <p:nvSpPr>
+          <p:cNvPr id="14" name="VOTE_BOX_3">
+            <a:extLst>
+              <a:ext uri="{FF2B5EF4-FFF2-40B4-BE49-F238E27FC236}">
+                <a16:creationId xmlns:a16="http://schemas.microsoft.com/office/drawing/2014/main" id="{4EBDDA66-1AB1-45A8-BD0E-103D9310632C}"/>
+              </a:ext>
+            </a:extLst>
+          </p:cNvPr>
+          <p:cNvSpPr/>
+          <p:nvPr/>
+        </p:nvSpPr>
+        <p:spPr>
+          <a:xfrm>
+            <a:off x="9372600" y="2880360"/>
+            <a:ext cx="2240280" cy="502920"/>
+          </a:xfrm>
+          <a:prstGeom prst="rect">
+            <a:avLst/>
+          </a:prstGeom>
+          <a:solidFill>
+            <a:srgbClr val="FFFFFF"/>
+          </a:solidFill>
+          <a:ln w="9525">
+            <a:solidFill>
+              <a:srgbClr val="6F6F6A"/>
+            </a:solidFill>
+          </a:ln>
+        </p:spPr>
+        <p:style>
+          <a:lnRef idx="2">
+            <a:schemeClr val="accent1">
+              <a:shade val="15000"/>
+            </a:schemeClr>
+          </a:lnRef>
+          <a:fillRef idx="1">
+            <a:schemeClr val="accent1"/>
+          </a:fillRef>
+          <a:effectRef idx="0">
+            <a:schemeClr val="accent1"/>
+          </a:effectRef>
+          <a:fontRef idx="minor">
+            <a:schemeClr val="lt1"/>
+          </a:fontRef>
+        </p:style>
+        <p:txBody>
+          <a:bodyPr rtlCol="0" anchor="ctr"/>
+          <a:lstStyle/>
+          <a:p>
+            <a:pPr algn="ctr"/>
+            <a:endParaRPr lang="zh-CN" altLang="en-US"/>
+          </a:p>
+        </p:txBody>
+      </p:sp>
+      <p:sp>
+        <p:nvSpPr>
+          <p:cNvPr id="15" name="VOTE_3">
+            <a:extLst>
+              <a:ext uri="{FF2B5EF4-FFF2-40B4-BE49-F238E27FC236}">
+                <a16:creationId xmlns:a16="http://schemas.microsoft.com/office/drawing/2014/main" id="{BAA9054B-7103-AE35-6D7A-9C8FE8670C87}"/>
+              </a:ext>
+            </a:extLst>
+          </p:cNvPr>
+          <p:cNvSpPr txBox="1"/>
+          <p:nvPr/>
+        </p:nvSpPr>
+        <p:spPr>
+          <a:xfrm>
+            <a:off x="9509760" y="2880360"/>
+            <a:ext cx="1965960" cy="384048"/>
+          </a:xfrm>
+          <a:prstGeom prst="rect">
+            <a:avLst/>
+          </a:prstGeom>
+          <a:noFill/>
+        </p:spPr>
+        <p:txBody>
+          <a:bodyPr vert="horz" wrap="square" rtlCol="0">
+            <a:noAutofit/>
+          </a:bodyPr>
+          <a:lstStyle/>
+          <a:p>
+            <a:pPr algn="ctr"/>
+            <a:r>
+              <a:rPr lang="en-US" altLang="zh-CN" sz="1400" b="1">
+                <a:solidFill>
+                  <a:srgbClr val="E84C22"/>
+                </a:solidFill>
+                <a:latin typeface="Microsoft YaHei" panose="020B0503020204020204" pitchFamily="34" charset="-122"/>
+                <a:ea typeface="Microsoft YaHei" panose="020B0503020204020204" pitchFamily="34" charset="-122"/>
+              </a:rPr>
+              <a:t>____</a:t>
+            </a:r>
+            <a:r>
+              <a:rPr lang="zh-CN" altLang="en-US" sz="1400" b="1">
+                <a:solidFill>
+                  <a:srgbClr val="E84C22"/>
+                </a:solidFill>
+                <a:latin typeface="Microsoft YaHei" panose="020B0503020204020204" pitchFamily="34" charset="-122"/>
+                <a:ea typeface="Microsoft YaHei" panose="020B0503020204020204" pitchFamily="34" charset="-122"/>
+              </a:rPr>
+              <a:t>票</a:t>
+            </a:r>
+          </a:p>
+        </p:txBody>
+      </p:sp>
+      <p:sp>
+        <p:nvSpPr>
+          <p:cNvPr id="16" name="CHOICE_BAND_4">
+            <a:extLst>
+              <a:ext uri="{FF2B5EF4-FFF2-40B4-BE49-F238E27FC236}">
+                <a16:creationId xmlns:a16="http://schemas.microsoft.com/office/drawing/2014/main" id="{61208555-AAA2-B972-924F-2AEA24B66741}"/>
+              </a:ext>
+            </a:extLst>
+          </p:cNvPr>
+          <p:cNvSpPr/>
+          <p:nvPr/>
+        </p:nvSpPr>
+        <p:spPr>
+          <a:xfrm>
+            <a:off x="548640" y="3474720"/>
+            <a:ext cx="8686800" cy="502920"/>
+          </a:xfrm>
+          <a:prstGeom prst="rect">
+            <a:avLst/>
+          </a:prstGeom>
+          <a:solidFill>
+            <a:srgbClr val="EEECE1"/>
+          </a:solidFill>
+          <a:ln w="9525">
+            <a:solidFill>
+              <a:srgbClr val="6F6F6A"/>
+            </a:solidFill>
+          </a:ln>
+        </p:spPr>
+        <p:style>
+          <a:lnRef idx="2">
+            <a:schemeClr val="accent1">
+              <a:shade val="15000"/>
+            </a:schemeClr>
+          </a:lnRef>
+          <a:fillRef idx="1">
+            <a:schemeClr val="accent1"/>
+          </a:fillRef>
+          <a:effectRef idx="0">
+            <a:schemeClr val="accent1"/>
+          </a:effectRef>
+          <a:fontRef idx="minor">
+            <a:schemeClr val="lt1"/>
+          </a:fontRef>
+        </p:style>
+        <p:txBody>
+          <a:bodyPr rtlCol="0" anchor="ctr"/>
+          <a:lstStyle/>
+          <a:p>
+            <a:pPr algn="ctr"/>
+            <a:endParaRPr lang="zh-CN" altLang="en-US"/>
+          </a:p>
+        </p:txBody>
+      </p:sp>
+      <p:sp>
+        <p:nvSpPr>
+          <p:cNvPr id="17" name="CHOICE_4_TEXT">
+            <a:extLst>
+              <a:ext uri="{FF2B5EF4-FFF2-40B4-BE49-F238E27FC236}">
+                <a16:creationId xmlns:a16="http://schemas.microsoft.com/office/drawing/2014/main" id="{9B6CCFF2-FB85-F796-ECED-314603B5718C}"/>
+              </a:ext>
+            </a:extLst>
+          </p:cNvPr>
+          <p:cNvSpPr txBox="1"/>
+          <p:nvPr/>
+        </p:nvSpPr>
+        <p:spPr>
+          <a:xfrm>
+            <a:off x="822960" y="3474720"/>
+            <a:ext cx="8138160" cy="384048"/>
+          </a:xfrm>
+          <a:prstGeom prst="rect">
+            <a:avLst/>
+          </a:prstGeom>
+          <a:noFill/>
+        </p:spPr>
+        <p:txBody>
+          <a:bodyPr vert="horz" wrap="square" rtlCol="0">
+            <a:noAutofit/>
+          </a:bodyPr>
+          <a:lstStyle/>
+          <a:p>
+            <a:r>
+              <a:rPr lang="zh-CN" altLang="en-US" sz="1400">
+                <a:solidFill>
+                  <a:srgbClr val="505046"/>
+                </a:solidFill>
+                <a:latin typeface="Microsoft YaHei" panose="020B0503020204020204" pitchFamily="34" charset="-122"/>
+                <a:ea typeface="Microsoft YaHei" panose="020B0503020204020204" pitchFamily="34" charset="-122"/>
+              </a:rPr>
+              <a:t>攻人脉：工人、包工头与关键人运营</a:t>
+            </a:r>
+          </a:p>
+        </p:txBody>
+      </p:sp>
+      <p:sp>
+        <p:nvSpPr>
+          <p:cNvPr id="18" name="VOTE_BOX_4">
+            <a:extLst>
+              <a:ext uri="{FF2B5EF4-FFF2-40B4-BE49-F238E27FC236}">
+                <a16:creationId xmlns:a16="http://schemas.microsoft.com/office/drawing/2014/main" id="{82E22AB2-6D8E-3821-36FB-33C0328E6A91}"/>
+              </a:ext>
+            </a:extLst>
+          </p:cNvPr>
+          <p:cNvSpPr/>
+          <p:nvPr/>
+        </p:nvSpPr>
+        <p:spPr>
+          <a:xfrm>
+            <a:off x="9372600" y="3474720"/>
+            <a:ext cx="2240280" cy="502920"/>
+          </a:xfrm>
+          <a:prstGeom prst="rect">
+            <a:avLst/>
+          </a:prstGeom>
+          <a:solidFill>
+            <a:srgbClr val="FFFFFF"/>
+          </a:solidFill>
+          <a:ln w="9525">
+            <a:solidFill>
+              <a:srgbClr val="6F6F6A"/>
+            </a:solidFill>
+          </a:ln>
+        </p:spPr>
+        <p:style>
+          <a:lnRef idx="2">
+            <a:schemeClr val="accent1">
+              <a:shade val="15000"/>
+            </a:schemeClr>
+          </a:lnRef>
+          <a:fillRef idx="1">
+            <a:schemeClr val="accent1"/>
+          </a:fillRef>
+          <a:effectRef idx="0">
+            <a:schemeClr val="accent1"/>
+          </a:effectRef>
+          <a:fontRef idx="minor">
+            <a:schemeClr val="lt1"/>
+          </a:fontRef>
+        </p:style>
+        <p:txBody>
+          <a:bodyPr rtlCol="0" anchor="ctr"/>
+          <a:lstStyle/>
+          <a:p>
+            <a:pPr algn="ctr"/>
+            <a:endParaRPr lang="zh-CN" altLang="en-US"/>
+          </a:p>
+        </p:txBody>
+      </p:sp>
+      <p:sp>
+        <p:nvSpPr>
+          <p:cNvPr id="19" name="VOTE_4">
+            <a:extLst>
+              <a:ext uri="{FF2B5EF4-FFF2-40B4-BE49-F238E27FC236}">
+                <a16:creationId xmlns:a16="http://schemas.microsoft.com/office/drawing/2014/main" id="{EFC9BE45-6508-5BFD-ABD9-FD717D44C52E}"/>
+              </a:ext>
+            </a:extLst>
+          </p:cNvPr>
+          <p:cNvSpPr txBox="1"/>
+          <p:nvPr/>
+        </p:nvSpPr>
+        <p:spPr>
+          <a:xfrm>
+            <a:off x="9509760" y="3474720"/>
+            <a:ext cx="1965960" cy="384048"/>
+          </a:xfrm>
+          <a:prstGeom prst="rect">
+            <a:avLst/>
+          </a:prstGeom>
+          <a:noFill/>
+        </p:spPr>
+        <p:txBody>
+          <a:bodyPr vert="horz" wrap="square" rtlCol="0">
+            <a:noAutofit/>
+          </a:bodyPr>
+          <a:lstStyle/>
+          <a:p>
+            <a:pPr algn="ctr"/>
+            <a:r>
+              <a:rPr lang="en-US" altLang="zh-CN" sz="1400" b="1">
+                <a:solidFill>
+                  <a:srgbClr val="E84C22"/>
+                </a:solidFill>
+                <a:latin typeface="Microsoft YaHei" panose="020B0503020204020204" pitchFamily="34" charset="-122"/>
+                <a:ea typeface="Microsoft YaHei" panose="020B0503020204020204" pitchFamily="34" charset="-122"/>
+              </a:rPr>
+              <a:t>____</a:t>
+            </a:r>
+            <a:r>
+              <a:rPr lang="zh-CN" altLang="en-US" sz="1400" b="1">
+                <a:solidFill>
+                  <a:srgbClr val="E84C22"/>
+                </a:solidFill>
+                <a:latin typeface="Microsoft YaHei" panose="020B0503020204020204" pitchFamily="34" charset="-122"/>
+                <a:ea typeface="Microsoft YaHei" panose="020B0503020204020204" pitchFamily="34" charset="-122"/>
+              </a:rPr>
+              <a:t>票</a:t>
+            </a:r>
+          </a:p>
+        </p:txBody>
+      </p:sp>
+      <p:sp>
+        <p:nvSpPr>
+          <p:cNvPr id="20" name="METHOD_CUE">
+            <a:extLst>
+              <a:ext uri="{FF2B5EF4-FFF2-40B4-BE49-F238E27FC236}">
+                <a16:creationId xmlns:a16="http://schemas.microsoft.com/office/drawing/2014/main" id="{BA019673-F137-3BDD-09B0-497689C9B4C7}"/>
+              </a:ext>
+            </a:extLst>
+          </p:cNvPr>
+          <p:cNvSpPr txBox="1"/>
+          <p:nvPr/>
+        </p:nvSpPr>
+        <p:spPr>
+          <a:xfrm>
+            <a:off x="548640" y="4251960"/>
+            <a:ext cx="10789920" cy="369332"/>
+          </a:xfrm>
+          <a:prstGeom prst="rect">
+            <a:avLst/>
+          </a:prstGeom>
+          <a:noFill/>
+        </p:spPr>
+        <p:txBody>
+          <a:bodyPr vert="horz" wrap="square" rtlCol="0">
+            <a:noAutofit/>
+          </a:bodyPr>
+          <a:lstStyle/>
+          <a:p>
+            <a:r>
+              <a:rPr lang="zh-CN" altLang="en-US" sz="1300">
+                <a:solidFill>
+                  <a:srgbClr val="6F6F6A"/>
+                </a:solidFill>
+                <a:latin typeface="Microsoft YaHei" panose="020B0503020204020204" pitchFamily="34" charset="-122"/>
+                <a:ea typeface="Microsoft YaHei" panose="020B0503020204020204" pitchFamily="34" charset="-122"/>
+              </a:rPr>
+              <a:t>投票方式：举手或纸票；票数填在右侧。</a:t>
+            </a:r>
+          </a:p>
+        </p:txBody>
+      </p:sp>
+      <p:sp>
+        <p:nvSpPr>
+          <p:cNvPr id="21" name="DEBRIEF_CUE">
+            <a:extLst>
+              <a:ext uri="{FF2B5EF4-FFF2-40B4-BE49-F238E27FC236}">
+                <a16:creationId xmlns:a16="http://schemas.microsoft.com/office/drawing/2014/main" id="{5D329E22-5E33-48B9-3689-57569BB1EC1A}"/>
+              </a:ext>
+            </a:extLst>
+          </p:cNvPr>
+          <p:cNvSpPr txBox="1"/>
+          <p:nvPr/>
+        </p:nvSpPr>
+        <p:spPr>
+          <a:xfrm>
+            <a:off x="548640" y="4709160"/>
+            <a:ext cx="10789920" cy="369332"/>
+          </a:xfrm>
+          <a:prstGeom prst="rect">
+            <a:avLst/>
+          </a:prstGeom>
+          <a:noFill/>
+        </p:spPr>
+        <p:txBody>
+          <a:bodyPr vert="horz" wrap="square" rtlCol="0">
+            <a:noAutofit/>
+          </a:bodyPr>
+          <a:lstStyle/>
+          <a:p>
+            <a:r>
+              <a:rPr lang="zh-CN" altLang="en-US" sz="1300">
+                <a:solidFill>
+                  <a:srgbClr val="6F6F6A"/>
+                </a:solidFill>
+                <a:latin typeface="Microsoft YaHei" panose="020B0503020204020204" pitchFamily="34" charset="-122"/>
+                <a:ea typeface="Microsoft YaHei" panose="020B0503020204020204" pitchFamily="34" charset="-122"/>
+              </a:rPr>
+              <a:t>先听少数派理由，再定主战役与备选；票数不替代最终经营判断。</a:t>
+            </a:r>
+          </a:p>
+        </p:txBody>
+      </p:sp>
+      <p:sp>
+        <p:nvSpPr>
+          <p:cNvPr id="22" name="TEACHING_CUE">
+            <a:extLst>
+              <a:ext uri="{FF2B5EF4-FFF2-40B4-BE49-F238E27FC236}">
+                <a16:creationId xmlns:a16="http://schemas.microsoft.com/office/drawing/2014/main" id="{11D56D87-0939-4658-A469-1E6605AEB2C5}"/>
+              </a:ext>
+            </a:extLst>
+          </p:cNvPr>
+          <p:cNvSpPr txBox="1"/>
+          <p:nvPr/>
+        </p:nvSpPr>
+        <p:spPr>
+          <a:xfrm>
+            <a:off x="548640" y="5166360"/>
+            <a:ext cx="10789920" cy="365760"/>
+          </a:xfrm>
+          <a:prstGeom prst="rect">
+            <a:avLst/>
+          </a:prstGeom>
+          <a:noFill/>
+        </p:spPr>
+        <p:txBody>
+          <a:bodyPr vert="horz" wrap="square" rtlCol="0">
+            <a:noAutofit/>
+          </a:bodyPr>
+          <a:lstStyle/>
+          <a:p>
+            <a:r>
+              <a:rPr lang="en-US" altLang="zh-CN" sz="1200">
+                <a:solidFill>
+                  <a:srgbClr val="6F6F6A"/>
+                </a:solidFill>
+                <a:latin typeface="Microsoft YaHei" panose="020B0503020204020204" pitchFamily="34" charset="-122"/>
+                <a:ea typeface="Microsoft YaHei" panose="020B0503020204020204" pitchFamily="34" charset="-122"/>
+              </a:rPr>
+              <a:t>PPT </a:t>
+            </a:r>
+            <a:r>
+              <a:rPr lang="zh-CN" altLang="en-US" sz="1200">
+                <a:solidFill>
+                  <a:srgbClr val="6F6F6A"/>
+                </a:solidFill>
+                <a:latin typeface="Microsoft YaHei" panose="020B0503020204020204" pitchFamily="34" charset="-122"/>
+                <a:ea typeface="Microsoft YaHei" panose="020B0503020204020204" pitchFamily="34" charset="-122"/>
+              </a:rPr>
+              <a:t>不自动计票：用举手</a:t>
+            </a:r>
+            <a:r>
+              <a:rPr lang="en-US" altLang="zh-CN" sz="1200">
+                <a:solidFill>
+                  <a:srgbClr val="6F6F6A"/>
+                </a:solidFill>
+                <a:latin typeface="Microsoft YaHei" panose="020B0503020204020204" pitchFamily="34" charset="-122"/>
+                <a:ea typeface="Microsoft YaHei" panose="020B0503020204020204" pitchFamily="34" charset="-122"/>
+              </a:rPr>
+              <a:t>/</a:t>
+            </a:r>
+            <a:r>
+              <a:rPr lang="zh-CN" altLang="en-US" sz="1200">
+                <a:solidFill>
+                  <a:srgbClr val="6F6F6A"/>
+                </a:solidFill>
+                <a:latin typeface="Microsoft YaHei" panose="020B0503020204020204" pitchFamily="34" charset="-122"/>
+                <a:ea typeface="Microsoft YaHei" panose="020B0503020204020204" pitchFamily="34" charset="-122"/>
+              </a:rPr>
+              <a:t>纸票</a:t>
+            </a:r>
+            <a:r>
+              <a:rPr lang="en-US" altLang="zh-CN" sz="1200">
+                <a:solidFill>
+                  <a:srgbClr val="6F6F6A"/>
+                </a:solidFill>
+                <a:latin typeface="Microsoft YaHei" panose="020B0503020204020204" pitchFamily="34" charset="-122"/>
+                <a:ea typeface="Microsoft YaHei" panose="020B0503020204020204" pitchFamily="34" charset="-122"/>
+              </a:rPr>
+              <a:t>/</a:t>
+            </a:r>
+            <a:r>
+              <a:rPr lang="zh-CN" altLang="en-US" sz="1200">
+                <a:solidFill>
+                  <a:srgbClr val="6F6F6A"/>
+                </a:solidFill>
+                <a:latin typeface="Microsoft YaHei" panose="020B0503020204020204" pitchFamily="34" charset="-122"/>
+                <a:ea typeface="Microsoft YaHei" panose="020B0503020204020204" pitchFamily="34" charset="-122"/>
+              </a:rPr>
+              <a:t>表单；记录少数意见；投票后进入方法讲解。</a:t>
+            </a:r>
+          </a:p>
+        </p:txBody>
+      </p:sp>
+    </p:spTree>
+    <p:extLst>
+      <p:ext uri="{BB962C8B-B14F-4D97-AF65-F5344CB8AC3E}">
+        <p14:creationId xmlns:p14="http://schemas.microsoft.com/office/powerpoint/2010/main" val="2143700867"/>
       </p:ext>
     </p:extLst>
   </p:cSld>

</xml_diff>

<commit_message>
Fix color system on new components: deep red text (B22600), white light fills
User review caught two issues: E84C22 (orange-red accent) was used for all text labels, but ppt-design-spec layer 2 requires deep red B22600 for small text/badges; EEECE1 cream alternating fills read as yellow. Fixed slides 8-14 in the official deck (E84C22->B22600, EEECE1->FFFFFF), updated all 6 build scripts' token definitions, re-rendered previews, regenerated catalog/sheets (SHA 93280BD4), synced slots and contract.
</commit_message>
<xml_diff>
--- a/domains/yuhong/assets/components/yuhong-county-course-components-branded.pptx
+++ b/domains/yuhong/assets/components/yuhong-county-course-components-branded.pptx
@@ -2707,7 +2707,7 @@
             <a:r>
               <a:rPr lang="zh-CN" altLang="en-US" sz="1500" b="1">
                 <a:solidFill>
-                  <a:srgbClr val="E84C22"/>
+                  <a:srgbClr val="B22600"/>
                 </a:solidFill>
                 <a:latin typeface="Microsoft YaHei" panose="020B0503020204020204" pitchFamily="34" charset="-122"/>
                 <a:ea typeface="Microsoft YaHei" panose="020B0503020204020204" pitchFamily="34" charset="-122"/>
@@ -2914,7 +2914,7 @@
             <a:avLst/>
           </a:prstGeom>
           <a:solidFill>
-            <a:srgbClr val="EEECE1"/>
+            <a:srgbClr val="FFFFFF"/>
           </a:solidFill>
           <a:ln w="9525">
             <a:solidFill>
@@ -3236,7 +3236,7 @@
             <a:r>
               <a:rPr lang="zh-CN" altLang="en-US" sz="1500" b="1">
                 <a:solidFill>
-                  <a:srgbClr val="E84C22"/>
+                  <a:srgbClr val="B22600"/>
                 </a:solidFill>
                 <a:latin typeface="Microsoft YaHei" panose="020B0503020204020204" pitchFamily="34" charset="-122"/>
                 <a:ea typeface="Microsoft YaHei" panose="020B0503020204020204" pitchFamily="34" charset="-122"/>
@@ -3246,7 +3246,7 @@
             <a:r>
               <a:rPr lang="en-US" altLang="zh-CN" sz="1500" b="1">
                 <a:solidFill>
-                  <a:srgbClr val="E84C22"/>
+                  <a:srgbClr val="B22600"/>
                 </a:solidFill>
                 <a:latin typeface="Microsoft YaHei" panose="020B0503020204020204" pitchFamily="34" charset="-122"/>
                 <a:ea typeface="Microsoft YaHei" panose="020B0503020204020204" pitchFamily="34" charset="-122"/>
@@ -3256,7 +3256,7 @@
             <a:r>
               <a:rPr lang="zh-CN" altLang="en-US" sz="1500" b="1">
                 <a:solidFill>
-                  <a:srgbClr val="E84C22"/>
+                  <a:srgbClr val="B22600"/>
                 </a:solidFill>
                 <a:latin typeface="Microsoft YaHei" panose="020B0503020204020204" pitchFamily="34" charset="-122"/>
                 <a:ea typeface="Microsoft YaHei" panose="020B0503020204020204" pitchFamily="34" charset="-122"/>
@@ -3351,7 +3351,7 @@
             <a:r>
               <a:rPr lang="zh-CN" altLang="en-US" sz="1300" b="1">
                 <a:solidFill>
-                  <a:srgbClr val="E84C22"/>
+                  <a:srgbClr val="B22600"/>
                 </a:solidFill>
                 <a:latin typeface="Microsoft YaHei" panose="020B0503020204020204" pitchFamily="34" charset="-122"/>
                 <a:ea typeface="Microsoft YaHei" panose="020B0503020204020204" pitchFamily="34" charset="-122"/>
@@ -3491,7 +3491,7 @@
             <a:avLst/>
           </a:prstGeom>
           <a:solidFill>
-            <a:srgbClr val="EEECE1"/>
+            <a:srgbClr val="FFFFFF"/>
           </a:solidFill>
           <a:ln w="9525">
             <a:solidFill>
@@ -3555,7 +3555,7 @@
             <a:r>
               <a:rPr lang="zh-CN" altLang="en-US" sz="1300" b="1">
                 <a:solidFill>
-                  <a:srgbClr val="E84C22"/>
+                  <a:srgbClr val="B22600"/>
                 </a:solidFill>
                 <a:latin typeface="Microsoft YaHei" panose="020B0503020204020204" pitchFamily="34" charset="-122"/>
                 <a:ea typeface="Microsoft YaHei" panose="020B0503020204020204" pitchFamily="34" charset="-122"/>
@@ -3759,7 +3759,7 @@
             <a:r>
               <a:rPr lang="zh-CN" altLang="en-US" sz="1300" b="1">
                 <a:solidFill>
-                  <a:srgbClr val="E84C22"/>
+                  <a:srgbClr val="B22600"/>
                 </a:solidFill>
                 <a:latin typeface="Microsoft YaHei" panose="020B0503020204020204" pitchFamily="34" charset="-122"/>
                 <a:ea typeface="Microsoft YaHei" panose="020B0503020204020204" pitchFamily="34" charset="-122"/>
@@ -3899,7 +3899,7 @@
             <a:avLst/>
           </a:prstGeom>
           <a:solidFill>
-            <a:srgbClr val="EEECE1"/>
+            <a:srgbClr val="FFFFFF"/>
           </a:solidFill>
           <a:ln w="9525">
             <a:solidFill>
@@ -3963,7 +3963,7 @@
             <a:r>
               <a:rPr lang="zh-CN" altLang="en-US" sz="1300" b="1">
                 <a:solidFill>
-                  <a:srgbClr val="E84C22"/>
+                  <a:srgbClr val="B22600"/>
                 </a:solidFill>
                 <a:latin typeface="Microsoft YaHei" panose="020B0503020204020204" pitchFamily="34" charset="-122"/>
                 <a:ea typeface="Microsoft YaHei" panose="020B0503020204020204" pitchFamily="34" charset="-122"/>
@@ -4911,7 +4911,7 @@
             <a:r>
               <a:rPr lang="zh-CN" altLang="en-US" sz="1500" b="1">
                 <a:solidFill>
-                  <a:srgbClr val="E84C22"/>
+                  <a:srgbClr val="B22600"/>
                 </a:solidFill>
                 <a:latin typeface="Microsoft YaHei" panose="020B0503020204020204" pitchFamily="34" charset="-122"/>
                 <a:ea typeface="Microsoft YaHei" panose="020B0503020204020204" pitchFamily="34" charset="-122"/>
@@ -4921,7 +4921,7 @@
             <a:r>
               <a:rPr lang="en-US" altLang="zh-CN" sz="1500" b="1">
                 <a:solidFill>
-                  <a:srgbClr val="E84C22"/>
+                  <a:srgbClr val="B22600"/>
                 </a:solidFill>
                 <a:latin typeface="Microsoft YaHei" panose="020B0503020204020204" pitchFamily="34" charset="-122"/>
                 <a:ea typeface="Microsoft YaHei" panose="020B0503020204020204" pitchFamily="34" charset="-122"/>
@@ -4931,7 +4931,7 @@
             <a:r>
               <a:rPr lang="zh-CN" altLang="en-US" sz="1500" b="1">
                 <a:solidFill>
-                  <a:srgbClr val="E84C22"/>
+                  <a:srgbClr val="B22600"/>
                 </a:solidFill>
                 <a:latin typeface="Microsoft YaHei" panose="020B0503020204020204" pitchFamily="34" charset="-122"/>
                 <a:ea typeface="Microsoft YaHei" panose="020B0503020204020204" pitchFamily="34" charset="-122"/>
@@ -5095,7 +5095,7 @@
             <a:r>
               <a:rPr lang="en-US" altLang="zh-CN" sz="2000" b="1">
                 <a:solidFill>
-                  <a:srgbClr val="E84C22"/>
+                  <a:srgbClr val="B22600"/>
                 </a:solidFill>
                 <a:latin typeface="Microsoft YaHei" panose="020B0503020204020204" pitchFamily="34" charset="-122"/>
                 <a:ea typeface="Microsoft YaHei" panose="020B0503020204020204" pitchFamily="34" charset="-122"/>
@@ -5104,7 +5104,7 @@
             </a:r>
             <a:endParaRPr lang="zh-CN" altLang="en-US" sz="2000" b="1">
               <a:solidFill>
-                <a:srgbClr val="E84C22"/>
+                <a:srgbClr val="B22600"/>
               </a:solidFill>
               <a:latin typeface="Microsoft YaHei" panose="020B0503020204020204" pitchFamily="34" charset="-122"/>
               <a:ea typeface="Microsoft YaHei" panose="020B0503020204020204" pitchFamily="34" charset="-122"/>
@@ -5133,7 +5133,7 @@
             <a:avLst/>
           </a:prstGeom>
           <a:solidFill>
-            <a:srgbClr val="EEECE1"/>
+            <a:srgbClr val="FFFFFF"/>
           </a:solidFill>
           <a:ln w="9525">
             <a:solidFill>
@@ -5197,7 +5197,7 @@
             <a:r>
               <a:rPr lang="zh-CN" altLang="en-US" sz="1500" b="1">
                 <a:solidFill>
-                  <a:srgbClr val="E84C22"/>
+                  <a:srgbClr val="B22600"/>
                 </a:solidFill>
                 <a:latin typeface="Microsoft YaHei" panose="020B0503020204020204" pitchFamily="34" charset="-122"/>
                 <a:ea typeface="Microsoft YaHei" panose="020B0503020204020204" pitchFamily="34" charset="-122"/>
@@ -5207,7 +5207,7 @@
             <a:r>
               <a:rPr lang="en-US" altLang="zh-CN" sz="1500" b="1">
                 <a:solidFill>
-                  <a:srgbClr val="E84C22"/>
+                  <a:srgbClr val="B22600"/>
                 </a:solidFill>
                 <a:latin typeface="Microsoft YaHei" panose="020B0503020204020204" pitchFamily="34" charset="-122"/>
                 <a:ea typeface="Microsoft YaHei" panose="020B0503020204020204" pitchFamily="34" charset="-122"/>
@@ -5217,7 +5217,7 @@
             <a:r>
               <a:rPr lang="zh-CN" altLang="en-US" sz="1500" b="1">
                 <a:solidFill>
-                  <a:srgbClr val="E84C22"/>
+                  <a:srgbClr val="B22600"/>
                 </a:solidFill>
                 <a:latin typeface="Microsoft YaHei" panose="020B0503020204020204" pitchFamily="34" charset="-122"/>
                 <a:ea typeface="Microsoft YaHei" panose="020B0503020204020204" pitchFamily="34" charset="-122"/>
@@ -5381,7 +5381,7 @@
             <a:r>
               <a:rPr lang="en-US" altLang="zh-CN" sz="2000" b="1">
                 <a:solidFill>
-                  <a:srgbClr val="E84C22"/>
+                  <a:srgbClr val="B22600"/>
                 </a:solidFill>
                 <a:latin typeface="Microsoft YaHei" panose="020B0503020204020204" pitchFamily="34" charset="-122"/>
                 <a:ea typeface="Microsoft YaHei" panose="020B0503020204020204" pitchFamily="34" charset="-122"/>
@@ -5390,7 +5390,7 @@
             </a:r>
             <a:endParaRPr lang="zh-CN" altLang="en-US" sz="2000" b="1">
               <a:solidFill>
-                <a:srgbClr val="E84C22"/>
+                <a:srgbClr val="B22600"/>
               </a:solidFill>
               <a:latin typeface="Microsoft YaHei" panose="020B0503020204020204" pitchFamily="34" charset="-122"/>
               <a:ea typeface="Microsoft YaHei" panose="020B0503020204020204" pitchFamily="34" charset="-122"/>
@@ -5483,7 +5483,7 @@
             <a:r>
               <a:rPr lang="zh-CN" altLang="en-US" sz="1500" b="1">
                 <a:solidFill>
-                  <a:srgbClr val="E84C22"/>
+                  <a:srgbClr val="B22600"/>
                 </a:solidFill>
                 <a:latin typeface="Microsoft YaHei" panose="020B0503020204020204" pitchFamily="34" charset="-122"/>
                 <a:ea typeface="Microsoft YaHei" panose="020B0503020204020204" pitchFamily="34" charset="-122"/>
@@ -5493,7 +5493,7 @@
             <a:r>
               <a:rPr lang="en-US" altLang="zh-CN" sz="1500" b="1">
                 <a:solidFill>
-                  <a:srgbClr val="E84C22"/>
+                  <a:srgbClr val="B22600"/>
                 </a:solidFill>
                 <a:latin typeface="Microsoft YaHei" panose="020B0503020204020204" pitchFamily="34" charset="-122"/>
                 <a:ea typeface="Microsoft YaHei" panose="020B0503020204020204" pitchFamily="34" charset="-122"/>
@@ -5503,7 +5503,7 @@
             <a:r>
               <a:rPr lang="zh-CN" altLang="en-US" sz="1500" b="1">
                 <a:solidFill>
-                  <a:srgbClr val="E84C22"/>
+                  <a:srgbClr val="B22600"/>
                 </a:solidFill>
                 <a:latin typeface="Microsoft YaHei" panose="020B0503020204020204" pitchFamily="34" charset="-122"/>
                 <a:ea typeface="Microsoft YaHei" panose="020B0503020204020204" pitchFamily="34" charset="-122"/>
@@ -5862,7 +5862,7 @@
             <a:r>
               <a:rPr lang="zh-CN" altLang="en-US" sz="1500" b="1">
                 <a:solidFill>
-                  <a:srgbClr val="E84C22"/>
+                  <a:srgbClr val="B22600"/>
                 </a:solidFill>
                 <a:latin typeface="Microsoft YaHei" panose="020B0503020204020204" pitchFamily="34" charset="-122"/>
                 <a:ea typeface="Microsoft YaHei" panose="020B0503020204020204" pitchFamily="34" charset="-122"/>
@@ -5957,7 +5957,7 @@
             <a:r>
               <a:rPr lang="zh-CN" altLang="en-US" sz="1300" b="1">
                 <a:solidFill>
-                  <a:srgbClr val="E84C22"/>
+                  <a:srgbClr val="B22600"/>
                 </a:solidFill>
                 <a:latin typeface="Microsoft YaHei" panose="020B0503020204020204" pitchFamily="34" charset="-122"/>
                 <a:ea typeface="Microsoft YaHei" panose="020B0503020204020204" pitchFamily="34" charset="-122"/>
@@ -6029,7 +6029,7 @@
             <a:avLst/>
           </a:prstGeom>
           <a:solidFill>
-            <a:srgbClr val="EEECE1"/>
+            <a:srgbClr val="FFFFFF"/>
           </a:solidFill>
           <a:ln w="9525">
             <a:solidFill>
@@ -6093,7 +6093,7 @@
             <a:r>
               <a:rPr lang="zh-CN" altLang="en-US" sz="1300" b="1">
                 <a:solidFill>
-                  <a:srgbClr val="E84C22"/>
+                  <a:srgbClr val="B22600"/>
                 </a:solidFill>
                 <a:latin typeface="Microsoft YaHei" panose="020B0503020204020204" pitchFamily="34" charset="-122"/>
                 <a:ea typeface="Microsoft YaHei" panose="020B0503020204020204" pitchFamily="34" charset="-122"/>
@@ -6229,7 +6229,7 @@
             <a:r>
               <a:rPr lang="zh-CN" altLang="en-US" sz="1300" b="1">
                 <a:solidFill>
-                  <a:srgbClr val="E84C22"/>
+                  <a:srgbClr val="B22600"/>
                 </a:solidFill>
                 <a:latin typeface="Microsoft YaHei" panose="020B0503020204020204" pitchFamily="34" charset="-122"/>
                 <a:ea typeface="Microsoft YaHei" panose="020B0503020204020204" pitchFamily="34" charset="-122"/>
@@ -6301,7 +6301,7 @@
             <a:avLst/>
           </a:prstGeom>
           <a:solidFill>
-            <a:srgbClr val="EEECE1"/>
+            <a:srgbClr val="FFFFFF"/>
           </a:solidFill>
           <a:ln w="9525">
             <a:solidFill>
@@ -6365,7 +6365,7 @@
             <a:r>
               <a:rPr lang="zh-CN" altLang="en-US" sz="1300" b="1">
                 <a:solidFill>
-                  <a:srgbClr val="E84C22"/>
+                  <a:srgbClr val="B22600"/>
                 </a:solidFill>
                 <a:latin typeface="Microsoft YaHei" panose="020B0503020204020204" pitchFamily="34" charset="-122"/>
                 <a:ea typeface="Microsoft YaHei" panose="020B0503020204020204" pitchFamily="34" charset="-122"/>
@@ -6613,7 +6613,7 @@
             <a:r>
               <a:rPr lang="zh-CN" altLang="en-US" sz="1400" b="1">
                 <a:solidFill>
-                  <a:srgbClr val="E84C22"/>
+                  <a:srgbClr val="B22600"/>
                 </a:solidFill>
                 <a:latin typeface="Microsoft YaHei" panose="020B0503020204020204" pitchFamily="34" charset="-122"/>
                 <a:ea typeface="Microsoft YaHei" panose="020B0503020204020204" pitchFamily="34" charset="-122"/>
@@ -6735,7 +6735,7 @@
             <a:r>
               <a:rPr lang="zh-CN" altLang="en-US" sz="1600" b="1">
                 <a:solidFill>
-                  <a:srgbClr val="E84C22"/>
+                  <a:srgbClr val="B22600"/>
                 </a:solidFill>
                 <a:latin typeface="Microsoft YaHei" panose="020B0503020204020204" pitchFamily="34" charset="-122"/>
                 <a:ea typeface="Microsoft YaHei" panose="020B0503020204020204" pitchFamily="34" charset="-122"/>
@@ -6861,7 +6861,7 @@
             <a:avLst/>
           </a:prstGeom>
           <a:solidFill>
-            <a:srgbClr val="EEECE1"/>
+            <a:srgbClr val="FFFFFF"/>
           </a:solidFill>
           <a:ln w="9525">
             <a:solidFill>
@@ -7071,7 +7071,7 @@
             <a:avLst/>
           </a:prstGeom>
           <a:solidFill>
-            <a:srgbClr val="EEECE1"/>
+            <a:srgbClr val="FFFFFF"/>
           </a:solidFill>
           <a:ln w="9525">
             <a:solidFill>
@@ -7370,7 +7370,7 @@
             <a:r>
               <a:rPr lang="zh-CN" altLang="en-US" sz="1300" b="1">
                 <a:solidFill>
-                  <a:srgbClr val="E84C22"/>
+                  <a:srgbClr val="B22600"/>
                 </a:solidFill>
                 <a:latin typeface="Microsoft YaHei" panose="020B0503020204020204" pitchFamily="34" charset="-122"/>
                 <a:ea typeface="Microsoft YaHei" panose="020B0503020204020204" pitchFamily="34" charset="-122"/>
@@ -7411,7 +7411,7 @@
             <a:r>
               <a:rPr lang="zh-CN" altLang="en-US" sz="1300" b="1">
                 <a:solidFill>
-                  <a:srgbClr val="E84C22"/>
+                  <a:srgbClr val="B22600"/>
                 </a:solidFill>
                 <a:latin typeface="Microsoft YaHei" panose="020B0503020204020204" pitchFamily="34" charset="-122"/>
                 <a:ea typeface="Microsoft YaHei" panose="020B0503020204020204" pitchFamily="34" charset="-122"/>
@@ -7452,7 +7452,7 @@
             <a:r>
               <a:rPr lang="zh-CN" altLang="en-US" sz="1300" b="1">
                 <a:solidFill>
-                  <a:srgbClr val="E84C22"/>
+                  <a:srgbClr val="B22600"/>
                 </a:solidFill>
                 <a:latin typeface="Microsoft YaHei" panose="020B0503020204020204" pitchFamily="34" charset="-122"/>
                 <a:ea typeface="Microsoft YaHei" panose="020B0503020204020204" pitchFamily="34" charset="-122"/>
@@ -7493,7 +7493,7 @@
             <a:r>
               <a:rPr lang="zh-CN" altLang="en-US" sz="1300" b="1">
                 <a:solidFill>
-                  <a:srgbClr val="E84C22"/>
+                  <a:srgbClr val="B22600"/>
                 </a:solidFill>
                 <a:latin typeface="Microsoft YaHei" panose="020B0503020204020204" pitchFamily="34" charset="-122"/>
                 <a:ea typeface="Microsoft YaHei" panose="020B0503020204020204" pitchFamily="34" charset="-122"/>
@@ -7670,7 +7670,7 @@
             <a:r>
               <a:rPr lang="zh-CN" altLang="en-US" sz="1200">
                 <a:solidFill>
-                  <a:srgbClr val="E84C22"/>
+                  <a:srgbClr val="B22600"/>
                 </a:solidFill>
                 <a:latin typeface="Microsoft YaHei" panose="020B0503020204020204" pitchFamily="34" charset="-122"/>
                 <a:ea typeface="Microsoft YaHei" panose="020B0503020204020204" pitchFamily="34" charset="-122"/>
@@ -7782,7 +7782,7 @@
             <a:avLst/>
           </a:prstGeom>
           <a:solidFill>
-            <a:srgbClr val="EEECE1"/>
+            <a:srgbClr val="FFFFFF"/>
           </a:solidFill>
           <a:ln w="9525">
             <a:solidFill>
@@ -7928,7 +7928,7 @@
             <a:r>
               <a:rPr lang="zh-CN" altLang="en-US" sz="1200">
                 <a:solidFill>
-                  <a:srgbClr val="E84C22"/>
+                  <a:srgbClr val="B22600"/>
                 </a:solidFill>
                 <a:latin typeface="Microsoft YaHei" panose="020B0503020204020204" pitchFamily="34" charset="-122"/>
                 <a:ea typeface="Microsoft YaHei" panose="020B0503020204020204" pitchFamily="34" charset="-122"/>
@@ -8146,7 +8146,7 @@
             <a:r>
               <a:rPr lang="zh-CN" altLang="en-US" sz="1200">
                 <a:solidFill>
-                  <a:srgbClr val="E84C22"/>
+                  <a:srgbClr val="B22600"/>
                 </a:solidFill>
                 <a:latin typeface="Microsoft YaHei" panose="020B0503020204020204" pitchFamily="34" charset="-122"/>
                 <a:ea typeface="Microsoft YaHei" panose="020B0503020204020204" pitchFamily="34" charset="-122"/>
@@ -8238,7 +8238,7 @@
             <a:avLst/>
           </a:prstGeom>
           <a:solidFill>
-            <a:srgbClr val="EEECE1"/>
+            <a:srgbClr val="FFFFFF"/>
           </a:solidFill>
           <a:ln w="9525">
             <a:solidFill>
@@ -8384,7 +8384,7 @@
             <a:r>
               <a:rPr lang="zh-CN" altLang="en-US" sz="1200">
                 <a:solidFill>
-                  <a:srgbClr val="E84C22"/>
+                  <a:srgbClr val="B22600"/>
                 </a:solidFill>
                 <a:latin typeface="Microsoft YaHei" panose="020B0503020204020204" pitchFamily="34" charset="-122"/>
                 <a:ea typeface="Microsoft YaHei" panose="020B0503020204020204" pitchFamily="34" charset="-122"/>
@@ -8659,7 +8659,7 @@
             <a:r>
               <a:rPr lang="zh-CN" altLang="en-US" sz="1500" b="1">
                 <a:solidFill>
-                  <a:srgbClr val="E84C22"/>
+                  <a:srgbClr val="B22600"/>
                 </a:solidFill>
                 <a:latin typeface="Microsoft YaHei" panose="020B0503020204020204" pitchFamily="34" charset="-122"/>
                 <a:ea typeface="Microsoft YaHei" panose="020B0503020204020204" pitchFamily="34" charset="-122"/>
@@ -8850,7 +8850,7 @@
             <a:r>
               <a:rPr lang="en-US" altLang="zh-CN" sz="1400" b="1">
                 <a:solidFill>
-                  <a:srgbClr val="E84C22"/>
+                  <a:srgbClr val="B22600"/>
                 </a:solidFill>
                 <a:latin typeface="Microsoft YaHei" panose="020B0503020204020204" pitchFamily="34" charset="-122"/>
                 <a:ea typeface="Microsoft YaHei" panose="020B0503020204020204" pitchFamily="34" charset="-122"/>
@@ -8860,7 +8860,7 @@
             <a:r>
               <a:rPr lang="zh-CN" altLang="en-US" sz="1400" b="1">
                 <a:solidFill>
-                  <a:srgbClr val="E84C22"/>
+                  <a:srgbClr val="B22600"/>
                 </a:solidFill>
                 <a:latin typeface="Microsoft YaHei" panose="020B0503020204020204" pitchFamily="34" charset="-122"/>
                 <a:ea typeface="Microsoft YaHei" panose="020B0503020204020204" pitchFamily="34" charset="-122"/>
@@ -8891,7 +8891,7 @@
             <a:avLst/>
           </a:prstGeom>
           <a:solidFill>
-            <a:srgbClr val="EEECE1"/>
+            <a:srgbClr val="FFFFFF"/>
           </a:solidFill>
           <a:ln w="9525">
             <a:solidFill>
@@ -9051,7 +9051,7 @@
             <a:r>
               <a:rPr lang="en-US" altLang="zh-CN" sz="1400" b="1">
                 <a:solidFill>
-                  <a:srgbClr val="E84C22"/>
+                  <a:srgbClr val="B22600"/>
                 </a:solidFill>
                 <a:latin typeface="Microsoft YaHei" panose="020B0503020204020204" pitchFamily="34" charset="-122"/>
                 <a:ea typeface="Microsoft YaHei" panose="020B0503020204020204" pitchFamily="34" charset="-122"/>
@@ -9061,7 +9061,7 @@
             <a:r>
               <a:rPr lang="zh-CN" altLang="en-US" sz="1400" b="1">
                 <a:solidFill>
-                  <a:srgbClr val="E84C22"/>
+                  <a:srgbClr val="B22600"/>
                 </a:solidFill>
                 <a:latin typeface="Microsoft YaHei" panose="020B0503020204020204" pitchFamily="34" charset="-122"/>
                 <a:ea typeface="Microsoft YaHei" panose="020B0503020204020204" pitchFamily="34" charset="-122"/>
@@ -9252,7 +9252,7 @@
             <a:r>
               <a:rPr lang="en-US" altLang="zh-CN" sz="1400" b="1">
                 <a:solidFill>
-                  <a:srgbClr val="E84C22"/>
+                  <a:srgbClr val="B22600"/>
                 </a:solidFill>
                 <a:latin typeface="Microsoft YaHei" panose="020B0503020204020204" pitchFamily="34" charset="-122"/>
                 <a:ea typeface="Microsoft YaHei" panose="020B0503020204020204" pitchFamily="34" charset="-122"/>
@@ -9262,7 +9262,7 @@
             <a:r>
               <a:rPr lang="zh-CN" altLang="en-US" sz="1400" b="1">
                 <a:solidFill>
-                  <a:srgbClr val="E84C22"/>
+                  <a:srgbClr val="B22600"/>
                 </a:solidFill>
                 <a:latin typeface="Microsoft YaHei" panose="020B0503020204020204" pitchFamily="34" charset="-122"/>
                 <a:ea typeface="Microsoft YaHei" panose="020B0503020204020204" pitchFamily="34" charset="-122"/>
@@ -9293,7 +9293,7 @@
             <a:avLst/>
           </a:prstGeom>
           <a:solidFill>
-            <a:srgbClr val="EEECE1"/>
+            <a:srgbClr val="FFFFFF"/>
           </a:solidFill>
           <a:ln w="9525">
             <a:solidFill>
@@ -9453,7 +9453,7 @@
             <a:r>
               <a:rPr lang="en-US" altLang="zh-CN" sz="1400" b="1">
                 <a:solidFill>
-                  <a:srgbClr val="E84C22"/>
+                  <a:srgbClr val="B22600"/>
                 </a:solidFill>
                 <a:latin typeface="Microsoft YaHei" panose="020B0503020204020204" pitchFamily="34" charset="-122"/>
                 <a:ea typeface="Microsoft YaHei" panose="020B0503020204020204" pitchFamily="34" charset="-122"/>
@@ -9463,7 +9463,7 @@
             <a:r>
               <a:rPr lang="zh-CN" altLang="en-US" sz="1400" b="1">
                 <a:solidFill>
-                  <a:srgbClr val="E84C22"/>
+                  <a:srgbClr val="B22600"/>
                 </a:solidFill>
                 <a:latin typeface="Microsoft YaHei" panose="020B0503020204020204" pitchFamily="34" charset="-122"/>
                 <a:ea typeface="Microsoft YaHei" panose="020B0503020204020204" pitchFamily="34" charset="-122"/>
@@ -19797,7 +19797,7 @@
             <a:r>
               <a:rPr lang="zh-CN" altLang="en-US" sz="1500" b="1">
                 <a:solidFill>
-                  <a:srgbClr val="E84C22"/>
+                  <a:srgbClr val="B22600"/>
                 </a:solidFill>
                 <a:latin typeface="Microsoft YaHei" panose="020B0503020204020204" pitchFamily="34" charset="-122"/>
                 <a:ea typeface="Microsoft YaHei" panose="020B0503020204020204" pitchFamily="34" charset="-122"/>
@@ -19807,7 +19807,7 @@
             <a:r>
               <a:rPr lang="en-US" altLang="zh-CN" sz="1500" b="1">
                 <a:solidFill>
-                  <a:srgbClr val="E84C22"/>
+                  <a:srgbClr val="B22600"/>
                 </a:solidFill>
                 <a:latin typeface="Microsoft YaHei" panose="020B0503020204020204" pitchFamily="34" charset="-122"/>
                 <a:ea typeface="Microsoft YaHei" panose="020B0503020204020204" pitchFamily="34" charset="-122"/>
@@ -19817,7 +19817,7 @@
             <a:r>
               <a:rPr lang="zh-CN" altLang="en-US" sz="1500" b="1">
                 <a:solidFill>
-                  <a:srgbClr val="E84C22"/>
+                  <a:srgbClr val="B22600"/>
                 </a:solidFill>
                 <a:latin typeface="Microsoft YaHei" panose="020B0503020204020204" pitchFamily="34" charset="-122"/>
                 <a:ea typeface="Microsoft YaHei" panose="020B0503020204020204" pitchFamily="34" charset="-122"/>
@@ -19981,7 +19981,7 @@
             <a:r>
               <a:rPr lang="en-US" altLang="zh-CN" sz="2000" b="1">
                 <a:solidFill>
-                  <a:srgbClr val="E84C22"/>
+                  <a:srgbClr val="B22600"/>
                 </a:solidFill>
                 <a:latin typeface="Microsoft YaHei" panose="020B0503020204020204" pitchFamily="34" charset="-122"/>
                 <a:ea typeface="Microsoft YaHei" panose="020B0503020204020204" pitchFamily="34" charset="-122"/>
@@ -19990,7 +19990,7 @@
             </a:r>
             <a:endParaRPr lang="zh-CN" altLang="en-US" sz="2000" b="1">
               <a:solidFill>
-                <a:srgbClr val="E84C22"/>
+                <a:srgbClr val="B22600"/>
               </a:solidFill>
               <a:latin typeface="Microsoft YaHei" panose="020B0503020204020204" pitchFamily="34" charset="-122"/>
               <a:ea typeface="Microsoft YaHei" panose="020B0503020204020204" pitchFamily="34" charset="-122"/>
@@ -20019,7 +20019,7 @@
             <a:avLst/>
           </a:prstGeom>
           <a:solidFill>
-            <a:srgbClr val="EEECE1"/>
+            <a:srgbClr val="FFFFFF"/>
           </a:solidFill>
           <a:ln w="9525">
             <a:solidFill>
@@ -20083,7 +20083,7 @@
             <a:r>
               <a:rPr lang="zh-CN" altLang="en-US" sz="1500" b="1">
                 <a:solidFill>
-                  <a:srgbClr val="E84C22"/>
+                  <a:srgbClr val="B22600"/>
                 </a:solidFill>
                 <a:latin typeface="Microsoft YaHei" panose="020B0503020204020204" pitchFamily="34" charset="-122"/>
                 <a:ea typeface="Microsoft YaHei" panose="020B0503020204020204" pitchFamily="34" charset="-122"/>
@@ -20093,7 +20093,7 @@
             <a:r>
               <a:rPr lang="en-US" altLang="zh-CN" sz="1500" b="1">
                 <a:solidFill>
-                  <a:srgbClr val="E84C22"/>
+                  <a:srgbClr val="B22600"/>
                 </a:solidFill>
                 <a:latin typeface="Microsoft YaHei" panose="020B0503020204020204" pitchFamily="34" charset="-122"/>
                 <a:ea typeface="Microsoft YaHei" panose="020B0503020204020204" pitchFamily="34" charset="-122"/>
@@ -20103,7 +20103,7 @@
             <a:r>
               <a:rPr lang="zh-CN" altLang="en-US" sz="1500" b="1">
                 <a:solidFill>
-                  <a:srgbClr val="E84C22"/>
+                  <a:srgbClr val="B22600"/>
                 </a:solidFill>
                 <a:latin typeface="Microsoft YaHei" panose="020B0503020204020204" pitchFamily="34" charset="-122"/>
                 <a:ea typeface="Microsoft YaHei" panose="020B0503020204020204" pitchFamily="34" charset="-122"/>
@@ -20267,7 +20267,7 @@
             <a:r>
               <a:rPr lang="en-US" altLang="zh-CN" sz="2000" b="1">
                 <a:solidFill>
-                  <a:srgbClr val="E84C22"/>
+                  <a:srgbClr val="B22600"/>
                 </a:solidFill>
                 <a:latin typeface="Microsoft YaHei" panose="020B0503020204020204" pitchFamily="34" charset="-122"/>
                 <a:ea typeface="Microsoft YaHei" panose="020B0503020204020204" pitchFamily="34" charset="-122"/>
@@ -20276,7 +20276,7 @@
             </a:r>
             <a:endParaRPr lang="zh-CN" altLang="en-US" sz="2000" b="1">
               <a:solidFill>
-                <a:srgbClr val="E84C22"/>
+                <a:srgbClr val="B22600"/>
               </a:solidFill>
               <a:latin typeface="Microsoft YaHei" panose="020B0503020204020204" pitchFamily="34" charset="-122"/>
               <a:ea typeface="Microsoft YaHei" panose="020B0503020204020204" pitchFamily="34" charset="-122"/>
@@ -20369,7 +20369,7 @@
             <a:r>
               <a:rPr lang="zh-CN" altLang="en-US" sz="1500" b="1">
                 <a:solidFill>
-                  <a:srgbClr val="E84C22"/>
+                  <a:srgbClr val="B22600"/>
                 </a:solidFill>
                 <a:latin typeface="Microsoft YaHei" panose="020B0503020204020204" pitchFamily="34" charset="-122"/>
                 <a:ea typeface="Microsoft YaHei" panose="020B0503020204020204" pitchFamily="34" charset="-122"/>
@@ -20379,7 +20379,7 @@
             <a:r>
               <a:rPr lang="en-US" altLang="zh-CN" sz="1500" b="1">
                 <a:solidFill>
-                  <a:srgbClr val="E84C22"/>
+                  <a:srgbClr val="B22600"/>
                 </a:solidFill>
                 <a:latin typeface="Microsoft YaHei" panose="020B0503020204020204" pitchFamily="34" charset="-122"/>
                 <a:ea typeface="Microsoft YaHei" panose="020B0503020204020204" pitchFamily="34" charset="-122"/>
@@ -20389,7 +20389,7 @@
             <a:r>
               <a:rPr lang="zh-CN" altLang="en-US" sz="1500" b="1">
                 <a:solidFill>
-                  <a:srgbClr val="E84C22"/>
+                  <a:srgbClr val="B22600"/>
                 </a:solidFill>
                 <a:latin typeface="Microsoft YaHei" panose="020B0503020204020204" pitchFamily="34" charset="-122"/>
                 <a:ea typeface="Microsoft YaHei" panose="020B0503020204020204" pitchFamily="34" charset="-122"/>
@@ -20748,7 +20748,7 @@
             <a:r>
               <a:rPr lang="zh-CN" altLang="en-US" sz="1500" b="1">
                 <a:solidFill>
-                  <a:srgbClr val="E84C22"/>
+                  <a:srgbClr val="B22600"/>
                 </a:solidFill>
                 <a:latin typeface="Microsoft YaHei" panose="020B0503020204020204" pitchFamily="34" charset="-122"/>
                 <a:ea typeface="Microsoft YaHei" panose="020B0503020204020204" pitchFamily="34" charset="-122"/>
@@ -20979,7 +20979,7 @@
             <a:r>
               <a:rPr lang="zh-CN" altLang="en-US" sz="1600" b="1">
                 <a:solidFill>
-                  <a:srgbClr val="E84C22"/>
+                  <a:srgbClr val="B22600"/>
                 </a:solidFill>
                 <a:latin typeface="Microsoft YaHei" panose="020B0503020204020204" pitchFamily="34" charset="-122"/>
                 <a:ea typeface="Microsoft YaHei" panose="020B0503020204020204" pitchFamily="34" charset="-122"/>
@@ -21105,7 +21105,7 @@
             <a:avLst/>
           </a:prstGeom>
           <a:solidFill>
-            <a:srgbClr val="EEECE1"/>
+            <a:srgbClr val="FFFFFF"/>
           </a:solidFill>
           <a:ln w="9525">
             <a:solidFill>

</xml_diff>

<commit_message>
Rebuild legacy components 1-7 to token colors (user-confirmed)
Per-page mapping applied: Office default colors (blue 246AA8 / green 26866A / yellow B87700 / standard red D6001C / grey-blue 5F646B), dark grey ramp (slide 4) and legacy palette (slide 7: 172A3A/C61720/66747C) all mapped to template theme1 tokens - text deep red B22600, emphasis red E84C22, amber FFBD47, ink 505046, grey 6F6F6A, light fills F7F7F8/FFFFFF. DC-01 semantic invariant updated from red-blue-green to deep-red/red/amber. All 14 slides now pass token-color check (SHA E0C1D00A).
</commit_message>
<xml_diff>
--- a/domains/yuhong/assets/components/yuhong-county-course-components-branded.pptx
+++ b/domains/yuhong/assets/components/yuhong-county-course-components-branded.pptx
@@ -1366,7 +1366,7 @@
             <a:pPr algn="l">
               <a:defRPr sz="975" b="1">
                 <a:solidFill>
-                  <a:srgbClr val="D6001C"/>
+                  <a:srgbClr val="E84C22"/>
                 </a:solidFill>
                 <a:latin typeface="Microsoft YaHei"/>
                 <a:ea typeface="Microsoft YaHei"/>
@@ -1376,7 +1376,7 @@
             <a:r>
               <a:rPr sz="975" b="1">
                 <a:solidFill>
-                  <a:srgbClr val="D6001C"/>
+                  <a:srgbClr val="E84C22"/>
                 </a:solidFill>
                 <a:latin typeface="Microsoft YaHei"/>
                 <a:ea typeface="Microsoft YaHei"/>
@@ -1482,7 +1482,7 @@
             <a:pPr algn="l">
               <a:defRPr sz="1200" b="0">
                 <a:solidFill>
-                  <a:srgbClr val="5F646B"/>
+                  <a:srgbClr val="6F6F6A"/>
                 </a:solidFill>
                 <a:latin typeface="Microsoft YaHei"/>
                 <a:ea typeface="Microsoft YaHei"/>
@@ -1492,7 +1492,7 @@
             <a:r>
               <a:rPr sz="1200" b="0">
                 <a:solidFill>
-                  <a:srgbClr val="5F646B"/>
+                  <a:srgbClr val="6F6F6A"/>
                 </a:solidFill>
                 <a:latin typeface="Microsoft YaHei"/>
                 <a:ea typeface="Microsoft YaHei"/>
@@ -1528,7 +1528,7 @@
           <a:noFill/>
           <a:ln w="9525">
             <a:solidFill>
-              <a:srgbClr val="D8DCE0"/>
+              <a:srgbClr val="F7F7F8"/>
             </a:solidFill>
             <a:prstDash val="solid"/>
           </a:ln>
@@ -1571,7 +1571,7 @@
             <a:pPr algn="l">
               <a:defRPr sz="3150" b="1">
                 <a:solidFill>
-                  <a:srgbClr val="D6001C"/>
+                  <a:srgbClr val="E84C22"/>
                 </a:solidFill>
                 <a:latin typeface="Microsoft YaHei"/>
                 <a:ea typeface="Microsoft YaHei"/>
@@ -1581,7 +1581,7 @@
             <a:r>
               <a:rPr sz="3150" b="1">
                 <a:solidFill>
-                  <a:srgbClr val="D6001C"/>
+                  <a:srgbClr val="E84C22"/>
                 </a:solidFill>
                 <a:latin typeface="Microsoft YaHei"/>
                 <a:ea typeface="Microsoft YaHei"/>
@@ -1687,7 +1687,7 @@
             <a:pPr algn="ctr">
               <a:defRPr sz="1425" b="0">
                 <a:solidFill>
-                  <a:srgbClr val="5F646B"/>
+                  <a:srgbClr val="6F6F6A"/>
                 </a:solidFill>
                 <a:latin typeface="Microsoft YaHei"/>
                 <a:ea typeface="Microsoft YaHei"/>
@@ -1697,7 +1697,7 @@
             <a:r>
               <a:rPr sz="1425" b="0">
                 <a:solidFill>
-                  <a:srgbClr val="5F646B"/>
+                  <a:srgbClr val="6F6F6A"/>
                 </a:solidFill>
                 <a:latin typeface="Microsoft YaHei"/>
                 <a:ea typeface="Microsoft YaHei"/>
@@ -1731,7 +1731,7 @@
             <a:avLst/>
           </a:prstGeom>
           <a:solidFill>
-            <a:srgbClr val="D6001C"/>
+            <a:srgbClr val="E84C22"/>
           </a:solidFill>
           <a:ln w="0">
             <a:noFill/>
@@ -1764,11 +1764,11 @@
             </a:avLst>
           </a:prstGeom>
           <a:solidFill>
-            <a:srgbClr val="FFF0F2"/>
+            <a:srgbClr val="F7F7F8"/>
           </a:solidFill>
           <a:ln w="14288">
             <a:solidFill>
-              <a:srgbClr val="D6001C"/>
+              <a:srgbClr val="E84C22"/>
             </a:solidFill>
             <a:prstDash val="solid"/>
           </a:ln>
@@ -1811,7 +1811,7 @@
             <a:pPr algn="ctr">
               <a:defRPr sz="1425" b="1">
                 <a:solidFill>
-                  <a:srgbClr val="D6001C"/>
+                  <a:srgbClr val="E84C22"/>
                 </a:solidFill>
                 <a:latin typeface="Microsoft YaHei"/>
                 <a:ea typeface="Microsoft YaHei"/>
@@ -1821,7 +1821,7 @@
             <a:r>
               <a:rPr sz="1425" b="1">
                 <a:solidFill>
-                  <a:srgbClr val="D6001C"/>
+                  <a:srgbClr val="E84C22"/>
                 </a:solidFill>
                 <a:latin typeface="Microsoft YaHei"/>
                 <a:ea typeface="Microsoft YaHei"/>
@@ -1869,7 +1869,7 @@
             <a:pPr algn="l">
               <a:defRPr sz="3150" b="1">
                 <a:solidFill>
-                  <a:srgbClr val="246AA8"/>
+                  <a:srgbClr val="B22600"/>
                 </a:solidFill>
                 <a:latin typeface="Microsoft YaHei"/>
                 <a:ea typeface="Microsoft YaHei"/>
@@ -1879,7 +1879,7 @@
             <a:r>
               <a:rPr sz="3150" b="1">
                 <a:solidFill>
-                  <a:srgbClr val="246AA8"/>
+                  <a:srgbClr val="B22600"/>
                 </a:solidFill>
                 <a:latin typeface="Microsoft YaHei"/>
                 <a:ea typeface="Microsoft YaHei"/>
@@ -1985,7 +1985,7 @@
             <a:pPr algn="ctr">
               <a:defRPr sz="1425" b="0">
                 <a:solidFill>
-                  <a:srgbClr val="5F646B"/>
+                  <a:srgbClr val="6F6F6A"/>
                 </a:solidFill>
                 <a:latin typeface="Microsoft YaHei"/>
                 <a:ea typeface="Microsoft YaHei"/>
@@ -1995,7 +1995,7 @@
             <a:r>
               <a:rPr sz="1425" b="0">
                 <a:solidFill>
-                  <a:srgbClr val="5F646B"/>
+                  <a:srgbClr val="6F6F6A"/>
                 </a:solidFill>
                 <a:latin typeface="Microsoft YaHei"/>
                 <a:ea typeface="Microsoft YaHei"/>
@@ -2029,7 +2029,7 @@
             <a:avLst/>
           </a:prstGeom>
           <a:solidFill>
-            <a:srgbClr val="246AA8"/>
+            <a:srgbClr val="B22600"/>
           </a:solidFill>
           <a:ln w="0">
             <a:noFill/>
@@ -2062,11 +2062,11 @@
             </a:avLst>
           </a:prstGeom>
           <a:solidFill>
-            <a:srgbClr val="EAF2FA"/>
+            <a:srgbClr val="F7F7F8"/>
           </a:solidFill>
           <a:ln w="14288">
             <a:solidFill>
-              <a:srgbClr val="246AA8"/>
+              <a:srgbClr val="B22600"/>
             </a:solidFill>
             <a:prstDash val="solid"/>
           </a:ln>
@@ -2109,7 +2109,7 @@
             <a:pPr algn="ctr">
               <a:defRPr sz="1425" b="1">
                 <a:solidFill>
-                  <a:srgbClr val="246AA8"/>
+                  <a:srgbClr val="B22600"/>
                 </a:solidFill>
                 <a:latin typeface="Microsoft YaHei"/>
                 <a:ea typeface="Microsoft YaHei"/>
@@ -2119,7 +2119,7 @@
             <a:r>
               <a:rPr sz="1425" b="1">
                 <a:solidFill>
-                  <a:srgbClr val="246AA8"/>
+                  <a:srgbClr val="B22600"/>
                 </a:solidFill>
                 <a:latin typeface="Microsoft YaHei"/>
                 <a:ea typeface="Microsoft YaHei"/>
@@ -2167,7 +2167,7 @@
             <a:pPr algn="l">
               <a:defRPr sz="3150" b="1">
                 <a:solidFill>
-                  <a:srgbClr val="26866A"/>
+                  <a:srgbClr val="FFBD47"/>
                 </a:solidFill>
                 <a:latin typeface="Microsoft YaHei"/>
                 <a:ea typeface="Microsoft YaHei"/>
@@ -2177,7 +2177,7 @@
             <a:r>
               <a:rPr sz="3150" b="1">
                 <a:solidFill>
-                  <a:srgbClr val="26866A"/>
+                  <a:srgbClr val="FFBD47"/>
                 </a:solidFill>
                 <a:latin typeface="Microsoft YaHei"/>
                 <a:ea typeface="Microsoft YaHei"/>
@@ -2283,7 +2283,7 @@
             <a:pPr algn="ctr">
               <a:defRPr sz="1425" b="0">
                 <a:solidFill>
-                  <a:srgbClr val="5F646B"/>
+                  <a:srgbClr val="6F6F6A"/>
                 </a:solidFill>
                 <a:latin typeface="Microsoft YaHei"/>
                 <a:ea typeface="Microsoft YaHei"/>
@@ -2293,7 +2293,7 @@
             <a:r>
               <a:rPr sz="1425" b="0">
                 <a:solidFill>
-                  <a:srgbClr val="5F646B"/>
+                  <a:srgbClr val="6F6F6A"/>
                 </a:solidFill>
                 <a:latin typeface="Microsoft YaHei"/>
                 <a:ea typeface="Microsoft YaHei"/>
@@ -2327,7 +2327,7 @@
             <a:avLst/>
           </a:prstGeom>
           <a:solidFill>
-            <a:srgbClr val="26866A"/>
+            <a:srgbClr val="FFBD47"/>
           </a:solidFill>
           <a:ln w="0">
             <a:noFill/>
@@ -2360,11 +2360,11 @@
             </a:avLst>
           </a:prstGeom>
           <a:solidFill>
-            <a:srgbClr val="EAF5F1"/>
+            <a:srgbClr val="F7F7F8"/>
           </a:solidFill>
           <a:ln w="14288">
             <a:solidFill>
-              <a:srgbClr val="26866A"/>
+              <a:srgbClr val="FFBD47"/>
             </a:solidFill>
             <a:prstDash val="solid"/>
           </a:ln>
@@ -2407,7 +2407,7 @@
             <a:pPr algn="ctr">
               <a:defRPr sz="1425" b="1">
                 <a:solidFill>
-                  <a:srgbClr val="26866A"/>
+                  <a:srgbClr val="FFBD47"/>
                 </a:solidFill>
                 <a:latin typeface="Microsoft YaHei"/>
                 <a:ea typeface="Microsoft YaHei"/>
@@ -2417,7 +2417,7 @@
             <a:r>
               <a:rPr sz="1425" b="1">
                 <a:solidFill>
-                  <a:srgbClr val="26866A"/>
+                  <a:srgbClr val="FFBD47"/>
                 </a:solidFill>
                 <a:latin typeface="Microsoft YaHei"/>
                 <a:ea typeface="Microsoft YaHei"/>
@@ -2465,7 +2465,7 @@
             <a:pPr algn="l">
               <a:defRPr sz="975" b="0">
                 <a:solidFill>
-                  <a:srgbClr val="5F646B"/>
+                  <a:srgbClr val="6F6F6A"/>
                 </a:solidFill>
                 <a:latin typeface="Microsoft YaHei"/>
                 <a:ea typeface="Microsoft YaHei"/>
@@ -2475,7 +2475,7 @@
             <a:r>
               <a:rPr sz="975" b="0">
                 <a:solidFill>
-                  <a:srgbClr val="5F646B"/>
+                  <a:srgbClr val="6F6F6A"/>
                 </a:solidFill>
                 <a:latin typeface="Microsoft YaHei"/>
                 <a:ea typeface="Microsoft YaHei"/>
@@ -2523,7 +2523,7 @@
             <a:pPr algn="r">
               <a:defRPr sz="1050" b="1">
                 <a:solidFill>
-                  <a:srgbClr val="D6001C"/>
+                  <a:srgbClr val="E84C22"/>
                 </a:solidFill>
                 <a:latin typeface="Microsoft YaHei"/>
                 <a:ea typeface="Microsoft YaHei"/>
@@ -2533,7 +2533,7 @@
             <a:r>
               <a:rPr sz="1050" b="1">
                 <a:solidFill>
-                  <a:srgbClr val="D6001C"/>
+                  <a:srgbClr val="E84C22"/>
                 </a:solidFill>
                 <a:latin typeface="Microsoft YaHei"/>
                 <a:ea typeface="Microsoft YaHei"/>
@@ -9713,7 +9713,7 @@
             <a:pPr algn="l">
               <a:defRPr sz="975" b="1">
                 <a:solidFill>
-                  <a:srgbClr val="D6001C"/>
+                  <a:srgbClr val="B22600"/>
                 </a:solidFill>
                 <a:latin typeface="Microsoft YaHei"/>
                 <a:ea typeface="Microsoft YaHei"/>
@@ -9723,7 +9723,7 @@
             <a:r>
               <a:rPr sz="975" b="1">
                 <a:solidFill>
-                  <a:srgbClr val="D6001C"/>
+                  <a:srgbClr val="B22600"/>
                 </a:solidFill>
                 <a:latin typeface="Microsoft YaHei"/>
                 <a:ea typeface="Microsoft YaHei"/>
@@ -9829,7 +9829,7 @@
             <a:pPr algn="l">
               <a:defRPr sz="1200" b="0">
                 <a:solidFill>
-                  <a:srgbClr val="5F646B"/>
+                  <a:srgbClr val="6F6F6A"/>
                 </a:solidFill>
                 <a:latin typeface="Microsoft YaHei"/>
                 <a:ea typeface="Microsoft YaHei"/>
@@ -9839,7 +9839,7 @@
             <a:r>
               <a:rPr sz="1200" b="0">
                 <a:solidFill>
-                  <a:srgbClr val="5F646B"/>
+                  <a:srgbClr val="6F6F6A"/>
                 </a:solidFill>
                 <a:latin typeface="Microsoft YaHei"/>
                 <a:ea typeface="Microsoft YaHei"/>
@@ -9875,7 +9875,7 @@
           <a:noFill/>
           <a:ln w="9525">
             <a:solidFill>
-              <a:srgbClr val="D8DCE0"/>
+              <a:srgbClr val="F7F7F8"/>
             </a:solidFill>
             <a:prstDash val="solid"/>
           </a:ln>
@@ -9904,7 +9904,7 @@
             <a:avLst/>
           </a:prstGeom>
           <a:solidFill>
-            <a:srgbClr val="D6001C"/>
+            <a:srgbClr val="B22600"/>
           </a:solidFill>
           <a:ln w="0">
             <a:noFill/>
@@ -10053,7 +10053,7 @@
           <a:noFill/>
           <a:ln w="19050">
             <a:solidFill>
-              <a:srgbClr val="26866A"/>
+              <a:srgbClr val="E84C22"/>
             </a:solidFill>
             <a:prstDash val="solid"/>
           </a:ln>
@@ -10082,11 +10082,11 @@
             <a:avLst/>
           </a:prstGeom>
           <a:solidFill>
-            <a:srgbClr val="EAF5F1"/>
+            <a:srgbClr val="F7F7F8"/>
           </a:solidFill>
           <a:ln w="19050">
             <a:solidFill>
-              <a:srgbClr val="26866A"/>
+              <a:srgbClr val="E84C22"/>
             </a:solidFill>
             <a:prstDash val="solid"/>
           </a:ln>
@@ -10187,7 +10187,7 @@
             <a:pPr algn="ctr">
               <a:defRPr sz="1125" b="1">
                 <a:solidFill>
-                  <a:srgbClr val="26866A"/>
+                  <a:srgbClr val="E84C22"/>
                 </a:solidFill>
                 <a:latin typeface="Microsoft YaHei"/>
                 <a:ea typeface="Microsoft YaHei"/>
@@ -10197,7 +10197,7 @@
             <a:r>
               <a:rPr sz="1125" b="1">
                 <a:solidFill>
-                  <a:srgbClr val="26866A"/>
+                  <a:srgbClr val="E84C22"/>
                 </a:solidFill>
                 <a:latin typeface="Microsoft YaHei"/>
                 <a:ea typeface="Microsoft YaHei"/>
@@ -10233,7 +10233,7 @@
           <a:noFill/>
           <a:ln w="19050">
             <a:solidFill>
-              <a:srgbClr val="246AA8"/>
+              <a:srgbClr val="505046"/>
             </a:solidFill>
             <a:prstDash val="solid"/>
           </a:ln>
@@ -10262,11 +10262,11 @@
             <a:avLst/>
           </a:prstGeom>
           <a:solidFill>
-            <a:srgbClr val="EAF2FA"/>
+            <a:srgbClr val="F7F7F8"/>
           </a:solidFill>
           <a:ln w="19050">
             <a:solidFill>
-              <a:srgbClr val="246AA8"/>
+              <a:srgbClr val="505046"/>
             </a:solidFill>
             <a:prstDash val="solid"/>
           </a:ln>
@@ -10367,7 +10367,7 @@
             <a:pPr algn="ctr">
               <a:defRPr sz="1125" b="1">
                 <a:solidFill>
-                  <a:srgbClr val="246AA8"/>
+                  <a:srgbClr val="505046"/>
                 </a:solidFill>
                 <a:latin typeface="Microsoft YaHei"/>
                 <a:ea typeface="Microsoft YaHei"/>
@@ -10377,7 +10377,7 @@
             <a:r>
               <a:rPr sz="1125" b="1">
                 <a:solidFill>
-                  <a:srgbClr val="246AA8"/>
+                  <a:srgbClr val="505046"/>
                 </a:solidFill>
                 <a:latin typeface="Microsoft YaHei"/>
                 <a:ea typeface="Microsoft YaHei"/>
@@ -10413,7 +10413,7 @@
           <a:noFill/>
           <a:ln w="19050">
             <a:solidFill>
-              <a:srgbClr val="B87700"/>
+              <a:srgbClr val="FFBD47"/>
             </a:solidFill>
             <a:prstDash val="solid"/>
           </a:ln>
@@ -10442,11 +10442,11 @@
             <a:avLst/>
           </a:prstGeom>
           <a:solidFill>
-            <a:srgbClr val="FFF4DC"/>
+            <a:srgbClr val="F7F7F8"/>
           </a:solidFill>
           <a:ln w="19050">
             <a:solidFill>
-              <a:srgbClr val="B87700"/>
+              <a:srgbClr val="FFBD47"/>
             </a:solidFill>
             <a:prstDash val="solid"/>
           </a:ln>
@@ -10547,7 +10547,7 @@
             <a:pPr algn="ctr">
               <a:defRPr sz="1125" b="1">
                 <a:solidFill>
-                  <a:srgbClr val="B87700"/>
+                  <a:srgbClr val="FFBD47"/>
                 </a:solidFill>
                 <a:latin typeface="Microsoft YaHei"/>
                 <a:ea typeface="Microsoft YaHei"/>
@@ -10557,7 +10557,7 @@
             <a:r>
               <a:rPr sz="1125" b="1">
                 <a:solidFill>
-                  <a:srgbClr val="B87700"/>
+                  <a:srgbClr val="FFBD47"/>
                 </a:solidFill>
                 <a:latin typeface="Microsoft YaHei"/>
                 <a:ea typeface="Microsoft YaHei"/>
@@ -10593,7 +10593,7 @@
           <a:noFill/>
           <a:ln w="19050">
             <a:solidFill>
-              <a:srgbClr val="5F646B"/>
+              <a:srgbClr val="6F6F6A"/>
             </a:solidFill>
             <a:prstDash val="solid"/>
           </a:ln>
@@ -10622,11 +10622,11 @@
             <a:avLst/>
           </a:prstGeom>
           <a:solidFill>
-            <a:srgbClr val="F4F5F6"/>
+            <a:srgbClr val="F7F7F8"/>
           </a:solidFill>
           <a:ln w="19050">
             <a:solidFill>
-              <a:srgbClr val="5F646B"/>
+              <a:srgbClr val="6F6F6A"/>
             </a:solidFill>
             <a:prstDash val="solid"/>
           </a:ln>
@@ -10727,7 +10727,7 @@
             <a:pPr algn="ctr">
               <a:defRPr sz="1125" b="1">
                 <a:solidFill>
-                  <a:srgbClr val="5F646B"/>
+                  <a:srgbClr val="6F6F6A"/>
                 </a:solidFill>
                 <a:latin typeface="Microsoft YaHei"/>
                 <a:ea typeface="Microsoft YaHei"/>
@@ -10737,7 +10737,7 @@
             <a:r>
               <a:rPr sz="1125" b="1">
                 <a:solidFill>
-                  <a:srgbClr val="5F646B"/>
+                  <a:srgbClr val="6F6F6A"/>
                 </a:solidFill>
                 <a:latin typeface="Microsoft YaHei"/>
                 <a:ea typeface="Microsoft YaHei"/>
@@ -10785,7 +10785,7 @@
             <a:pPr algn="ctr">
               <a:defRPr sz="1050" b="1">
                 <a:solidFill>
-                  <a:srgbClr val="246AA8"/>
+                  <a:srgbClr val="505046"/>
                 </a:solidFill>
                 <a:latin typeface="Microsoft YaHei"/>
                 <a:ea typeface="Microsoft YaHei"/>
@@ -10795,7 +10795,7 @@
             <a:r>
               <a:rPr sz="1050" b="1">
                 <a:solidFill>
-                  <a:srgbClr val="246AA8"/>
+                  <a:srgbClr val="505046"/>
                 </a:solidFill>
                 <a:latin typeface="Microsoft YaHei"/>
                 <a:ea typeface="Microsoft YaHei"/>
@@ -10843,7 +10843,7 @@
             <a:pPr algn="ctr">
               <a:defRPr sz="1050" b="1">
                 <a:solidFill>
-                  <a:srgbClr val="26866A"/>
+                  <a:srgbClr val="E84C22"/>
                 </a:solidFill>
                 <a:latin typeface="Microsoft YaHei"/>
                 <a:ea typeface="Microsoft YaHei"/>
@@ -10853,7 +10853,7 @@
             <a:r>
               <a:rPr sz="1050" b="1">
                 <a:solidFill>
-                  <a:srgbClr val="26866A"/>
+                  <a:srgbClr val="E84C22"/>
                 </a:solidFill>
                 <a:latin typeface="Microsoft YaHei"/>
                 <a:ea typeface="Microsoft YaHei"/>
@@ -10901,7 +10901,7 @@
             <a:pPr algn="ctr">
               <a:defRPr sz="1050" b="1">
                 <a:solidFill>
-                  <a:srgbClr val="B87700"/>
+                  <a:srgbClr val="FFBD47"/>
                 </a:solidFill>
                 <a:latin typeface="Microsoft YaHei"/>
                 <a:ea typeface="Microsoft YaHei"/>
@@ -10911,7 +10911,7 @@
             <a:r>
               <a:rPr sz="1050" b="1">
                 <a:solidFill>
-                  <a:srgbClr val="B87700"/>
+                  <a:srgbClr val="FFBD47"/>
                 </a:solidFill>
                 <a:latin typeface="Microsoft YaHei"/>
                 <a:ea typeface="Microsoft YaHei"/>
@@ -10959,7 +10959,7 @@
             <a:pPr algn="l">
               <a:defRPr sz="975" b="0">
                 <a:solidFill>
-                  <a:srgbClr val="5F646B"/>
+                  <a:srgbClr val="6F6F6A"/>
                 </a:solidFill>
                 <a:latin typeface="Microsoft YaHei"/>
                 <a:ea typeface="Microsoft YaHei"/>
@@ -10969,7 +10969,7 @@
             <a:r>
               <a:rPr sz="975" b="0">
                 <a:solidFill>
-                  <a:srgbClr val="5F646B"/>
+                  <a:srgbClr val="6F6F6A"/>
                 </a:solidFill>
                 <a:latin typeface="Microsoft YaHei"/>
                 <a:ea typeface="Microsoft YaHei"/>
@@ -11017,7 +11017,7 @@
             <a:pPr algn="r">
               <a:defRPr sz="1050" b="1">
                 <a:solidFill>
-                  <a:srgbClr val="D6001C"/>
+                  <a:srgbClr val="B22600"/>
                 </a:solidFill>
                 <a:latin typeface="Microsoft YaHei"/>
                 <a:ea typeface="Microsoft YaHei"/>
@@ -11027,7 +11027,7 @@
             <a:r>
               <a:rPr sz="1050" b="1">
                 <a:solidFill>
-                  <a:srgbClr val="D6001C"/>
+                  <a:srgbClr val="B22600"/>
                 </a:solidFill>
                 <a:latin typeface="Microsoft YaHei"/>
                 <a:ea typeface="Microsoft YaHei"/>
@@ -11105,7 +11105,7 @@
             <a:pPr algn="l">
               <a:defRPr sz="975" b="1">
                 <a:solidFill>
-                  <a:srgbClr val="D6001C"/>
+                  <a:srgbClr val="B22600"/>
                 </a:solidFill>
                 <a:latin typeface="Microsoft YaHei"/>
                 <a:ea typeface="Microsoft YaHei"/>
@@ -11115,7 +11115,7 @@
             <a:r>
               <a:rPr sz="975" b="1">
                 <a:solidFill>
-                  <a:srgbClr val="D6001C"/>
+                  <a:srgbClr val="B22600"/>
                 </a:solidFill>
                 <a:latin typeface="Microsoft YaHei"/>
                 <a:ea typeface="Microsoft YaHei"/>
@@ -11221,7 +11221,7 @@
             <a:pPr algn="l">
               <a:defRPr sz="1200" b="0">
                 <a:solidFill>
-                  <a:srgbClr val="5F646B"/>
+                  <a:srgbClr val="6F6F6A"/>
                 </a:solidFill>
                 <a:latin typeface="Microsoft YaHei"/>
                 <a:ea typeface="Microsoft YaHei"/>
@@ -11231,7 +11231,7 @@
             <a:r>
               <a:rPr sz="1200" b="0">
                 <a:solidFill>
-                  <a:srgbClr val="5F646B"/>
+                  <a:srgbClr val="6F6F6A"/>
                 </a:solidFill>
                 <a:latin typeface="Microsoft YaHei"/>
                 <a:ea typeface="Microsoft YaHei"/>
@@ -11267,7 +11267,7 @@
           <a:noFill/>
           <a:ln w="9525">
             <a:solidFill>
-              <a:srgbClr val="D8DCE0"/>
+              <a:srgbClr val="F7F7F8"/>
             </a:solidFill>
             <a:prstDash val="solid"/>
           </a:ln>
@@ -11410,7 +11410,7 @@
           <a:noFill/>
           <a:ln w="19050">
             <a:solidFill>
-              <a:srgbClr val="D6001C"/>
+              <a:srgbClr val="B22600"/>
             </a:solidFill>
             <a:prstDash val="solid"/>
           </a:ln>
@@ -11441,11 +11441,11 @@
             </a:avLst>
           </a:prstGeom>
           <a:solidFill>
-            <a:srgbClr val="FFF0F2"/>
+            <a:srgbClr val="F7F7F8"/>
           </a:solidFill>
           <a:ln w="19050">
             <a:solidFill>
-              <a:srgbClr val="D6001C"/>
+              <a:srgbClr val="B22600"/>
             </a:solidFill>
             <a:prstDash val="solid"/>
           </a:ln>
@@ -11488,7 +11488,7 @@
             <a:pPr algn="l">
               <a:defRPr sz="1650" b="1">
                 <a:solidFill>
-                  <a:srgbClr val="D6001C"/>
+                  <a:srgbClr val="B22600"/>
                 </a:solidFill>
                 <a:latin typeface="Microsoft YaHei"/>
                 <a:ea typeface="Microsoft YaHei"/>
@@ -11498,7 +11498,7 @@
             <a:r>
               <a:rPr sz="1650" b="1">
                 <a:solidFill>
-                  <a:srgbClr val="D6001C"/>
+                  <a:srgbClr val="B22600"/>
                 </a:solidFill>
                 <a:latin typeface="Microsoft YaHei"/>
                 <a:ea typeface="Microsoft YaHei"/>
@@ -11604,7 +11604,7 @@
             <a:pPr algn="l">
               <a:defRPr sz="975" b="0">
                 <a:solidFill>
-                  <a:srgbClr val="5F646B"/>
+                  <a:srgbClr val="6F6F6A"/>
                 </a:solidFill>
                 <a:latin typeface="Microsoft YaHei"/>
                 <a:ea typeface="Microsoft YaHei"/>
@@ -11614,7 +11614,7 @@
             <a:r>
               <a:rPr sz="975" b="0">
                 <a:solidFill>
-                  <a:srgbClr val="5F646B"/>
+                  <a:srgbClr val="6F6F6A"/>
                 </a:solidFill>
                 <a:latin typeface="Microsoft YaHei"/>
                 <a:ea typeface="Microsoft YaHei"/>
@@ -11650,7 +11650,7 @@
           <a:noFill/>
           <a:ln w="19050">
             <a:solidFill>
-              <a:srgbClr val="246AA8"/>
+              <a:srgbClr val="505046"/>
             </a:solidFill>
             <a:prstDash val="solid"/>
           </a:ln>
@@ -11681,11 +11681,11 @@
             </a:avLst>
           </a:prstGeom>
           <a:solidFill>
-            <a:srgbClr val="EAF2FA"/>
+            <a:srgbClr val="F7F7F8"/>
           </a:solidFill>
           <a:ln w="19050">
             <a:solidFill>
-              <a:srgbClr val="246AA8"/>
+              <a:srgbClr val="505046"/>
             </a:solidFill>
             <a:prstDash val="solid"/>
           </a:ln>
@@ -11728,7 +11728,7 @@
             <a:pPr algn="l">
               <a:defRPr sz="1650" b="1">
                 <a:solidFill>
-                  <a:srgbClr val="246AA8"/>
+                  <a:srgbClr val="505046"/>
                 </a:solidFill>
                 <a:latin typeface="Microsoft YaHei"/>
                 <a:ea typeface="Microsoft YaHei"/>
@@ -11738,7 +11738,7 @@
             <a:r>
               <a:rPr sz="1650" b="1">
                 <a:solidFill>
-                  <a:srgbClr val="246AA8"/>
+                  <a:srgbClr val="505046"/>
                 </a:solidFill>
                 <a:latin typeface="Microsoft YaHei"/>
                 <a:ea typeface="Microsoft YaHei"/>
@@ -11844,7 +11844,7 @@
             <a:pPr algn="l">
               <a:defRPr sz="975" b="0">
                 <a:solidFill>
-                  <a:srgbClr val="5F646B"/>
+                  <a:srgbClr val="6F6F6A"/>
                 </a:solidFill>
                 <a:latin typeface="Microsoft YaHei"/>
                 <a:ea typeface="Microsoft YaHei"/>
@@ -11854,7 +11854,7 @@
             <a:r>
               <a:rPr sz="975" b="0">
                 <a:solidFill>
-                  <a:srgbClr val="5F646B"/>
+                  <a:srgbClr val="6F6F6A"/>
                 </a:solidFill>
                 <a:latin typeface="Microsoft YaHei"/>
                 <a:ea typeface="Microsoft YaHei"/>
@@ -11890,7 +11890,7 @@
           <a:noFill/>
           <a:ln w="19050">
             <a:solidFill>
-              <a:srgbClr val="B87700"/>
+              <a:srgbClr val="FFBD47"/>
             </a:solidFill>
             <a:prstDash val="solid"/>
           </a:ln>
@@ -11921,11 +11921,11 @@
             </a:avLst>
           </a:prstGeom>
           <a:solidFill>
-            <a:srgbClr val="FFF4DC"/>
+            <a:srgbClr val="F7F7F8"/>
           </a:solidFill>
           <a:ln w="19050">
             <a:solidFill>
-              <a:srgbClr val="B87700"/>
+              <a:srgbClr val="FFBD47"/>
             </a:solidFill>
             <a:prstDash val="solid"/>
           </a:ln>
@@ -11968,7 +11968,7 @@
             <a:pPr algn="l">
               <a:defRPr sz="1650" b="1">
                 <a:solidFill>
-                  <a:srgbClr val="B87700"/>
+                  <a:srgbClr val="FFBD47"/>
                 </a:solidFill>
                 <a:latin typeface="Microsoft YaHei"/>
                 <a:ea typeface="Microsoft YaHei"/>
@@ -11978,7 +11978,7 @@
             <a:r>
               <a:rPr sz="1650" b="1">
                 <a:solidFill>
-                  <a:srgbClr val="B87700"/>
+                  <a:srgbClr val="FFBD47"/>
                 </a:solidFill>
                 <a:latin typeface="Microsoft YaHei"/>
                 <a:ea typeface="Microsoft YaHei"/>
@@ -12084,7 +12084,7 @@
             <a:pPr algn="l">
               <a:defRPr sz="975" b="0">
                 <a:solidFill>
-                  <a:srgbClr val="5F646B"/>
+                  <a:srgbClr val="6F6F6A"/>
                 </a:solidFill>
                 <a:latin typeface="Microsoft YaHei"/>
                 <a:ea typeface="Microsoft YaHei"/>
@@ -12094,7 +12094,7 @@
             <a:r>
               <a:rPr sz="975" b="0">
                 <a:solidFill>
-                  <a:srgbClr val="5F646B"/>
+                  <a:srgbClr val="6F6F6A"/>
                 </a:solidFill>
                 <a:latin typeface="Microsoft YaHei"/>
                 <a:ea typeface="Microsoft YaHei"/>
@@ -12130,7 +12130,7 @@
           <a:noFill/>
           <a:ln w="19050">
             <a:solidFill>
-              <a:srgbClr val="26866A"/>
+              <a:srgbClr val="E84C22"/>
             </a:solidFill>
             <a:prstDash val="solid"/>
           </a:ln>
@@ -12161,11 +12161,11 @@
             </a:avLst>
           </a:prstGeom>
           <a:solidFill>
-            <a:srgbClr val="EAF5F1"/>
+            <a:srgbClr val="F7F7F8"/>
           </a:solidFill>
           <a:ln w="19050">
             <a:solidFill>
-              <a:srgbClr val="26866A"/>
+              <a:srgbClr val="E84C22"/>
             </a:solidFill>
             <a:prstDash val="solid"/>
           </a:ln>
@@ -12208,7 +12208,7 @@
             <a:pPr algn="l">
               <a:defRPr sz="1650" b="1">
                 <a:solidFill>
-                  <a:srgbClr val="26866A"/>
+                  <a:srgbClr val="E84C22"/>
                 </a:solidFill>
                 <a:latin typeface="Microsoft YaHei"/>
                 <a:ea typeface="Microsoft YaHei"/>
@@ -12218,7 +12218,7 @@
             <a:r>
               <a:rPr sz="1650" b="1">
                 <a:solidFill>
-                  <a:srgbClr val="26866A"/>
+                  <a:srgbClr val="E84C22"/>
                 </a:solidFill>
                 <a:latin typeface="Microsoft YaHei"/>
                 <a:ea typeface="Microsoft YaHei"/>
@@ -12324,7 +12324,7 @@
             <a:pPr algn="l">
               <a:defRPr sz="975" b="0">
                 <a:solidFill>
-                  <a:srgbClr val="5F646B"/>
+                  <a:srgbClr val="6F6F6A"/>
                 </a:solidFill>
                 <a:latin typeface="Microsoft YaHei"/>
                 <a:ea typeface="Microsoft YaHei"/>
@@ -12334,7 +12334,7 @@
             <a:r>
               <a:rPr sz="975" b="0">
                 <a:solidFill>
-                  <a:srgbClr val="5F646B"/>
+                  <a:srgbClr val="6F6F6A"/>
                 </a:solidFill>
                 <a:latin typeface="Microsoft YaHei"/>
                 <a:ea typeface="Microsoft YaHei"/>
@@ -12382,7 +12382,7 @@
             <a:pPr algn="l">
               <a:defRPr sz="975" b="0">
                 <a:solidFill>
-                  <a:srgbClr val="5F646B"/>
+                  <a:srgbClr val="6F6F6A"/>
                 </a:solidFill>
                 <a:latin typeface="Microsoft YaHei"/>
                 <a:ea typeface="Microsoft YaHei"/>
@@ -12392,7 +12392,7 @@
             <a:r>
               <a:rPr sz="975" b="0">
                 <a:solidFill>
-                  <a:srgbClr val="5F646B"/>
+                  <a:srgbClr val="6F6F6A"/>
                 </a:solidFill>
                 <a:latin typeface="Microsoft YaHei"/>
                 <a:ea typeface="Microsoft YaHei"/>
@@ -12440,7 +12440,7 @@
             <a:pPr algn="r">
               <a:defRPr sz="1050" b="1">
                 <a:solidFill>
-                  <a:srgbClr val="D6001C"/>
+                  <a:srgbClr val="B22600"/>
                 </a:solidFill>
                 <a:latin typeface="Microsoft YaHei"/>
                 <a:ea typeface="Microsoft YaHei"/>
@@ -12450,7 +12450,7 @@
             <a:r>
               <a:rPr sz="1050" b="1">
                 <a:solidFill>
-                  <a:srgbClr val="D6001C"/>
+                  <a:srgbClr val="B22600"/>
                 </a:solidFill>
                 <a:latin typeface="Microsoft YaHei"/>
                 <a:ea typeface="Microsoft YaHei"/>
@@ -12528,7 +12528,7 @@
             <a:pPr algn="l">
               <a:defRPr sz="975" b="1">
                 <a:solidFill>
-                  <a:srgbClr val="D6001C"/>
+                  <a:srgbClr val="B22600"/>
                 </a:solidFill>
                 <a:latin typeface="Microsoft YaHei"/>
                 <a:ea typeface="Microsoft YaHei"/>
@@ -12538,7 +12538,7 @@
             <a:r>
               <a:rPr sz="975" b="1">
                 <a:solidFill>
-                  <a:srgbClr val="D6001C"/>
+                  <a:srgbClr val="B22600"/>
                 </a:solidFill>
                 <a:latin typeface="Microsoft YaHei"/>
                 <a:ea typeface="Microsoft YaHei"/>
@@ -12644,7 +12644,7 @@
             <a:pPr algn="l">
               <a:defRPr sz="1200" b="0">
                 <a:solidFill>
-                  <a:srgbClr val="5F646B"/>
+                  <a:srgbClr val="6F6F6A"/>
                 </a:solidFill>
                 <a:latin typeface="Microsoft YaHei"/>
                 <a:ea typeface="Microsoft YaHei"/>
@@ -12654,7 +12654,7 @@
             <a:r>
               <a:rPr sz="1200" b="0">
                 <a:solidFill>
-                  <a:srgbClr val="5F646B"/>
+                  <a:srgbClr val="6F6F6A"/>
                 </a:solidFill>
                 <a:latin typeface="Microsoft YaHei"/>
                 <a:ea typeface="Microsoft YaHei"/>
@@ -12690,7 +12690,7 @@
           <a:noFill/>
           <a:ln w="9525">
             <a:solidFill>
-              <a:srgbClr val="D8DCE0"/>
+              <a:srgbClr val="F7F7F8"/>
             </a:solidFill>
             <a:prstDash val="solid"/>
           </a:ln>
@@ -12719,7 +12719,7 @@
             <a:avLst/>
           </a:prstGeom>
           <a:solidFill>
-            <a:srgbClr val="E9ECEF"/>
+            <a:srgbClr val="F7F7F8"/>
           </a:solidFill>
           <a:ln w="0">
             <a:noFill/>
@@ -12764,7 +12764,7 @@
             <a:pPr algn="l">
               <a:defRPr sz="2175" b="1">
                 <a:solidFill>
-                  <a:srgbClr val="4C5258"/>
+                  <a:srgbClr val="505046"/>
                 </a:solidFill>
                 <a:latin typeface="Microsoft YaHei"/>
                 <a:ea typeface="Microsoft YaHei"/>
@@ -12774,7 +12774,7 @@
             <a:r>
               <a:rPr sz="2175" b="1">
                 <a:solidFill>
-                  <a:srgbClr val="4C5258"/>
+                  <a:srgbClr val="505046"/>
                 </a:solidFill>
                 <a:latin typeface="Microsoft YaHei"/>
                 <a:ea typeface="Microsoft YaHei"/>
@@ -12822,7 +12822,7 @@
             <a:pPr algn="l">
               <a:defRPr sz="1875" b="1">
                 <a:solidFill>
-                  <a:srgbClr val="4C5258"/>
+                  <a:srgbClr val="505046"/>
                 </a:solidFill>
                 <a:latin typeface="Microsoft YaHei"/>
                 <a:ea typeface="Microsoft YaHei"/>
@@ -12832,7 +12832,7 @@
             <a:r>
               <a:rPr sz="1875" b="1">
                 <a:solidFill>
-                  <a:srgbClr val="4C5258"/>
+                  <a:srgbClr val="505046"/>
                 </a:solidFill>
                 <a:latin typeface="Microsoft YaHei"/>
                 <a:ea typeface="Microsoft YaHei"/>
@@ -12880,7 +12880,7 @@
             <a:pPr algn="l">
               <a:defRPr sz="1200" b="1">
                 <a:solidFill>
-                  <a:srgbClr val="4C5258"/>
+                  <a:srgbClr val="505046"/>
                 </a:solidFill>
                 <a:latin typeface="Microsoft YaHei"/>
                 <a:ea typeface="Microsoft YaHei"/>
@@ -12890,7 +12890,7 @@
             <a:r>
               <a:rPr sz="1200" b="1">
                 <a:solidFill>
-                  <a:srgbClr val="4C5258"/>
+                  <a:srgbClr val="505046"/>
                 </a:solidFill>
                 <a:latin typeface="Microsoft YaHei"/>
                 <a:ea typeface="Microsoft YaHei"/>
@@ -12938,7 +12938,7 @@
             <a:pPr algn="l">
               <a:defRPr sz="1050" b="0">
                 <a:solidFill>
-                  <a:srgbClr val="4C5258"/>
+                  <a:srgbClr val="505046"/>
                 </a:solidFill>
                 <a:latin typeface="Microsoft YaHei"/>
                 <a:ea typeface="Microsoft YaHei"/>
@@ -12948,7 +12948,7 @@
             <a:r>
               <a:rPr sz="1050" b="0">
                 <a:solidFill>
-                  <a:srgbClr val="4C5258"/>
+                  <a:srgbClr val="505046"/>
                 </a:solidFill>
                 <a:latin typeface="Microsoft YaHei"/>
                 <a:ea typeface="Microsoft YaHei"/>
@@ -12982,7 +12982,7 @@
             <a:avLst/>
           </a:prstGeom>
           <a:solidFill>
-            <a:srgbClr val="D9DEE3"/>
+            <a:srgbClr val="F7F7F8"/>
           </a:solidFill>
           <a:ln w="0">
             <a:noFill/>
@@ -13027,7 +13027,7 @@
             <a:pPr algn="l">
               <a:defRPr sz="2175" b="1">
                 <a:solidFill>
-                  <a:srgbClr val="343A40"/>
+                  <a:srgbClr val="505046"/>
                 </a:solidFill>
                 <a:latin typeface="Microsoft YaHei"/>
                 <a:ea typeface="Microsoft YaHei"/>
@@ -13037,7 +13037,7 @@
             <a:r>
               <a:rPr sz="2175" b="1">
                 <a:solidFill>
-                  <a:srgbClr val="343A40"/>
+                  <a:srgbClr val="505046"/>
                 </a:solidFill>
                 <a:latin typeface="Microsoft YaHei"/>
                 <a:ea typeface="Microsoft YaHei"/>
@@ -13085,7 +13085,7 @@
             <a:pPr algn="l">
               <a:defRPr sz="1875" b="1">
                 <a:solidFill>
-                  <a:srgbClr val="343A40"/>
+                  <a:srgbClr val="505046"/>
                 </a:solidFill>
                 <a:latin typeface="Microsoft YaHei"/>
                 <a:ea typeface="Microsoft YaHei"/>
@@ -13095,7 +13095,7 @@
             <a:r>
               <a:rPr sz="1875" b="1">
                 <a:solidFill>
-                  <a:srgbClr val="343A40"/>
+                  <a:srgbClr val="505046"/>
                 </a:solidFill>
                 <a:latin typeface="Microsoft YaHei"/>
                 <a:ea typeface="Microsoft YaHei"/>
@@ -13143,7 +13143,7 @@
             <a:pPr algn="l">
               <a:defRPr sz="1200" b="1">
                 <a:solidFill>
-                  <a:srgbClr val="343A40"/>
+                  <a:srgbClr val="505046"/>
                 </a:solidFill>
                 <a:latin typeface="Microsoft YaHei"/>
                 <a:ea typeface="Microsoft YaHei"/>
@@ -13153,7 +13153,7 @@
             <a:r>
               <a:rPr sz="1200" b="1">
                 <a:solidFill>
-                  <a:srgbClr val="343A40"/>
+                  <a:srgbClr val="505046"/>
                 </a:solidFill>
                 <a:latin typeface="Microsoft YaHei"/>
                 <a:ea typeface="Microsoft YaHei"/>
@@ -13201,7 +13201,7 @@
             <a:pPr algn="l">
               <a:defRPr sz="1050" b="0">
                 <a:solidFill>
-                  <a:srgbClr val="343A40"/>
+                  <a:srgbClr val="505046"/>
                 </a:solidFill>
                 <a:latin typeface="Microsoft YaHei"/>
                 <a:ea typeface="Microsoft YaHei"/>
@@ -13211,7 +13211,7 @@
             <a:r>
               <a:rPr sz="1050" b="0">
                 <a:solidFill>
-                  <a:srgbClr val="343A40"/>
+                  <a:srgbClr val="505046"/>
                 </a:solidFill>
                 <a:latin typeface="Microsoft YaHei"/>
                 <a:ea typeface="Microsoft YaHei"/>
@@ -13245,7 +13245,7 @@
             <a:avLst/>
           </a:prstGeom>
           <a:solidFill>
-            <a:srgbClr val="2D3136"/>
+            <a:srgbClr val="505046"/>
           </a:solidFill>
           <a:ln w="0">
             <a:noFill/>
@@ -13508,7 +13508,7 @@
             <a:avLst/>
           </a:prstGeom>
           <a:solidFill>
-            <a:srgbClr val="D6001C"/>
+            <a:srgbClr val="B22600"/>
           </a:solidFill>
           <a:ln w="0">
             <a:noFill/>
@@ -13843,7 +13843,7 @@
             <a:pPr algn="l">
               <a:defRPr sz="975" b="0">
                 <a:solidFill>
-                  <a:srgbClr val="5F646B"/>
+                  <a:srgbClr val="6F6F6A"/>
                 </a:solidFill>
                 <a:latin typeface="Microsoft YaHei"/>
                 <a:ea typeface="Microsoft YaHei"/>
@@ -13853,7 +13853,7 @@
             <a:r>
               <a:rPr sz="975" b="0">
                 <a:solidFill>
-                  <a:srgbClr val="5F646B"/>
+                  <a:srgbClr val="6F6F6A"/>
                 </a:solidFill>
                 <a:latin typeface="Microsoft YaHei"/>
                 <a:ea typeface="Microsoft YaHei"/>
@@ -13901,7 +13901,7 @@
             <a:pPr algn="r">
               <a:defRPr sz="1050" b="1">
                 <a:solidFill>
-                  <a:srgbClr val="D6001C"/>
+                  <a:srgbClr val="B22600"/>
                 </a:solidFill>
                 <a:latin typeface="Microsoft YaHei"/>
                 <a:ea typeface="Microsoft YaHei"/>
@@ -13911,7 +13911,7 @@
             <a:r>
               <a:rPr sz="1050" b="1">
                 <a:solidFill>
-                  <a:srgbClr val="D6001C"/>
+                  <a:srgbClr val="B22600"/>
                 </a:solidFill>
                 <a:latin typeface="Microsoft YaHei"/>
                 <a:ea typeface="Microsoft YaHei"/>
@@ -13989,7 +13989,7 @@
             <a:pPr algn="l">
               <a:defRPr sz="975" b="1">
                 <a:solidFill>
-                  <a:srgbClr val="D6001C"/>
+                  <a:srgbClr val="B22600"/>
                 </a:solidFill>
                 <a:latin typeface="Microsoft YaHei"/>
                 <a:ea typeface="Microsoft YaHei"/>
@@ -13999,7 +13999,7 @@
             <a:r>
               <a:rPr sz="975" b="1">
                 <a:solidFill>
-                  <a:srgbClr val="D6001C"/>
+                  <a:srgbClr val="B22600"/>
                 </a:solidFill>
                 <a:latin typeface="Microsoft YaHei"/>
                 <a:ea typeface="Microsoft YaHei"/>
@@ -14105,7 +14105,7 @@
             <a:pPr algn="l">
               <a:defRPr sz="1200" b="0">
                 <a:solidFill>
-                  <a:srgbClr val="5F646B"/>
+                  <a:srgbClr val="6F6F6A"/>
                 </a:solidFill>
                 <a:latin typeface="Microsoft YaHei"/>
                 <a:ea typeface="Microsoft YaHei"/>
@@ -14115,7 +14115,7 @@
             <a:r>
               <a:rPr sz="1200" b="0">
                 <a:solidFill>
-                  <a:srgbClr val="5F646B"/>
+                  <a:srgbClr val="6F6F6A"/>
                 </a:solidFill>
                 <a:latin typeface="Microsoft YaHei"/>
                 <a:ea typeface="Microsoft YaHei"/>
@@ -14151,7 +14151,7 @@
           <a:noFill/>
           <a:ln w="9525">
             <a:solidFill>
-              <a:srgbClr val="D8DCE0"/>
+              <a:srgbClr val="F7F7F8"/>
             </a:solidFill>
             <a:prstDash val="solid"/>
           </a:ln>
@@ -14180,11 +14180,11 @@
             <a:avLst/>
           </a:prstGeom>
           <a:solidFill>
-            <a:srgbClr val="FFF8D8"/>
+            <a:srgbClr val="F7F7F8"/>
           </a:solidFill>
           <a:ln w="9525">
             <a:solidFill>
-              <a:srgbClr val="E7CC67"/>
+              <a:srgbClr val="FFBD47"/>
             </a:solidFill>
             <a:prstDash val="solid"/>
           </a:ln>
@@ -14306,11 +14306,11 @@
             <a:avLst/>
           </a:prstGeom>
           <a:solidFill>
-            <a:srgbClr val="FFF3B8"/>
+            <a:srgbClr val="F7F7F8"/>
           </a:solidFill>
           <a:ln w="9525">
             <a:solidFill>
-              <a:srgbClr val="E7CC67"/>
+              <a:srgbClr val="FFBD47"/>
             </a:solidFill>
             <a:prstDash val="solid"/>
           </a:ln>
@@ -14432,11 +14432,11 @@
             <a:avLst/>
           </a:prstGeom>
           <a:solidFill>
-            <a:srgbClr val="FFF8D8"/>
+            <a:srgbClr val="F7F7F8"/>
           </a:solidFill>
           <a:ln w="9525">
             <a:solidFill>
-              <a:srgbClr val="E7CC67"/>
+              <a:srgbClr val="FFBD47"/>
             </a:solidFill>
             <a:prstDash val="solid"/>
           </a:ln>
@@ -14558,11 +14558,11 @@
             <a:avLst/>
           </a:prstGeom>
           <a:solidFill>
-            <a:srgbClr val="FFF3B8"/>
+            <a:srgbClr val="F7F7F8"/>
           </a:solidFill>
           <a:ln w="9525">
             <a:solidFill>
-              <a:srgbClr val="E7CC67"/>
+              <a:srgbClr val="FFBD47"/>
             </a:solidFill>
             <a:prstDash val="solid"/>
           </a:ln>
@@ -14684,11 +14684,11 @@
             <a:avLst/>
           </a:prstGeom>
           <a:solidFill>
-            <a:srgbClr val="FFF8D8"/>
+            <a:srgbClr val="F7F7F8"/>
           </a:solidFill>
           <a:ln w="9525">
             <a:solidFill>
-              <a:srgbClr val="E7CC67"/>
+              <a:srgbClr val="FFBD47"/>
             </a:solidFill>
             <a:prstDash val="solid"/>
           </a:ln>
@@ -14810,11 +14810,11 @@
             <a:avLst/>
           </a:prstGeom>
           <a:solidFill>
-            <a:srgbClr val="FFF3B8"/>
+            <a:srgbClr val="F7F7F8"/>
           </a:solidFill>
           <a:ln w="9525">
             <a:solidFill>
-              <a:srgbClr val="E7CC67"/>
+              <a:srgbClr val="FFBD47"/>
             </a:solidFill>
             <a:prstDash val="solid"/>
           </a:ln>
@@ -14936,11 +14936,11 @@
             <a:avLst/>
           </a:prstGeom>
           <a:solidFill>
-            <a:srgbClr val="FFF8D8"/>
+            <a:srgbClr val="F7F7F8"/>
           </a:solidFill>
           <a:ln w="9525">
             <a:solidFill>
-              <a:srgbClr val="E7CC67"/>
+              <a:srgbClr val="FFBD47"/>
             </a:solidFill>
             <a:prstDash val="solid"/>
           </a:ln>
@@ -15062,11 +15062,11 @@
             <a:avLst/>
           </a:prstGeom>
           <a:solidFill>
-            <a:srgbClr val="FFF3B8"/>
+            <a:srgbClr val="F7F7F8"/>
           </a:solidFill>
           <a:ln w="9525">
             <a:solidFill>
-              <a:srgbClr val="E7CC67"/>
+              <a:srgbClr val="FFBD47"/>
             </a:solidFill>
             <a:prstDash val="solid"/>
           </a:ln>
@@ -15188,7 +15188,7 @@
             <a:avLst/>
           </a:prstGeom>
           <a:solidFill>
-            <a:srgbClr val="D6001C"/>
+            <a:srgbClr val="B22600"/>
           </a:solidFill>
           <a:ln w="0">
             <a:noFill/>
@@ -15221,11 +15221,11 @@
             </a:avLst>
           </a:prstGeom>
           <a:solidFill>
-            <a:srgbClr val="FFF0F2"/>
+            <a:srgbClr val="F7F7F8"/>
           </a:solidFill>
           <a:ln w="19050">
             <a:solidFill>
-              <a:srgbClr val="D6001C"/>
+              <a:srgbClr val="B22600"/>
             </a:solidFill>
             <a:prstDash val="solid"/>
           </a:ln>
@@ -15268,7 +15268,7 @@
             <a:pPr algn="ctr">
               <a:defRPr sz="1650" b="1">
                 <a:solidFill>
-                  <a:srgbClr val="D6001C"/>
+                  <a:srgbClr val="B22600"/>
                 </a:solidFill>
                 <a:latin typeface="Microsoft YaHei"/>
                 <a:ea typeface="Microsoft YaHei"/>
@@ -15278,7 +15278,7 @@
             <a:r>
               <a:rPr sz="1650" b="1">
                 <a:solidFill>
-                  <a:srgbClr val="D6001C"/>
+                  <a:srgbClr val="B22600"/>
                 </a:solidFill>
                 <a:latin typeface="Microsoft YaHei"/>
                 <a:ea typeface="Microsoft YaHei"/>
@@ -15372,11 +15372,11 @@
             </a:avLst>
           </a:prstGeom>
           <a:solidFill>
-            <a:srgbClr val="EAF2FA"/>
+            <a:srgbClr val="F7F7F8"/>
           </a:solidFill>
           <a:ln w="19050">
             <a:solidFill>
-              <a:srgbClr val="246AA8"/>
+              <a:srgbClr val="505046"/>
             </a:solidFill>
             <a:prstDash val="solid"/>
           </a:ln>
@@ -15419,7 +15419,7 @@
             <a:pPr algn="ctr">
               <a:defRPr sz="1650" b="1">
                 <a:solidFill>
-                  <a:srgbClr val="246AA8"/>
+                  <a:srgbClr val="505046"/>
                 </a:solidFill>
                 <a:latin typeface="Microsoft YaHei"/>
                 <a:ea typeface="Microsoft YaHei"/>
@@ -15429,7 +15429,7 @@
             <a:r>
               <a:rPr sz="1650" b="1">
                 <a:solidFill>
-                  <a:srgbClr val="246AA8"/>
+                  <a:srgbClr val="505046"/>
                 </a:solidFill>
                 <a:latin typeface="Microsoft YaHei"/>
                 <a:ea typeface="Microsoft YaHei"/>
@@ -15523,11 +15523,11 @@
             </a:avLst>
           </a:prstGeom>
           <a:solidFill>
-            <a:srgbClr val="FFF4DC"/>
+            <a:srgbClr val="F7F7F8"/>
           </a:solidFill>
           <a:ln w="19050">
             <a:solidFill>
-              <a:srgbClr val="B87700"/>
+              <a:srgbClr val="FFBD47"/>
             </a:solidFill>
             <a:prstDash val="solid"/>
           </a:ln>
@@ -15570,7 +15570,7 @@
             <a:pPr algn="ctr">
               <a:defRPr sz="1650" b="1">
                 <a:solidFill>
-                  <a:srgbClr val="B87700"/>
+                  <a:srgbClr val="FFBD47"/>
                 </a:solidFill>
                 <a:latin typeface="Microsoft YaHei"/>
                 <a:ea typeface="Microsoft YaHei"/>
@@ -15580,7 +15580,7 @@
             <a:r>
               <a:rPr sz="1650" b="1">
                 <a:solidFill>
-                  <a:srgbClr val="B87700"/>
+                  <a:srgbClr val="FFBD47"/>
                 </a:solidFill>
                 <a:latin typeface="Microsoft YaHei"/>
                 <a:ea typeface="Microsoft YaHei"/>
@@ -15674,11 +15674,11 @@
             </a:avLst>
           </a:prstGeom>
           <a:solidFill>
-            <a:srgbClr val="EAF5F1"/>
+            <a:srgbClr val="F7F7F8"/>
           </a:solidFill>
           <a:ln w="19050">
             <a:solidFill>
-              <a:srgbClr val="26866A"/>
+              <a:srgbClr val="E84C22"/>
             </a:solidFill>
             <a:prstDash val="solid"/>
           </a:ln>
@@ -15721,7 +15721,7 @@
             <a:pPr algn="ctr">
               <a:defRPr sz="1650" b="1">
                 <a:solidFill>
-                  <a:srgbClr val="26866A"/>
+                  <a:srgbClr val="E84C22"/>
                 </a:solidFill>
                 <a:latin typeface="Microsoft YaHei"/>
                 <a:ea typeface="Microsoft YaHei"/>
@@ -15731,7 +15731,7 @@
             <a:r>
               <a:rPr sz="1650" b="1">
                 <a:solidFill>
-                  <a:srgbClr val="26866A"/>
+                  <a:srgbClr val="E84C22"/>
                 </a:solidFill>
                 <a:latin typeface="Microsoft YaHei"/>
                 <a:ea typeface="Microsoft YaHei"/>
@@ -15837,7 +15837,7 @@
             <a:pPr algn="l">
               <a:defRPr sz="975" b="0">
                 <a:solidFill>
-                  <a:srgbClr val="5F646B"/>
+                  <a:srgbClr val="6F6F6A"/>
                 </a:solidFill>
                 <a:latin typeface="Microsoft YaHei"/>
                 <a:ea typeface="Microsoft YaHei"/>
@@ -15847,7 +15847,7 @@
             <a:r>
               <a:rPr sz="975" b="0">
                 <a:solidFill>
-                  <a:srgbClr val="5F646B"/>
+                  <a:srgbClr val="6F6F6A"/>
                 </a:solidFill>
                 <a:latin typeface="Microsoft YaHei"/>
                 <a:ea typeface="Microsoft YaHei"/>
@@ -15895,7 +15895,7 @@
             <a:pPr algn="r">
               <a:defRPr sz="1050" b="1">
                 <a:solidFill>
-                  <a:srgbClr val="D6001C"/>
+                  <a:srgbClr val="B22600"/>
                 </a:solidFill>
                 <a:latin typeface="Microsoft YaHei"/>
                 <a:ea typeface="Microsoft YaHei"/>
@@ -15905,7 +15905,7 @@
             <a:r>
               <a:rPr sz="1050" b="1">
                 <a:solidFill>
-                  <a:srgbClr val="D6001C"/>
+                  <a:srgbClr val="B22600"/>
                 </a:solidFill>
                 <a:latin typeface="Microsoft YaHei"/>
                 <a:ea typeface="Microsoft YaHei"/>
@@ -15983,7 +15983,7 @@
             <a:pPr algn="l">
               <a:defRPr sz="975" b="1">
                 <a:solidFill>
-                  <a:srgbClr val="D6001C"/>
+                  <a:srgbClr val="B22600"/>
                 </a:solidFill>
                 <a:latin typeface="Microsoft YaHei"/>
                 <a:ea typeface="Microsoft YaHei"/>
@@ -15993,7 +15993,7 @@
             <a:r>
               <a:rPr sz="975" b="1">
                 <a:solidFill>
-                  <a:srgbClr val="D6001C"/>
+                  <a:srgbClr val="B22600"/>
                 </a:solidFill>
                 <a:latin typeface="Microsoft YaHei"/>
                 <a:ea typeface="Microsoft YaHei"/>
@@ -16099,7 +16099,7 @@
             <a:pPr algn="l">
               <a:defRPr sz="1200" b="0">
                 <a:solidFill>
-                  <a:srgbClr val="5F646B"/>
+                  <a:srgbClr val="6F6F6A"/>
                 </a:solidFill>
                 <a:latin typeface="Microsoft YaHei"/>
                 <a:ea typeface="Microsoft YaHei"/>
@@ -16109,7 +16109,7 @@
             <a:r>
               <a:rPr sz="1200" b="0">
                 <a:solidFill>
-                  <a:srgbClr val="5F646B"/>
+                  <a:srgbClr val="6F6F6A"/>
                 </a:solidFill>
                 <a:latin typeface="Microsoft YaHei"/>
                 <a:ea typeface="Microsoft YaHei"/>
@@ -16145,7 +16145,7 @@
           <a:noFill/>
           <a:ln w="9525">
             <a:solidFill>
-              <a:srgbClr val="D8DCE0"/>
+              <a:srgbClr val="F7F7F8"/>
             </a:solidFill>
             <a:prstDash val="solid"/>
           </a:ln>
@@ -16176,7 +16176,7 @@
           <a:noFill/>
           <a:ln w="38100">
             <a:solidFill>
-              <a:srgbClr val="D6001C"/>
+              <a:srgbClr val="B22600"/>
             </a:solidFill>
             <a:prstDash val="solid"/>
           </a:ln>
@@ -16205,7 +16205,7 @@
             <a:avLst/>
           </a:prstGeom>
           <a:solidFill>
-            <a:srgbClr val="246AA8"/>
+            <a:srgbClr val="505046"/>
           </a:solidFill>
           <a:ln w="0">
             <a:noFill/>
@@ -16308,7 +16308,7 @@
             <a:pPr algn="r">
               <a:defRPr sz="1650" b="1">
                 <a:solidFill>
-                  <a:srgbClr val="246AA8"/>
+                  <a:srgbClr val="505046"/>
                 </a:solidFill>
                 <a:latin typeface="Microsoft YaHei"/>
                 <a:ea typeface="Microsoft YaHei"/>
@@ -16318,7 +16318,7 @@
             <a:r>
               <a:rPr sz="1650" b="1">
                 <a:solidFill>
-                  <a:srgbClr val="246AA8"/>
+                  <a:srgbClr val="505046"/>
                 </a:solidFill>
                 <a:latin typeface="Microsoft YaHei"/>
                 <a:ea typeface="Microsoft YaHei"/>
@@ -16412,11 +16412,11 @@
             </a:avLst>
           </a:prstGeom>
           <a:solidFill>
-            <a:srgbClr val="EAF2FA"/>
+            <a:srgbClr val="F7F7F8"/>
           </a:solidFill>
           <a:ln w="14288">
             <a:solidFill>
-              <a:srgbClr val="246AA8"/>
+              <a:srgbClr val="505046"/>
             </a:solidFill>
             <a:prstDash val="solid"/>
           </a:ln>
@@ -16459,7 +16459,7 @@
             <a:pPr algn="l">
               <a:defRPr sz="1275" b="1">
                 <a:solidFill>
-                  <a:srgbClr val="246AA8"/>
+                  <a:srgbClr val="505046"/>
                 </a:solidFill>
                 <a:latin typeface="Microsoft YaHei"/>
                 <a:ea typeface="Microsoft YaHei"/>
@@ -16469,7 +16469,7 @@
             <a:r>
               <a:rPr sz="1275" b="1">
                 <a:solidFill>
-                  <a:srgbClr val="246AA8"/>
+                  <a:srgbClr val="505046"/>
                 </a:solidFill>
                 <a:latin typeface="Microsoft YaHei"/>
                 <a:ea typeface="Microsoft YaHei"/>
@@ -16503,7 +16503,7 @@
             <a:avLst/>
           </a:prstGeom>
           <a:solidFill>
-            <a:srgbClr val="D6001C"/>
+            <a:srgbClr val="B22600"/>
           </a:solidFill>
           <a:ln w="0">
             <a:noFill/>
@@ -16606,7 +16606,7 @@
             <a:pPr algn="r">
               <a:defRPr sz="1650" b="1">
                 <a:solidFill>
-                  <a:srgbClr val="D6001C"/>
+                  <a:srgbClr val="B22600"/>
                 </a:solidFill>
                 <a:latin typeface="Microsoft YaHei"/>
                 <a:ea typeface="Microsoft YaHei"/>
@@ -16616,7 +16616,7 @@
             <a:r>
               <a:rPr sz="1650" b="1">
                 <a:solidFill>
-                  <a:srgbClr val="D6001C"/>
+                  <a:srgbClr val="B22600"/>
                 </a:solidFill>
                 <a:latin typeface="Microsoft YaHei"/>
                 <a:ea typeface="Microsoft YaHei"/>
@@ -16710,11 +16710,11 @@
             </a:avLst>
           </a:prstGeom>
           <a:solidFill>
-            <a:srgbClr val="FFF0F2"/>
+            <a:srgbClr val="F7F7F8"/>
           </a:solidFill>
           <a:ln w="14288">
             <a:solidFill>
-              <a:srgbClr val="D6001C"/>
+              <a:srgbClr val="B22600"/>
             </a:solidFill>
             <a:prstDash val="solid"/>
           </a:ln>
@@ -16757,7 +16757,7 @@
             <a:pPr algn="l">
               <a:defRPr sz="1275" b="1">
                 <a:solidFill>
-                  <a:srgbClr val="D6001C"/>
+                  <a:srgbClr val="B22600"/>
                 </a:solidFill>
                 <a:latin typeface="Microsoft YaHei"/>
                 <a:ea typeface="Microsoft YaHei"/>
@@ -16767,7 +16767,7 @@
             <a:r>
               <a:rPr sz="1275" b="1">
                 <a:solidFill>
-                  <a:srgbClr val="D6001C"/>
+                  <a:srgbClr val="B22600"/>
                 </a:solidFill>
                 <a:latin typeface="Microsoft YaHei"/>
                 <a:ea typeface="Microsoft YaHei"/>
@@ -16801,7 +16801,7 @@
             <a:avLst/>
           </a:prstGeom>
           <a:solidFill>
-            <a:srgbClr val="B87700"/>
+            <a:srgbClr val="FFBD47"/>
           </a:solidFill>
           <a:ln w="0">
             <a:noFill/>
@@ -16904,7 +16904,7 @@
             <a:pPr algn="r">
               <a:defRPr sz="1650" b="1">
                 <a:solidFill>
-                  <a:srgbClr val="B87700"/>
+                  <a:srgbClr val="FFBD47"/>
                 </a:solidFill>
                 <a:latin typeface="Microsoft YaHei"/>
                 <a:ea typeface="Microsoft YaHei"/>
@@ -16914,7 +16914,7 @@
             <a:r>
               <a:rPr sz="1650" b="1">
                 <a:solidFill>
-                  <a:srgbClr val="B87700"/>
+                  <a:srgbClr val="FFBD47"/>
                 </a:solidFill>
                 <a:latin typeface="Microsoft YaHei"/>
                 <a:ea typeface="Microsoft YaHei"/>
@@ -17008,11 +17008,11 @@
             </a:avLst>
           </a:prstGeom>
           <a:solidFill>
-            <a:srgbClr val="FFF4DC"/>
+            <a:srgbClr val="F7F7F8"/>
           </a:solidFill>
           <a:ln w="14288">
             <a:solidFill>
-              <a:srgbClr val="B87700"/>
+              <a:srgbClr val="FFBD47"/>
             </a:solidFill>
             <a:prstDash val="solid"/>
           </a:ln>
@@ -17055,7 +17055,7 @@
             <a:pPr algn="l">
               <a:defRPr sz="1275" b="1">
                 <a:solidFill>
-                  <a:srgbClr val="B87700"/>
+                  <a:srgbClr val="FFBD47"/>
                 </a:solidFill>
                 <a:latin typeface="Microsoft YaHei"/>
                 <a:ea typeface="Microsoft YaHei"/>
@@ -17065,7 +17065,7 @@
             <a:r>
               <a:rPr sz="1275" b="1">
                 <a:solidFill>
-                  <a:srgbClr val="B87700"/>
+                  <a:srgbClr val="FFBD47"/>
                 </a:solidFill>
                 <a:latin typeface="Microsoft YaHei"/>
                 <a:ea typeface="Microsoft YaHei"/>
@@ -17099,7 +17099,7 @@
             <a:avLst/>
           </a:prstGeom>
           <a:solidFill>
-            <a:srgbClr val="26866A"/>
+            <a:srgbClr val="E84C22"/>
           </a:solidFill>
           <a:ln w="0">
             <a:noFill/>
@@ -17202,7 +17202,7 @@
             <a:pPr algn="r">
               <a:defRPr sz="1650" b="1">
                 <a:solidFill>
-                  <a:srgbClr val="26866A"/>
+                  <a:srgbClr val="E84C22"/>
                 </a:solidFill>
                 <a:latin typeface="Microsoft YaHei"/>
                 <a:ea typeface="Microsoft YaHei"/>
@@ -17212,7 +17212,7 @@
             <a:r>
               <a:rPr sz="1650" b="1">
                 <a:solidFill>
-                  <a:srgbClr val="26866A"/>
+                  <a:srgbClr val="E84C22"/>
                 </a:solidFill>
                 <a:latin typeface="Microsoft YaHei"/>
                 <a:ea typeface="Microsoft YaHei"/>
@@ -17306,11 +17306,11 @@
             </a:avLst>
           </a:prstGeom>
           <a:solidFill>
-            <a:srgbClr val="EAF5F1"/>
+            <a:srgbClr val="F7F7F8"/>
           </a:solidFill>
           <a:ln w="14288">
             <a:solidFill>
-              <a:srgbClr val="26866A"/>
+              <a:srgbClr val="E84C22"/>
             </a:solidFill>
             <a:prstDash val="solid"/>
           </a:ln>
@@ -17353,7 +17353,7 @@
             <a:pPr algn="l">
               <a:defRPr sz="1275" b="1">
                 <a:solidFill>
-                  <a:srgbClr val="26866A"/>
+                  <a:srgbClr val="E84C22"/>
                 </a:solidFill>
                 <a:latin typeface="Microsoft YaHei"/>
                 <a:ea typeface="Microsoft YaHei"/>
@@ -17363,7 +17363,7 @@
             <a:r>
               <a:rPr sz="1275" b="1">
                 <a:solidFill>
-                  <a:srgbClr val="26866A"/>
+                  <a:srgbClr val="E84C22"/>
                 </a:solidFill>
                 <a:latin typeface="Microsoft YaHei"/>
                 <a:ea typeface="Microsoft YaHei"/>
@@ -17604,7 +17604,7 @@
             </a:avLst>
           </a:prstGeom>
           <a:solidFill>
-            <a:srgbClr val="F4F5F6"/>
+            <a:srgbClr val="F7F7F8"/>
           </a:solidFill>
           <a:ln w="14288">
             <a:solidFill>
@@ -17709,7 +17709,7 @@
             <a:pPr algn="l">
               <a:defRPr sz="1275" b="0">
                 <a:solidFill>
-                  <a:srgbClr val="5F646B"/>
+                  <a:srgbClr val="6F6F6A"/>
                 </a:solidFill>
                 <a:latin typeface="Microsoft YaHei"/>
                 <a:ea typeface="Microsoft YaHei"/>
@@ -17719,7 +17719,7 @@
             <a:r>
               <a:rPr sz="1275" b="0">
                 <a:solidFill>
-                  <a:srgbClr val="5F646B"/>
+                  <a:srgbClr val="6F6F6A"/>
                 </a:solidFill>
                 <a:latin typeface="Microsoft YaHei"/>
                 <a:ea typeface="Microsoft YaHei"/>
@@ -17767,7 +17767,7 @@
             <a:pPr algn="l">
               <a:defRPr sz="975" b="0">
                 <a:solidFill>
-                  <a:srgbClr val="5F646B"/>
+                  <a:srgbClr val="6F6F6A"/>
                 </a:solidFill>
                 <a:latin typeface="Microsoft YaHei"/>
                 <a:ea typeface="Microsoft YaHei"/>
@@ -17777,7 +17777,7 @@
             <a:r>
               <a:rPr sz="975" b="0">
                 <a:solidFill>
-                  <a:srgbClr val="5F646B"/>
+                  <a:srgbClr val="6F6F6A"/>
                 </a:solidFill>
                 <a:latin typeface="Microsoft YaHei"/>
                 <a:ea typeface="Microsoft YaHei"/>
@@ -17825,7 +17825,7 @@
             <a:pPr algn="r">
               <a:defRPr sz="1050" b="1">
                 <a:solidFill>
-                  <a:srgbClr val="D6001C"/>
+                  <a:srgbClr val="B22600"/>
                 </a:solidFill>
                 <a:latin typeface="Microsoft YaHei"/>
                 <a:ea typeface="Microsoft YaHei"/>
@@ -17835,7 +17835,7 @@
             <a:r>
               <a:rPr sz="1050" b="1">
                 <a:solidFill>
-                  <a:srgbClr val="D6001C"/>
+                  <a:srgbClr val="B22600"/>
                 </a:solidFill>
                 <a:latin typeface="Microsoft YaHei"/>
                 <a:ea typeface="Microsoft YaHei"/>
@@ -17907,7 +17907,7 @@
             <a:r>
               <a:rPr lang="zh-CN" altLang="en-US" sz="2600" b="1">
                 <a:solidFill>
-                  <a:srgbClr val="172A3A"/>
+                  <a:srgbClr val="505046"/>
                 </a:solidFill>
                 <a:latin typeface="Microsoft YaHei" panose="020B0503020204020204" pitchFamily="34" charset="-122"/>
                 <a:ea typeface="Microsoft YaHei" panose="020B0503020204020204" pitchFamily="34" charset="-122"/>
@@ -17917,7 +17917,7 @@
             <a:r>
               <a:rPr lang="en-US" altLang="zh-CN" sz="2600" b="1">
                 <a:solidFill>
-                  <a:srgbClr val="172A3A"/>
+                  <a:srgbClr val="505046"/>
                 </a:solidFill>
                 <a:latin typeface="Microsoft YaHei" panose="020B0503020204020204" pitchFamily="34" charset="-122"/>
                 <a:ea typeface="Microsoft YaHei" panose="020B0503020204020204" pitchFamily="34" charset="-122"/>
@@ -17927,7 +17927,7 @@
             <a:r>
               <a:rPr lang="zh-CN" altLang="en-US" sz="2600" b="1">
                 <a:solidFill>
-                  <a:srgbClr val="172A3A"/>
+                  <a:srgbClr val="505046"/>
                 </a:solidFill>
                 <a:latin typeface="Microsoft YaHei" panose="020B0503020204020204" pitchFamily="34" charset="-122"/>
                 <a:ea typeface="Microsoft YaHei" panose="020B0503020204020204" pitchFamily="34" charset="-122"/>
@@ -17968,7 +17968,7 @@
             <a:r>
               <a:rPr lang="zh-CN" altLang="en-US" sz="1400">
                 <a:solidFill>
-                  <a:srgbClr val="66747C"/>
+                  <a:srgbClr val="6F6F6A"/>
                 </a:solidFill>
                 <a:latin typeface="Microsoft YaHei" panose="020B0503020204020204" pitchFamily="34" charset="-122"/>
                 <a:ea typeface="Microsoft YaHei" panose="020B0503020204020204" pitchFamily="34" charset="-122"/>
@@ -17978,7 +17978,7 @@
             <a:r>
               <a:rPr lang="en-US" altLang="zh-CN" sz="1400">
                 <a:solidFill>
-                  <a:srgbClr val="66747C"/>
+                  <a:srgbClr val="6F6F6A"/>
                 </a:solidFill>
                 <a:latin typeface="Microsoft YaHei" panose="020B0503020204020204" pitchFamily="34" charset="-122"/>
                 <a:ea typeface="Microsoft YaHei" panose="020B0503020204020204" pitchFamily="34" charset="-122"/>
@@ -17988,7 +17988,7 @@
             <a:r>
               <a:rPr lang="zh-CN" altLang="en-US" sz="1400">
                 <a:solidFill>
-                  <a:srgbClr val="66747C"/>
+                  <a:srgbClr val="6F6F6A"/>
                 </a:solidFill>
                 <a:latin typeface="Microsoft YaHei" panose="020B0503020204020204" pitchFamily="34" charset="-122"/>
                 <a:ea typeface="Microsoft YaHei" panose="020B0503020204020204" pitchFamily="34" charset="-122"/>
@@ -17998,7 +17998,7 @@
             <a:r>
               <a:rPr lang="en-US" altLang="zh-CN" sz="1400">
                 <a:solidFill>
-                  <a:srgbClr val="66747C"/>
+                  <a:srgbClr val="6F6F6A"/>
                 </a:solidFill>
                 <a:latin typeface="Microsoft YaHei" panose="020B0503020204020204" pitchFamily="34" charset="-122"/>
                 <a:ea typeface="Microsoft YaHei" panose="020B0503020204020204" pitchFamily="34" charset="-122"/>
@@ -18008,7 +18008,7 @@
             <a:r>
               <a:rPr lang="zh-CN" altLang="en-US" sz="1400">
                 <a:solidFill>
-                  <a:srgbClr val="66747C"/>
+                  <a:srgbClr val="6F6F6A"/>
                 </a:solidFill>
                 <a:latin typeface="Microsoft YaHei" panose="020B0503020204020204" pitchFamily="34" charset="-122"/>
                 <a:ea typeface="Microsoft YaHei" panose="020B0503020204020204" pitchFamily="34" charset="-122"/>
@@ -18018,7 +18018,7 @@
             <a:r>
               <a:rPr lang="en-US" altLang="zh-CN" sz="1400">
                 <a:solidFill>
-                  <a:srgbClr val="66747C"/>
+                  <a:srgbClr val="6F6F6A"/>
                 </a:solidFill>
                 <a:latin typeface="Microsoft YaHei" panose="020B0503020204020204" pitchFamily="34" charset="-122"/>
                 <a:ea typeface="Microsoft YaHei" panose="020B0503020204020204" pitchFamily="34" charset="-122"/>
@@ -18028,7 +18028,7 @@
             <a:r>
               <a:rPr lang="zh-CN" altLang="en-US" sz="1400">
                 <a:solidFill>
-                  <a:srgbClr val="66747C"/>
+                  <a:srgbClr val="6F6F6A"/>
                 </a:solidFill>
                 <a:latin typeface="Microsoft YaHei" panose="020B0503020204020204" pitchFamily="34" charset="-122"/>
                 <a:ea typeface="Microsoft YaHei" panose="020B0503020204020204" pitchFamily="34" charset="-122"/>
@@ -18038,7 +18038,7 @@
             <a:r>
               <a:rPr lang="en-US" altLang="zh-CN" sz="1400">
                 <a:solidFill>
-                  <a:srgbClr val="66747C"/>
+                  <a:srgbClr val="6F6F6A"/>
                 </a:solidFill>
                 <a:latin typeface="Microsoft YaHei" panose="020B0503020204020204" pitchFamily="34" charset="-122"/>
                 <a:ea typeface="Microsoft YaHei" panose="020B0503020204020204" pitchFamily="34" charset="-122"/>
@@ -18048,7 +18048,7 @@
             <a:r>
               <a:rPr lang="zh-CN" altLang="en-US" sz="1400">
                 <a:solidFill>
-                  <a:srgbClr val="66747C"/>
+                  <a:srgbClr val="6F6F6A"/>
                 </a:solidFill>
                 <a:latin typeface="Microsoft YaHei" panose="020B0503020204020204" pitchFamily="34" charset="-122"/>
                 <a:ea typeface="Microsoft YaHei" panose="020B0503020204020204" pitchFamily="34" charset="-122"/>
@@ -18058,7 +18058,7 @@
             <a:r>
               <a:rPr lang="en-US" altLang="zh-CN" sz="1400">
                 <a:solidFill>
-                  <a:srgbClr val="66747C"/>
+                  <a:srgbClr val="6F6F6A"/>
                 </a:solidFill>
                 <a:latin typeface="Microsoft YaHei" panose="020B0503020204020204" pitchFamily="34" charset="-122"/>
                 <a:ea typeface="Microsoft YaHei" panose="020B0503020204020204" pitchFamily="34" charset="-122"/>
@@ -18068,7 +18068,7 @@
             <a:r>
               <a:rPr lang="zh-CN" altLang="en-US" sz="1400">
                 <a:solidFill>
-                  <a:srgbClr val="66747C"/>
+                  <a:srgbClr val="6F6F6A"/>
                 </a:solidFill>
                 <a:latin typeface="Microsoft YaHei" panose="020B0503020204020204" pitchFamily="34" charset="-122"/>
                 <a:ea typeface="Microsoft YaHei" panose="020B0503020204020204" pitchFamily="34" charset="-122"/>
@@ -18109,7 +18109,7 @@
             <a:r>
               <a:rPr lang="zh-CN" altLang="en-US" sz="1300" b="1">
                 <a:solidFill>
-                  <a:srgbClr val="C61720"/>
+                  <a:srgbClr val="B22600"/>
                 </a:solidFill>
                 <a:latin typeface="Microsoft YaHei" panose="020B0503020204020204" pitchFamily="34" charset="-122"/>
                 <a:ea typeface="Microsoft YaHei" panose="020B0503020204020204" pitchFamily="34" charset="-122"/>
@@ -18150,7 +18150,7 @@
             <a:r>
               <a:rPr lang="zh-CN" altLang="en-US" sz="1300" b="1">
                 <a:solidFill>
-                  <a:srgbClr val="C61720"/>
+                  <a:srgbClr val="B22600"/>
                 </a:solidFill>
                 <a:latin typeface="Microsoft YaHei" panose="020B0503020204020204" pitchFamily="34" charset="-122"/>
                 <a:ea typeface="Microsoft YaHei" panose="020B0503020204020204" pitchFamily="34" charset="-122"/>
@@ -18191,7 +18191,7 @@
             <a:r>
               <a:rPr lang="zh-CN" altLang="en-US" sz="1300" b="1">
                 <a:solidFill>
-                  <a:srgbClr val="C61720"/>
+                  <a:srgbClr val="B22600"/>
                 </a:solidFill>
                 <a:latin typeface="Microsoft YaHei" panose="020B0503020204020204" pitchFamily="34" charset="-122"/>
                 <a:ea typeface="Microsoft YaHei" panose="020B0503020204020204" pitchFamily="34" charset="-122"/>
@@ -18232,7 +18232,7 @@
             <a:r>
               <a:rPr lang="zh-CN" altLang="en-US" sz="1300" b="1">
                 <a:solidFill>
-                  <a:srgbClr val="C61720"/>
+                  <a:srgbClr val="B22600"/>
                 </a:solidFill>
                 <a:latin typeface="Microsoft YaHei" panose="020B0503020204020204" pitchFamily="34" charset="-122"/>
                 <a:ea typeface="Microsoft YaHei" panose="020B0503020204020204" pitchFamily="34" charset="-122"/>
@@ -18273,7 +18273,7 @@
             <a:r>
               <a:rPr lang="zh-CN" altLang="en-US" sz="1300" b="1">
                 <a:solidFill>
-                  <a:srgbClr val="C61720"/>
+                  <a:srgbClr val="B22600"/>
                 </a:solidFill>
                 <a:latin typeface="Microsoft YaHei" panose="020B0503020204020204" pitchFamily="34" charset="-122"/>
                 <a:ea typeface="Microsoft YaHei" panose="020B0503020204020204" pitchFamily="34" charset="-122"/>
@@ -18304,11 +18304,11 @@
             <a:avLst/>
           </a:prstGeom>
           <a:solidFill>
-            <a:srgbClr val="F0F1EF"/>
+            <a:srgbClr val="F7F7F8"/>
           </a:solidFill>
           <a:ln w="9525">
             <a:solidFill>
-              <a:srgbClr val="66747C"/>
+              <a:srgbClr val="6F6F6A"/>
             </a:solidFill>
           </a:ln>
         </p:spPr>
@@ -18368,7 +18368,7 @@
             <a:r>
               <a:rPr lang="en-US" altLang="zh-CN" sz="1300">
                 <a:solidFill>
-                  <a:srgbClr val="172A3A"/>
+                  <a:srgbClr val="505046"/>
                 </a:solidFill>
                 <a:latin typeface="Microsoft YaHei" panose="020B0503020204020204" pitchFamily="34" charset="-122"/>
                 <a:ea typeface="Microsoft YaHei" panose="020B0503020204020204" pitchFamily="34" charset="-122"/>
@@ -18377,7 +18377,7 @@
             </a:r>
             <a:endParaRPr lang="zh-CN" altLang="en-US" sz="1300">
               <a:solidFill>
-                <a:srgbClr val="172A3A"/>
+                <a:srgbClr val="505046"/>
               </a:solidFill>
               <a:latin typeface="Microsoft YaHei" panose="020B0503020204020204" pitchFamily="34" charset="-122"/>
               <a:ea typeface="Microsoft YaHei" panose="020B0503020204020204" pitchFamily="34" charset="-122"/>
@@ -18416,7 +18416,7 @@
             <a:r>
               <a:rPr lang="en-US" altLang="zh-CN" sz="1300">
                 <a:solidFill>
-                  <a:srgbClr val="172A3A"/>
+                  <a:srgbClr val="505046"/>
                 </a:solidFill>
                 <a:latin typeface="Microsoft YaHei" panose="020B0503020204020204" pitchFamily="34" charset="-122"/>
                 <a:ea typeface="Microsoft YaHei" panose="020B0503020204020204" pitchFamily="34" charset="-122"/>
@@ -18425,7 +18425,7 @@
             </a:r>
             <a:endParaRPr lang="zh-CN" altLang="en-US" sz="1300">
               <a:solidFill>
-                <a:srgbClr val="172A3A"/>
+                <a:srgbClr val="505046"/>
               </a:solidFill>
               <a:latin typeface="Microsoft YaHei" panose="020B0503020204020204" pitchFamily="34" charset="-122"/>
               <a:ea typeface="Microsoft YaHei" panose="020B0503020204020204" pitchFamily="34" charset="-122"/>
@@ -18464,7 +18464,7 @@
             <a:r>
               <a:rPr lang="en-US" altLang="zh-CN" sz="1300">
                 <a:solidFill>
-                  <a:srgbClr val="172A3A"/>
+                  <a:srgbClr val="505046"/>
                 </a:solidFill>
                 <a:latin typeface="Microsoft YaHei" panose="020B0503020204020204" pitchFamily="34" charset="-122"/>
                 <a:ea typeface="Microsoft YaHei" panose="020B0503020204020204" pitchFamily="34" charset="-122"/>
@@ -18473,7 +18473,7 @@
             </a:r>
             <a:endParaRPr lang="zh-CN" altLang="en-US" sz="1300">
               <a:solidFill>
-                <a:srgbClr val="172A3A"/>
+                <a:srgbClr val="505046"/>
               </a:solidFill>
               <a:latin typeface="Microsoft YaHei" panose="020B0503020204020204" pitchFamily="34" charset="-122"/>
               <a:ea typeface="Microsoft YaHei" panose="020B0503020204020204" pitchFamily="34" charset="-122"/>
@@ -18512,7 +18512,7 @@
             <a:r>
               <a:rPr lang="en-US" altLang="zh-CN" sz="1300">
                 <a:solidFill>
-                  <a:srgbClr val="172A3A"/>
+                  <a:srgbClr val="505046"/>
                 </a:solidFill>
                 <a:latin typeface="Microsoft YaHei" panose="020B0503020204020204" pitchFamily="34" charset="-122"/>
                 <a:ea typeface="Microsoft YaHei" panose="020B0503020204020204" pitchFamily="34" charset="-122"/>
@@ -18521,7 +18521,7 @@
             </a:r>
             <a:endParaRPr lang="zh-CN" altLang="en-US" sz="1300">
               <a:solidFill>
-                <a:srgbClr val="172A3A"/>
+                <a:srgbClr val="505046"/>
               </a:solidFill>
               <a:latin typeface="Microsoft YaHei" panose="020B0503020204020204" pitchFamily="34" charset="-122"/>
               <a:ea typeface="Microsoft YaHei" panose="020B0503020204020204" pitchFamily="34" charset="-122"/>
@@ -18560,7 +18560,7 @@
             <a:r>
               <a:rPr lang="en-US" altLang="zh-CN" sz="1300">
                 <a:solidFill>
-                  <a:srgbClr val="172A3A"/>
+                  <a:srgbClr val="505046"/>
                 </a:solidFill>
                 <a:latin typeface="Microsoft YaHei" panose="020B0503020204020204" pitchFamily="34" charset="-122"/>
                 <a:ea typeface="Microsoft YaHei" panose="020B0503020204020204" pitchFamily="34" charset="-122"/>
@@ -18569,7 +18569,7 @@
             </a:r>
             <a:endParaRPr lang="zh-CN" altLang="en-US" sz="1300">
               <a:solidFill>
-                <a:srgbClr val="172A3A"/>
+                <a:srgbClr val="505046"/>
               </a:solidFill>
               <a:latin typeface="Microsoft YaHei" panose="020B0503020204020204" pitchFamily="34" charset="-122"/>
               <a:ea typeface="Microsoft YaHei" panose="020B0503020204020204" pitchFamily="34" charset="-122"/>
@@ -18598,11 +18598,11 @@
             <a:avLst/>
           </a:prstGeom>
           <a:solidFill>
-            <a:srgbClr val="F7E6E6"/>
+            <a:srgbClr val="FFFFFF"/>
           </a:solidFill>
           <a:ln w="9525">
             <a:solidFill>
-              <a:srgbClr val="66747C"/>
+              <a:srgbClr val="6F6F6A"/>
             </a:solidFill>
           </a:ln>
         </p:spPr>
@@ -18662,7 +18662,7 @@
             <a:r>
               <a:rPr lang="en-US" altLang="zh-CN" sz="1300">
                 <a:solidFill>
-                  <a:srgbClr val="172A3A"/>
+                  <a:srgbClr val="505046"/>
                 </a:solidFill>
                 <a:latin typeface="Microsoft YaHei" panose="020B0503020204020204" pitchFamily="34" charset="-122"/>
                 <a:ea typeface="Microsoft YaHei" panose="020B0503020204020204" pitchFamily="34" charset="-122"/>
@@ -18671,7 +18671,7 @@
             </a:r>
             <a:endParaRPr lang="zh-CN" altLang="en-US" sz="1300">
               <a:solidFill>
-                <a:srgbClr val="172A3A"/>
+                <a:srgbClr val="505046"/>
               </a:solidFill>
               <a:latin typeface="Microsoft YaHei" panose="020B0503020204020204" pitchFamily="34" charset="-122"/>
               <a:ea typeface="Microsoft YaHei" panose="020B0503020204020204" pitchFamily="34" charset="-122"/>
@@ -18710,7 +18710,7 @@
             <a:r>
               <a:rPr lang="en-US" altLang="zh-CN" sz="1300">
                 <a:solidFill>
-                  <a:srgbClr val="172A3A"/>
+                  <a:srgbClr val="505046"/>
                 </a:solidFill>
                 <a:latin typeface="Microsoft YaHei" panose="020B0503020204020204" pitchFamily="34" charset="-122"/>
                 <a:ea typeface="Microsoft YaHei" panose="020B0503020204020204" pitchFamily="34" charset="-122"/>
@@ -18719,7 +18719,7 @@
             </a:r>
             <a:endParaRPr lang="zh-CN" altLang="en-US" sz="1300">
               <a:solidFill>
-                <a:srgbClr val="172A3A"/>
+                <a:srgbClr val="505046"/>
               </a:solidFill>
               <a:latin typeface="Microsoft YaHei" panose="020B0503020204020204" pitchFamily="34" charset="-122"/>
               <a:ea typeface="Microsoft YaHei" panose="020B0503020204020204" pitchFamily="34" charset="-122"/>
@@ -18758,7 +18758,7 @@
             <a:r>
               <a:rPr lang="en-US" altLang="zh-CN" sz="1300">
                 <a:solidFill>
-                  <a:srgbClr val="172A3A"/>
+                  <a:srgbClr val="505046"/>
                 </a:solidFill>
                 <a:latin typeface="Microsoft YaHei" panose="020B0503020204020204" pitchFamily="34" charset="-122"/>
                 <a:ea typeface="Microsoft YaHei" panose="020B0503020204020204" pitchFamily="34" charset="-122"/>
@@ -18767,7 +18767,7 @@
             </a:r>
             <a:endParaRPr lang="zh-CN" altLang="en-US" sz="1300">
               <a:solidFill>
-                <a:srgbClr val="172A3A"/>
+                <a:srgbClr val="505046"/>
               </a:solidFill>
               <a:latin typeface="Microsoft YaHei" panose="020B0503020204020204" pitchFamily="34" charset="-122"/>
               <a:ea typeface="Microsoft YaHei" panose="020B0503020204020204" pitchFamily="34" charset="-122"/>
@@ -18806,7 +18806,7 @@
             <a:r>
               <a:rPr lang="en-US" altLang="zh-CN" sz="1300">
                 <a:solidFill>
-                  <a:srgbClr val="172A3A"/>
+                  <a:srgbClr val="505046"/>
                 </a:solidFill>
                 <a:latin typeface="Microsoft YaHei" panose="020B0503020204020204" pitchFamily="34" charset="-122"/>
                 <a:ea typeface="Microsoft YaHei" panose="020B0503020204020204" pitchFamily="34" charset="-122"/>
@@ -18815,7 +18815,7 @@
             </a:r>
             <a:endParaRPr lang="zh-CN" altLang="en-US" sz="1300">
               <a:solidFill>
-                <a:srgbClr val="172A3A"/>
+                <a:srgbClr val="505046"/>
               </a:solidFill>
               <a:latin typeface="Microsoft YaHei" panose="020B0503020204020204" pitchFamily="34" charset="-122"/>
               <a:ea typeface="Microsoft YaHei" panose="020B0503020204020204" pitchFamily="34" charset="-122"/>
@@ -18854,7 +18854,7 @@
             <a:r>
               <a:rPr lang="en-US" altLang="zh-CN" sz="1300">
                 <a:solidFill>
-                  <a:srgbClr val="172A3A"/>
+                  <a:srgbClr val="505046"/>
                 </a:solidFill>
                 <a:latin typeface="Microsoft YaHei" panose="020B0503020204020204" pitchFamily="34" charset="-122"/>
                 <a:ea typeface="Microsoft YaHei" panose="020B0503020204020204" pitchFamily="34" charset="-122"/>
@@ -18863,7 +18863,7 @@
             </a:r>
             <a:endParaRPr lang="zh-CN" altLang="en-US" sz="1300">
               <a:solidFill>
-                <a:srgbClr val="172A3A"/>
+                <a:srgbClr val="505046"/>
               </a:solidFill>
               <a:latin typeface="Microsoft YaHei" panose="020B0503020204020204" pitchFamily="34" charset="-122"/>
               <a:ea typeface="Microsoft YaHei" panose="020B0503020204020204" pitchFamily="34" charset="-122"/>
@@ -18892,11 +18892,11 @@
             <a:avLst/>
           </a:prstGeom>
           <a:solidFill>
-            <a:srgbClr val="F0F1EF"/>
+            <a:srgbClr val="F7F7F8"/>
           </a:solidFill>
           <a:ln w="9525">
             <a:solidFill>
-              <a:srgbClr val="66747C"/>
+              <a:srgbClr val="6F6F6A"/>
             </a:solidFill>
           </a:ln>
         </p:spPr>
@@ -18956,7 +18956,7 @@
             <a:r>
               <a:rPr lang="en-US" altLang="zh-CN" sz="1300">
                 <a:solidFill>
-                  <a:srgbClr val="172A3A"/>
+                  <a:srgbClr val="505046"/>
                 </a:solidFill>
                 <a:latin typeface="Microsoft YaHei" panose="020B0503020204020204" pitchFamily="34" charset="-122"/>
                 <a:ea typeface="Microsoft YaHei" panose="020B0503020204020204" pitchFamily="34" charset="-122"/>
@@ -18965,7 +18965,7 @@
             </a:r>
             <a:endParaRPr lang="zh-CN" altLang="en-US" sz="1300">
               <a:solidFill>
-                <a:srgbClr val="172A3A"/>
+                <a:srgbClr val="505046"/>
               </a:solidFill>
               <a:latin typeface="Microsoft YaHei" panose="020B0503020204020204" pitchFamily="34" charset="-122"/>
               <a:ea typeface="Microsoft YaHei" panose="020B0503020204020204" pitchFamily="34" charset="-122"/>
@@ -19004,7 +19004,7 @@
             <a:r>
               <a:rPr lang="en-US" altLang="zh-CN" sz="1300">
                 <a:solidFill>
-                  <a:srgbClr val="172A3A"/>
+                  <a:srgbClr val="505046"/>
                 </a:solidFill>
                 <a:latin typeface="Microsoft YaHei" panose="020B0503020204020204" pitchFamily="34" charset="-122"/>
                 <a:ea typeface="Microsoft YaHei" panose="020B0503020204020204" pitchFamily="34" charset="-122"/>
@@ -19013,7 +19013,7 @@
             </a:r>
             <a:endParaRPr lang="zh-CN" altLang="en-US" sz="1300">
               <a:solidFill>
-                <a:srgbClr val="172A3A"/>
+                <a:srgbClr val="505046"/>
               </a:solidFill>
               <a:latin typeface="Microsoft YaHei" panose="020B0503020204020204" pitchFamily="34" charset="-122"/>
               <a:ea typeface="Microsoft YaHei" panose="020B0503020204020204" pitchFamily="34" charset="-122"/>
@@ -19052,7 +19052,7 @@
             <a:r>
               <a:rPr lang="en-US" altLang="zh-CN" sz="1300">
                 <a:solidFill>
-                  <a:srgbClr val="172A3A"/>
+                  <a:srgbClr val="505046"/>
                 </a:solidFill>
                 <a:latin typeface="Microsoft YaHei" panose="020B0503020204020204" pitchFamily="34" charset="-122"/>
                 <a:ea typeface="Microsoft YaHei" panose="020B0503020204020204" pitchFamily="34" charset="-122"/>
@@ -19061,7 +19061,7 @@
             </a:r>
             <a:endParaRPr lang="zh-CN" altLang="en-US" sz="1300">
               <a:solidFill>
-                <a:srgbClr val="172A3A"/>
+                <a:srgbClr val="505046"/>
               </a:solidFill>
               <a:latin typeface="Microsoft YaHei" panose="020B0503020204020204" pitchFamily="34" charset="-122"/>
               <a:ea typeface="Microsoft YaHei" panose="020B0503020204020204" pitchFamily="34" charset="-122"/>
@@ -19100,7 +19100,7 @@
             <a:r>
               <a:rPr lang="en-US" altLang="zh-CN" sz="1300">
                 <a:solidFill>
-                  <a:srgbClr val="172A3A"/>
+                  <a:srgbClr val="505046"/>
                 </a:solidFill>
                 <a:latin typeface="Microsoft YaHei" panose="020B0503020204020204" pitchFamily="34" charset="-122"/>
                 <a:ea typeface="Microsoft YaHei" panose="020B0503020204020204" pitchFamily="34" charset="-122"/>
@@ -19109,7 +19109,7 @@
             </a:r>
             <a:endParaRPr lang="zh-CN" altLang="en-US" sz="1300">
               <a:solidFill>
-                <a:srgbClr val="172A3A"/>
+                <a:srgbClr val="505046"/>
               </a:solidFill>
               <a:latin typeface="Microsoft YaHei" panose="020B0503020204020204" pitchFamily="34" charset="-122"/>
               <a:ea typeface="Microsoft YaHei" panose="020B0503020204020204" pitchFamily="34" charset="-122"/>
@@ -19148,7 +19148,7 @@
             <a:r>
               <a:rPr lang="en-US" altLang="zh-CN" sz="1300">
                 <a:solidFill>
-                  <a:srgbClr val="172A3A"/>
+                  <a:srgbClr val="505046"/>
                 </a:solidFill>
                 <a:latin typeface="Microsoft YaHei" panose="020B0503020204020204" pitchFamily="34" charset="-122"/>
                 <a:ea typeface="Microsoft YaHei" panose="020B0503020204020204" pitchFamily="34" charset="-122"/>
@@ -19157,7 +19157,7 @@
             </a:r>
             <a:endParaRPr lang="zh-CN" altLang="en-US" sz="1300">
               <a:solidFill>
-                <a:srgbClr val="172A3A"/>
+                <a:srgbClr val="505046"/>
               </a:solidFill>
               <a:latin typeface="Microsoft YaHei" panose="020B0503020204020204" pitchFamily="34" charset="-122"/>
               <a:ea typeface="Microsoft YaHei" panose="020B0503020204020204" pitchFamily="34" charset="-122"/>
@@ -19186,11 +19186,11 @@
             <a:avLst/>
           </a:prstGeom>
           <a:solidFill>
-            <a:srgbClr val="F7E6E6"/>
+            <a:srgbClr val="FFFFFF"/>
           </a:solidFill>
           <a:ln w="9525">
             <a:solidFill>
-              <a:srgbClr val="66747C"/>
+              <a:srgbClr val="6F6F6A"/>
             </a:solidFill>
           </a:ln>
         </p:spPr>
@@ -19250,7 +19250,7 @@
             <a:r>
               <a:rPr lang="en-US" altLang="zh-CN" sz="1300">
                 <a:solidFill>
-                  <a:srgbClr val="172A3A"/>
+                  <a:srgbClr val="505046"/>
                 </a:solidFill>
                 <a:latin typeface="Microsoft YaHei" panose="020B0503020204020204" pitchFamily="34" charset="-122"/>
                 <a:ea typeface="Microsoft YaHei" panose="020B0503020204020204" pitchFamily="34" charset="-122"/>
@@ -19259,7 +19259,7 @@
             </a:r>
             <a:endParaRPr lang="zh-CN" altLang="en-US" sz="1300">
               <a:solidFill>
-                <a:srgbClr val="172A3A"/>
+                <a:srgbClr val="505046"/>
               </a:solidFill>
               <a:latin typeface="Microsoft YaHei" panose="020B0503020204020204" pitchFamily="34" charset="-122"/>
               <a:ea typeface="Microsoft YaHei" panose="020B0503020204020204" pitchFamily="34" charset="-122"/>
@@ -19298,7 +19298,7 @@
             <a:r>
               <a:rPr lang="en-US" altLang="zh-CN" sz="1300">
                 <a:solidFill>
-                  <a:srgbClr val="172A3A"/>
+                  <a:srgbClr val="505046"/>
                 </a:solidFill>
                 <a:latin typeface="Microsoft YaHei" panose="020B0503020204020204" pitchFamily="34" charset="-122"/>
                 <a:ea typeface="Microsoft YaHei" panose="020B0503020204020204" pitchFamily="34" charset="-122"/>
@@ -19307,7 +19307,7 @@
             </a:r>
             <a:endParaRPr lang="zh-CN" altLang="en-US" sz="1300">
               <a:solidFill>
-                <a:srgbClr val="172A3A"/>
+                <a:srgbClr val="505046"/>
               </a:solidFill>
               <a:latin typeface="Microsoft YaHei" panose="020B0503020204020204" pitchFamily="34" charset="-122"/>
               <a:ea typeface="Microsoft YaHei" panose="020B0503020204020204" pitchFamily="34" charset="-122"/>
@@ -19346,7 +19346,7 @@
             <a:r>
               <a:rPr lang="en-US" altLang="zh-CN" sz="1300">
                 <a:solidFill>
-                  <a:srgbClr val="172A3A"/>
+                  <a:srgbClr val="505046"/>
                 </a:solidFill>
                 <a:latin typeface="Microsoft YaHei" panose="020B0503020204020204" pitchFamily="34" charset="-122"/>
                 <a:ea typeface="Microsoft YaHei" panose="020B0503020204020204" pitchFamily="34" charset="-122"/>
@@ -19355,7 +19355,7 @@
             </a:r>
             <a:endParaRPr lang="zh-CN" altLang="en-US" sz="1300">
               <a:solidFill>
-                <a:srgbClr val="172A3A"/>
+                <a:srgbClr val="505046"/>
               </a:solidFill>
               <a:latin typeface="Microsoft YaHei" panose="020B0503020204020204" pitchFamily="34" charset="-122"/>
               <a:ea typeface="Microsoft YaHei" panose="020B0503020204020204" pitchFamily="34" charset="-122"/>
@@ -19394,7 +19394,7 @@
             <a:r>
               <a:rPr lang="en-US" altLang="zh-CN" sz="1300">
                 <a:solidFill>
-                  <a:srgbClr val="172A3A"/>
+                  <a:srgbClr val="505046"/>
                 </a:solidFill>
                 <a:latin typeface="Microsoft YaHei" panose="020B0503020204020204" pitchFamily="34" charset="-122"/>
                 <a:ea typeface="Microsoft YaHei" panose="020B0503020204020204" pitchFamily="34" charset="-122"/>
@@ -19403,7 +19403,7 @@
             </a:r>
             <a:endParaRPr lang="zh-CN" altLang="en-US" sz="1300">
               <a:solidFill>
-                <a:srgbClr val="172A3A"/>
+                <a:srgbClr val="505046"/>
               </a:solidFill>
               <a:latin typeface="Microsoft YaHei" panose="020B0503020204020204" pitchFamily="34" charset="-122"/>
               <a:ea typeface="Microsoft YaHei" panose="020B0503020204020204" pitchFamily="34" charset="-122"/>
@@ -19442,7 +19442,7 @@
             <a:r>
               <a:rPr lang="en-US" altLang="zh-CN" sz="1300">
                 <a:solidFill>
-                  <a:srgbClr val="172A3A"/>
+                  <a:srgbClr val="505046"/>
                 </a:solidFill>
                 <a:latin typeface="Microsoft YaHei" panose="020B0503020204020204" pitchFamily="34" charset="-122"/>
                 <a:ea typeface="Microsoft YaHei" panose="020B0503020204020204" pitchFamily="34" charset="-122"/>
@@ -19451,7 +19451,7 @@
             </a:r>
             <a:endParaRPr lang="zh-CN" altLang="en-US" sz="1300">
               <a:solidFill>
-                <a:srgbClr val="172A3A"/>
+                <a:srgbClr val="505046"/>
               </a:solidFill>
               <a:latin typeface="Microsoft YaHei" panose="020B0503020204020204" pitchFamily="34" charset="-122"/>
               <a:ea typeface="Microsoft YaHei" panose="020B0503020204020204" pitchFamily="34" charset="-122"/>
@@ -19490,7 +19490,7 @@
             <a:r>
               <a:rPr lang="zh-CN" altLang="en-US" sz="1200">
                 <a:solidFill>
-                  <a:srgbClr val="66747C"/>
+                  <a:srgbClr val="6F6F6A"/>
                 </a:solidFill>
                 <a:latin typeface="Microsoft YaHei" panose="020B0503020204020204" pitchFamily="34" charset="-122"/>
                 <a:ea typeface="Microsoft YaHei" panose="020B0503020204020204" pitchFamily="34" charset="-122"/>
@@ -19500,7 +19500,7 @@
             <a:r>
               <a:rPr lang="en-US" altLang="zh-CN" sz="1200">
                 <a:solidFill>
-                  <a:srgbClr val="66747C"/>
+                  <a:srgbClr val="6F6F6A"/>
                 </a:solidFill>
                 <a:latin typeface="Microsoft YaHei" panose="020B0503020204020204" pitchFamily="34" charset="-122"/>
                 <a:ea typeface="Microsoft YaHei" panose="020B0503020204020204" pitchFamily="34" charset="-122"/>
@@ -19510,7 +19510,7 @@
             <a:r>
               <a:rPr lang="zh-CN" altLang="en-US" sz="1200">
                 <a:solidFill>
-                  <a:srgbClr val="66747C"/>
+                  <a:srgbClr val="6F6F6A"/>
                 </a:solidFill>
                 <a:latin typeface="Microsoft YaHei" panose="020B0503020204020204" pitchFamily="34" charset="-122"/>
                 <a:ea typeface="Microsoft YaHei" panose="020B0503020204020204" pitchFamily="34" charset="-122"/>

</xml_diff>

<commit_message>
Remove orange/amber from all text runs: text is deep red, color only in graphics
User review: slides still showed orange-red (E84C22) and amber (FFBD47) text after the first legacy remap - the semantic colors had been applied to text labels (step names, result cards). Second pass: inside every <a:rPr> text run on slides 1-7, E84C22/FFBD47 -> B22600 deep red; remaining FFBD47 (graphics) -> E84C22. Verified: no text run anywhere (slides 1-14) contains E84C22 or FFBD47. Palette now: deep red text + red graphics + ink/grey/white (SHA 490A4318).
</commit_message>
<xml_diff>
--- a/domains/yuhong/assets/components/yuhong-county-course-components-branded.pptx
+++ b/domains/yuhong/assets/components/yuhong-county-course-components-branded.pptx
@@ -1376,7 +1376,7 @@
             <a:r>
               <a:rPr sz="975" b="1">
                 <a:solidFill>
-                  <a:srgbClr val="E84C22"/>
+                  <a:srgbClr val="B22600"/>
                 </a:solidFill>
                 <a:latin typeface="Microsoft YaHei"/>
                 <a:ea typeface="Microsoft YaHei"/>
@@ -1581,7 +1581,7 @@
             <a:r>
               <a:rPr sz="3150" b="1">
                 <a:solidFill>
-                  <a:srgbClr val="E84C22"/>
+                  <a:srgbClr val="B22600"/>
                 </a:solidFill>
                 <a:latin typeface="Microsoft YaHei"/>
                 <a:ea typeface="Microsoft YaHei"/>
@@ -1821,7 +1821,7 @@
             <a:r>
               <a:rPr sz="1425" b="1">
                 <a:solidFill>
-                  <a:srgbClr val="E84C22"/>
+                  <a:srgbClr val="B22600"/>
                 </a:solidFill>
                 <a:latin typeface="Microsoft YaHei"/>
                 <a:ea typeface="Microsoft YaHei"/>
@@ -2167,7 +2167,7 @@
             <a:pPr algn="l">
               <a:defRPr sz="3150" b="1">
                 <a:solidFill>
-                  <a:srgbClr val="FFBD47"/>
+                  <a:srgbClr val="E84C22"/>
                 </a:solidFill>
                 <a:latin typeface="Microsoft YaHei"/>
                 <a:ea typeface="Microsoft YaHei"/>
@@ -2177,7 +2177,7 @@
             <a:r>
               <a:rPr sz="3150" b="1">
                 <a:solidFill>
-                  <a:srgbClr val="FFBD47"/>
+                  <a:srgbClr val="B22600"/>
                 </a:solidFill>
                 <a:latin typeface="Microsoft YaHei"/>
                 <a:ea typeface="Microsoft YaHei"/>
@@ -2327,7 +2327,7 @@
             <a:avLst/>
           </a:prstGeom>
           <a:solidFill>
-            <a:srgbClr val="FFBD47"/>
+            <a:srgbClr val="E84C22"/>
           </a:solidFill>
           <a:ln w="0">
             <a:noFill/>
@@ -2364,7 +2364,7 @@
           </a:solidFill>
           <a:ln w="14288">
             <a:solidFill>
-              <a:srgbClr val="FFBD47"/>
+              <a:srgbClr val="E84C22"/>
             </a:solidFill>
             <a:prstDash val="solid"/>
           </a:ln>
@@ -2407,7 +2407,7 @@
             <a:pPr algn="ctr">
               <a:defRPr sz="1425" b="1">
                 <a:solidFill>
-                  <a:srgbClr val="FFBD47"/>
+                  <a:srgbClr val="E84C22"/>
                 </a:solidFill>
                 <a:latin typeface="Microsoft YaHei"/>
                 <a:ea typeface="Microsoft YaHei"/>
@@ -2417,7 +2417,7 @@
             <a:r>
               <a:rPr sz="1425" b="1">
                 <a:solidFill>
-                  <a:srgbClr val="FFBD47"/>
+                  <a:srgbClr val="B22600"/>
                 </a:solidFill>
                 <a:latin typeface="Microsoft YaHei"/>
                 <a:ea typeface="Microsoft YaHei"/>
@@ -2533,7 +2533,7 @@
             <a:r>
               <a:rPr sz="1050" b="1">
                 <a:solidFill>
-                  <a:srgbClr val="E84C22"/>
+                  <a:srgbClr val="B22600"/>
                 </a:solidFill>
                 <a:latin typeface="Microsoft YaHei"/>
                 <a:ea typeface="Microsoft YaHei"/>
@@ -10197,7 +10197,7 @@
             <a:r>
               <a:rPr sz="1125" b="1">
                 <a:solidFill>
-                  <a:srgbClr val="E84C22"/>
+                  <a:srgbClr val="B22600"/>
                 </a:solidFill>
                 <a:latin typeface="Microsoft YaHei"/>
                 <a:ea typeface="Microsoft YaHei"/>
@@ -10413,7 +10413,7 @@
           <a:noFill/>
           <a:ln w="19050">
             <a:solidFill>
-              <a:srgbClr val="FFBD47"/>
+              <a:srgbClr val="E84C22"/>
             </a:solidFill>
             <a:prstDash val="solid"/>
           </a:ln>
@@ -10446,7 +10446,7 @@
           </a:solidFill>
           <a:ln w="19050">
             <a:solidFill>
-              <a:srgbClr val="FFBD47"/>
+              <a:srgbClr val="E84C22"/>
             </a:solidFill>
             <a:prstDash val="solid"/>
           </a:ln>
@@ -10547,7 +10547,7 @@
             <a:pPr algn="ctr">
               <a:defRPr sz="1125" b="1">
                 <a:solidFill>
-                  <a:srgbClr val="FFBD47"/>
+                  <a:srgbClr val="E84C22"/>
                 </a:solidFill>
                 <a:latin typeface="Microsoft YaHei"/>
                 <a:ea typeface="Microsoft YaHei"/>
@@ -10557,7 +10557,7 @@
             <a:r>
               <a:rPr sz="1125" b="1">
                 <a:solidFill>
-                  <a:srgbClr val="FFBD47"/>
+                  <a:srgbClr val="B22600"/>
                 </a:solidFill>
                 <a:latin typeface="Microsoft YaHei"/>
                 <a:ea typeface="Microsoft YaHei"/>
@@ -10853,7 +10853,7 @@
             <a:r>
               <a:rPr sz="1050" b="1">
                 <a:solidFill>
-                  <a:srgbClr val="E84C22"/>
+                  <a:srgbClr val="B22600"/>
                 </a:solidFill>
                 <a:latin typeface="Microsoft YaHei"/>
                 <a:ea typeface="Microsoft YaHei"/>
@@ -10901,7 +10901,7 @@
             <a:pPr algn="ctr">
               <a:defRPr sz="1050" b="1">
                 <a:solidFill>
-                  <a:srgbClr val="FFBD47"/>
+                  <a:srgbClr val="E84C22"/>
                 </a:solidFill>
                 <a:latin typeface="Microsoft YaHei"/>
                 <a:ea typeface="Microsoft YaHei"/>
@@ -10911,7 +10911,7 @@
             <a:r>
               <a:rPr sz="1050" b="1">
                 <a:solidFill>
-                  <a:srgbClr val="FFBD47"/>
+                  <a:srgbClr val="B22600"/>
                 </a:solidFill>
                 <a:latin typeface="Microsoft YaHei"/>
                 <a:ea typeface="Microsoft YaHei"/>
@@ -11890,7 +11890,7 @@
           <a:noFill/>
           <a:ln w="19050">
             <a:solidFill>
-              <a:srgbClr val="FFBD47"/>
+              <a:srgbClr val="E84C22"/>
             </a:solidFill>
             <a:prstDash val="solid"/>
           </a:ln>
@@ -11913,246 +11913,6 @@
         <p:spPr>
           <a:xfrm>
             <a:off x="1104900" y="4476750"/>
-            <a:ext cx="3048000" cy="1143000"/>
-          </a:xfrm>
-          <a:prstGeom prst="roundRect">
-            <a:avLst>
-              <a:gd name="adj" fmla="val 6667"/>
-            </a:avLst>
-          </a:prstGeom>
-          <a:solidFill>
-            <a:srgbClr val="F7F7F8"/>
-          </a:solidFill>
-          <a:ln w="19050">
-            <a:solidFill>
-              <a:srgbClr val="FFBD47"/>
-            </a:solidFill>
-            <a:prstDash val="solid"/>
-          </a:ln>
-        </p:spPr>
-      </p:sp>
-      <p:sp>
-        <p:nvSpPr>
-          <p:cNvPr id="21" name="SCENE_LABEL">
-            <a:extLst>
-              <a:ext uri="{FF2B5EF4-FFF2-40B4-BE49-F238E27FC236}">
-                <a16:creationId xmlns:a16="http://schemas.microsoft.com/office/drawing/2014/main" id="{E3533932-C006-40A8-9E62-8E18828978D1}"/>
-              </a:ext>
-            </a:extLst>
-          </p:cNvPr>
-          <p:cNvSpPr>
-            <a:spLocks noGrp="1"/>
-          </p:cNvSpPr>
-          <p:nvPr/>
-        </p:nvSpPr>
-        <p:spPr>
-          <a:xfrm>
-            <a:off x="1295400" y="4619625"/>
-            <a:ext cx="876300" cy="266700"/>
-          </a:xfrm>
-          <a:prstGeom prst="rect">
-            <a:avLst/>
-          </a:prstGeom>
-          <a:noFill/>
-          <a:ln w="0">
-            <a:noFill/>
-            <a:prstDash val="solid"/>
-          </a:ln>
-        </p:spPr>
-        <p:txBody>
-          <a:bodyPr wrap="square" lIns="38100" tIns="19050" rIns="38100" bIns="19050" anchor="t">
-            <a:normAutofit fontScale="90909"/>
-          </a:bodyPr>
-          <a:lstStyle/>
-          <a:p>
-            <a:pPr algn="l">
-              <a:defRPr sz="1650" b="1">
-                <a:solidFill>
-                  <a:srgbClr val="FFBD47"/>
-                </a:solidFill>
-                <a:latin typeface="Microsoft YaHei"/>
-                <a:ea typeface="Microsoft YaHei"/>
-                <a:cs typeface="Microsoft YaHei"/>
-              </a:defRPr>
-            </a:pPr>
-            <a:r>
-              <a:rPr sz="1650" b="1">
-                <a:solidFill>
-                  <a:srgbClr val="FFBD47"/>
-                </a:solidFill>
-                <a:latin typeface="Microsoft YaHei"/>
-                <a:ea typeface="Microsoft YaHei"/>
-                <a:cs typeface="Microsoft YaHei"/>
-              </a:rPr>
-              <a:t>场景力</a:t>
-            </a:r>
-          </a:p>
-        </p:txBody>
-      </p:sp>
-      <p:sp>
-        <p:nvSpPr>
-          <p:cNvPr id="22" name="SCENE_QUESTION">
-            <a:extLst>
-              <a:ext uri="{FF2B5EF4-FFF2-40B4-BE49-F238E27FC236}">
-                <a16:creationId xmlns:a16="http://schemas.microsoft.com/office/drawing/2014/main" id="{AF84A24B-3E37-41C9-832E-072F6D2CD257}"/>
-              </a:ext>
-            </a:extLst>
-          </p:cNvPr>
-          <p:cNvSpPr>
-            <a:spLocks noGrp="1"/>
-          </p:cNvSpPr>
-          <p:nvPr/>
-        </p:nvSpPr>
-        <p:spPr>
-          <a:xfrm>
-            <a:off x="1295400" y="4962525"/>
-            <a:ext cx="2647950" cy="285750"/>
-          </a:xfrm>
-          <a:prstGeom prst="rect">
-            <a:avLst/>
-          </a:prstGeom>
-          <a:noFill/>
-          <a:ln w="0">
-            <a:noFill/>
-            <a:prstDash val="solid"/>
-          </a:ln>
-        </p:spPr>
-        <p:txBody>
-          <a:bodyPr wrap="square" lIns="38100" tIns="19050" rIns="38100" bIns="19050" anchor="t">
-            <a:normAutofit/>
-          </a:bodyPr>
-          <a:lstStyle/>
-          <a:p>
-            <a:pPr algn="l">
-              <a:defRPr sz="1275" b="1">
-                <a:solidFill>
-                  <a:srgbClr val="191919"/>
-                </a:solidFill>
-                <a:latin typeface="Microsoft YaHei"/>
-                <a:ea typeface="Microsoft YaHei"/>
-                <a:cs typeface="Microsoft YaHei"/>
-              </a:defRPr>
-            </a:pPr>
-            <a:r>
-              <a:rPr sz="1275" b="1">
-                <a:solidFill>
-                  <a:srgbClr val="191919"/>
-                </a:solidFill>
-                <a:latin typeface="Microsoft YaHei"/>
-                <a:ea typeface="Microsoft YaHei"/>
-                <a:cs typeface="Microsoft YaHei"/>
-              </a:rPr>
-              <a:t>能不能持续找到真实项目？</a:t>
-            </a:r>
-          </a:p>
-        </p:txBody>
-      </p:sp>
-      <p:sp>
-        <p:nvSpPr>
-          <p:cNvPr id="23" name="SCENE_EVIDENCE">
-            <a:extLst>
-              <a:ext uri="{FF2B5EF4-FFF2-40B4-BE49-F238E27FC236}">
-                <a16:creationId xmlns:a16="http://schemas.microsoft.com/office/drawing/2014/main" id="{742863A3-607C-426F-8A6A-34E907E4F79B}"/>
-              </a:ext>
-            </a:extLst>
-          </p:cNvPr>
-          <p:cNvSpPr>
-            <a:spLocks noGrp="1"/>
-          </p:cNvSpPr>
-          <p:nvPr/>
-        </p:nvSpPr>
-        <p:spPr>
-          <a:xfrm>
-            <a:off x="1295400" y="5314950"/>
-            <a:ext cx="2647950" cy="209550"/>
-          </a:xfrm>
-          <a:prstGeom prst="rect">
-            <a:avLst/>
-          </a:prstGeom>
-          <a:noFill/>
-          <a:ln w="0">
-            <a:noFill/>
-            <a:prstDash val="solid"/>
-          </a:ln>
-        </p:spPr>
-        <p:txBody>
-          <a:bodyPr wrap="square" lIns="38100" tIns="19050" rIns="38100" bIns="19050" anchor="t">
-            <a:normAutofit/>
-          </a:bodyPr>
-          <a:lstStyle/>
-          <a:p>
-            <a:pPr algn="l">
-              <a:defRPr sz="975" b="0">
-                <a:solidFill>
-                  <a:srgbClr val="6F6F6A"/>
-                </a:solidFill>
-                <a:latin typeface="Microsoft YaHei"/>
-                <a:ea typeface="Microsoft YaHei"/>
-                <a:cs typeface="Microsoft YaHei"/>
-              </a:defRPr>
-            </a:pPr>
-            <a:r>
-              <a:rPr sz="975" b="0">
-                <a:solidFill>
-                  <a:srgbClr val="6F6F6A"/>
-                </a:solidFill>
-                <a:latin typeface="Microsoft YaHei"/>
-                <a:ea typeface="Microsoft YaHei"/>
-                <a:cs typeface="Microsoft YaHei"/>
-              </a:rPr>
-              <a:t>线索｜节点｜转化</a:t>
-            </a:r>
-          </a:p>
-        </p:txBody>
-      </p:sp>
-      <p:sp>
-        <p:nvSpPr>
-          <p:cNvPr id="24" name="PRODUCT_LINK">
-            <a:extLst>
-              <a:ext uri="{FF2B5EF4-FFF2-40B4-BE49-F238E27FC236}">
-                <a16:creationId xmlns:a16="http://schemas.microsoft.com/office/drawing/2014/main" id="{7E89A4B1-D239-4EDA-A50C-733CC008129C}"/>
-              </a:ext>
-            </a:extLst>
-          </p:cNvPr>
-          <p:cNvSpPr>
-            <a:spLocks noGrp="1"/>
-          </p:cNvSpPr>
-          <p:nvPr/>
-        </p:nvSpPr>
-        <p:spPr>
-          <a:xfrm>
-            <a:off x="6972300" y="4476750"/>
-            <a:ext cx="1143000" cy="523875"/>
-          </a:xfrm>
-          <a:prstGeom prst="line">
-            <a:avLst/>
-          </a:prstGeom>
-          <a:noFill/>
-          <a:ln w="19050">
-            <a:solidFill>
-              <a:srgbClr val="E84C22"/>
-            </a:solidFill>
-            <a:prstDash val="solid"/>
-          </a:ln>
-        </p:spPr>
-      </p:sp>
-      <p:sp>
-        <p:nvSpPr>
-          <p:cNvPr id="25" name="PRODUCT_SURFACE">
-            <a:extLst>
-              <a:ext uri="{FF2B5EF4-FFF2-40B4-BE49-F238E27FC236}">
-                <a16:creationId xmlns:a16="http://schemas.microsoft.com/office/drawing/2014/main" id="{657347C3-132A-4654-BC89-24367335A8B5}"/>
-              </a:ext>
-            </a:extLst>
-          </p:cNvPr>
-          <p:cNvSpPr>
-            <a:spLocks noGrp="1"/>
-          </p:cNvSpPr>
-          <p:nvPr/>
-        </p:nvSpPr>
-        <p:spPr>
-          <a:xfrm>
-            <a:off x="8115300" y="4476750"/>
             <a:ext cx="3048000" cy="1143000"/>
           </a:xfrm>
           <a:prstGeom prst="roundRect">
@@ -12173,10 +11933,10 @@
       </p:sp>
       <p:sp>
         <p:nvSpPr>
-          <p:cNvPr id="26" name="PRODUCT_LABEL">
-            <a:extLst>
-              <a:ext uri="{FF2B5EF4-FFF2-40B4-BE49-F238E27FC236}">
-                <a16:creationId xmlns:a16="http://schemas.microsoft.com/office/drawing/2014/main" id="{BC94698D-B6BE-4902-8DF9-CBE9F7CD4EE3}"/>
+          <p:cNvPr id="21" name="SCENE_LABEL">
+            <a:extLst>
+              <a:ext uri="{FF2B5EF4-FFF2-40B4-BE49-F238E27FC236}">
+                <a16:creationId xmlns:a16="http://schemas.microsoft.com/office/drawing/2014/main" id="{E3533932-C006-40A8-9E62-8E18828978D1}"/>
               </a:ext>
             </a:extLst>
           </p:cNvPr>
@@ -12187,7 +11947,7 @@
         </p:nvSpPr>
         <p:spPr>
           <a:xfrm>
-            <a:off x="8305800" y="4619625"/>
+            <a:off x="1295400" y="4619625"/>
             <a:ext cx="876300" cy="266700"/>
           </a:xfrm>
           <a:prstGeom prst="rect">
@@ -12218,7 +11978,247 @@
             <a:r>
               <a:rPr sz="1650" b="1">
                 <a:solidFill>
+                  <a:srgbClr val="B22600"/>
+                </a:solidFill>
+                <a:latin typeface="Microsoft YaHei"/>
+                <a:ea typeface="Microsoft YaHei"/>
+                <a:cs typeface="Microsoft YaHei"/>
+              </a:rPr>
+              <a:t>场景力</a:t>
+            </a:r>
+          </a:p>
+        </p:txBody>
+      </p:sp>
+      <p:sp>
+        <p:nvSpPr>
+          <p:cNvPr id="22" name="SCENE_QUESTION">
+            <a:extLst>
+              <a:ext uri="{FF2B5EF4-FFF2-40B4-BE49-F238E27FC236}">
+                <a16:creationId xmlns:a16="http://schemas.microsoft.com/office/drawing/2014/main" id="{AF84A24B-3E37-41C9-832E-072F6D2CD257}"/>
+              </a:ext>
+            </a:extLst>
+          </p:cNvPr>
+          <p:cNvSpPr>
+            <a:spLocks noGrp="1"/>
+          </p:cNvSpPr>
+          <p:nvPr/>
+        </p:nvSpPr>
+        <p:spPr>
+          <a:xfrm>
+            <a:off x="1295400" y="4962525"/>
+            <a:ext cx="2647950" cy="285750"/>
+          </a:xfrm>
+          <a:prstGeom prst="rect">
+            <a:avLst/>
+          </a:prstGeom>
+          <a:noFill/>
+          <a:ln w="0">
+            <a:noFill/>
+            <a:prstDash val="solid"/>
+          </a:ln>
+        </p:spPr>
+        <p:txBody>
+          <a:bodyPr wrap="square" lIns="38100" tIns="19050" rIns="38100" bIns="19050" anchor="t">
+            <a:normAutofit/>
+          </a:bodyPr>
+          <a:lstStyle/>
+          <a:p>
+            <a:pPr algn="l">
+              <a:defRPr sz="1275" b="1">
+                <a:solidFill>
+                  <a:srgbClr val="191919"/>
+                </a:solidFill>
+                <a:latin typeface="Microsoft YaHei"/>
+                <a:ea typeface="Microsoft YaHei"/>
+                <a:cs typeface="Microsoft YaHei"/>
+              </a:defRPr>
+            </a:pPr>
+            <a:r>
+              <a:rPr sz="1275" b="1">
+                <a:solidFill>
+                  <a:srgbClr val="191919"/>
+                </a:solidFill>
+                <a:latin typeface="Microsoft YaHei"/>
+                <a:ea typeface="Microsoft YaHei"/>
+                <a:cs typeface="Microsoft YaHei"/>
+              </a:rPr>
+              <a:t>能不能持续找到真实项目？</a:t>
+            </a:r>
+          </a:p>
+        </p:txBody>
+      </p:sp>
+      <p:sp>
+        <p:nvSpPr>
+          <p:cNvPr id="23" name="SCENE_EVIDENCE">
+            <a:extLst>
+              <a:ext uri="{FF2B5EF4-FFF2-40B4-BE49-F238E27FC236}">
+                <a16:creationId xmlns:a16="http://schemas.microsoft.com/office/drawing/2014/main" id="{742863A3-607C-426F-8A6A-34E907E4F79B}"/>
+              </a:ext>
+            </a:extLst>
+          </p:cNvPr>
+          <p:cNvSpPr>
+            <a:spLocks noGrp="1"/>
+          </p:cNvSpPr>
+          <p:nvPr/>
+        </p:nvSpPr>
+        <p:spPr>
+          <a:xfrm>
+            <a:off x="1295400" y="5314950"/>
+            <a:ext cx="2647950" cy="209550"/>
+          </a:xfrm>
+          <a:prstGeom prst="rect">
+            <a:avLst/>
+          </a:prstGeom>
+          <a:noFill/>
+          <a:ln w="0">
+            <a:noFill/>
+            <a:prstDash val="solid"/>
+          </a:ln>
+        </p:spPr>
+        <p:txBody>
+          <a:bodyPr wrap="square" lIns="38100" tIns="19050" rIns="38100" bIns="19050" anchor="t">
+            <a:normAutofit/>
+          </a:bodyPr>
+          <a:lstStyle/>
+          <a:p>
+            <a:pPr algn="l">
+              <a:defRPr sz="975" b="0">
+                <a:solidFill>
+                  <a:srgbClr val="6F6F6A"/>
+                </a:solidFill>
+                <a:latin typeface="Microsoft YaHei"/>
+                <a:ea typeface="Microsoft YaHei"/>
+                <a:cs typeface="Microsoft YaHei"/>
+              </a:defRPr>
+            </a:pPr>
+            <a:r>
+              <a:rPr sz="975" b="0">
+                <a:solidFill>
+                  <a:srgbClr val="6F6F6A"/>
+                </a:solidFill>
+                <a:latin typeface="Microsoft YaHei"/>
+                <a:ea typeface="Microsoft YaHei"/>
+                <a:cs typeface="Microsoft YaHei"/>
+              </a:rPr>
+              <a:t>线索｜节点｜转化</a:t>
+            </a:r>
+          </a:p>
+        </p:txBody>
+      </p:sp>
+      <p:sp>
+        <p:nvSpPr>
+          <p:cNvPr id="24" name="PRODUCT_LINK">
+            <a:extLst>
+              <a:ext uri="{FF2B5EF4-FFF2-40B4-BE49-F238E27FC236}">
+                <a16:creationId xmlns:a16="http://schemas.microsoft.com/office/drawing/2014/main" id="{7E89A4B1-D239-4EDA-A50C-733CC008129C}"/>
+              </a:ext>
+            </a:extLst>
+          </p:cNvPr>
+          <p:cNvSpPr>
+            <a:spLocks noGrp="1"/>
+          </p:cNvSpPr>
+          <p:nvPr/>
+        </p:nvSpPr>
+        <p:spPr>
+          <a:xfrm>
+            <a:off x="6972300" y="4476750"/>
+            <a:ext cx="1143000" cy="523875"/>
+          </a:xfrm>
+          <a:prstGeom prst="line">
+            <a:avLst/>
+          </a:prstGeom>
+          <a:noFill/>
+          <a:ln w="19050">
+            <a:solidFill>
+              <a:srgbClr val="E84C22"/>
+            </a:solidFill>
+            <a:prstDash val="solid"/>
+          </a:ln>
+        </p:spPr>
+      </p:sp>
+      <p:sp>
+        <p:nvSpPr>
+          <p:cNvPr id="25" name="PRODUCT_SURFACE">
+            <a:extLst>
+              <a:ext uri="{FF2B5EF4-FFF2-40B4-BE49-F238E27FC236}">
+                <a16:creationId xmlns:a16="http://schemas.microsoft.com/office/drawing/2014/main" id="{657347C3-132A-4654-BC89-24367335A8B5}"/>
+              </a:ext>
+            </a:extLst>
+          </p:cNvPr>
+          <p:cNvSpPr>
+            <a:spLocks noGrp="1"/>
+          </p:cNvSpPr>
+          <p:nvPr/>
+        </p:nvSpPr>
+        <p:spPr>
+          <a:xfrm>
+            <a:off x="8115300" y="4476750"/>
+            <a:ext cx="3048000" cy="1143000"/>
+          </a:xfrm>
+          <a:prstGeom prst="roundRect">
+            <a:avLst>
+              <a:gd name="adj" fmla="val 6667"/>
+            </a:avLst>
+          </a:prstGeom>
+          <a:solidFill>
+            <a:srgbClr val="F7F7F8"/>
+          </a:solidFill>
+          <a:ln w="19050">
+            <a:solidFill>
+              <a:srgbClr val="E84C22"/>
+            </a:solidFill>
+            <a:prstDash val="solid"/>
+          </a:ln>
+        </p:spPr>
+      </p:sp>
+      <p:sp>
+        <p:nvSpPr>
+          <p:cNvPr id="26" name="PRODUCT_LABEL">
+            <a:extLst>
+              <a:ext uri="{FF2B5EF4-FFF2-40B4-BE49-F238E27FC236}">
+                <a16:creationId xmlns:a16="http://schemas.microsoft.com/office/drawing/2014/main" id="{BC94698D-B6BE-4902-8DF9-CBE9F7CD4EE3}"/>
+              </a:ext>
+            </a:extLst>
+          </p:cNvPr>
+          <p:cNvSpPr>
+            <a:spLocks noGrp="1"/>
+          </p:cNvSpPr>
+          <p:nvPr/>
+        </p:nvSpPr>
+        <p:spPr>
+          <a:xfrm>
+            <a:off x="8305800" y="4619625"/>
+            <a:ext cx="876300" cy="266700"/>
+          </a:xfrm>
+          <a:prstGeom prst="rect">
+            <a:avLst/>
+          </a:prstGeom>
+          <a:noFill/>
+          <a:ln w="0">
+            <a:noFill/>
+            <a:prstDash val="solid"/>
+          </a:ln>
+        </p:spPr>
+        <p:txBody>
+          <a:bodyPr wrap="square" lIns="38100" tIns="19050" rIns="38100" bIns="19050" anchor="t">
+            <a:normAutofit fontScale="90909"/>
+          </a:bodyPr>
+          <a:lstStyle/>
+          <a:p>
+            <a:pPr algn="l">
+              <a:defRPr sz="1650" b="1">
+                <a:solidFill>
                   <a:srgbClr val="E84C22"/>
+                </a:solidFill>
+                <a:latin typeface="Microsoft YaHei"/>
+                <a:ea typeface="Microsoft YaHei"/>
+                <a:cs typeface="Microsoft YaHei"/>
+              </a:defRPr>
+            </a:pPr>
+            <a:r>
+              <a:rPr sz="1650" b="1">
+                <a:solidFill>
+                  <a:srgbClr val="B22600"/>
                 </a:solidFill>
                 <a:latin typeface="Microsoft YaHei"/>
                 <a:ea typeface="Microsoft YaHei"/>
@@ -14184,7 +14184,7 @@
           </a:solidFill>
           <a:ln w="9525">
             <a:solidFill>
-              <a:srgbClr val="FFBD47"/>
+              <a:srgbClr val="E84C22"/>
             </a:solidFill>
             <a:prstDash val="solid"/>
           </a:ln>
@@ -14310,7 +14310,7 @@
           </a:solidFill>
           <a:ln w="9525">
             <a:solidFill>
-              <a:srgbClr val="FFBD47"/>
+              <a:srgbClr val="E84C22"/>
             </a:solidFill>
             <a:prstDash val="solid"/>
           </a:ln>
@@ -14436,7 +14436,7 @@
           </a:solidFill>
           <a:ln w="9525">
             <a:solidFill>
-              <a:srgbClr val="FFBD47"/>
+              <a:srgbClr val="E84C22"/>
             </a:solidFill>
             <a:prstDash val="solid"/>
           </a:ln>
@@ -14562,7 +14562,7 @@
           </a:solidFill>
           <a:ln w="9525">
             <a:solidFill>
-              <a:srgbClr val="FFBD47"/>
+              <a:srgbClr val="E84C22"/>
             </a:solidFill>
             <a:prstDash val="solid"/>
           </a:ln>
@@ -14688,7 +14688,7 @@
           </a:solidFill>
           <a:ln w="9525">
             <a:solidFill>
-              <a:srgbClr val="FFBD47"/>
+              <a:srgbClr val="E84C22"/>
             </a:solidFill>
             <a:prstDash val="solid"/>
           </a:ln>
@@ -14814,7 +14814,7 @@
           </a:solidFill>
           <a:ln w="9525">
             <a:solidFill>
-              <a:srgbClr val="FFBD47"/>
+              <a:srgbClr val="E84C22"/>
             </a:solidFill>
             <a:prstDash val="solid"/>
           </a:ln>
@@ -14940,7 +14940,7 @@
           </a:solidFill>
           <a:ln w="9525">
             <a:solidFill>
-              <a:srgbClr val="FFBD47"/>
+              <a:srgbClr val="E84C22"/>
             </a:solidFill>
             <a:prstDash val="solid"/>
           </a:ln>
@@ -15066,7 +15066,7 @@
           </a:solidFill>
           <a:ln w="9525">
             <a:solidFill>
-              <a:srgbClr val="FFBD47"/>
+              <a:srgbClr val="E84C22"/>
             </a:solidFill>
             <a:prstDash val="solid"/>
           </a:ln>
@@ -15527,7 +15527,7 @@
           </a:solidFill>
           <a:ln w="19050">
             <a:solidFill>
-              <a:srgbClr val="FFBD47"/>
+              <a:srgbClr val="E84C22"/>
             </a:solidFill>
             <a:prstDash val="solid"/>
           </a:ln>
@@ -15570,7 +15570,7 @@
             <a:pPr algn="ctr">
               <a:defRPr sz="1650" b="1">
                 <a:solidFill>
-                  <a:srgbClr val="FFBD47"/>
+                  <a:srgbClr val="E84C22"/>
                 </a:solidFill>
                 <a:latin typeface="Microsoft YaHei"/>
                 <a:ea typeface="Microsoft YaHei"/>
@@ -15580,7 +15580,7 @@
             <a:r>
               <a:rPr sz="1650" b="1">
                 <a:solidFill>
-                  <a:srgbClr val="FFBD47"/>
+                  <a:srgbClr val="B22600"/>
                 </a:solidFill>
                 <a:latin typeface="Microsoft YaHei"/>
                 <a:ea typeface="Microsoft YaHei"/>
@@ -15731,7 +15731,7 @@
             <a:r>
               <a:rPr sz="1650" b="1">
                 <a:solidFill>
-                  <a:srgbClr val="E84C22"/>
+                  <a:srgbClr val="B22600"/>
                 </a:solidFill>
                 <a:latin typeface="Microsoft YaHei"/>
                 <a:ea typeface="Microsoft YaHei"/>
@@ -16801,304 +16801,6 @@
             <a:avLst/>
           </a:prstGeom>
           <a:solidFill>
-            <a:srgbClr val="FFBD47"/>
-          </a:solidFill>
-          <a:ln w="0">
-            <a:noFill/>
-            <a:prstDash val="solid"/>
-          </a:ln>
-        </p:spPr>
-      </p:sp>
-      <p:sp>
-        <p:nvSpPr>
-          <p:cNvPr id="21" name="STEP_3_NUMBER">
-            <a:extLst>
-              <a:ext uri="{FF2B5EF4-FFF2-40B4-BE49-F238E27FC236}">
-                <a16:creationId xmlns:a16="http://schemas.microsoft.com/office/drawing/2014/main" id="{C2A6D2D2-5002-4573-9D22-D258ECBF94DA}"/>
-              </a:ext>
-            </a:extLst>
-          </p:cNvPr>
-          <p:cNvSpPr>
-            <a:spLocks noGrp="1"/>
-          </p:cNvSpPr>
-          <p:nvPr/>
-        </p:nvSpPr>
-        <p:spPr>
-          <a:xfrm>
-            <a:off x="2924175" y="3714750"/>
-            <a:ext cx="247650" cy="247650"/>
-          </a:xfrm>
-          <a:prstGeom prst="rect">
-            <a:avLst/>
-          </a:prstGeom>
-          <a:noFill/>
-          <a:ln w="0">
-            <a:noFill/>
-            <a:prstDash val="solid"/>
-          </a:ln>
-        </p:spPr>
-        <p:txBody>
-          <a:bodyPr wrap="square" lIns="38100" tIns="19050" rIns="38100" bIns="19050" anchor="ctr">
-            <a:normAutofit/>
-          </a:bodyPr>
-          <a:lstStyle/>
-          <a:p>
-            <a:pPr algn="ctr">
-              <a:defRPr sz="1350" b="1">
-                <a:solidFill>
-                  <a:srgbClr val="FFFFFF"/>
-                </a:solidFill>
-                <a:latin typeface="Microsoft YaHei"/>
-                <a:ea typeface="Microsoft YaHei"/>
-                <a:cs typeface="Microsoft YaHei"/>
-              </a:defRPr>
-            </a:pPr>
-            <a:r>
-              <a:rPr sz="1350" b="1">
-                <a:solidFill>
-                  <a:srgbClr val="FFFFFF"/>
-                </a:solidFill>
-                <a:latin typeface="Microsoft YaHei"/>
-                <a:ea typeface="Microsoft YaHei"/>
-                <a:cs typeface="Microsoft YaHei"/>
-              </a:rPr>
-              <a:t>3</a:t>
-            </a:r>
-          </a:p>
-        </p:txBody>
-      </p:sp>
-      <p:sp>
-        <p:nvSpPr>
-          <p:cNvPr id="22" name="STEP_3_LABEL">
-            <a:extLst>
-              <a:ext uri="{FF2B5EF4-FFF2-40B4-BE49-F238E27FC236}">
-                <a16:creationId xmlns:a16="http://schemas.microsoft.com/office/drawing/2014/main" id="{DA58EDCD-1675-43A4-8E5E-8D8CD9768C3A}"/>
-              </a:ext>
-            </a:extLst>
-          </p:cNvPr>
-          <p:cNvSpPr>
-            <a:spLocks noGrp="1"/>
-          </p:cNvSpPr>
-          <p:nvPr/>
-        </p:nvSpPr>
-        <p:spPr>
-          <a:xfrm>
-            <a:off x="666750" y="3619500"/>
-            <a:ext cx="1809750" cy="323850"/>
-          </a:xfrm>
-          <a:prstGeom prst="rect">
-            <a:avLst/>
-          </a:prstGeom>
-          <a:noFill/>
-          <a:ln w="0">
-            <a:noFill/>
-            <a:prstDash val="solid"/>
-          </a:ln>
-        </p:spPr>
-        <p:txBody>
-          <a:bodyPr wrap="square" lIns="38100" tIns="19050" rIns="38100" bIns="19050" anchor="t">
-            <a:normAutofit/>
-          </a:bodyPr>
-          <a:lstStyle/>
-          <a:p>
-            <a:pPr algn="r">
-              <a:defRPr sz="1650" b="1">
-                <a:solidFill>
-                  <a:srgbClr val="FFBD47"/>
-                </a:solidFill>
-                <a:latin typeface="Microsoft YaHei"/>
-                <a:ea typeface="Microsoft YaHei"/>
-                <a:cs typeface="Microsoft YaHei"/>
-              </a:defRPr>
-            </a:pPr>
-            <a:r>
-              <a:rPr sz="1650" b="1">
-                <a:solidFill>
-                  <a:srgbClr val="FFBD47"/>
-                </a:solidFill>
-                <a:latin typeface="Microsoft YaHei"/>
-                <a:ea typeface="Microsoft YaHei"/>
-                <a:cs typeface="Microsoft YaHei"/>
-              </a:rPr>
-              <a:t>病症</a:t>
-            </a:r>
-          </a:p>
-        </p:txBody>
-      </p:sp>
-      <p:sp>
-        <p:nvSpPr>
-          <p:cNvPr id="23" name="STEP_3_QUESTION">
-            <a:extLst>
-              <a:ext uri="{FF2B5EF4-FFF2-40B4-BE49-F238E27FC236}">
-                <a16:creationId xmlns:a16="http://schemas.microsoft.com/office/drawing/2014/main" id="{B736A411-6933-4569-95F7-1C9863011DE3}"/>
-              </a:ext>
-            </a:extLst>
-          </p:cNvPr>
-          <p:cNvSpPr>
-            <a:spLocks noGrp="1"/>
-          </p:cNvSpPr>
-          <p:nvPr/>
-        </p:nvSpPr>
-        <p:spPr>
-          <a:xfrm>
-            <a:off x="3619500" y="3571875"/>
-            <a:ext cx="3476625" cy="438150"/>
-          </a:xfrm>
-          <a:prstGeom prst="rect">
-            <a:avLst/>
-          </a:prstGeom>
-          <a:noFill/>
-          <a:ln w="0">
-            <a:noFill/>
-            <a:prstDash val="solid"/>
-          </a:ln>
-        </p:spPr>
-        <p:txBody>
-          <a:bodyPr wrap="square" lIns="38100" tIns="19050" rIns="38100" bIns="19050" anchor="ctr">
-            <a:normAutofit/>
-          </a:bodyPr>
-          <a:lstStyle/>
-          <a:p>
-            <a:pPr algn="l">
-              <a:defRPr sz="1350" b="1">
-                <a:solidFill>
-                  <a:srgbClr val="191919"/>
-                </a:solidFill>
-                <a:latin typeface="Microsoft YaHei"/>
-                <a:ea typeface="Microsoft YaHei"/>
-                <a:cs typeface="Microsoft YaHei"/>
-              </a:defRPr>
-            </a:pPr>
-            <a:r>
-              <a:rPr sz="1350" b="1">
-                <a:solidFill>
-                  <a:srgbClr val="191919"/>
-                </a:solidFill>
-                <a:latin typeface="Microsoft YaHei"/>
-                <a:ea typeface="Microsoft YaHei"/>
-                <a:cs typeface="Microsoft YaHei"/>
-              </a:rPr>
-              <a:t>投入与结果哪里不匹配？</a:t>
-            </a:r>
-          </a:p>
-        </p:txBody>
-      </p:sp>
-      <p:sp>
-        <p:nvSpPr>
-          <p:cNvPr id="24" name="STEP_3_OUTPUT_SURFACE">
-            <a:extLst>
-              <a:ext uri="{FF2B5EF4-FFF2-40B4-BE49-F238E27FC236}">
-                <a16:creationId xmlns:a16="http://schemas.microsoft.com/office/drawing/2014/main" id="{7313737C-9491-47CD-B1E7-69621995364B}"/>
-              </a:ext>
-            </a:extLst>
-          </p:cNvPr>
-          <p:cNvSpPr>
-            <a:spLocks noGrp="1"/>
-          </p:cNvSpPr>
-          <p:nvPr/>
-        </p:nvSpPr>
-        <p:spPr>
-          <a:xfrm>
-            <a:off x="7524750" y="3552825"/>
-            <a:ext cx="3714750" cy="552450"/>
-          </a:xfrm>
-          <a:prstGeom prst="roundRect">
-            <a:avLst>
-              <a:gd name="adj" fmla="val 13793"/>
-            </a:avLst>
-          </a:prstGeom>
-          <a:solidFill>
-            <a:srgbClr val="F7F7F8"/>
-          </a:solidFill>
-          <a:ln w="14288">
-            <a:solidFill>
-              <a:srgbClr val="FFBD47"/>
-            </a:solidFill>
-            <a:prstDash val="solid"/>
-          </a:ln>
-        </p:spPr>
-      </p:sp>
-      <p:sp>
-        <p:nvSpPr>
-          <p:cNvPr id="25" name="STEP_3_OUTPUT">
-            <a:extLst>
-              <a:ext uri="{FF2B5EF4-FFF2-40B4-BE49-F238E27FC236}">
-                <a16:creationId xmlns:a16="http://schemas.microsoft.com/office/drawing/2014/main" id="{8F98B9D2-8880-4445-AD78-FDEB3DFCFF93}"/>
-              </a:ext>
-            </a:extLst>
-          </p:cNvPr>
-          <p:cNvSpPr>
-            <a:spLocks noGrp="1"/>
-          </p:cNvSpPr>
-          <p:nvPr/>
-        </p:nvSpPr>
-        <p:spPr>
-          <a:xfrm>
-            <a:off x="7715250" y="3667125"/>
-            <a:ext cx="3333750" cy="323850"/>
-          </a:xfrm>
-          <a:prstGeom prst="rect">
-            <a:avLst/>
-          </a:prstGeom>
-          <a:noFill/>
-          <a:ln w="0">
-            <a:noFill/>
-            <a:prstDash val="solid"/>
-          </a:ln>
-        </p:spPr>
-        <p:txBody>
-          <a:bodyPr wrap="square" lIns="38100" tIns="19050" rIns="38100" bIns="19050" anchor="ctr">
-            <a:normAutofit/>
-          </a:bodyPr>
-          <a:lstStyle/>
-          <a:p>
-            <a:pPr algn="l">
-              <a:defRPr sz="1275" b="1">
-                <a:solidFill>
-                  <a:srgbClr val="FFBD47"/>
-                </a:solidFill>
-                <a:latin typeface="Microsoft YaHei"/>
-                <a:ea typeface="Microsoft YaHei"/>
-                <a:cs typeface="Microsoft YaHei"/>
-              </a:defRPr>
-            </a:pPr>
-            <a:r>
-              <a:rPr sz="1275" b="1">
-                <a:solidFill>
-                  <a:srgbClr val="FFBD47"/>
-                </a:solidFill>
-                <a:latin typeface="Microsoft YaHei"/>
-                <a:ea typeface="Microsoft YaHei"/>
-                <a:cs typeface="Microsoft YaHei"/>
-              </a:rPr>
-              <a:t>主病症：首单依赖</a:t>
-            </a:r>
-          </a:p>
-        </p:txBody>
-      </p:sp>
-      <p:sp>
-        <p:nvSpPr>
-          <p:cNvPr id="26" name="STEP_4_DOT">
-            <a:extLst>
-              <a:ext uri="{FF2B5EF4-FFF2-40B4-BE49-F238E27FC236}">
-                <a16:creationId xmlns:a16="http://schemas.microsoft.com/office/drawing/2014/main" id="{A573DEE1-9024-4BBB-9BA1-91E3CB650908}"/>
-              </a:ext>
-            </a:extLst>
-          </p:cNvPr>
-          <p:cNvSpPr>
-            <a:spLocks noGrp="1"/>
-          </p:cNvSpPr>
-          <p:nvPr/>
-        </p:nvSpPr>
-        <p:spPr>
-          <a:xfrm>
-            <a:off x="2800350" y="4381500"/>
-            <a:ext cx="495300" cy="495300"/>
-          </a:xfrm>
-          <a:prstGeom prst="ellipse">
-            <a:avLst/>
-          </a:prstGeom>
-          <a:solidFill>
             <a:srgbClr val="E84C22"/>
           </a:solidFill>
           <a:ln w="0">
@@ -17109,10 +16811,10 @@
       </p:sp>
       <p:sp>
         <p:nvSpPr>
-          <p:cNvPr id="27" name="STEP_4_NUMBER">
-            <a:extLst>
-              <a:ext uri="{FF2B5EF4-FFF2-40B4-BE49-F238E27FC236}">
-                <a16:creationId xmlns:a16="http://schemas.microsoft.com/office/drawing/2014/main" id="{53FAA616-C888-4C38-B67B-E402E21584EE}"/>
+          <p:cNvPr id="21" name="STEP_3_NUMBER">
+            <a:extLst>
+              <a:ext uri="{FF2B5EF4-FFF2-40B4-BE49-F238E27FC236}">
+                <a16:creationId xmlns:a16="http://schemas.microsoft.com/office/drawing/2014/main" id="{C2A6D2D2-5002-4573-9D22-D258ECBF94DA}"/>
               </a:ext>
             </a:extLst>
           </p:cNvPr>
@@ -17123,7 +16825,7 @@
         </p:nvSpPr>
         <p:spPr>
           <a:xfrm>
-            <a:off x="2924175" y="4476750"/>
+            <a:off x="2924175" y="3714750"/>
             <a:ext cx="247650" cy="247650"/>
           </a:xfrm>
           <a:prstGeom prst="rect">
@@ -17160,17 +16862,17 @@
                 <a:ea typeface="Microsoft YaHei"/>
                 <a:cs typeface="Microsoft YaHei"/>
               </a:rPr>
-              <a:t>4</a:t>
-            </a:r>
-          </a:p>
-        </p:txBody>
-      </p:sp>
-      <p:sp>
-        <p:nvSpPr>
-          <p:cNvPr id="28" name="STEP_4_LABEL">
-            <a:extLst>
-              <a:ext uri="{FF2B5EF4-FFF2-40B4-BE49-F238E27FC236}">
-                <a16:creationId xmlns:a16="http://schemas.microsoft.com/office/drawing/2014/main" id="{A83AA673-2482-432F-9E4E-EEE1AAB7BC83}"/>
+              <a:t>3</a:t>
+            </a:r>
+          </a:p>
+        </p:txBody>
+      </p:sp>
+      <p:sp>
+        <p:nvSpPr>
+          <p:cNvPr id="22" name="STEP_3_LABEL">
+            <a:extLst>
+              <a:ext uri="{FF2B5EF4-FFF2-40B4-BE49-F238E27FC236}">
+                <a16:creationId xmlns:a16="http://schemas.microsoft.com/office/drawing/2014/main" id="{DA58EDCD-1675-43A4-8E5E-8D8CD9768C3A}"/>
               </a:ext>
             </a:extLst>
           </p:cNvPr>
@@ -17181,7 +16883,7 @@
         </p:nvSpPr>
         <p:spPr>
           <a:xfrm>
-            <a:off x="666750" y="4381500"/>
+            <a:off x="666750" y="3619500"/>
             <a:ext cx="1809750" cy="323850"/>
           </a:xfrm>
           <a:prstGeom prst="rect">
@@ -17212,23 +16914,23 @@
             <a:r>
               <a:rPr sz="1650" b="1">
                 <a:solidFill>
-                  <a:srgbClr val="E84C22"/>
-                </a:solidFill>
-                <a:latin typeface="Microsoft YaHei"/>
-                <a:ea typeface="Microsoft YaHei"/>
-                <a:cs typeface="Microsoft YaHei"/>
-              </a:rPr>
-              <a:t>四力短板</a:t>
-            </a:r>
-          </a:p>
-        </p:txBody>
-      </p:sp>
-      <p:sp>
-        <p:nvSpPr>
-          <p:cNvPr id="29" name="STEP_4_QUESTION">
-            <a:extLst>
-              <a:ext uri="{FF2B5EF4-FFF2-40B4-BE49-F238E27FC236}">
-                <a16:creationId xmlns:a16="http://schemas.microsoft.com/office/drawing/2014/main" id="{3CE317E3-6A4C-4FDF-8E72-6CB4A15495DA}"/>
+                  <a:srgbClr val="B22600"/>
+                </a:solidFill>
+                <a:latin typeface="Microsoft YaHei"/>
+                <a:ea typeface="Microsoft YaHei"/>
+                <a:cs typeface="Microsoft YaHei"/>
+              </a:rPr>
+              <a:t>病症</a:t>
+            </a:r>
+          </a:p>
+        </p:txBody>
+      </p:sp>
+      <p:sp>
+        <p:nvSpPr>
+          <p:cNvPr id="23" name="STEP_3_QUESTION">
+            <a:extLst>
+              <a:ext uri="{FF2B5EF4-FFF2-40B4-BE49-F238E27FC236}">
+                <a16:creationId xmlns:a16="http://schemas.microsoft.com/office/drawing/2014/main" id="{B736A411-6933-4569-95F7-1C9863011DE3}"/>
               </a:ext>
             </a:extLst>
           </p:cNvPr>
@@ -17239,7 +16941,7 @@
         </p:nvSpPr>
         <p:spPr>
           <a:xfrm>
-            <a:off x="3619500" y="4333875"/>
+            <a:off x="3619500" y="3571875"/>
             <a:ext cx="3476625" cy="438150"/>
           </a:xfrm>
           <a:prstGeom prst="rect">
@@ -17276,17 +16978,17 @@
                 <a:ea typeface="Microsoft YaHei"/>
                 <a:cs typeface="Microsoft YaHei"/>
               </a:rPr>
-              <a:t>哪一力最能解释病症？</a:t>
-            </a:r>
-          </a:p>
-        </p:txBody>
-      </p:sp>
-      <p:sp>
-        <p:nvSpPr>
-          <p:cNvPr id="30" name="STEP_4_OUTPUT_SURFACE">
-            <a:extLst>
-              <a:ext uri="{FF2B5EF4-FFF2-40B4-BE49-F238E27FC236}">
-                <a16:creationId xmlns:a16="http://schemas.microsoft.com/office/drawing/2014/main" id="{FDEF4397-8E2E-4CDD-917A-6FA2D1669F7F}"/>
+              <a:t>投入与结果哪里不匹配？</a:t>
+            </a:r>
+          </a:p>
+        </p:txBody>
+      </p:sp>
+      <p:sp>
+        <p:nvSpPr>
+          <p:cNvPr id="24" name="STEP_3_OUTPUT_SURFACE">
+            <a:extLst>
+              <a:ext uri="{FF2B5EF4-FFF2-40B4-BE49-F238E27FC236}">
+                <a16:creationId xmlns:a16="http://schemas.microsoft.com/office/drawing/2014/main" id="{7313737C-9491-47CD-B1E7-69621995364B}"/>
               </a:ext>
             </a:extLst>
           </p:cNvPr>
@@ -17297,7 +16999,7 @@
         </p:nvSpPr>
         <p:spPr>
           <a:xfrm>
-            <a:off x="7524750" y="4314825"/>
+            <a:off x="7524750" y="3552825"/>
             <a:ext cx="3714750" cy="552450"/>
           </a:xfrm>
           <a:prstGeom prst="roundRect">
@@ -17318,10 +17020,10 @@
       </p:sp>
       <p:sp>
         <p:nvSpPr>
-          <p:cNvPr id="31" name="STEP_4_OUTPUT">
-            <a:extLst>
-              <a:ext uri="{FF2B5EF4-FFF2-40B4-BE49-F238E27FC236}">
-                <a16:creationId xmlns:a16="http://schemas.microsoft.com/office/drawing/2014/main" id="{377542C7-CC1D-439C-AA5E-568ECDD6891A}"/>
+          <p:cNvPr id="25" name="STEP_3_OUTPUT">
+            <a:extLst>
+              <a:ext uri="{FF2B5EF4-FFF2-40B4-BE49-F238E27FC236}">
+                <a16:creationId xmlns:a16="http://schemas.microsoft.com/office/drawing/2014/main" id="{8F98B9D2-8880-4445-AD78-FDEB3DFCFF93}"/>
               </a:ext>
             </a:extLst>
           </p:cNvPr>
@@ -17332,7 +17034,7 @@
         </p:nvSpPr>
         <p:spPr>
           <a:xfrm>
-            <a:off x="7715250" y="4429125"/>
+            <a:off x="7715250" y="3667125"/>
             <a:ext cx="3333750" cy="323850"/>
           </a:xfrm>
           <a:prstGeom prst="rect">
@@ -17363,7 +17065,305 @@
             <a:r>
               <a:rPr sz="1275" b="1">
                 <a:solidFill>
+                  <a:srgbClr val="B22600"/>
+                </a:solidFill>
+                <a:latin typeface="Microsoft YaHei"/>
+                <a:ea typeface="Microsoft YaHei"/>
+                <a:cs typeface="Microsoft YaHei"/>
+              </a:rPr>
+              <a:t>主病症：首单依赖</a:t>
+            </a:r>
+          </a:p>
+        </p:txBody>
+      </p:sp>
+      <p:sp>
+        <p:nvSpPr>
+          <p:cNvPr id="26" name="STEP_4_DOT">
+            <a:extLst>
+              <a:ext uri="{FF2B5EF4-FFF2-40B4-BE49-F238E27FC236}">
+                <a16:creationId xmlns:a16="http://schemas.microsoft.com/office/drawing/2014/main" id="{A573DEE1-9024-4BBB-9BA1-91E3CB650908}"/>
+              </a:ext>
+            </a:extLst>
+          </p:cNvPr>
+          <p:cNvSpPr>
+            <a:spLocks noGrp="1"/>
+          </p:cNvSpPr>
+          <p:nvPr/>
+        </p:nvSpPr>
+        <p:spPr>
+          <a:xfrm>
+            <a:off x="2800350" y="4381500"/>
+            <a:ext cx="495300" cy="495300"/>
+          </a:xfrm>
+          <a:prstGeom prst="ellipse">
+            <a:avLst/>
+          </a:prstGeom>
+          <a:solidFill>
+            <a:srgbClr val="E84C22"/>
+          </a:solidFill>
+          <a:ln w="0">
+            <a:noFill/>
+            <a:prstDash val="solid"/>
+          </a:ln>
+        </p:spPr>
+      </p:sp>
+      <p:sp>
+        <p:nvSpPr>
+          <p:cNvPr id="27" name="STEP_4_NUMBER">
+            <a:extLst>
+              <a:ext uri="{FF2B5EF4-FFF2-40B4-BE49-F238E27FC236}">
+                <a16:creationId xmlns:a16="http://schemas.microsoft.com/office/drawing/2014/main" id="{53FAA616-C888-4C38-B67B-E402E21584EE}"/>
+              </a:ext>
+            </a:extLst>
+          </p:cNvPr>
+          <p:cNvSpPr>
+            <a:spLocks noGrp="1"/>
+          </p:cNvSpPr>
+          <p:nvPr/>
+        </p:nvSpPr>
+        <p:spPr>
+          <a:xfrm>
+            <a:off x="2924175" y="4476750"/>
+            <a:ext cx="247650" cy="247650"/>
+          </a:xfrm>
+          <a:prstGeom prst="rect">
+            <a:avLst/>
+          </a:prstGeom>
+          <a:noFill/>
+          <a:ln w="0">
+            <a:noFill/>
+            <a:prstDash val="solid"/>
+          </a:ln>
+        </p:spPr>
+        <p:txBody>
+          <a:bodyPr wrap="square" lIns="38100" tIns="19050" rIns="38100" bIns="19050" anchor="ctr">
+            <a:normAutofit/>
+          </a:bodyPr>
+          <a:lstStyle/>
+          <a:p>
+            <a:pPr algn="ctr">
+              <a:defRPr sz="1350" b="1">
+                <a:solidFill>
+                  <a:srgbClr val="FFFFFF"/>
+                </a:solidFill>
+                <a:latin typeface="Microsoft YaHei"/>
+                <a:ea typeface="Microsoft YaHei"/>
+                <a:cs typeface="Microsoft YaHei"/>
+              </a:defRPr>
+            </a:pPr>
+            <a:r>
+              <a:rPr sz="1350" b="1">
+                <a:solidFill>
+                  <a:srgbClr val="FFFFFF"/>
+                </a:solidFill>
+                <a:latin typeface="Microsoft YaHei"/>
+                <a:ea typeface="Microsoft YaHei"/>
+                <a:cs typeface="Microsoft YaHei"/>
+              </a:rPr>
+              <a:t>4</a:t>
+            </a:r>
+          </a:p>
+        </p:txBody>
+      </p:sp>
+      <p:sp>
+        <p:nvSpPr>
+          <p:cNvPr id="28" name="STEP_4_LABEL">
+            <a:extLst>
+              <a:ext uri="{FF2B5EF4-FFF2-40B4-BE49-F238E27FC236}">
+                <a16:creationId xmlns:a16="http://schemas.microsoft.com/office/drawing/2014/main" id="{A83AA673-2482-432F-9E4E-EEE1AAB7BC83}"/>
+              </a:ext>
+            </a:extLst>
+          </p:cNvPr>
+          <p:cNvSpPr>
+            <a:spLocks noGrp="1"/>
+          </p:cNvSpPr>
+          <p:nvPr/>
+        </p:nvSpPr>
+        <p:spPr>
+          <a:xfrm>
+            <a:off x="666750" y="4381500"/>
+            <a:ext cx="1809750" cy="323850"/>
+          </a:xfrm>
+          <a:prstGeom prst="rect">
+            <a:avLst/>
+          </a:prstGeom>
+          <a:noFill/>
+          <a:ln w="0">
+            <a:noFill/>
+            <a:prstDash val="solid"/>
+          </a:ln>
+        </p:spPr>
+        <p:txBody>
+          <a:bodyPr wrap="square" lIns="38100" tIns="19050" rIns="38100" bIns="19050" anchor="t">
+            <a:normAutofit/>
+          </a:bodyPr>
+          <a:lstStyle/>
+          <a:p>
+            <a:pPr algn="r">
+              <a:defRPr sz="1650" b="1">
+                <a:solidFill>
                   <a:srgbClr val="E84C22"/>
+                </a:solidFill>
+                <a:latin typeface="Microsoft YaHei"/>
+                <a:ea typeface="Microsoft YaHei"/>
+                <a:cs typeface="Microsoft YaHei"/>
+              </a:defRPr>
+            </a:pPr>
+            <a:r>
+              <a:rPr sz="1650" b="1">
+                <a:solidFill>
+                  <a:srgbClr val="B22600"/>
+                </a:solidFill>
+                <a:latin typeface="Microsoft YaHei"/>
+                <a:ea typeface="Microsoft YaHei"/>
+                <a:cs typeface="Microsoft YaHei"/>
+              </a:rPr>
+              <a:t>四力短板</a:t>
+            </a:r>
+          </a:p>
+        </p:txBody>
+      </p:sp>
+      <p:sp>
+        <p:nvSpPr>
+          <p:cNvPr id="29" name="STEP_4_QUESTION">
+            <a:extLst>
+              <a:ext uri="{FF2B5EF4-FFF2-40B4-BE49-F238E27FC236}">
+                <a16:creationId xmlns:a16="http://schemas.microsoft.com/office/drawing/2014/main" id="{3CE317E3-6A4C-4FDF-8E72-6CB4A15495DA}"/>
+              </a:ext>
+            </a:extLst>
+          </p:cNvPr>
+          <p:cNvSpPr>
+            <a:spLocks noGrp="1"/>
+          </p:cNvSpPr>
+          <p:nvPr/>
+        </p:nvSpPr>
+        <p:spPr>
+          <a:xfrm>
+            <a:off x="3619500" y="4333875"/>
+            <a:ext cx="3476625" cy="438150"/>
+          </a:xfrm>
+          <a:prstGeom prst="rect">
+            <a:avLst/>
+          </a:prstGeom>
+          <a:noFill/>
+          <a:ln w="0">
+            <a:noFill/>
+            <a:prstDash val="solid"/>
+          </a:ln>
+        </p:spPr>
+        <p:txBody>
+          <a:bodyPr wrap="square" lIns="38100" tIns="19050" rIns="38100" bIns="19050" anchor="ctr">
+            <a:normAutofit/>
+          </a:bodyPr>
+          <a:lstStyle/>
+          <a:p>
+            <a:pPr algn="l">
+              <a:defRPr sz="1350" b="1">
+                <a:solidFill>
+                  <a:srgbClr val="191919"/>
+                </a:solidFill>
+                <a:latin typeface="Microsoft YaHei"/>
+                <a:ea typeface="Microsoft YaHei"/>
+                <a:cs typeface="Microsoft YaHei"/>
+              </a:defRPr>
+            </a:pPr>
+            <a:r>
+              <a:rPr sz="1350" b="1">
+                <a:solidFill>
+                  <a:srgbClr val="191919"/>
+                </a:solidFill>
+                <a:latin typeface="Microsoft YaHei"/>
+                <a:ea typeface="Microsoft YaHei"/>
+                <a:cs typeface="Microsoft YaHei"/>
+              </a:rPr>
+              <a:t>哪一力最能解释病症？</a:t>
+            </a:r>
+          </a:p>
+        </p:txBody>
+      </p:sp>
+      <p:sp>
+        <p:nvSpPr>
+          <p:cNvPr id="30" name="STEP_4_OUTPUT_SURFACE">
+            <a:extLst>
+              <a:ext uri="{FF2B5EF4-FFF2-40B4-BE49-F238E27FC236}">
+                <a16:creationId xmlns:a16="http://schemas.microsoft.com/office/drawing/2014/main" id="{FDEF4397-8E2E-4CDD-917A-6FA2D1669F7F}"/>
+              </a:ext>
+            </a:extLst>
+          </p:cNvPr>
+          <p:cNvSpPr>
+            <a:spLocks noGrp="1"/>
+          </p:cNvSpPr>
+          <p:nvPr/>
+        </p:nvSpPr>
+        <p:spPr>
+          <a:xfrm>
+            <a:off x="7524750" y="4314825"/>
+            <a:ext cx="3714750" cy="552450"/>
+          </a:xfrm>
+          <a:prstGeom prst="roundRect">
+            <a:avLst>
+              <a:gd name="adj" fmla="val 13793"/>
+            </a:avLst>
+          </a:prstGeom>
+          <a:solidFill>
+            <a:srgbClr val="F7F7F8"/>
+          </a:solidFill>
+          <a:ln w="14288">
+            <a:solidFill>
+              <a:srgbClr val="E84C22"/>
+            </a:solidFill>
+            <a:prstDash val="solid"/>
+          </a:ln>
+        </p:spPr>
+      </p:sp>
+      <p:sp>
+        <p:nvSpPr>
+          <p:cNvPr id="31" name="STEP_4_OUTPUT">
+            <a:extLst>
+              <a:ext uri="{FF2B5EF4-FFF2-40B4-BE49-F238E27FC236}">
+                <a16:creationId xmlns:a16="http://schemas.microsoft.com/office/drawing/2014/main" id="{377542C7-CC1D-439C-AA5E-568ECDD6891A}"/>
+              </a:ext>
+            </a:extLst>
+          </p:cNvPr>
+          <p:cNvSpPr>
+            <a:spLocks noGrp="1"/>
+          </p:cNvSpPr>
+          <p:nvPr/>
+        </p:nvSpPr>
+        <p:spPr>
+          <a:xfrm>
+            <a:off x="7715250" y="4429125"/>
+            <a:ext cx="3333750" cy="323850"/>
+          </a:xfrm>
+          <a:prstGeom prst="rect">
+            <a:avLst/>
+          </a:prstGeom>
+          <a:noFill/>
+          <a:ln w="0">
+            <a:noFill/>
+            <a:prstDash val="solid"/>
+          </a:ln>
+        </p:spPr>
+        <p:txBody>
+          <a:bodyPr wrap="square" lIns="38100" tIns="19050" rIns="38100" bIns="19050" anchor="ctr">
+            <a:normAutofit/>
+          </a:bodyPr>
+          <a:lstStyle/>
+          <a:p>
+            <a:pPr algn="l">
+              <a:defRPr sz="1275" b="1">
+                <a:solidFill>
+                  <a:srgbClr val="E84C22"/>
+                </a:solidFill>
+                <a:latin typeface="Microsoft YaHei"/>
+                <a:ea typeface="Microsoft YaHei"/>
+                <a:cs typeface="Microsoft YaHei"/>
+              </a:defRPr>
+            </a:pPr>
+            <a:r>
+              <a:rPr sz="1275" b="1">
+                <a:solidFill>
+                  <a:srgbClr val="B22600"/>
                 </a:solidFill>
                 <a:latin typeface="Microsoft YaHei"/>
                 <a:ea typeface="Microsoft YaHei"/>

</xml_diff>

<commit_message>
Unify all graphics to deep red B22600 - full palette is now deep red/ink/grey/white
User: graphics also need unification. All remaining orange-red (E84C22) and amber (FFBD47) across slides 1-14 (graphics: dots, lines, outlines) mapped to deep red B22600. Verified: zero E84C22/FFBD47 anywhere in the deck. DC-01 invariant updated to 'unified deep red'. Full palette: deep red + ink + grey + white/near-white (SHA B4830534).
</commit_message>
<xml_diff>
--- a/domains/yuhong/assets/components/yuhong-county-course-components-branded.pptx
+++ b/domains/yuhong/assets/components/yuhong-county-course-components-branded.pptx
@@ -1366,7 +1366,7 @@
             <a:pPr algn="l">
               <a:defRPr sz="975" b="1">
                 <a:solidFill>
-                  <a:srgbClr val="E84C22"/>
+                  <a:srgbClr val="B22600"/>
                 </a:solidFill>
                 <a:latin typeface="Microsoft YaHei"/>
                 <a:ea typeface="Microsoft YaHei"/>
@@ -1571,7 +1571,7 @@
             <a:pPr algn="l">
               <a:defRPr sz="3150" b="1">
                 <a:solidFill>
-                  <a:srgbClr val="E84C22"/>
+                  <a:srgbClr val="B22600"/>
                 </a:solidFill>
                 <a:latin typeface="Microsoft YaHei"/>
                 <a:ea typeface="Microsoft YaHei"/>
@@ -1725,304 +1725,6 @@
         <p:spPr>
           <a:xfrm>
             <a:off x="6724650" y="2133600"/>
-            <a:ext cx="1066800" cy="361950"/>
-          </a:xfrm>
-          <a:prstGeom prst="rightArrow">
-            <a:avLst/>
-          </a:prstGeom>
-          <a:solidFill>
-            <a:srgbClr val="E84C22"/>
-          </a:solidFill>
-          <a:ln w="0">
-            <a:noFill/>
-            <a:prstDash val="solid"/>
-          </a:ln>
-        </p:spPr>
-      </p:sp>
-      <p:sp>
-        <p:nvSpPr>
-          <p:cNvPr id="11" name="J01_TO_SURFACE">
-            <a:extLst>
-              <a:ext uri="{FF2B5EF4-FFF2-40B4-BE49-F238E27FC236}">
-                <a16:creationId xmlns:a16="http://schemas.microsoft.com/office/drawing/2014/main" id="{CBB658FB-269F-46D0-80D2-DB4C8BC974DD}"/>
-              </a:ext>
-            </a:extLst>
-          </p:cNvPr>
-          <p:cNvSpPr>
-            <a:spLocks noGrp="1"/>
-          </p:cNvSpPr>
-          <p:nvPr/>
-        </p:nvSpPr>
-        <p:spPr>
-          <a:xfrm>
-            <a:off x="8020050" y="2019300"/>
-            <a:ext cx="3333750" cy="590550"/>
-          </a:xfrm>
-          <a:prstGeom prst="roundRect">
-            <a:avLst>
-              <a:gd name="adj" fmla="val 12903"/>
-            </a:avLst>
-          </a:prstGeom>
-          <a:solidFill>
-            <a:srgbClr val="F7F7F8"/>
-          </a:solidFill>
-          <a:ln w="14288">
-            <a:solidFill>
-              <a:srgbClr val="E84C22"/>
-            </a:solidFill>
-            <a:prstDash val="solid"/>
-          </a:ln>
-        </p:spPr>
-      </p:sp>
-      <p:sp>
-        <p:nvSpPr>
-          <p:cNvPr id="12" name="J01_TO">
-            <a:extLst>
-              <a:ext uri="{FF2B5EF4-FFF2-40B4-BE49-F238E27FC236}">
-                <a16:creationId xmlns:a16="http://schemas.microsoft.com/office/drawing/2014/main" id="{F3D14615-927C-45BC-B09F-CC27811BFD1F}"/>
-              </a:ext>
-            </a:extLst>
-          </p:cNvPr>
-          <p:cNvSpPr>
-            <a:spLocks noGrp="1"/>
-          </p:cNvSpPr>
-          <p:nvPr/>
-        </p:nvSpPr>
-        <p:spPr>
-          <a:xfrm>
-            <a:off x="8172450" y="2124075"/>
-            <a:ext cx="3028950" cy="381000"/>
-          </a:xfrm>
-          <a:prstGeom prst="rect">
-            <a:avLst/>
-          </a:prstGeom>
-          <a:noFill/>
-          <a:ln w="0">
-            <a:noFill/>
-            <a:prstDash val="solid"/>
-          </a:ln>
-        </p:spPr>
-        <p:txBody>
-          <a:bodyPr wrap="square" lIns="38100" tIns="19050" rIns="38100" bIns="19050" anchor="ctr">
-            <a:normAutofit/>
-          </a:bodyPr>
-          <a:lstStyle/>
-          <a:p>
-            <a:pPr algn="ctr">
-              <a:defRPr sz="1425" b="1">
-                <a:solidFill>
-                  <a:srgbClr val="E84C22"/>
-                </a:solidFill>
-                <a:latin typeface="Microsoft YaHei"/>
-                <a:ea typeface="Microsoft YaHei"/>
-                <a:cs typeface="Microsoft YaHei"/>
-              </a:defRPr>
-            </a:pPr>
-            <a:r>
-              <a:rPr sz="1425" b="1">
-                <a:solidFill>
-                  <a:srgbClr val="B22600"/>
-                </a:solidFill>
-                <a:latin typeface="Microsoft YaHei"/>
-                <a:ea typeface="Microsoft YaHei"/>
-                <a:cs typeface="Microsoft YaHei"/>
-              </a:rPr>
-              <a:t>新建 + 翻修 + 维修 + 更新</a:t>
-            </a:r>
-          </a:p>
-        </p:txBody>
-      </p:sp>
-      <p:sp>
-        <p:nvSpPr>
-          <p:cNvPr id="13" name="J02_NUMBER">
-            <a:extLst>
-              <a:ext uri="{FF2B5EF4-FFF2-40B4-BE49-F238E27FC236}">
-                <a16:creationId xmlns:a16="http://schemas.microsoft.com/office/drawing/2014/main" id="{348DA8DF-6A44-478D-A237-895FED395D86}"/>
-              </a:ext>
-            </a:extLst>
-          </p:cNvPr>
-          <p:cNvSpPr>
-            <a:spLocks noGrp="1"/>
-          </p:cNvSpPr>
-          <p:nvPr/>
-        </p:nvSpPr>
-        <p:spPr>
-          <a:xfrm>
-            <a:off x="533400" y="3390900"/>
-            <a:ext cx="609600" cy="609600"/>
-          </a:xfrm>
-          <a:prstGeom prst="rect">
-            <a:avLst/>
-          </a:prstGeom>
-          <a:noFill/>
-          <a:ln w="0">
-            <a:noFill/>
-            <a:prstDash val="solid"/>
-          </a:ln>
-        </p:spPr>
-        <p:txBody>
-          <a:bodyPr wrap="square" lIns="38100" tIns="19050" rIns="38100" bIns="19050" anchor="t">
-            <a:normAutofit/>
-          </a:bodyPr>
-          <a:lstStyle/>
-          <a:p>
-            <a:pPr algn="l">
-              <a:defRPr sz="3150" b="1">
-                <a:solidFill>
-                  <a:srgbClr val="B22600"/>
-                </a:solidFill>
-                <a:latin typeface="Microsoft YaHei"/>
-                <a:ea typeface="Microsoft YaHei"/>
-                <a:cs typeface="Microsoft YaHei"/>
-              </a:defRPr>
-            </a:pPr>
-            <a:r>
-              <a:rPr sz="3150" b="1">
-                <a:solidFill>
-                  <a:srgbClr val="B22600"/>
-                </a:solidFill>
-                <a:latin typeface="Microsoft YaHei"/>
-                <a:ea typeface="Microsoft YaHei"/>
-                <a:cs typeface="Microsoft YaHei"/>
-              </a:rPr>
-              <a:t>02</a:t>
-            </a:r>
-          </a:p>
-        </p:txBody>
-      </p:sp>
-      <p:sp>
-        <p:nvSpPr>
-          <p:cNvPr id="14" name="J02_LABEL">
-            <a:extLst>
-              <a:ext uri="{FF2B5EF4-FFF2-40B4-BE49-F238E27FC236}">
-                <a16:creationId xmlns:a16="http://schemas.microsoft.com/office/drawing/2014/main" id="{B0B969D8-36D6-4B22-952F-5034E8666BAD}"/>
-              </a:ext>
-            </a:extLst>
-          </p:cNvPr>
-          <p:cNvSpPr>
-            <a:spLocks noGrp="1"/>
-          </p:cNvSpPr>
-          <p:nvPr/>
-        </p:nvSpPr>
-        <p:spPr>
-          <a:xfrm>
-            <a:off x="1352550" y="3409950"/>
-            <a:ext cx="2190750" cy="361950"/>
-          </a:xfrm>
-          <a:prstGeom prst="rect">
-            <a:avLst/>
-          </a:prstGeom>
-          <a:noFill/>
-          <a:ln w="0">
-            <a:noFill/>
-            <a:prstDash val="solid"/>
-          </a:ln>
-        </p:spPr>
-        <p:txBody>
-          <a:bodyPr wrap="square" lIns="38100" tIns="19050" rIns="38100" bIns="19050" anchor="t">
-            <a:normAutofit/>
-          </a:bodyPr>
-          <a:lstStyle/>
-          <a:p>
-            <a:pPr algn="l">
-              <a:defRPr sz="1725" b="1">
-                <a:solidFill>
-                  <a:srgbClr val="191919"/>
-                </a:solidFill>
-                <a:latin typeface="Microsoft YaHei"/>
-                <a:ea typeface="Microsoft YaHei"/>
-                <a:cs typeface="Microsoft YaHei"/>
-              </a:defRPr>
-            </a:pPr>
-            <a:r>
-              <a:rPr sz="1725" b="1">
-                <a:solidFill>
-                  <a:srgbClr val="191919"/>
-                </a:solidFill>
-                <a:latin typeface="Microsoft YaHei"/>
-                <a:ea typeface="Microsoft YaHei"/>
-                <a:cs typeface="Microsoft YaHei"/>
-              </a:rPr>
-              <a:t>机会位置变了</a:t>
-            </a:r>
-          </a:p>
-        </p:txBody>
-      </p:sp>
-      <p:sp>
-        <p:nvSpPr>
-          <p:cNvPr id="15" name="J02_FROM">
-            <a:extLst>
-              <a:ext uri="{FF2B5EF4-FFF2-40B4-BE49-F238E27FC236}">
-                <a16:creationId xmlns:a16="http://schemas.microsoft.com/office/drawing/2014/main" id="{D06E2F57-162B-4FDF-B228-74D11F8257F4}"/>
-              </a:ext>
-            </a:extLst>
-          </p:cNvPr>
-          <p:cNvSpPr>
-            <a:spLocks noGrp="1"/>
-          </p:cNvSpPr>
-          <p:nvPr/>
-        </p:nvSpPr>
-        <p:spPr>
-          <a:xfrm>
-            <a:off x="3810000" y="3333750"/>
-            <a:ext cx="2762250" cy="552450"/>
-          </a:xfrm>
-          <a:prstGeom prst="rect">
-            <a:avLst/>
-          </a:prstGeom>
-          <a:noFill/>
-          <a:ln w="0">
-            <a:noFill/>
-            <a:prstDash val="solid"/>
-          </a:ln>
-        </p:spPr>
-        <p:txBody>
-          <a:bodyPr wrap="square" lIns="38100" tIns="19050" rIns="38100" bIns="19050" anchor="ctr">
-            <a:normAutofit/>
-          </a:bodyPr>
-          <a:lstStyle/>
-          <a:p>
-            <a:pPr algn="ctr">
-              <a:defRPr sz="1425" b="0">
-                <a:solidFill>
-                  <a:srgbClr val="6F6F6A"/>
-                </a:solidFill>
-                <a:latin typeface="Microsoft YaHei"/>
-                <a:ea typeface="Microsoft YaHei"/>
-                <a:cs typeface="Microsoft YaHei"/>
-              </a:defRPr>
-            </a:pPr>
-            <a:r>
-              <a:rPr sz="1425" b="0">
-                <a:solidFill>
-                  <a:srgbClr val="6F6F6A"/>
-                </a:solidFill>
-                <a:latin typeface="Microsoft YaHei"/>
-                <a:ea typeface="Microsoft YaHei"/>
-                <a:cs typeface="Microsoft YaHei"/>
-              </a:rPr>
-              <a:t>只盯县城门店</a:t>
-            </a:r>
-          </a:p>
-        </p:txBody>
-      </p:sp>
-      <p:sp>
-        <p:nvSpPr>
-          <p:cNvPr id="16" name="J02_ARROW">
-            <a:extLst>
-              <a:ext uri="{FF2B5EF4-FFF2-40B4-BE49-F238E27FC236}">
-                <a16:creationId xmlns:a16="http://schemas.microsoft.com/office/drawing/2014/main" id="{E31BA782-9A19-418B-B8B7-3C853731F226}"/>
-              </a:ext>
-            </a:extLst>
-          </p:cNvPr>
-          <p:cNvSpPr>
-            <a:spLocks noGrp="1"/>
-          </p:cNvSpPr>
-          <p:nvPr/>
-        </p:nvSpPr>
-        <p:spPr>
-          <a:xfrm>
-            <a:off x="6724650" y="3429000"/>
             <a:ext cx="1066800" cy="361950"/>
           </a:xfrm>
           <a:prstGeom prst="rightArrow">
@@ -2039,10 +1741,10 @@
       </p:sp>
       <p:sp>
         <p:nvSpPr>
-          <p:cNvPr id="17" name="J02_TO_SURFACE">
-            <a:extLst>
-              <a:ext uri="{FF2B5EF4-FFF2-40B4-BE49-F238E27FC236}">
-                <a16:creationId xmlns:a16="http://schemas.microsoft.com/office/drawing/2014/main" id="{1E1EBA9A-2EDB-4355-9ECE-E249B6BF7D43}"/>
+          <p:cNvPr id="11" name="J01_TO_SURFACE">
+            <a:extLst>
+              <a:ext uri="{FF2B5EF4-FFF2-40B4-BE49-F238E27FC236}">
+                <a16:creationId xmlns:a16="http://schemas.microsoft.com/office/drawing/2014/main" id="{CBB658FB-269F-46D0-80D2-DB4C8BC974DD}"/>
               </a:ext>
             </a:extLst>
           </p:cNvPr>
@@ -2053,7 +1755,7 @@
         </p:nvSpPr>
         <p:spPr>
           <a:xfrm>
-            <a:off x="8020050" y="3314700"/>
+            <a:off x="8020050" y="2019300"/>
             <a:ext cx="3333750" cy="590550"/>
           </a:xfrm>
           <a:prstGeom prst="roundRect">
@@ -2074,10 +1776,10 @@
       </p:sp>
       <p:sp>
         <p:nvSpPr>
-          <p:cNvPr id="18" name="J02_TO">
-            <a:extLst>
-              <a:ext uri="{FF2B5EF4-FFF2-40B4-BE49-F238E27FC236}">
-                <a16:creationId xmlns:a16="http://schemas.microsoft.com/office/drawing/2014/main" id="{E8E3C8E5-B537-4173-9ECD-4E709F1B2167}"/>
+          <p:cNvPr id="12" name="J01_TO">
+            <a:extLst>
+              <a:ext uri="{FF2B5EF4-FFF2-40B4-BE49-F238E27FC236}">
+                <a16:creationId xmlns:a16="http://schemas.microsoft.com/office/drawing/2014/main" id="{F3D14615-927C-45BC-B09F-CC27811BFD1F}"/>
               </a:ext>
             </a:extLst>
           </p:cNvPr>
@@ -2088,7 +1790,7 @@
         </p:nvSpPr>
         <p:spPr>
           <a:xfrm>
-            <a:off x="8172450" y="3419475"/>
+            <a:off x="8172450" y="2124075"/>
             <a:ext cx="3028950" cy="381000"/>
           </a:xfrm>
           <a:prstGeom prst="rect">
@@ -2125,17 +1827,17 @@
                 <a:ea typeface="Microsoft YaHei"/>
                 <a:cs typeface="Microsoft YaHei"/>
               </a:rPr>
-              <a:t>县城经营中心 + 重点乡镇需求触点</a:t>
-            </a:r>
-          </a:p>
-        </p:txBody>
-      </p:sp>
-      <p:sp>
-        <p:nvSpPr>
-          <p:cNvPr id="19" name="J03_NUMBER">
-            <a:extLst>
-              <a:ext uri="{FF2B5EF4-FFF2-40B4-BE49-F238E27FC236}">
-                <a16:creationId xmlns:a16="http://schemas.microsoft.com/office/drawing/2014/main" id="{3FAF351A-76BC-49AD-A1B2-8CE7C5073567}"/>
+              <a:t>新建 + 翻修 + 维修 + 更新</a:t>
+            </a:r>
+          </a:p>
+        </p:txBody>
+      </p:sp>
+      <p:sp>
+        <p:nvSpPr>
+          <p:cNvPr id="13" name="J02_NUMBER">
+            <a:extLst>
+              <a:ext uri="{FF2B5EF4-FFF2-40B4-BE49-F238E27FC236}">
+                <a16:creationId xmlns:a16="http://schemas.microsoft.com/office/drawing/2014/main" id="{348DA8DF-6A44-478D-A237-895FED395D86}"/>
               </a:ext>
             </a:extLst>
           </p:cNvPr>
@@ -2146,7 +1848,7 @@
         </p:nvSpPr>
         <p:spPr>
           <a:xfrm>
-            <a:off x="533400" y="4686300"/>
+            <a:off x="533400" y="3390900"/>
             <a:ext cx="609600" cy="609600"/>
           </a:xfrm>
           <a:prstGeom prst="rect">
@@ -2167,7 +1869,7 @@
             <a:pPr algn="l">
               <a:defRPr sz="3150" b="1">
                 <a:solidFill>
-                  <a:srgbClr val="E84C22"/>
+                  <a:srgbClr val="B22600"/>
                 </a:solidFill>
                 <a:latin typeface="Microsoft YaHei"/>
                 <a:ea typeface="Microsoft YaHei"/>
@@ -2183,17 +1885,17 @@
                 <a:ea typeface="Microsoft YaHei"/>
                 <a:cs typeface="Microsoft YaHei"/>
               </a:rPr>
-              <a:t>03</a:t>
-            </a:r>
-          </a:p>
-        </p:txBody>
-      </p:sp>
-      <p:sp>
-        <p:nvSpPr>
-          <p:cNvPr id="20" name="J03_LABEL">
-            <a:extLst>
-              <a:ext uri="{FF2B5EF4-FFF2-40B4-BE49-F238E27FC236}">
-                <a16:creationId xmlns:a16="http://schemas.microsoft.com/office/drawing/2014/main" id="{C0FDA0D9-0C3A-40BF-8055-76E0C7011050}"/>
+              <a:t>02</a:t>
+            </a:r>
+          </a:p>
+        </p:txBody>
+      </p:sp>
+      <p:sp>
+        <p:nvSpPr>
+          <p:cNvPr id="14" name="J02_LABEL">
+            <a:extLst>
+              <a:ext uri="{FF2B5EF4-FFF2-40B4-BE49-F238E27FC236}">
+                <a16:creationId xmlns:a16="http://schemas.microsoft.com/office/drawing/2014/main" id="{B0B969D8-36D6-4B22-952F-5034E8666BAD}"/>
               </a:ext>
             </a:extLst>
           </p:cNvPr>
@@ -2204,7 +1906,7 @@
         </p:nvSpPr>
         <p:spPr>
           <a:xfrm>
-            <a:off x="1352550" y="4705350"/>
+            <a:off x="1352550" y="3409950"/>
             <a:ext cx="2190750" cy="361950"/>
           </a:xfrm>
           <a:prstGeom prst="rect">
@@ -2241,17 +1943,17 @@
                 <a:ea typeface="Microsoft YaHei"/>
                 <a:cs typeface="Microsoft YaHei"/>
               </a:rPr>
-              <a:t>购买逻辑变了</a:t>
-            </a:r>
-          </a:p>
-        </p:txBody>
-      </p:sp>
-      <p:sp>
-        <p:nvSpPr>
-          <p:cNvPr id="21" name="J03_FROM">
-            <a:extLst>
-              <a:ext uri="{FF2B5EF4-FFF2-40B4-BE49-F238E27FC236}">
-                <a16:creationId xmlns:a16="http://schemas.microsoft.com/office/drawing/2014/main" id="{A15819D4-F01B-4DF7-A69F-3D4A9ADDA2B8}"/>
+              <a:t>机会位置变了</a:t>
+            </a:r>
+          </a:p>
+        </p:txBody>
+      </p:sp>
+      <p:sp>
+        <p:nvSpPr>
+          <p:cNvPr id="15" name="J02_FROM">
+            <a:extLst>
+              <a:ext uri="{FF2B5EF4-FFF2-40B4-BE49-F238E27FC236}">
+                <a16:creationId xmlns:a16="http://schemas.microsoft.com/office/drawing/2014/main" id="{D06E2F57-162B-4FDF-B228-74D11F8257F4}"/>
               </a:ext>
             </a:extLst>
           </p:cNvPr>
@@ -2262,7 +1964,7 @@
         </p:nvSpPr>
         <p:spPr>
           <a:xfrm>
-            <a:off x="3810000" y="4629150"/>
+            <a:off x="3810000" y="3333750"/>
             <a:ext cx="2762250" cy="552450"/>
           </a:xfrm>
           <a:prstGeom prst="rect">
@@ -2299,17 +2001,17 @@
                 <a:ea typeface="Microsoft YaHei"/>
                 <a:cs typeface="Microsoft YaHei"/>
               </a:rPr>
-              <a:t>产品与价格</a:t>
-            </a:r>
-          </a:p>
-        </p:txBody>
-      </p:sp>
-      <p:sp>
-        <p:nvSpPr>
-          <p:cNvPr id="22" name="J03_ARROW">
-            <a:extLst>
-              <a:ext uri="{FF2B5EF4-FFF2-40B4-BE49-F238E27FC236}">
-                <a16:creationId xmlns:a16="http://schemas.microsoft.com/office/drawing/2014/main" id="{A5FDEBE8-FB0A-4371-A995-65961A8FE8DA}"/>
+              <a:t>只盯县城门店</a:t>
+            </a:r>
+          </a:p>
+        </p:txBody>
+      </p:sp>
+      <p:sp>
+        <p:nvSpPr>
+          <p:cNvPr id="16" name="J02_ARROW">
+            <a:extLst>
+              <a:ext uri="{FF2B5EF4-FFF2-40B4-BE49-F238E27FC236}">
+                <a16:creationId xmlns:a16="http://schemas.microsoft.com/office/drawing/2014/main" id="{E31BA782-9A19-418B-B8B7-3C853731F226}"/>
               </a:ext>
             </a:extLst>
           </p:cNvPr>
@@ -2320,14 +2022,14 @@
         </p:nvSpPr>
         <p:spPr>
           <a:xfrm>
-            <a:off x="6724650" y="4724400"/>
+            <a:off x="6724650" y="3429000"/>
             <a:ext cx="1066800" cy="361950"/>
           </a:xfrm>
           <a:prstGeom prst="rightArrow">
             <a:avLst/>
           </a:prstGeom>
           <a:solidFill>
-            <a:srgbClr val="E84C22"/>
+            <a:srgbClr val="B22600"/>
           </a:solidFill>
           <a:ln w="0">
             <a:noFill/>
@@ -2337,10 +2039,10 @@
       </p:sp>
       <p:sp>
         <p:nvSpPr>
-          <p:cNvPr id="23" name="J03_TO_SURFACE">
-            <a:extLst>
-              <a:ext uri="{FF2B5EF4-FFF2-40B4-BE49-F238E27FC236}">
-                <a16:creationId xmlns:a16="http://schemas.microsoft.com/office/drawing/2014/main" id="{A60BA2DD-F7E3-4999-B8F2-DA8EC4632080}"/>
+          <p:cNvPr id="17" name="J02_TO_SURFACE">
+            <a:extLst>
+              <a:ext uri="{FF2B5EF4-FFF2-40B4-BE49-F238E27FC236}">
+                <a16:creationId xmlns:a16="http://schemas.microsoft.com/office/drawing/2014/main" id="{1E1EBA9A-2EDB-4355-9ECE-E249B6BF7D43}"/>
               </a:ext>
             </a:extLst>
           </p:cNvPr>
@@ -2351,7 +2053,7 @@
         </p:nvSpPr>
         <p:spPr>
           <a:xfrm>
-            <a:off x="8020050" y="4610100"/>
+            <a:off x="8020050" y="3314700"/>
             <a:ext cx="3333750" cy="590550"/>
           </a:xfrm>
           <a:prstGeom prst="roundRect">
@@ -2364,7 +2066,7 @@
           </a:solidFill>
           <a:ln w="14288">
             <a:solidFill>
-              <a:srgbClr val="E84C22"/>
+              <a:srgbClr val="B22600"/>
             </a:solidFill>
             <a:prstDash val="solid"/>
           </a:ln>
@@ -2372,10 +2074,10 @@
       </p:sp>
       <p:sp>
         <p:nvSpPr>
-          <p:cNvPr id="24" name="J03_TO">
-            <a:extLst>
-              <a:ext uri="{FF2B5EF4-FFF2-40B4-BE49-F238E27FC236}">
-                <a16:creationId xmlns:a16="http://schemas.microsoft.com/office/drawing/2014/main" id="{ADBD459D-66CB-4E01-AE5D-A1A803814D88}"/>
+          <p:cNvPr id="18" name="J02_TO">
+            <a:extLst>
+              <a:ext uri="{FF2B5EF4-FFF2-40B4-BE49-F238E27FC236}">
+                <a16:creationId xmlns:a16="http://schemas.microsoft.com/office/drawing/2014/main" id="{E8E3C8E5-B537-4173-9ECD-4E709F1B2167}"/>
               </a:ext>
             </a:extLst>
           </p:cNvPr>
@@ -2386,7 +2088,7 @@
         </p:nvSpPr>
         <p:spPr>
           <a:xfrm>
-            <a:off x="8172450" y="4714875"/>
+            <a:off x="8172450" y="3419475"/>
             <a:ext cx="3028950" cy="381000"/>
           </a:xfrm>
           <a:prstGeom prst="rect">
@@ -2400,14 +2102,14 @@
         </p:spPr>
         <p:txBody>
           <a:bodyPr wrap="square" lIns="38100" tIns="19050" rIns="38100" bIns="19050" anchor="ctr">
-            <a:normAutofit fontScale="97829"/>
+            <a:normAutofit/>
           </a:bodyPr>
           <a:lstStyle/>
           <a:p>
             <a:pPr algn="ctr">
               <a:defRPr sz="1425" b="1">
                 <a:solidFill>
-                  <a:srgbClr val="E84C22"/>
+                  <a:srgbClr val="B22600"/>
                 </a:solidFill>
                 <a:latin typeface="Microsoft YaHei"/>
                 <a:ea typeface="Microsoft YaHei"/>
@@ -2423,17 +2125,17 @@
                 <a:ea typeface="Microsoft YaHei"/>
                 <a:cs typeface="Microsoft YaHei"/>
               </a:rPr>
-              <a:t>品牌 + 熟人推荐 + 施工与售后确定性</a:t>
-            </a:r>
-          </a:p>
-        </p:txBody>
-      </p:sp>
-      <p:sp>
-        <p:nvSpPr>
-          <p:cNvPr id="25" name="TEACHING_CUE">
-            <a:extLst>
-              <a:ext uri="{FF2B5EF4-FFF2-40B4-BE49-F238E27FC236}">
-                <a16:creationId xmlns:a16="http://schemas.microsoft.com/office/drawing/2014/main" id="{E1EFE987-8404-48B5-9F5C-5766F6BAE40D}"/>
+              <a:t>县城经营中心 + 重点乡镇需求触点</a:t>
+            </a:r>
+          </a:p>
+        </p:txBody>
+      </p:sp>
+      <p:sp>
+        <p:nvSpPr>
+          <p:cNvPr id="19" name="J03_NUMBER">
+            <a:extLst>
+              <a:ext uri="{FF2B5EF4-FFF2-40B4-BE49-F238E27FC236}">
+                <a16:creationId xmlns:a16="http://schemas.microsoft.com/office/drawing/2014/main" id="{3FAF351A-76BC-49AD-A1B2-8CE7C5073567}"/>
               </a:ext>
             </a:extLst>
           </p:cNvPr>
@@ -2444,8 +2146,8 @@
         </p:nvSpPr>
         <p:spPr>
           <a:xfrm>
-            <a:off x="514350" y="6410325"/>
-            <a:ext cx="9810750" cy="228600"/>
+            <a:off x="533400" y="4686300"/>
+            <a:ext cx="609600" cy="609600"/>
           </a:xfrm>
           <a:prstGeom prst="rect">
             <a:avLst/>
@@ -2463,9 +2165,9 @@
           <a:lstStyle/>
           <a:p>
             <a:pPr algn="l">
-              <a:defRPr sz="975" b="0">
-                <a:solidFill>
-                  <a:srgbClr val="6F6F6A"/>
+              <a:defRPr sz="3150" b="1">
+                <a:solidFill>
+                  <a:srgbClr val="B22600"/>
                 </a:solidFill>
                 <a:latin typeface="Microsoft YaHei"/>
                 <a:ea typeface="Microsoft YaHei"/>
@@ -2473,25 +2175,25 @@
               </a:defRPr>
             </a:pPr>
             <a:r>
-              <a:rPr sz="975" b="0">
-                <a:solidFill>
-                  <a:srgbClr val="6F6F6A"/>
-                </a:solidFill>
-                <a:latin typeface="Microsoft YaHei"/>
-                <a:ea typeface="Microsoft YaHei"/>
-                <a:cs typeface="Microsoft YaHei"/>
-              </a:rPr>
-              <a:t>讲师动作：先问“机会哪里变了”，收集答案后逐条揭示三条判断。</a:t>
-            </a:r>
-          </a:p>
-        </p:txBody>
-      </p:sp>
-      <p:sp>
-        <p:nvSpPr>
-          <p:cNvPr id="26" name="PAGE_NUMBER">
-            <a:extLst>
-              <a:ext uri="{FF2B5EF4-FFF2-40B4-BE49-F238E27FC236}">
-                <a16:creationId xmlns:a16="http://schemas.microsoft.com/office/drawing/2014/main" id="{EE5A4A45-F944-4D1C-B0A6-6E5A090FBF12}"/>
+              <a:rPr sz="3150" b="1">
+                <a:solidFill>
+                  <a:srgbClr val="B22600"/>
+                </a:solidFill>
+                <a:latin typeface="Microsoft YaHei"/>
+                <a:ea typeface="Microsoft YaHei"/>
+                <a:cs typeface="Microsoft YaHei"/>
+              </a:rPr>
+              <a:t>03</a:t>
+            </a:r>
+          </a:p>
+        </p:txBody>
+      </p:sp>
+      <p:sp>
+        <p:nvSpPr>
+          <p:cNvPr id="20" name="J03_LABEL">
+            <a:extLst>
+              <a:ext uri="{FF2B5EF4-FFF2-40B4-BE49-F238E27FC236}">
+                <a16:creationId xmlns:a16="http://schemas.microsoft.com/office/drawing/2014/main" id="{C0FDA0D9-0C3A-40BF-8055-76E0C7011050}"/>
               </a:ext>
             </a:extLst>
           </p:cNvPr>
@@ -2502,8 +2204,8 @@
         </p:nvSpPr>
         <p:spPr>
           <a:xfrm>
-            <a:off x="11049000" y="6391275"/>
-            <a:ext cx="666750" cy="228600"/>
+            <a:off x="1352550" y="4705350"/>
+            <a:ext cx="2190750" cy="361950"/>
           </a:xfrm>
           <a:prstGeom prst="rect">
             <a:avLst/>
@@ -2520,10 +2222,308 @@
           </a:bodyPr>
           <a:lstStyle/>
           <a:p>
+            <a:pPr algn="l">
+              <a:defRPr sz="1725" b="1">
+                <a:solidFill>
+                  <a:srgbClr val="191919"/>
+                </a:solidFill>
+                <a:latin typeface="Microsoft YaHei"/>
+                <a:ea typeface="Microsoft YaHei"/>
+                <a:cs typeface="Microsoft YaHei"/>
+              </a:defRPr>
+            </a:pPr>
+            <a:r>
+              <a:rPr sz="1725" b="1">
+                <a:solidFill>
+                  <a:srgbClr val="191919"/>
+                </a:solidFill>
+                <a:latin typeface="Microsoft YaHei"/>
+                <a:ea typeface="Microsoft YaHei"/>
+                <a:cs typeface="Microsoft YaHei"/>
+              </a:rPr>
+              <a:t>购买逻辑变了</a:t>
+            </a:r>
+          </a:p>
+        </p:txBody>
+      </p:sp>
+      <p:sp>
+        <p:nvSpPr>
+          <p:cNvPr id="21" name="J03_FROM">
+            <a:extLst>
+              <a:ext uri="{FF2B5EF4-FFF2-40B4-BE49-F238E27FC236}">
+                <a16:creationId xmlns:a16="http://schemas.microsoft.com/office/drawing/2014/main" id="{A15819D4-F01B-4DF7-A69F-3D4A9ADDA2B8}"/>
+              </a:ext>
+            </a:extLst>
+          </p:cNvPr>
+          <p:cNvSpPr>
+            <a:spLocks noGrp="1"/>
+          </p:cNvSpPr>
+          <p:nvPr/>
+        </p:nvSpPr>
+        <p:spPr>
+          <a:xfrm>
+            <a:off x="3810000" y="4629150"/>
+            <a:ext cx="2762250" cy="552450"/>
+          </a:xfrm>
+          <a:prstGeom prst="rect">
+            <a:avLst/>
+          </a:prstGeom>
+          <a:noFill/>
+          <a:ln w="0">
+            <a:noFill/>
+            <a:prstDash val="solid"/>
+          </a:ln>
+        </p:spPr>
+        <p:txBody>
+          <a:bodyPr wrap="square" lIns="38100" tIns="19050" rIns="38100" bIns="19050" anchor="ctr">
+            <a:normAutofit/>
+          </a:bodyPr>
+          <a:lstStyle/>
+          <a:p>
+            <a:pPr algn="ctr">
+              <a:defRPr sz="1425" b="0">
+                <a:solidFill>
+                  <a:srgbClr val="6F6F6A"/>
+                </a:solidFill>
+                <a:latin typeface="Microsoft YaHei"/>
+                <a:ea typeface="Microsoft YaHei"/>
+                <a:cs typeface="Microsoft YaHei"/>
+              </a:defRPr>
+            </a:pPr>
+            <a:r>
+              <a:rPr sz="1425" b="0">
+                <a:solidFill>
+                  <a:srgbClr val="6F6F6A"/>
+                </a:solidFill>
+                <a:latin typeface="Microsoft YaHei"/>
+                <a:ea typeface="Microsoft YaHei"/>
+                <a:cs typeface="Microsoft YaHei"/>
+              </a:rPr>
+              <a:t>产品与价格</a:t>
+            </a:r>
+          </a:p>
+        </p:txBody>
+      </p:sp>
+      <p:sp>
+        <p:nvSpPr>
+          <p:cNvPr id="22" name="J03_ARROW">
+            <a:extLst>
+              <a:ext uri="{FF2B5EF4-FFF2-40B4-BE49-F238E27FC236}">
+                <a16:creationId xmlns:a16="http://schemas.microsoft.com/office/drawing/2014/main" id="{A5FDEBE8-FB0A-4371-A995-65961A8FE8DA}"/>
+              </a:ext>
+            </a:extLst>
+          </p:cNvPr>
+          <p:cNvSpPr>
+            <a:spLocks noGrp="1"/>
+          </p:cNvSpPr>
+          <p:nvPr/>
+        </p:nvSpPr>
+        <p:spPr>
+          <a:xfrm>
+            <a:off x="6724650" y="4724400"/>
+            <a:ext cx="1066800" cy="361950"/>
+          </a:xfrm>
+          <a:prstGeom prst="rightArrow">
+            <a:avLst/>
+          </a:prstGeom>
+          <a:solidFill>
+            <a:srgbClr val="B22600"/>
+          </a:solidFill>
+          <a:ln w="0">
+            <a:noFill/>
+            <a:prstDash val="solid"/>
+          </a:ln>
+        </p:spPr>
+      </p:sp>
+      <p:sp>
+        <p:nvSpPr>
+          <p:cNvPr id="23" name="J03_TO_SURFACE">
+            <a:extLst>
+              <a:ext uri="{FF2B5EF4-FFF2-40B4-BE49-F238E27FC236}">
+                <a16:creationId xmlns:a16="http://schemas.microsoft.com/office/drawing/2014/main" id="{A60BA2DD-F7E3-4999-B8F2-DA8EC4632080}"/>
+              </a:ext>
+            </a:extLst>
+          </p:cNvPr>
+          <p:cNvSpPr>
+            <a:spLocks noGrp="1"/>
+          </p:cNvSpPr>
+          <p:nvPr/>
+        </p:nvSpPr>
+        <p:spPr>
+          <a:xfrm>
+            <a:off x="8020050" y="4610100"/>
+            <a:ext cx="3333750" cy="590550"/>
+          </a:xfrm>
+          <a:prstGeom prst="roundRect">
+            <a:avLst>
+              <a:gd name="adj" fmla="val 12903"/>
+            </a:avLst>
+          </a:prstGeom>
+          <a:solidFill>
+            <a:srgbClr val="F7F7F8"/>
+          </a:solidFill>
+          <a:ln w="14288">
+            <a:solidFill>
+              <a:srgbClr val="B22600"/>
+            </a:solidFill>
+            <a:prstDash val="solid"/>
+          </a:ln>
+        </p:spPr>
+      </p:sp>
+      <p:sp>
+        <p:nvSpPr>
+          <p:cNvPr id="24" name="J03_TO">
+            <a:extLst>
+              <a:ext uri="{FF2B5EF4-FFF2-40B4-BE49-F238E27FC236}">
+                <a16:creationId xmlns:a16="http://schemas.microsoft.com/office/drawing/2014/main" id="{ADBD459D-66CB-4E01-AE5D-A1A803814D88}"/>
+              </a:ext>
+            </a:extLst>
+          </p:cNvPr>
+          <p:cNvSpPr>
+            <a:spLocks noGrp="1"/>
+          </p:cNvSpPr>
+          <p:nvPr/>
+        </p:nvSpPr>
+        <p:spPr>
+          <a:xfrm>
+            <a:off x="8172450" y="4714875"/>
+            <a:ext cx="3028950" cy="381000"/>
+          </a:xfrm>
+          <a:prstGeom prst="rect">
+            <a:avLst/>
+          </a:prstGeom>
+          <a:noFill/>
+          <a:ln w="0">
+            <a:noFill/>
+            <a:prstDash val="solid"/>
+          </a:ln>
+        </p:spPr>
+        <p:txBody>
+          <a:bodyPr wrap="square" lIns="38100" tIns="19050" rIns="38100" bIns="19050" anchor="ctr">
+            <a:normAutofit fontScale="97829"/>
+          </a:bodyPr>
+          <a:lstStyle/>
+          <a:p>
+            <a:pPr algn="ctr">
+              <a:defRPr sz="1425" b="1">
+                <a:solidFill>
+                  <a:srgbClr val="B22600"/>
+                </a:solidFill>
+                <a:latin typeface="Microsoft YaHei"/>
+                <a:ea typeface="Microsoft YaHei"/>
+                <a:cs typeface="Microsoft YaHei"/>
+              </a:defRPr>
+            </a:pPr>
+            <a:r>
+              <a:rPr sz="1425" b="1">
+                <a:solidFill>
+                  <a:srgbClr val="B22600"/>
+                </a:solidFill>
+                <a:latin typeface="Microsoft YaHei"/>
+                <a:ea typeface="Microsoft YaHei"/>
+                <a:cs typeface="Microsoft YaHei"/>
+              </a:rPr>
+              <a:t>品牌 + 熟人推荐 + 施工与售后确定性</a:t>
+            </a:r>
+          </a:p>
+        </p:txBody>
+      </p:sp>
+      <p:sp>
+        <p:nvSpPr>
+          <p:cNvPr id="25" name="TEACHING_CUE">
+            <a:extLst>
+              <a:ext uri="{FF2B5EF4-FFF2-40B4-BE49-F238E27FC236}">
+                <a16:creationId xmlns:a16="http://schemas.microsoft.com/office/drawing/2014/main" id="{E1EFE987-8404-48B5-9F5C-5766F6BAE40D}"/>
+              </a:ext>
+            </a:extLst>
+          </p:cNvPr>
+          <p:cNvSpPr>
+            <a:spLocks noGrp="1"/>
+          </p:cNvSpPr>
+          <p:nvPr/>
+        </p:nvSpPr>
+        <p:spPr>
+          <a:xfrm>
+            <a:off x="514350" y="6410325"/>
+            <a:ext cx="9810750" cy="228600"/>
+          </a:xfrm>
+          <a:prstGeom prst="rect">
+            <a:avLst/>
+          </a:prstGeom>
+          <a:noFill/>
+          <a:ln w="0">
+            <a:noFill/>
+            <a:prstDash val="solid"/>
+          </a:ln>
+        </p:spPr>
+        <p:txBody>
+          <a:bodyPr wrap="square" lIns="38100" tIns="19050" rIns="38100" bIns="19050" anchor="t">
+            <a:normAutofit/>
+          </a:bodyPr>
+          <a:lstStyle/>
+          <a:p>
+            <a:pPr algn="l">
+              <a:defRPr sz="975" b="0">
+                <a:solidFill>
+                  <a:srgbClr val="6F6F6A"/>
+                </a:solidFill>
+                <a:latin typeface="Microsoft YaHei"/>
+                <a:ea typeface="Microsoft YaHei"/>
+                <a:cs typeface="Microsoft YaHei"/>
+              </a:defRPr>
+            </a:pPr>
+            <a:r>
+              <a:rPr sz="975" b="0">
+                <a:solidFill>
+                  <a:srgbClr val="6F6F6A"/>
+                </a:solidFill>
+                <a:latin typeface="Microsoft YaHei"/>
+                <a:ea typeface="Microsoft YaHei"/>
+                <a:cs typeface="Microsoft YaHei"/>
+              </a:rPr>
+              <a:t>讲师动作：先问“机会哪里变了”，收集答案后逐条揭示三条判断。</a:t>
+            </a:r>
+          </a:p>
+        </p:txBody>
+      </p:sp>
+      <p:sp>
+        <p:nvSpPr>
+          <p:cNvPr id="26" name="PAGE_NUMBER">
+            <a:extLst>
+              <a:ext uri="{FF2B5EF4-FFF2-40B4-BE49-F238E27FC236}">
+                <a16:creationId xmlns:a16="http://schemas.microsoft.com/office/drawing/2014/main" id="{EE5A4A45-F944-4D1C-B0A6-6E5A090FBF12}"/>
+              </a:ext>
+            </a:extLst>
+          </p:cNvPr>
+          <p:cNvSpPr>
+            <a:spLocks noGrp="1"/>
+          </p:cNvSpPr>
+          <p:nvPr/>
+        </p:nvSpPr>
+        <p:spPr>
+          <a:xfrm>
+            <a:off x="11049000" y="6391275"/>
+            <a:ext cx="666750" cy="228600"/>
+          </a:xfrm>
+          <a:prstGeom prst="rect">
+            <a:avLst/>
+          </a:prstGeom>
+          <a:noFill/>
+          <a:ln w="0">
+            <a:noFill/>
+            <a:prstDash val="solid"/>
+          </a:ln>
+        </p:spPr>
+        <p:txBody>
+          <a:bodyPr wrap="square" lIns="38100" tIns="19050" rIns="38100" bIns="19050" anchor="t">
+            <a:normAutofit/>
+          </a:bodyPr>
+          <a:lstStyle/>
+          <a:p>
             <a:pPr algn="r">
               <a:defRPr sz="1050" b="1">
                 <a:solidFill>
-                  <a:srgbClr val="E84C22"/>
+                  <a:srgbClr val="B22600"/>
                 </a:solidFill>
                 <a:latin typeface="Microsoft YaHei"/>
                 <a:ea typeface="Microsoft YaHei"/>
@@ -10053,7 +10053,7 @@
           <a:noFill/>
           <a:ln w="19050">
             <a:solidFill>
-              <a:srgbClr val="E84C22"/>
+              <a:srgbClr val="B22600"/>
             </a:solidFill>
             <a:prstDash val="solid"/>
           </a:ln>
@@ -10086,7 +10086,7 @@
           </a:solidFill>
           <a:ln w="19050">
             <a:solidFill>
-              <a:srgbClr val="E84C22"/>
+              <a:srgbClr val="B22600"/>
             </a:solidFill>
             <a:prstDash val="solid"/>
           </a:ln>
@@ -10187,7 +10187,7 @@
             <a:pPr algn="ctr">
               <a:defRPr sz="1125" b="1">
                 <a:solidFill>
-                  <a:srgbClr val="E84C22"/>
+                  <a:srgbClr val="B22600"/>
                 </a:solidFill>
                 <a:latin typeface="Microsoft YaHei"/>
                 <a:ea typeface="Microsoft YaHei"/>
@@ -10413,7 +10413,7 @@
           <a:noFill/>
           <a:ln w="19050">
             <a:solidFill>
-              <a:srgbClr val="E84C22"/>
+              <a:srgbClr val="B22600"/>
             </a:solidFill>
             <a:prstDash val="solid"/>
           </a:ln>
@@ -10446,7 +10446,7 @@
           </a:solidFill>
           <a:ln w="19050">
             <a:solidFill>
-              <a:srgbClr val="E84C22"/>
+              <a:srgbClr val="B22600"/>
             </a:solidFill>
             <a:prstDash val="solid"/>
           </a:ln>
@@ -10547,7 +10547,7 @@
             <a:pPr algn="ctr">
               <a:defRPr sz="1125" b="1">
                 <a:solidFill>
-                  <a:srgbClr val="E84C22"/>
+                  <a:srgbClr val="B22600"/>
                 </a:solidFill>
                 <a:latin typeface="Microsoft YaHei"/>
                 <a:ea typeface="Microsoft YaHei"/>
@@ -10843,7 +10843,7 @@
             <a:pPr algn="ctr">
               <a:defRPr sz="1050" b="1">
                 <a:solidFill>
-                  <a:srgbClr val="E84C22"/>
+                  <a:srgbClr val="B22600"/>
                 </a:solidFill>
                 <a:latin typeface="Microsoft YaHei"/>
                 <a:ea typeface="Microsoft YaHei"/>
@@ -10901,7 +10901,7 @@
             <a:pPr algn="ctr">
               <a:defRPr sz="1050" b="1">
                 <a:solidFill>
-                  <a:srgbClr val="E84C22"/>
+                  <a:srgbClr val="B22600"/>
                 </a:solidFill>
                 <a:latin typeface="Microsoft YaHei"/>
                 <a:ea typeface="Microsoft YaHei"/>
@@ -11890,7 +11890,7 @@
           <a:noFill/>
           <a:ln w="19050">
             <a:solidFill>
-              <a:srgbClr val="E84C22"/>
+              <a:srgbClr val="B22600"/>
             </a:solidFill>
             <a:prstDash val="solid"/>
           </a:ln>
@@ -11925,7 +11925,7 @@
           </a:solidFill>
           <a:ln w="19050">
             <a:solidFill>
-              <a:srgbClr val="E84C22"/>
+              <a:srgbClr val="B22600"/>
             </a:solidFill>
             <a:prstDash val="solid"/>
           </a:ln>
@@ -11968,7 +11968,7 @@
             <a:pPr algn="l">
               <a:defRPr sz="1650" b="1">
                 <a:solidFill>
-                  <a:srgbClr val="E84C22"/>
+                  <a:srgbClr val="B22600"/>
                 </a:solidFill>
                 <a:latin typeface="Microsoft YaHei"/>
                 <a:ea typeface="Microsoft YaHei"/>
@@ -12130,7 +12130,7 @@
           <a:noFill/>
           <a:ln w="19050">
             <a:solidFill>
-              <a:srgbClr val="E84C22"/>
+              <a:srgbClr val="B22600"/>
             </a:solidFill>
             <a:prstDash val="solid"/>
           </a:ln>
@@ -12165,7 +12165,7 @@
           </a:solidFill>
           <a:ln w="19050">
             <a:solidFill>
-              <a:srgbClr val="E84C22"/>
+              <a:srgbClr val="B22600"/>
             </a:solidFill>
             <a:prstDash val="solid"/>
           </a:ln>
@@ -12208,7 +12208,7 @@
             <a:pPr algn="l">
               <a:defRPr sz="1650" b="1">
                 <a:solidFill>
-                  <a:srgbClr val="E84C22"/>
+                  <a:srgbClr val="B22600"/>
                 </a:solidFill>
                 <a:latin typeface="Microsoft YaHei"/>
                 <a:ea typeface="Microsoft YaHei"/>
@@ -14184,7 +14184,7 @@
           </a:solidFill>
           <a:ln w="9525">
             <a:solidFill>
-              <a:srgbClr val="E84C22"/>
+              <a:srgbClr val="B22600"/>
             </a:solidFill>
             <a:prstDash val="solid"/>
           </a:ln>
@@ -14310,7 +14310,7 @@
           </a:solidFill>
           <a:ln w="9525">
             <a:solidFill>
-              <a:srgbClr val="E84C22"/>
+              <a:srgbClr val="B22600"/>
             </a:solidFill>
             <a:prstDash val="solid"/>
           </a:ln>
@@ -14436,7 +14436,7 @@
           </a:solidFill>
           <a:ln w="9525">
             <a:solidFill>
-              <a:srgbClr val="E84C22"/>
+              <a:srgbClr val="B22600"/>
             </a:solidFill>
             <a:prstDash val="solid"/>
           </a:ln>
@@ -14562,7 +14562,7 @@
           </a:solidFill>
           <a:ln w="9525">
             <a:solidFill>
-              <a:srgbClr val="E84C22"/>
+              <a:srgbClr val="B22600"/>
             </a:solidFill>
             <a:prstDash val="solid"/>
           </a:ln>
@@ -14688,7 +14688,7 @@
           </a:solidFill>
           <a:ln w="9525">
             <a:solidFill>
-              <a:srgbClr val="E84C22"/>
+              <a:srgbClr val="B22600"/>
             </a:solidFill>
             <a:prstDash val="solid"/>
           </a:ln>
@@ -14814,7 +14814,7 @@
           </a:solidFill>
           <a:ln w="9525">
             <a:solidFill>
-              <a:srgbClr val="E84C22"/>
+              <a:srgbClr val="B22600"/>
             </a:solidFill>
             <a:prstDash val="solid"/>
           </a:ln>
@@ -14940,7 +14940,7 @@
           </a:solidFill>
           <a:ln w="9525">
             <a:solidFill>
-              <a:srgbClr val="E84C22"/>
+              <a:srgbClr val="B22600"/>
             </a:solidFill>
             <a:prstDash val="solid"/>
           </a:ln>
@@ -15066,7 +15066,7 @@
           </a:solidFill>
           <a:ln w="9525">
             <a:solidFill>
-              <a:srgbClr val="E84C22"/>
+              <a:srgbClr val="B22600"/>
             </a:solidFill>
             <a:prstDash val="solid"/>
           </a:ln>
@@ -15527,7 +15527,7 @@
           </a:solidFill>
           <a:ln w="19050">
             <a:solidFill>
-              <a:srgbClr val="E84C22"/>
+              <a:srgbClr val="B22600"/>
             </a:solidFill>
             <a:prstDash val="solid"/>
           </a:ln>
@@ -15570,7 +15570,7 @@
             <a:pPr algn="ctr">
               <a:defRPr sz="1650" b="1">
                 <a:solidFill>
-                  <a:srgbClr val="E84C22"/>
+                  <a:srgbClr val="B22600"/>
                 </a:solidFill>
                 <a:latin typeface="Microsoft YaHei"/>
                 <a:ea typeface="Microsoft YaHei"/>
@@ -15678,7 +15678,7 @@
           </a:solidFill>
           <a:ln w="19050">
             <a:solidFill>
-              <a:srgbClr val="E84C22"/>
+              <a:srgbClr val="B22600"/>
             </a:solidFill>
             <a:prstDash val="solid"/>
           </a:ln>
@@ -15721,7 +15721,7 @@
             <a:pPr algn="ctr">
               <a:defRPr sz="1650" b="1">
                 <a:solidFill>
-                  <a:srgbClr val="E84C22"/>
+                  <a:srgbClr val="B22600"/>
                 </a:solidFill>
                 <a:latin typeface="Microsoft YaHei"/>
                 <a:ea typeface="Microsoft YaHei"/>
@@ -16801,7 +16801,7 @@
             <a:avLst/>
           </a:prstGeom>
           <a:solidFill>
-            <a:srgbClr val="E84C22"/>
+            <a:srgbClr val="B22600"/>
           </a:solidFill>
           <a:ln w="0">
             <a:noFill/>
@@ -16904,7 +16904,7 @@
             <a:pPr algn="r">
               <a:defRPr sz="1650" b="1">
                 <a:solidFill>
-                  <a:srgbClr val="E84C22"/>
+                  <a:srgbClr val="B22600"/>
                 </a:solidFill>
                 <a:latin typeface="Microsoft YaHei"/>
                 <a:ea typeface="Microsoft YaHei"/>
@@ -17012,7 +17012,7 @@
           </a:solidFill>
           <a:ln w="14288">
             <a:solidFill>
-              <a:srgbClr val="E84C22"/>
+              <a:srgbClr val="B22600"/>
             </a:solidFill>
             <a:prstDash val="solid"/>
           </a:ln>
@@ -17055,7 +17055,7 @@
             <a:pPr algn="l">
               <a:defRPr sz="1275" b="1">
                 <a:solidFill>
-                  <a:srgbClr val="E84C22"/>
+                  <a:srgbClr val="B22600"/>
                 </a:solidFill>
                 <a:latin typeface="Microsoft YaHei"/>
                 <a:ea typeface="Microsoft YaHei"/>
@@ -17099,7 +17099,7 @@
             <a:avLst/>
           </a:prstGeom>
           <a:solidFill>
-            <a:srgbClr val="E84C22"/>
+            <a:srgbClr val="B22600"/>
           </a:solidFill>
           <a:ln w="0">
             <a:noFill/>
@@ -17202,7 +17202,7 @@
             <a:pPr algn="r">
               <a:defRPr sz="1650" b="1">
                 <a:solidFill>
-                  <a:srgbClr val="E84C22"/>
+                  <a:srgbClr val="B22600"/>
                 </a:solidFill>
                 <a:latin typeface="Microsoft YaHei"/>
                 <a:ea typeface="Microsoft YaHei"/>
@@ -17310,7 +17310,7 @@
           </a:solidFill>
           <a:ln w="14288">
             <a:solidFill>
-              <a:srgbClr val="E84C22"/>
+              <a:srgbClr val="B22600"/>
             </a:solidFill>
             <a:prstDash val="solid"/>
           </a:ln>
@@ -17353,7 +17353,7 @@
             <a:pPr algn="l">
               <a:defRPr sz="1275" b="1">
                 <a:solidFill>
-                  <a:srgbClr val="E84C22"/>
+                  <a:srgbClr val="B22600"/>
                 </a:solidFill>
                 <a:latin typeface="Microsoft YaHei"/>
                 <a:ea typeface="Microsoft YaHei"/>

</xml_diff>